<commit_message>
Refresh model wording and screenshots; retain the Google Slides submission URL
</commit_message>
<xml_diff>
--- a/docs/G045_Semiconductor_Agent.pptx
+++ b/docs/G045_Semiconductor_Agent.pptx
@@ -14508,8 +14508,8 @@
         </p:blipFill>
         <p:spPr>
           <a:xfrm>
-            <a:off x="6723210" y="1874519"/>
-            <a:ext cx="4384380" cy="4160520"/>
+            <a:off x="6492240" y="2240767"/>
+            <a:ext cx="4846320" cy="3428024"/>
           </a:xfrm>
           <a:prstGeom prst="rect">
             <a:avLst/>
@@ -15027,8 +15027,8 @@
         </p:blipFill>
         <p:spPr>
           <a:xfrm>
-            <a:off x="6569264" y="1874519"/>
-            <a:ext cx="4692271" cy="4160520"/>
+            <a:off x="6842508" y="1874519"/>
+            <a:ext cx="4145783" cy="4160520"/>
           </a:xfrm>
           <a:prstGeom prst="rect">
             <a:avLst/>

</xml_diff>

<commit_message>
Restore local Qwen and add measured explanation judge evaluation
</commit_message>
<xml_diff>
--- a/docs/G045_Semiconductor_Agent.pptx
+++ b/docs/G045_Semiconductor_Agent.pptx
@@ -517,7 +517,7 @@
           <a:lstStyle/>
           <a:p>
             <a:r>
-              <a:t>안녕하세요. SKALA 광주 2반 G045 김용찬입니다. 반도체 검사 데이터를 넣으면 모델을 비교하고, 결과에 따라 다음 실험을 제안하는 Agent를 만들었습니다.</a:t>
+              <a:t>안녕하세요. SKALA 광주 2반 G045 김용찬입니다. 반도체 검사 데이터를 넣으면 여러 모델을 비교하고, 어떤 후보를 선택했는지 근거를 보여 주는 Agent를 만들었습니다.</a:t>
             </a:r>
           </a:p>
           <a:p/>
@@ -593,7 +593,7 @@
           <a:lstStyle/>
           <a:p>
             <a:r>
-              <a:t>핵심 성과는 가장 좋은 모델 이름을 말하는 것보다, 계획 승인부터 비교 결과와 다음 실험까지 연결했다는 점입니다. Recall을 높이면 정상 오판이 늘 수 있고, 선택 기준이 결과를 바꾼다는 것을 배웠습니다. 합성 데이터와 작은 표본, 반복 비교가 한계입니다. 다음에는 현장 기준과 독립 기간 데이터로 검증하고 실제 작업시간 절감도 측정하겠습니다. 감사합니다.</a:t>
+              <a:t>핵심 성과는 데이터 점검부터 승인된 모델 비교, 선택 근거와 결과 확인까지 한 흐름으로 연결했다는 점입니다. Recall을 높이면 정상 오판이 늘 수 있고, 선택 기준이 결과를 바꾼다는 것을 배웠습니다. 합성 데이터와 작은 표본, 반복 비교가 한계입니다. 다음에는 현장 기준과 독립 기간 데이터로 검증하고 실제 작업시간 절감도 측정하겠습니다. 감사합니다.</a:t>
             </a:r>
           </a:p>
           <a:p/>
@@ -821,13 +821,13 @@
           <a:lstStyle/>
           <a:p>
             <a:r>
-              <a:t>정답이 없으면 Recall을 직접 계산할 수 없습니다. 향후 드리프트 감지를 검토할 수 있지만 변화 감지만으로 재학습 효과를 확정하지 않습니다. 현재는 새 정답 데이터의 Train 구간으로 점검하고 승인 후 후보를 비교합니다. 운영 모델을 자동 교체하지 않습니다.</a:t>
+              <a:t>같은 Test에서 후보가 불량을 더 찾았지만 정상 오판도 늘었습니다. 목표는 검사 단계와 업무 비용에 따라 정해야 합니다. 이번 실험에서는 두 목표 충족 여부, Recall 우선, 동률 시 정상 오판률 순서로 후보를 비교했습니다.</a:t>
             </a:r>
           </a:p>
           <a:p/>
           <a:p>
             <a:r>
-              <a:t>출처: app/monitoring.py; docs/evaluation/model_management.json</a:t>
+              <a:t>출처: app/metrics.py; docs/evaluation/synthetic_process.json</a:t>
             </a:r>
           </a:p>
         </p:txBody>
@@ -1201,7 +1201,7 @@
           <a:lstStyle/>
           <a:p>
             <a:r>
-              <a:t>구조입니다. 데이터 점검, 근거 검색, 실험 계획을 LangGraph로 연결했습니다. 계획과 데이터의 해시를 저장하고 엔지니어가 승인한 뒤에만 학습합니다. 결과 검토에서는 부족한 지표를 보여 주고 새 모델 비교나 기존 모델 점검으로 이어집니다. 학습과 수치는 실험 엔진이 계산하고, LLM은 제한된 근거와 설명을 보조합니다. 자율 Supervisor나 자동 배포까지 구현한 것은 아닙니다.</a:t>
+              <a:t>구조입니다. 데이터 점검, 근거 검색, 실험 계획을 LangGraph로 연결했습니다. 계획과 데이터의 해시를 저장하고 엔지니어가 승인한 뒤에만 학습합니다. 결과에서는 선택 근거와 불량 발견·정상 오판을 함께 보여 줍니다. 학습과 수치는 실험 엔진이 계산하고, LLM은 제한된 근거와 설명을 보조합니다.</a:t>
             </a:r>
           </a:p>
           <a:p/>
@@ -1505,7 +1505,7 @@
           <a:lstStyle/>
           <a:p>
             <a:r>
-              <a:t>마지막 Test입니다. 같은 불량 32개 중 기본 Logistic은 20개, 후보 CatBoost는 27개를 찾았습니다. 대신 정상을 불량으로 오판한 수는 1개에서 14개로 늘었습니다. 후보 Recall 84.4%는 목표 90퍼센트에 못 미쳤습니다. 선택 후보와 현장 적용 확정은 다른 단계이며, 이 결과를 보고 다음 실험으로 이어갑니다.</a:t>
+              <a:t>마지막 Test입니다. 같은 불량 32개 중 기본 Logistic은 20개, 후보 CatBoost는 27개를 찾았습니다. 대신 정상을 불량으로 오판한 수는 1개에서 14개로 늘었습니다. 후보 Recall 84.4%는 목표 90퍼센트에 못 미쳤습니다. 그래서 이 후보를 바로 현장 적용 모델로 확정하지 않고 추가 검증이 필요하다고 설명합니다.</a:t>
             </a:r>
           </a:p>
           <a:p/>
@@ -1581,7 +1581,7 @@
           <a:lstStyle/>
           <a:p>
             <a:r>
-              <a:t>다음 행동은 새 모델 비교입니다. 공식 모델 목록과 문서를 조회하고, RAG로 근거를 연결해 ExtraTrees와 Gaussian Naive Bayes를 제안합니다. 승인받아 기존 후보와 같은 조건으로 학습하고 후보 목록에 기록했습니다. 이 추가 실험에서는 CatBoost를 유지했습니다. 현재는 검토된 두 모델 연결을 지원합니다. 기존 Test를 재사용한 탐색 비교여서 최종 적용에는 새로운 독립 데이터가 필요합니다.</a:t>
+              <a:t>기존 비교 목록에 없는 후보를 추가하는 기능입니다. 공식 모델 목록과 문서를 조회하고, RAG로 근거를 연결해 ExtraTrees와 Gaussian Naive Bayes를 제안합니다. 승인받아 기존 후보와 같은 조건으로 학습하고 후보 목록에 기록했습니다. 이 추가 실험에서는 CatBoost를 유지했습니다. 현재는 검토된 두 모델 연결을 지원합니다. 기존 Test를 재사용한 탐색 비교여서 최종 적용에는 새로운 독립 데이터가 필요합니다.</a:t>
             </a:r>
           </a:p>
           <a:p/>
@@ -1657,13 +1657,13 @@
           <a:lstStyle/>
           <a:p>
             <a:r>
-              <a:t>기술은 LangGraph 역할 분리, MCP 네 도구와 지식 리소스, RAG와 의존성 주입을 적용했습니다. LangSmith에는 이 노트북에서 실제 계획 생성과 하위 실행 기록을 보내고 다시 조회했습니다. 다만 이 노트북의 현재 모드는 로컬 LLM 미사용입니다. 기존 노트북의 LLM 실행 기록과 구분하고, 응답 실패는 규칙 설명으로 표시합니다. LLM-as-a-Judge는 미구현입니다.</a:t>
+              <a:t>LangGraph로 역할을 연결하고 MCP와 RAG를 적용했습니다. 설명에는 수업에서 사용한 Qwen2.5를 로컬로 연결했습니다. LangSmith로 실제 실행 경로를 확인했고, 별도의 LLM 평가자가 설명과 실제 결과를 비교하도록 했습니다. 자체 예제 6/8개에서 사전 라벨과 일치했습니다. 작은 자체 개발 예제의 결과이며 LLM 평가도 틀릴 수 있어 코드 검사와 함께 사용합니다.</a:t>
             </a:r>
           </a:p>
           <a:p/>
           <a:p>
             <a:r>
-              <a:t>출처: docs/evaluation/langsmith_check.json; docs/evaluation/agent_integration.json; docs/evaluation/tests-windows.txt</a:t>
+              <a:t>출처: docs/evaluation/langsmith_check.json; docs/evaluation/local_llm_check.json; docs/evaluation/llm_judge.json; docs/evaluation/tests-windows.txt</a:t>
             </a:r>
           </a:p>
         </p:txBody>
@@ -4987,7 +4987,7 @@
               </a:defRPr>
             </a:pPr>
             <a:r>
-              <a:t>데이터를 점검하고, 승인받아 실험하고, 다음 비교를 제안합니다.</a:t>
+              <a:t>데이터를 점검하고, 승인받아 모델을 비교하고, 선택 근거를 보여 줍니다.</a:t>
             </a:r>
           </a:p>
         </p:txBody>
@@ -5545,7 +5545,7 @@
               </a:defRPr>
             </a:pPr>
             <a:r>
-              <a:t>다음 실험</a:t>
+              <a:t>선택 근거</a:t>
             </a:r>
           </a:p>
         </p:txBody>
@@ -5698,7 +5698,7 @@
               </a:defRPr>
             </a:pPr>
             <a:r>
-              <a:t>성과는 모델 이름보다, 다음 판단까지 연결한 흐름입니다</a:t>
+              <a:t>선택한 모델과 선택 이유를 함께 보여 줍니다</a:t>
             </a:r>
           </a:p>
         </p:txBody>
@@ -5910,7 +5910,7 @@
               </a:defRPr>
             </a:pPr>
             <a:r>
-              <a:t>구현: 데이터 점검 → 계획 승인 → 실제 비교 → 다음 실험 제안</a:t>
+              <a:t>구현: 데이터 점검 → 계획 승인 → 모델 비교 → 선택 근거·지표 확인</a:t>
             </a:r>
           </a:p>
         </p:txBody>
@@ -9136,7 +9136,7 @@
               </a:defRPr>
             </a:pPr>
             <a:r>
-              <a:t>부록 · 재학습 판단과 기존 모델 관리</a:t>
+              <a:t>부록 · 검사 목적과 판단 기준</a:t>
             </a:r>
           </a:p>
         </p:txBody>
@@ -9178,7 +9178,7 @@
               </a:defRPr>
             </a:pPr>
             <a:r>
-              <a:t>3σ는 변화 감지, Recall 목표는 판정 성능입니다</a:t>
+              <a:t>Recall만 높으면 좋은 모델인가요?</a:t>
             </a:r>
           </a:p>
         </p:txBody>
@@ -9390,7 +9390,7 @@
               </a:defRPr>
             </a:pPr>
             <a:r>
-              <a:t>3σ: 공정 값·오차가 평소와 다른가? 안정성·분포·관리도 가정을 먼저 확인</a:t>
+              <a:t>Recall: 실제 불량 중 찾아낸 비율 / 정상 오판률: 정상을 불량으로 잘못 본 비율</a:t>
             </a:r>
           </a:p>
         </p:txBody>
@@ -9475,7 +9475,7 @@
               </a:defRPr>
             </a:pPr>
             <a:r>
-              <a:t>Recall/FPR: 정답이 있는 새 데이터에서 검사 모델이 목표를 만족하는가?</a:t>
+              <a:t>전부 불량이라고 판단하면 Recall은 높지만 정상 오판도 커집니다.</a:t>
             </a:r>
           </a:p>
         </p:txBody>
@@ -9560,7 +9560,7 @@
               </a:defRPr>
             </a:pPr>
             <a:r>
-              <a:t>현재 구현은 교육용 Recall 90%·정상 오판 15% 점검 · 3σ 트리거 미구현</a:t>
+              <a:t>먼저 담당자와 불량 미검출·정상 오판의 허용 범위를 정합니다.</a:t>
             </a:r>
           </a:p>
         </p:txBody>
@@ -9645,7 +9645,7 @@
               </a:defRPr>
             </a:pPr>
             <a:r>
-              <a:t>새 합성 배치의 동일 Test: 불량 발견 43 → 153 / 167개</a:t>
+              <a:t>이번 90%·15%는 교육용 목표이며 회사의 공통 양산 기준이 아닙니다.</a:t>
             </a:r>
           </a:p>
         </p:txBody>
@@ -9730,7 +9730,7 @@
               </a:defRPr>
             </a:pPr>
             <a:r>
-              <a:t>정상 오판 96 → 79개 · 승인 후 같은 알고리즘 재학습</a:t>
+              <a:t>Precision·F1도 함께 보고, 작은 불량 표본의 불확실성을 확인합니다.</a:t>
             </a:r>
           </a:p>
         </p:txBody>
@@ -10792,7 +10792,7 @@
                     <a:lstStyle/>
                     <a:p>
                       <a:pPr>
-                        <a:defRPr sz="1300" b="1">
+                        <a:defRPr sz="1200" b="1">
                           <a:solidFill>
                             <a:srgbClr val="FFFFFF"/>
                           </a:solidFill>
@@ -10816,7 +10816,7 @@
                     <a:lstStyle/>
                     <a:p>
                       <a:pPr>
-                        <a:defRPr sz="1300" b="1">
+                        <a:defRPr sz="1200" b="1">
                           <a:solidFill>
                             <a:srgbClr val="FFFFFF"/>
                           </a:solidFill>
@@ -10840,7 +10840,7 @@
                     <a:lstStyle/>
                     <a:p>
                       <a:pPr>
-                        <a:defRPr sz="1300" b="1">
+                        <a:defRPr sz="1200" b="1">
                           <a:solidFill>
                             <a:srgbClr val="FFFFFF"/>
                           </a:solidFill>
@@ -10866,7 +10866,7 @@
                     <a:lstStyle/>
                     <a:p>
                       <a:pPr>
-                        <a:defRPr sz="1300" b="0">
+                        <a:defRPr sz="1200" b="0">
                           <a:solidFill>
                             <a:srgbClr val="173A49"/>
                           </a:solidFill>
@@ -10890,7 +10890,7 @@
                     <a:lstStyle/>
                     <a:p>
                       <a:pPr>
-                        <a:defRPr sz="1300" b="0">
+                        <a:defRPr sz="1200" b="0">
                           <a:solidFill>
                             <a:srgbClr val="173A49"/>
                           </a:solidFill>
@@ -10914,7 +10914,7 @@
                     <a:lstStyle/>
                     <a:p>
                       <a:pPr>
-                        <a:defRPr sz="1300" b="0">
+                        <a:defRPr sz="1200" b="0">
                           <a:solidFill>
                             <a:srgbClr val="173A49"/>
                           </a:solidFill>
@@ -10940,7 +10940,7 @@
                     <a:lstStyle/>
                     <a:p>
                       <a:pPr>
-                        <a:defRPr sz="1300" b="0">
+                        <a:defRPr sz="1200" b="0">
                           <a:solidFill>
                             <a:srgbClr val="173A49"/>
                           </a:solidFill>
@@ -10964,7 +10964,7 @@
                     <a:lstStyle/>
                     <a:p>
                       <a:pPr>
-                        <a:defRPr sz="1300" b="0">
+                        <a:defRPr sz="1200" b="0">
                           <a:solidFill>
                             <a:srgbClr val="173A49"/>
                           </a:solidFill>
@@ -10988,7 +10988,7 @@
                     <a:lstStyle/>
                     <a:p>
                       <a:pPr>
-                        <a:defRPr sz="1300" b="0">
+                        <a:defRPr sz="1200" b="0">
                           <a:solidFill>
                             <a:srgbClr val="173A49"/>
                           </a:solidFill>
@@ -11014,7 +11014,7 @@
                     <a:lstStyle/>
                     <a:p>
                       <a:pPr>
-                        <a:defRPr sz="1300" b="0">
+                        <a:defRPr sz="1200" b="0">
                           <a:solidFill>
                             <a:srgbClr val="173A49"/>
                           </a:solidFill>
@@ -11038,7 +11038,7 @@
                     <a:lstStyle/>
                     <a:p>
                       <a:pPr>
-                        <a:defRPr sz="1300" b="0">
+                        <a:defRPr sz="1200" b="0">
                           <a:solidFill>
                             <a:srgbClr val="173A49"/>
                           </a:solidFill>
@@ -11062,7 +11062,7 @@
                     <a:lstStyle/>
                     <a:p>
                       <a:pPr>
-                        <a:defRPr sz="1300" b="0">
+                        <a:defRPr sz="1200" b="0">
                           <a:solidFill>
                             <a:srgbClr val="173A49"/>
                           </a:solidFill>
@@ -11088,7 +11088,7 @@
                     <a:lstStyle/>
                     <a:p>
                       <a:pPr>
-                        <a:defRPr sz="1300" b="0">
+                        <a:defRPr sz="1200" b="0">
                           <a:solidFill>
                             <a:srgbClr val="173A49"/>
                           </a:solidFill>
@@ -11112,7 +11112,7 @@
                     <a:lstStyle/>
                     <a:p>
                       <a:pPr>
-                        <a:defRPr sz="1300" b="0">
+                        <a:defRPr sz="1200" b="0">
                           <a:solidFill>
                             <a:srgbClr val="173A49"/>
                           </a:solidFill>
@@ -11136,7 +11136,7 @@
                     <a:lstStyle/>
                     <a:p>
                       <a:pPr>
-                        <a:defRPr sz="1300" b="0">
+                        <a:defRPr sz="1200" b="0">
                           <a:solidFill>
                             <a:srgbClr val="173A49"/>
                           </a:solidFill>
@@ -11162,7 +11162,7 @@
                     <a:lstStyle/>
                     <a:p>
                       <a:pPr>
-                        <a:defRPr sz="1300" b="0">
+                        <a:defRPr sz="1200" b="0">
                           <a:solidFill>
                             <a:srgbClr val="173A49"/>
                           </a:solidFill>
@@ -11186,7 +11186,7 @@
                     <a:lstStyle/>
                     <a:p>
                       <a:pPr>
-                        <a:defRPr sz="1300" b="0">
+                        <a:defRPr sz="1200" b="0">
                           <a:solidFill>
                             <a:srgbClr val="173A49"/>
                           </a:solidFill>
@@ -11210,7 +11210,7 @@
                     <a:lstStyle/>
                     <a:p>
                       <a:pPr>
-                        <a:defRPr sz="1300" b="0">
+                        <a:defRPr sz="1200" b="0">
                           <a:solidFill>
                             <a:srgbClr val="173A49"/>
                           </a:solidFill>
@@ -11236,7 +11236,7 @@
                     <a:lstStyle/>
                     <a:p>
                       <a:pPr>
-                        <a:defRPr sz="1300" b="0">
+                        <a:defRPr sz="1200" b="0">
                           <a:solidFill>
                             <a:srgbClr val="173A49"/>
                           </a:solidFill>
@@ -11260,7 +11260,7 @@
                     <a:lstStyle/>
                     <a:p>
                       <a:pPr>
-                        <a:defRPr sz="1300" b="0">
+                        <a:defRPr sz="1200" b="0">
                           <a:solidFill>
                             <a:srgbClr val="173A49"/>
                           </a:solidFill>
@@ -11284,7 +11284,7 @@
                     <a:lstStyle/>
                     <a:p>
                       <a:pPr>
-                        <a:defRPr sz="1300" b="0">
+                        <a:defRPr sz="1200" b="0">
                           <a:solidFill>
                             <a:srgbClr val="173A49"/>
                           </a:solidFill>
@@ -11310,7 +11310,7 @@
                     <a:lstStyle/>
                     <a:p>
                       <a:pPr>
-                        <a:defRPr sz="1300" b="0">
+                        <a:defRPr sz="1200" b="0">
                           <a:solidFill>
                             <a:srgbClr val="173A49"/>
                           </a:solidFill>
@@ -11334,7 +11334,7 @@
                     <a:lstStyle/>
                     <a:p>
                       <a:pPr>
-                        <a:defRPr sz="1300" b="0">
+                        <a:defRPr sz="1200" b="0">
                           <a:solidFill>
                             <a:srgbClr val="173A49"/>
                           </a:solidFill>
@@ -11342,7 +11342,7 @@
                         </a:defRPr>
                       </a:pPr>
                       <a:r>
-                        <a:t>미구현</a:t>
+                        <a:t>로컬 Qwen으로 설명과 실제 결과 비교</a:t>
                       </a:r>
                     </a:p>
                   </a:txBody>
@@ -11358,7 +11358,7 @@
                     <a:lstStyle/>
                     <a:p>
                       <a:pPr>
-                        <a:defRPr sz="1300" b="0">
+                        <a:defRPr sz="1200" b="0">
                           <a:solidFill>
                             <a:srgbClr val="173A49"/>
                           </a:solidFill>
@@ -11366,7 +11366,7 @@
                         </a:defRPr>
                       </a:pPr>
                       <a:r>
-                        <a:t>허용 코드·출처 검사를 대신 사용</a:t>
+                        <a:t>자체 예제 6/8개에서 사전 라벨과 일치 · 독립 평가 아님</a:t>
                       </a:r>
                     </a:p>
                   </a:txBody>
@@ -13950,7 +13950,7 @@
               </a:defRPr>
             </a:pPr>
             <a:r>
-              <a:t>결과 검토 → 다음 실험</a:t>
+              <a:t>기본 모델과 후보 결과 비교</a:t>
             </a:r>
           </a:p>
         </p:txBody>
@@ -13992,7 +13992,7 @@
               </a:defRPr>
             </a:pPr>
             <a:r>
-              <a:t>새 후보 탐색 / 기존 모델 점검 → 새 승인</a:t>
+              <a:t>불량 발견·정상 오판 → 기준 충족 여부 확인</a:t>
             </a:r>
           </a:p>
         </p:txBody>
@@ -16826,7 +16826,7 @@
               </a:defRPr>
             </a:pPr>
             <a:r>
-              <a:t>다음 실험 · 모델 탐색 RAG</a:t>
+              <a:t>모델 비교의 확장 · 후보 탐색 RAG</a:t>
             </a:r>
           </a:p>
         </p:txBody>
@@ -16868,7 +16868,7 @@
               </a:defRPr>
             </a:pPr>
             <a:r>
-              <a:t>⑤ 공식 문서에서 새 후보를 찾아 다시 비교합니다</a:t>
+              <a:t>공식 문서에서 비교할 후보를 추가할 수 있습니다</a:t>
             </a:r>
           </a:p>
         </p:txBody>
@@ -17163,7 +17163,7 @@
               </a:defRPr>
             </a:pPr>
             <a:r>
-              <a:t>현재는 검토된 두 adapter 범위 · 임의 코드 자동 실행은 미구현</a:t>
+              <a:t>현재 실행 가능한 범위: 검토된 두 모델 adapter</a:t>
             </a:r>
           </a:p>
         </p:txBody>
@@ -17598,7 +17598,7 @@
               </a:defRPr>
             </a:pPr>
             <a:r>
-              <a:t>RAG: 교육 근거 14개 + 공식 외부 문서 검색</a:t>
+              <a:t>로컬 Qwen2.5 · RAG 근거 검색 · 공식 문서에서 비교 후보 추가</a:t>
             </a:r>
           </a:p>
         </p:txBody>
@@ -17682,7 +17682,7 @@
               </a:defRPr>
             </a:pPr>
             <a:r>
-              <a:t>30개 테스트 통과 · LLM 응답 실패/미사용은 규칙 설명으로 표시</a:t>
+              <a:t>LLM 평가 6/8 예제 일치 · 테스트 33개 통과</a:t>
             </a:r>
           </a:p>
         </p:txBody>
@@ -17813,7 +17813,7 @@
               </a:defRPr>
             </a:pPr>
             <a:r>
-              <a:t>API 재조회 성공 · child run 10개 · 15462174-e7e6-431d-bbdf-d3b8ae5a7c3d</a:t>
+              <a:t>API 재조회 성공 · child run 10개 · 78b9a699-ccfe-4533-a4f8-f0cbc021894b</a:t>
             </a:r>
           </a:p>
         </p:txBody>
@@ -17855,7 +17855,7 @@
               </a:defRPr>
             </a:pPr>
             <a:r>
-              <a:t>현재 Windows: LLM 미사용 / 기존 Mac: 역할별 verified·fallback 기록 보존 · LLM-as-a-Judge 미구현</a:t>
+              <a:t>LLM은 근거와 설명을 보조하고, 모델 학습·지표 계산·후보 순위는 실험 엔진이 담당합니다.</a:t>
             </a:r>
           </a:p>
         </p:txBody>

</xml_diff>

<commit_message>
Add approved Recall-first ensemble weight search and simplify presentation
</commit_message>
<xml_diff>
--- a/docs/G045_Semiconductor_Agent.pptx
+++ b/docs/G045_Semiconductor_Agent.pptx
@@ -19,8 +19,6 @@
     <p:sldId id="267" r:id="rId19"/>
     <p:sldId id="268" r:id="rId20"/>
     <p:sldId id="269" r:id="rId21"/>
-    <p:sldId id="270" r:id="rId22"/>
-    <p:sldId id="271" r:id="rId23"/>
   </p:sldIdLst>
   <p:sldSz cx="12191999" cy="6858000" type="screen4x3"/>
   <p:notesSz cx="6858000" cy="9144000"/>
@@ -517,7 +515,7 @@
           <a:lstStyle/>
           <a:p>
             <a:r>
-              <a:t>안녕하세요. 김용찬입니다. 검사 데이터를 넣으면 모델 비교 계획을 세우고, 승인 후 실제로 학습해서 선택 이유와 결과를 보여 주는 Agent를 만들었습니다.</a:t>
+              <a:t>안녕하세요. 김용찬입니다. 검사 데이터를 넣으면 모델과 앙상블 비율을 비교하고, 왜 그 비율을 선택했는지 결과와 함께 보여 주는 Agent를 만들었습니다.</a:t>
             </a:r>
           </a:p>
           <a:p/>
@@ -593,7 +591,7 @@
           <a:lstStyle/>
           <a:p>
             <a:r>
-              <a:t>성과는 데이터 입력부터 승인, 모델 비교와 선택 근거를 한 흐름으로 연결한 점입니다. 불량을 더 찾는 만큼 정상 오판도 늘 수 있다는 것을 배웠습니다. 합성 데이터와 작은 표본이 한계이며, 다음에는 현장 기준과 새로운 독립 데이터로 검증하겠습니다. 감사합니다.</a:t>
+              <a:t>모델 이름뿐 아니라 혼합 비율과 선택 근거까지 보여 주는 흐름을 구현했습니다. F1 하나로 고르기보다 업무의 우선순위를 먼저 정해야 한다는 것을 배웠습니다. 합성 데이터와 작은 표본이 한계이며, 다음에는 현장 기준과 독립 데이터로 검증하겠습니다. 감사합니다.</a:t>
             </a:r>
           </a:p>
           <a:p/>
@@ -669,13 +667,13 @@
           <a:lstStyle/>
           <a:p>
             <a:r>
-              <a:t>본문 6장에서는 앱의 상위 네 행만 보여 줍니다. 이 표는 제품 조합 확장 전 비교입니다. F1은 Precision과 Recall의 조화평균이며 업무 비용을 자동으로 반영하지 않습니다. 목표가 다르면 선택 기준도 바뀝니다.</a:t>
+              <a:t>초기 전체 제품 비교표입니다. AdaBoost는 F1이 더 높지만 이번에는 검출률을 먼저 보는 규칙을 따랐습니다. 초기 제품 조합 탐색의 CatBoost A+B+C와 이번 전체 제품 앙상블은 별도의 실험입니다.</a:t>
             </a:r>
           </a:p>
           <a:p/>
           <a:p>
             <a:r>
-              <a:t>출처: docs/evaluation/synthetic_process.json</a:t>
+              <a:t>출처: docs/evaluation/synthetic_process.json; docs/evaluation/weighted_ensemble.json</a:t>
             </a:r>
           </a:p>
         </p:txBody>
@@ -745,7 +743,7 @@
           <a:lstStyle/>
           <a:p>
             <a:r>
-              <a:t>SECOM은 1,567건 중 불합격104건입니다. 제조사·제품ID는 제공되지 않습니다. 이미지 Test의 불량15건은 작은 표본입니다.</a:t>
+              <a:t>SECOM은1,567건 중 불합격104건이며 제조사·제품ID는 제공되지 않습니다. 이미지 Test의 불량15건은 작은 표본입니다. 이 표는 이전 실험 기록이며 앙상블 적용 결과로 해석하지 않습니다.</a:t>
             </a:r>
           </a:p>
           <a:p/>
@@ -821,13 +819,13 @@
           <a:lstStyle/>
           <a:p>
             <a:r>
-              <a:t>6대2대2는 사전에 정한 재현 조건이며 모든 데이터의 최적 비율은 아닙니다. 생산 묶음·날짜 크기에 따라 실제 행 비율이 달라집니다. 후보 추가 탐색에 기존 Test를 다시 사용했으므로 독립 기간 검증이 필요합니다.</a:t>
+              <a:t>각 모델의 불량 확률을90대10으로 평균하고 Validation에서 정한 판정값 이상이면 불량으로 봅니다. 단일 모델과 균등 비율도 포함했습니다. 동률이면 적은 모델을 고르므로 단일 모델을 유지할 수도 있습니다. 모든 모델·모든 실수 비율의 전역 최적이라는 뜻은 아닙니다. 정확한 근거는 전체 비율 CSV로 확인할 수 있습니다.</a:t>
             </a:r>
           </a:p>
           <a:p/>
           <a:p>
             <a:r>
-              <a:t>출처: app/data.py; docs/MODEL_DISCOVERY_DESIGN.md</a:t>
+              <a:t>출처: app/ensemble.py; docs/evaluation/weighted_ensemble.json</a:t>
             </a:r>
           </a:p>
         </p:txBody>
@@ -897,165 +895,13 @@
           <a:lstStyle/>
           <a:p>
             <a:r>
-              <a:t>현재는 제한된 역할 구조입니다. 코드와 근거 연결 검사는 일반적인 사실성 보증이 아닙니다. LangSmith 추적을 켜면 기록이 외부로 전송되므로 로컬 추론과 별개로 관리해야 합니다.</a:t>
+              <a:t>LLM-as-a-Judge는 설명이 맞는지 LLM에게 검사시키는 기능입니다. 실제로27개를 찾았는데30개라고 설명하면 틀렸다고 알려줘야 합니다. 실제 결과와 문장을 함께 주고 검사했고, 직접 만든 예제8개 중6개는 맞게 판단했습니다. 하지만30개라는 오류는 놓쳤습니다. 그래서 보조 검사로 쓰고 중요한 숫자는 코드로 확인합니다. 이 예시는 앙상블 추가 전의 실험 기록을 기준으로 검사했습니다.</a:t>
             </a:r>
           </a:p>
           <a:p/>
           <a:p>
             <a:r>
-              <a:t>출처: docs/ASSIGNMENT_CHECKLIST.md; docs/EVALUATION.md</a:t>
-            </a:r>
-          </a:p>
-        </p:txBody>
-      </p:sp>
-      <p:sp>
-        <p:nvSpPr>
-          <p:cNvPr id="4" name="Slide Number Placeholder 3"/>
-          <p:cNvSpPr>
-            <a:spLocks noGrp="1"/>
-          </p:cNvSpPr>
-          <p:nvPr>
-            <p:ph type="sldNum" idx="5" sz="quarter"/>
-          </p:nvPr>
-        </p:nvSpPr>
-        <p:spPr/>
-      </p:sp>
-    </p:spTree>
-  </p:cSld>
-  <p:clrMapOvr>
-    <a:masterClrMapping/>
-  </p:clrMapOvr>
-</p:notes>
-</file>
-
-<file path=ppt/notesSlides/notesSlide15.xml><?xml version="1.0" encoding="utf-8"?>
-<p:notes xmlns:a="http://schemas.openxmlformats.org/drawingml/2006/main" xmlns:p="http://schemas.openxmlformats.org/presentationml/2006/main" xmlns:r="http://schemas.openxmlformats.org/officeDocument/2006/relationships">
-  <p:cSld>
-    <p:spTree>
-      <p:nvGrpSpPr>
-        <p:cNvPr id="1" name=""/>
-        <p:cNvGrpSpPr/>
-        <p:nvPr/>
-      </p:nvGrpSpPr>
-      <p:grpSpPr>
-        <a:xfrm>
-          <a:off x="0" y="0"/>
-          <a:ext cx="0" cy="0"/>
-          <a:chOff x="0" y="0"/>
-          <a:chExt cx="0" cy="0"/>
-        </a:xfrm>
-      </p:grpSpPr>
-      <p:sp>
-        <p:nvSpPr>
-          <p:cNvPr id="2" name="Slide Image Placeholder 1"/>
-          <p:cNvSpPr>
-            <a:spLocks noGrp="1"/>
-          </p:cNvSpPr>
-          <p:nvPr>
-            <p:ph type="sldImg" idx="2"/>
-          </p:nvPr>
-        </p:nvSpPr>
-        <p:spPr/>
-      </p:sp>
-      <p:sp>
-        <p:nvSpPr>
-          <p:cNvPr id="3" name="Notes Placeholder 2"/>
-          <p:cNvSpPr>
-            <a:spLocks noGrp="1"/>
-          </p:cNvSpPr>
-          <p:nvPr>
-            <p:ph type="body" idx="3" sz="quarter"/>
-          </p:nvPr>
-        </p:nvSpPr>
-        <p:spPr/>
-        <p:txBody>
-          <a:bodyPr/>
-          <a:lstStyle/>
-          <a:p>
-            <a:r>
-              <a:t>올바른 설명2개와 오류 설명6개를 평가했습니다. 라벨은 모델에 보내지 않았습니다. 생성자와 평가자가 같은 모델 계열이므로 유사 오류를 낼 수 있고, 수치·승인 코드 검사를 대체하지 않습니다.</a:t>
-            </a:r>
-          </a:p>
-          <a:p/>
-          <a:p>
-            <a:r>
-              <a:t>출처: docs/evaluation/llm_judge.json; docs/evaluation/llm_judge_initial.json</a:t>
-            </a:r>
-          </a:p>
-        </p:txBody>
-      </p:sp>
-      <p:sp>
-        <p:nvSpPr>
-          <p:cNvPr id="4" name="Slide Number Placeholder 3"/>
-          <p:cNvSpPr>
-            <a:spLocks noGrp="1"/>
-          </p:cNvSpPr>
-          <p:nvPr>
-            <p:ph type="sldNum" idx="5" sz="quarter"/>
-          </p:nvPr>
-        </p:nvSpPr>
-        <p:spPr/>
-      </p:sp>
-    </p:spTree>
-  </p:cSld>
-  <p:clrMapOvr>
-    <a:masterClrMapping/>
-  </p:clrMapOvr>
-</p:notes>
-</file>
-
-<file path=ppt/notesSlides/notesSlide16.xml><?xml version="1.0" encoding="utf-8"?>
-<p:notes xmlns:a="http://schemas.openxmlformats.org/drawingml/2006/main" xmlns:p="http://schemas.openxmlformats.org/presentationml/2006/main" xmlns:r="http://schemas.openxmlformats.org/officeDocument/2006/relationships">
-  <p:cSld>
-    <p:spTree>
-      <p:nvGrpSpPr>
-        <p:cNvPr id="1" name=""/>
-        <p:cNvGrpSpPr/>
-        <p:nvPr/>
-      </p:nvGrpSpPr>
-      <p:grpSpPr>
-        <a:xfrm>
-          <a:off x="0" y="0"/>
-          <a:ext cx="0" cy="0"/>
-          <a:chOff x="0" y="0"/>
-          <a:chExt cx="0" cy="0"/>
-        </a:xfrm>
-      </p:grpSpPr>
-      <p:sp>
-        <p:nvSpPr>
-          <p:cNvPr id="2" name="Slide Image Placeholder 1"/>
-          <p:cNvSpPr>
-            <a:spLocks noGrp="1"/>
-          </p:cNvSpPr>
-          <p:nvPr>
-            <p:ph type="sldImg" idx="2"/>
-          </p:nvPr>
-        </p:nvSpPr>
-        <p:spPr/>
-      </p:sp>
-      <p:sp>
-        <p:nvSpPr>
-          <p:cNvPr id="3" name="Notes Placeholder 2"/>
-          <p:cNvSpPr>
-            <a:spLocks noGrp="1"/>
-          </p:cNvSpPr>
-          <p:nvPr>
-            <p:ph type="body" idx="3" sz="quarter"/>
-          </p:nvPr>
-        </p:nvSpPr>
-        <p:spPr/>
-        <p:txBody>
-          <a:bodyPr/>
-          <a:lstStyle/>
-          <a:p>
-            <a:r>
-              <a:t>발표는 1~10장만 진행합니다. 부록은 질문 때만 엽니다. 모델 학습은 새로 기다리지 않고 실제 기록의 화면을 설명합니다. 교육자료 원본·제출 명단·API 키는 공개 저장소에 포함하지 않습니다.</a:t>
-            </a:r>
-          </a:p>
-          <a:p/>
-          <a:p>
-            <a:r>
-              <a:t>출처: docs/DEMO.md; docs/CURRICULUM_MODELS.md</a:t>
+              <a:t>출처: docs/evaluation/llm_judge.json; docs/EVALUATION.md</a:t>
             </a:r>
           </a:p>
         </p:txBody>
@@ -1125,7 +971,7 @@
           <a:lstStyle/>
           <a:p>
             <a:r>
-              <a:t>대상은 검사 모델을 만드는 엔지니어입니다. 데이터가 바뀔 때마다 전처리와 모델을 비교하고 이유를 기록해야 합니다. 이 반복 작업을 하나로 연결했습니다. 스칼라에서 배운 모델과 반도체 자료의 후보를 함께 넣었고, 오늘은 센서 사례 하나를 따라가겠습니다.</a:t>
+              <a:t>대상은 검사 모델을 만드는 엔지니어입니다. 데이터가 바뀌면 어떤 모델을 쓰고 예측을 어떤 비율로 섞을지 비교해야 합니다. 이 반복 작업을 연결했습니다. 스칼라에서 배운 모델과 반도체 자료의 후보를 함께 넣었고, 센서 사례 하나로 설명하겠습니다.</a:t>
             </a:r>
           </a:p>
           <a:p/>
@@ -1201,13 +1047,13 @@
           <a:lstStyle/>
           <a:p>
             <a:r>
-              <a:t>먼저 비교 기준입니다. 불량 검출률은 실제 불량 중 찾아낸 비율이고, 정상 오판률은 정상을 불량으로 잘못 본 비율입니다. 불량을 많이 찾는 것과 정상 오판을 줄이는 것을 함께 봐야 합니다. 이번에는 교육용 목표를 먼저 정하고, 목표를 충족한 후보 중 검출률을 우선하도록 했습니다.</a:t>
+              <a:t>불량을 놓치지 않는 것이 목적이라 검출률을 우선합니다. 다만 전부 불량으로 찍는 것을 막기 위해 정상 오판률을 십오 퍼센트 이하로 제한합니다. 그 안에서 검출률이 높고, 같으면 F1이 높은 비율을 고릅니다. F1은 불량 검출과 불량 판정의 정확성을 함께 보는 보조 지표입니다.</a:t>
             </a:r>
           </a:p>
           <a:p/>
           <a:p>
             <a:r>
-              <a:t>출처: app/metrics.py; docs/evaluation/synthetic_process.json</a:t>
+              <a:t>출처: app/ensemble.py; https://scikit-learn.org/stable/modules/model_evaluation.html</a:t>
             </a:r>
           </a:p>
         </p:txBody>
@@ -1277,13 +1123,13 @@
           <a:lstStyle/>
           <a:p>
             <a:r>
-              <a:t>실제 앱 화면입니다. 제품 A부터 D의 합성 센서 천이백팔십 건을 선택합니다. 이 중 불량 정답은 이백한 건입니다. 직접 만든 예제로, 실제 공장 데이터는 아닙니다. 내 센서 CSV나 검사 이미지 ZIP을 등록하는 기능도 있습니다.</a:t>
+              <a:t>실제 앱 화면입니다. 제품 A부터 D의 합성 센서 천이백팔십 건을 선택합니다. 불량 정답은 이백한 건입니다. 직접 만든 예제로, 실제 공장 데이터는 아닙니다. 내 센서 CSV나 검사 이미지 ZIP을 등록하는 기능도 있습니다.</a:t>
             </a:r>
           </a:p>
           <a:p/>
           <a:p>
             <a:r>
-              <a:t>출처: app/data.py; docs/assets/app-data.jpg</a:t>
+              <a:t>출처: app/data.py</a:t>
             </a:r>
           </a:p>
         </p:txBody>
@@ -1353,13 +1199,13 @@
           <a:lstStyle/>
           <a:p>
             <a:r>
-              <a:t>계획을 요청하면 데이터 점검과 전처리 이유가 나옵니다. 학습, 후보 선택, 마지막 확인 데이터를 육 대 이 대 이로 나누고, 같은 생산 묶음은 섞지 않습니다. 여러 모델과 제품 조합의 비교 범위를 확인한 다음 엔지니어가 승인해야 실제 학습을 시작합니다.</a:t>
+              <a:t>먼저 여러 모델을 같은 조건으로 비교하고 상위 세 알고리즘을 고릅니다. 화면은 그 확률을 섞는 비율 탐색 계획입니다. 학습, 후보 선택, 마지막 확인 데이터를 육 대 이 대 이로 나누고 같은 생산 묶음은 섞지 않습니다. 비교 범위를 확인하고 승인하면 실행합니다.</a:t>
             </a:r>
           </a:p>
           <a:p/>
           <a:p>
             <a:r>
-              <a:t>출처: app/planner.py; app/workbench.py; docs/assets/app-plan.jpg</a:t>
+              <a:t>출처: app/ensemble.py; docs/evaluation/weighted_ensemble.json</a:t>
             </a:r>
           </a:p>
         </p:txBody>
@@ -1429,13 +1275,13 @@
           <a:lstStyle/>
           <a:p>
             <a:r>
-              <a:t>학습이 끝나면 후보 선택용 데이터인 Validation에서 비교합니다. 화면처럼 검출률과 정상 오판률을 나란히 보여 줍니다. 같은 검출률에서는 정상 오판이 적은 CatBoost가 앞섰습니다. 상위 후보의 학습 제품 조합도 비교해 최종적으로 A B C로 학습한 CatBoost를 골랐습니다. 마지막 확인용 Test로 순위를 바꾸지는 않습니다.</a:t>
+              <a:t>후보 선택용 데이터인 Validation에서 비율과 판정 기준을 비교합니다. 다섯 퍼센트 간격과 균등 비율을 포함한 이백서른두 조합 중 CatBoost 구십, LightGBM 십 퍼센트가 선택됐습니다. 단일 모델과 검출률 백 퍼센트는 같지만 정상 오판이 스무 건에서 열아홉 건으로 줄고 F1도 개선됐습니다. 이 탐색 범위 안의 최선이라는 뜻입니다.</a:t>
             </a:r>
           </a:p>
           <a:p/>
           <a:p>
             <a:r>
-              <a:t>출처: docs/evaluation/synthetic_process.json; docs/evaluation/presentation_screenshots.json</a:t>
+              <a:t>출처: docs/evaluation/weighted_ensemble.json; docs/evaluation/ensemble_browser.json</a:t>
             </a:r>
           </a:p>
         </p:txBody>
@@ -1505,13 +1351,13 @@
           <a:lstStyle/>
           <a:p>
             <a:r>
-              <a:t>이제 남겨 둔 Test에서 기본 Logistic과 선택 후보를 비교합니다. 불량 서른두 개 중 발견은 스무 개에서 스물일곱 개로 늘었습니다. 대신 정상 오판도 한 개에서 열네 개로 늘었습니다. 후보 검출률 팔십사 점 사 퍼센트는 목표 구십 퍼센트에 못 미칩니다. 그래서 최고 모델이라고 끝내지 않고, 추가 검증이 필요하다는 판단까지 보여 줍니다.</a:t>
+              <a:t>비율을 고른 뒤 같은 Test에서 확인했습니다. 단일 CatBoost와 선택 조합은 둘 다 불량 서른두 개 중 서른 개를 찾았습니다. 정상 오판은 스물한 개에서 열아홉 개로 줄고 F1도 영 점 칠이삼에서 칠사일로 높아졌습니다. 이번 시연 목표는 충족했지만, 기존 Test를 다시 확인한 추가 탐색이므로 새로운 독립 데이터 검증이 필요합니다.</a:t>
             </a:r>
           </a:p>
           <a:p/>
           <a:p>
             <a:r>
-              <a:t>출처: docs/evaluation/windows_llm_synthetic.json; docs/evaluation/presentation_screenshots.json</a:t>
+              <a:t>출처: docs/evaluation/weighted_ensemble.json</a:t>
             </a:r>
           </a:p>
         </p:txBody>
@@ -1581,13 +1427,13 @@
           <a:lstStyle/>
           <a:p>
             <a:r>
-              <a:t>후보를 더 비교하고 싶으면 공식 문서를 검색합니다. 실제 저장된 검색 기록을 현재 화면에서 다시 보여 드립니다. 관련 근거와 제안 이유를 연결하는 것이 RAG입니다. 현재는 두 모델을 추가할 수 있습니다. 승인 후 비교한 기록에서는 CatBoost가 유지됐습니다.</a:t>
+              <a:t>후보를 더 비교하고 싶으면 공식 문서를 검색합니다. 저장된 실제 검색 기록을 현재 화면에서 다시 보여 드립니다. 관련 근거와 제안 이유를 연결하는 것이 RAG입니다. 현재는 두 모델을 추가할 수 있고, 이 경우도 승인 후 비교합니다.</a:t>
             </a:r>
           </a:p>
           <a:p/>
           <a:p>
             <a:r>
-              <a:t>출처: app/discovery.py; docs/evaluation/model_discovery.json; docs/evaluation/presentation_screenshots.json</a:t>
+              <a:t>출처: app/discovery.py; docs/evaluation/model_discovery.json</a:t>
             </a:r>
           </a:p>
         </p:txBody>
@@ -1657,13 +1503,13 @@
           <a:lstStyle/>
           <a:p>
             <a:r>
-              <a:t>방금 본 흐름의 내부입니다. LangGraph로 점검, 검색, 계획 역할을 연결하고 로컬 Qwen이 설명을 돕습니다. 승인은 사람, 학습과 수치 계산은 실험 엔진이 담당합니다. MCP는 조회와 계획 도구를 제공합니다. LangSmith로 실행 경로를 확인했고, 별도 LLM 평가자는 자체 예제 여덟 개 중 여섯 개를 맞혔습니다. 오판이 있어 중요한 수치와 승인은 코드로 검사합니다.</a:t>
+              <a:t>LangGraph로 점검, 검색, 계획 역할을 연결하고 로컬 Qwen이 설명을 돕습니다. MCP는 조회와 계획 도구를 제공하고, 실제 학습과 비율 비교는 실험 엔진이 계산합니다. LangSmith로 실행 경로를 확인했습니다. 또 설명이 실제 결과와 맞는지 LLM이 검사하게 했습니다. 직접 만든 예제 여덟 개 중 여섯 개는 맞혔지만, 오판도 있어 수치 검사는 코드로 유지합니다.</a:t>
             </a:r>
           </a:p>
           <a:p/>
           <a:p>
             <a:r>
-              <a:t>출처: app/planner.py; app/advisors.py; app/workbench.py; mcp_server.py; docs/evaluation/langsmith_check.json; docs/evaluation/llm_judge.json; docs/evaluation/tests-windows.txt</a:t>
+              <a:t>출처: app/planner.py; app/ensemble.py; docs/evaluation/langsmith_check.json; docs/evaluation/llm_judge.json; docs/evaluation/tests-windows.txt</a:t>
             </a:r>
           </a:p>
         </p:txBody>
@@ -4945,7 +4791,7 @@
               </a:defRPr>
             </a:pPr>
             <a:r>
-              <a:t>01 / 16</a:t>
+              <a:t>01 / 14</a:t>
             </a:r>
           </a:p>
         </p:txBody>
@@ -4987,7 +4833,7 @@
               </a:defRPr>
             </a:pPr>
             <a:r>
-              <a:t>검사 데이터를 넣으면, 비교 계획과 모델 선택 근거를 보여 주는 Agent</a:t>
+              <a:t>모델과 앙상블 비율을 비교하고, 선택 이유를 보여 주는 Agent</a:t>
             </a:r>
           </a:p>
         </p:txBody>
@@ -5416,7 +5262,7 @@
               </a:defRPr>
             </a:pPr>
             <a:r>
-              <a:t>실제 비교</a:t>
+              <a:t>모델·비율 비교</a:t>
             </a:r>
           </a:p>
         </p:txBody>
@@ -5698,7 +5544,7 @@
               </a:defRPr>
             </a:pPr>
             <a:r>
-              <a:t>모델 이름과 함께, 선택 이유와 한계를 남깁니다</a:t>
+              <a:t>추천 비율과 함께, 선택 이유와 한계를 남깁니다</a:t>
             </a:r>
           </a:p>
         </p:txBody>
@@ -5825,7 +5671,7 @@
               </a:defRPr>
             </a:pPr>
             <a:r>
-              <a:t>10 / 16</a:t>
+              <a:t>10 / 14</a:t>
             </a:r>
           </a:p>
         </p:txBody>
@@ -5910,7 +5756,7 @@
               </a:defRPr>
             </a:pPr>
             <a:r>
-              <a:t>성과: 데이터 입력부터 승인·비교·근거·결과 확인까지 연결</a:t>
+              <a:t>성과: 승인된 모델·앙상블 비율 비교와 선택 근거를 한 흐름으로 연결</a:t>
             </a:r>
           </a:p>
         </p:txBody>
@@ -5995,7 +5841,7 @@
               </a:defRPr>
             </a:pPr>
             <a:r>
-              <a:t>교훈: 불량 발견과 정상 오판을 함께 봐야 선택을 설명할 수 있습니다.</a:t>
+              <a:t>교훈: F1 하나보다 불량 미검출·정상 오판의 우선순위가 먼저입니다.</a:t>
             </a:r>
           </a:p>
         </p:txBody>
@@ -6165,7 +6011,7 @@
               </a:defRPr>
             </a:pPr>
             <a:r>
-              <a:t>개선: 현장 기준 합의 → 새로운 독립 데이터 검증 → 작업시간 절감 측정</a:t>
+              <a:t>개선: 현장 기준 합의 → 새 독립 데이터 검증 → 작업시간 절감 측정</a:t>
             </a:r>
           </a:p>
         </p:txBody>
@@ -6276,7 +6122,7 @@
               </a:defRPr>
             </a:pPr>
             <a:r>
-              <a:t>부록 A · 6장 비교표의 전체 내용</a:t>
+              <a:t>부록 A · 초기 전체 제품 Validation 비교</a:t>
             </a:r>
           </a:p>
         </p:txBody>
@@ -6318,7 +6164,7 @@
               </a:defRPr>
             </a:pPr>
             <a:r>
-              <a:t>전체 후보와 다른 선택 기준은 질문 때 확인합니다</a:t>
+              <a:t>비율을 섞기 전, 개별 모델 비교</a:t>
             </a:r>
           </a:p>
         </p:txBody>
@@ -6445,7 +6291,7 @@
               </a:defRPr>
             </a:pPr>
             <a:r>
-              <a:t>11 / 16  부록</a:t>
+              <a:t>11 / 14  부록</a:t>
             </a:r>
           </a:p>
         </p:txBody>
@@ -6487,7 +6333,7 @@
               </a:defRPr>
             </a:pPr>
             <a:r>
-              <a:t>전체 제품 Train의 24조건에서 모델별 최선 불균형 설정을 표시합니다.</a:t>
+              <a:t>전체 제품 Train의 24조건에서 알고리즘별 최선 불균형 설정을 표시합니다.</a:t>
             </a:r>
           </a:p>
         </p:txBody>
@@ -6529,7 +6375,7 @@
               </a:defRPr>
             </a:pPr>
             <a:r>
-              <a:t>AdaBoost의 F1은 더 높습니다. 이번에는 사전에 정한 검출률 우선 규칙을 따랐습니다.</a:t>
+              <a:t>앙상블은 같은 학습 범위의 CatBoost·HistGradientBoosting·LightGBM으로 비교했습니다.</a:t>
             </a:r>
           </a:p>
         </p:txBody>
@@ -8255,7 +8101,7 @@
               </a:defRPr>
             </a:pPr>
             <a:r>
-              <a:t>부록 B · 데이터별 추가 구현 결과</a:t>
+              <a:t>부록 B · 앙상블 추가 전의 별도 실험 기록</a:t>
             </a:r>
           </a:p>
         </p:txBody>
@@ -8424,7 +8270,7 @@
               </a:defRPr>
             </a:pPr>
             <a:r>
-              <a:t>12 / 16  부록</a:t>
+              <a:t>12 / 14  부록</a:t>
             </a:r>
           </a:p>
         </p:txBody>
@@ -8466,7 +8312,7 @@
               </a:defRPr>
             </a:pPr>
             <a:r>
-              <a:t>각 행 안에서 같은 Test를 비교합니다. 데이터 사이의 모델 종합 순위가 아닙니다.</a:t>
+              <a:t>본문의 앙상블 결과와 별개입니다. 각 행 안에서만 같은 Test를 비교합니다.</a:t>
             </a:r>
           </a:p>
         </p:txBody>
@@ -8508,7 +8354,7 @@
               </a:defRPr>
             </a:pPr>
             <a:r>
-              <a:t>SECOM은 실제 공개 자료입니다. 센서·이미지 예제는 합성 데이터입니다.</a:t>
+              <a:t>SECOM은 실제 공개 자료이며, 센서·이미지 예제는 합성 데이터입니다.</a:t>
             </a:r>
           </a:p>
         </p:txBody>
@@ -9136,7 +8982,7 @@
               </a:defRPr>
             </a:pPr>
             <a:r>
-              <a:t>부록 C · 데이터 분할과 모델 구조</a:t>
+              <a:t>부록 C · 앙상블 선택 근거와 범위</a:t>
             </a:r>
           </a:p>
         </p:txBody>
@@ -9178,7 +9024,7 @@
               </a:defRPr>
             </a:pPr>
             <a:r>
-              <a:t>6:2:2와 앙상블은 어떻게 적용했나요?</a:t>
+              <a:t>왜 이 비율을 선택했나요?</a:t>
             </a:r>
           </a:p>
         </p:txBody>
@@ -9305,7 +9151,7 @@
               </a:defRPr>
             </a:pPr>
             <a:r>
-              <a:t>13 / 16  부록</a:t>
+              <a:t>13 / 14  부록</a:t>
             </a:r>
           </a:p>
         </p:txBody>
@@ -9390,7 +9236,7 @@
               </a:defRPr>
             </a:pPr>
             <a:r>
-              <a:t>Train: 학습 / Validation: 후보·판정값 선택 / Test: 마지막 확인</a:t>
+              <a:t>Train: 학습 / Validation: 비율·판정 기준 선택 / Test: 선택 후 확인</a:t>
             </a:r>
           </a:p>
         </p:txBody>
@@ -9475,7 +9321,7 @@
               </a:defRPr>
             </a:pPr>
             <a:r>
-              <a:t>합성 센서 768 / 256 / 256 · 후보 A+B+C는 Train 중 544건 학습</a:t>
+              <a:t>동일 제품 A+B+C+D의 Train 768건으로 세 모델 학습 · 분할768/256/256</a:t>
             </a:r>
           </a:p>
         </p:txBody>
@@ -9560,7 +9406,7 @@
               </a:defRPr>
             </a:pPr>
             <a:r>
-              <a:t>같은 lot·날짜 경계 보존 · SECOM 실제 행 수 820 / 367 / 380</a:t>
+              <a:t>합계100% 비율을 5% 간격으로 모두 비교 + 균등 비율 = 232개</a:t>
             </a:r>
           </a:p>
         </p:txBody>
@@ -9645,7 +9491,7 @@
               </a:defRPr>
             </a:pPr>
             <a:r>
-              <a:t>RF·부스팅 모델은 사용 · 서로 다른 모델의 혼합 가중치 탐색은 미구현</a:t>
+              <a:t>정상 오판률15% 이하에서 Recall 최대 → 동률 F1 → 단순한 조합</a:t>
             </a:r>
           </a:p>
         </p:txBody>
@@ -9730,7 +9576,7 @@
               </a:defRPr>
             </a:pPr>
             <a:r>
-              <a:t>Test 재사용 탐색의 한계: 최종 적용 판단에는 새 독립 기간 데이터 필요</a:t>
+              <a:t>이 후보·간격·Validation 범위의 최선이며, 새 독립 데이터 확인이 필요합니다.</a:t>
             </a:r>
           </a:p>
         </p:txBody>
@@ -9841,7 +9687,7 @@
               </a:defRPr>
             </a:pPr>
             <a:r>
-              <a:t>부록 D · 9장 기술 설명의 상세 증빙</a:t>
+              <a:t>부록 D · 실제 예시로 이해하기</a:t>
             </a:r>
           </a:p>
         </p:txBody>
@@ -9883,7 +9729,7 @@
               </a:defRPr>
             </a:pPr>
             <a:r>
-              <a:t>구현 기술의 상세 범위</a:t>
+              <a:t>LLM-as-a-Judge: 설명이 맞는지 LLM이 검사합니다</a:t>
             </a:r>
           </a:p>
         </p:txBody>
@@ -10010,7 +9856,7 @@
               </a:defRPr>
             </a:pPr>
             <a:r>
-              <a:t>14 / 16  부록</a:t>
+              <a:t>14 / 14  부록</a:t>
             </a:r>
           </a:p>
         </p:txBody>
@@ -10052,22 +9898,106 @@
               </a:defRPr>
             </a:pPr>
             <a:r>
-              <a:t>질문이 있을 때만 확인합니다. 과제 기술 목록 전체 구현을 주장하지 않습니다.</a:t>
+              <a:t>검사용 기준: 이전 실험에서 불량27/32개 발견 · 목표90%에는 미달</a:t>
+            </a:r>
+          </a:p>
+        </p:txBody>
+      </p:sp>
+      <p:sp>
+        <p:nvSpPr>
+          <p:cNvPr id="9" name="TextBox 8"/>
+          <p:cNvSpPr txBox="1"/>
+          <p:nvPr/>
+        </p:nvSpPr>
+        <p:spPr>
+          <a:xfrm>
+            <a:off x="640080" y="2267712"/>
+            <a:ext cx="10972800" cy="402336"/>
+          </a:xfrm>
+          <a:prstGeom prst="rect">
+            <a:avLst/>
+          </a:prstGeom>
+          <a:noFill/>
+        </p:spPr>
+        <p:txBody>
+          <a:bodyPr wrap="square" lIns="18288" rIns="18288" tIns="18288" bIns="18288">
+            <a:spAutoFit/>
+          </a:bodyPr>
+          <a:lstStyle/>
+          <a:p>
+            <a:pPr>
+              <a:lnSpc>
+                <a:spcPct val="114000"/>
+              </a:lnSpc>
+              <a:spcAft>
+                <a:spcPts val="800"/>
+              </a:spcAft>
+              <a:defRPr sz="1800" b="0">
+                <a:solidFill>
+                  <a:srgbClr val="617681"/>
+                </a:solidFill>
+                <a:latin typeface="맑은 고딕"/>
+              </a:defRPr>
+            </a:pPr>
+            <a:r>
+              <a:t>실제 결과와 설명 문장을 주고 “맞는 설명인가?”를 물었습니다.</a:t>
+            </a:r>
+          </a:p>
+        </p:txBody>
+      </p:sp>
+      <p:sp>
+        <p:nvSpPr>
+          <p:cNvPr id="10" name="TextBox 9"/>
+          <p:cNvSpPr txBox="1"/>
+          <p:nvPr/>
+        </p:nvSpPr>
+        <p:spPr>
+          <a:xfrm>
+            <a:off x="640080" y="2688336"/>
+            <a:ext cx="10972800" cy="402336"/>
+          </a:xfrm>
+          <a:prstGeom prst="rect">
+            <a:avLst/>
+          </a:prstGeom>
+          <a:noFill/>
+        </p:spPr>
+        <p:txBody>
+          <a:bodyPr wrap="square" lIns="18288" rIns="18288" tIns="18288" bIns="18288">
+            <a:spAutoFit/>
+          </a:bodyPr>
+          <a:lstStyle/>
+          <a:p>
+            <a:pPr>
+              <a:lnSpc>
+                <a:spcPct val="114000"/>
+              </a:lnSpc>
+              <a:spcAft>
+                <a:spcPts val="800"/>
+              </a:spcAft>
+              <a:defRPr sz="1800" b="0">
+                <a:solidFill>
+                  <a:srgbClr val="617681"/>
+                </a:solidFill>
+                <a:latin typeface="맑은 고딕"/>
+              </a:defRPr>
+            </a:pPr>
+            <a:r>
+              <a:t>직접 만든 예제 8개 중 6개는 맞게 검사했고, 2개는 틀렸습니다.</a:t>
             </a:r>
           </a:p>
         </p:txBody>
       </p:sp>
       <p:graphicFrame>
         <p:nvGraphicFramePr>
-          <p:cNvPr id="9" name="Table 8"/>
+          <p:cNvPr id="11" name="Table 10"/>
           <p:cNvGraphicFramePr>
             <a:graphicFrameLocks noGrp="1"/>
           </p:cNvGraphicFramePr>
           <p:nvPr/>
         </p:nvGraphicFramePr>
         <p:xfrm>
-          <a:off x="594360" y="2505456"/>
-          <a:ext cx="11000232" cy="3566159"/>
+          <a:off x="594360" y="3346704"/>
+          <a:ext cx="11000232" cy="2724911"/>
         </p:xfrm>
         <a:graphic>
           <a:graphicData uri="http://schemas.openxmlformats.org/drawingml/2006/table">
@@ -10076,18 +10006,18 @@
                 <a:tableStyleId>{5C22544A-7EE6-4342-B048-85BDC9FD1C3A}</a:tableStyleId>
               </a:tblPr>
               <a:tblGrid>
-                <a:gridCol w="2148840"/>
-                <a:gridCol w="4572000"/>
-                <a:gridCol w="4279392"/>
+                <a:gridCol w="4846320"/>
+                <a:gridCol w="3017520"/>
+                <a:gridCol w="3136392"/>
               </a:tblGrid>
-              <a:tr h="445769">
+              <a:tr h="681227">
                 <a:tc>
                   <a:txBody>
                     <a:bodyPr/>
                     <a:lstStyle/>
                     <a:p>
                       <a:pPr>
-                        <a:defRPr sz="1200" b="1">
+                        <a:defRPr sz="1500" b="1">
                           <a:solidFill>
                             <a:srgbClr val="FFFFFF"/>
                           </a:solidFill>
@@ -10095,7 +10025,7 @@
                         </a:defRPr>
                       </a:pPr>
                       <a:r>
-                        <a:t>요소</a:t>
+                        <a:t>검사할 설명</a:t>
                       </a:r>
                     </a:p>
                   </a:txBody>
@@ -10111,7 +10041,7 @@
                     <a:lstStyle/>
                     <a:p>
                       <a:pPr>
-                        <a:defRPr sz="1200" b="1">
+                        <a:defRPr sz="1500" b="1">
                           <a:solidFill>
                             <a:srgbClr val="FFFFFF"/>
                           </a:solidFill>
@@ -10119,7 +10049,7 @@
                         </a:defRPr>
                       </a:pPr>
                       <a:r>
-                        <a:t>구현·증빙</a:t>
+                        <a:t>맞는 판단</a:t>
                       </a:r>
                     </a:p>
                   </a:txBody>
@@ -10135,7 +10065,7 @@
                     <a:lstStyle/>
                     <a:p>
                       <a:pPr>
-                        <a:defRPr sz="1200" b="1">
+                        <a:defRPr sz="1500" b="1">
                           <a:solidFill>
                             <a:srgbClr val="FFFFFF"/>
                           </a:solidFill>
@@ -10143,1032 +10073,7 @@
                         </a:defRPr>
                       </a:pPr>
                       <a:r>
-                        <a:t>현재 한계</a:t>
-                      </a:r>
-                    </a:p>
-                  </a:txBody>
-                  <a:tcPr marL="118872" marR="91440" marT="64008" marB="54864" anchor="ctr">
-                    <a:solidFill>
-                      <a:srgbClr val="147D82"/>
-                    </a:solidFill>
-                  </a:tcPr>
-                </a:tc>
-              </a:tr>
-              <a:tr h="445769">
-                <a:tc>
-                  <a:txBody>
-                    <a:bodyPr/>
-                    <a:lstStyle/>
-                    <a:p>
-                      <a:pPr>
-                        <a:defRPr sz="1200" b="0">
-                          <a:solidFill>
-                            <a:srgbClr val="173A49"/>
-                          </a:solidFill>
-                          <a:latin typeface="맑은 고딕"/>
-                        </a:defRPr>
-                      </a:pPr>
-                      <a:r>
-                        <a:t>Multi-Agent / LangGraph</a:t>
-                      </a:r>
-                    </a:p>
-                  </a:txBody>
-                  <a:tcPr marL="118872" marR="91440" marT="64008" marB="54864" anchor="ctr">
-                    <a:solidFill>
-                      <a:srgbClr val="FFFFFF"/>
-                    </a:solidFill>
-                  </a:tcPr>
-                </a:tc>
-                <a:tc>
-                  <a:txBody>
-                    <a:bodyPr/>
-                    <a:lstStyle/>
-                    <a:p>
-                      <a:pPr>
-                        <a:defRPr sz="1200" b="0">
-                          <a:solidFill>
-                            <a:srgbClr val="173A49"/>
-                          </a:solidFill>
-                          <a:latin typeface="맑은 고딕"/>
-                        </a:defRPr>
-                      </a:pPr>
-                      <a:r>
-                        <a:t>점검·검색·계획·결과 검토 역할</a:t>
-                      </a:r>
-                    </a:p>
-                  </a:txBody>
-                  <a:tcPr marL="118872" marR="91440" marT="64008" marB="54864" anchor="ctr">
-                    <a:solidFill>
-                      <a:srgbClr val="FFFFFF"/>
-                    </a:solidFill>
-                  </a:tcPr>
-                </a:tc>
-                <a:tc>
-                  <a:txBody>
-                    <a:bodyPr/>
-                    <a:lstStyle/>
-                    <a:p>
-                      <a:pPr>
-                        <a:defRPr sz="1200" b="0">
-                          <a:solidFill>
-                            <a:srgbClr val="173A49"/>
-                          </a:solidFill>
-                          <a:latin typeface="맑은 고딕"/>
-                        </a:defRPr>
-                      </a:pPr>
-                      <a:r>
-                        <a:t>고정 그래프 · 자율 Supervisor 미구현</a:t>
-                      </a:r>
-                    </a:p>
-                  </a:txBody>
-                  <a:tcPr marL="118872" marR="91440" marT="64008" marB="54864" anchor="ctr">
-                    <a:solidFill>
-                      <a:srgbClr val="FFFFFF"/>
-                    </a:solidFill>
-                  </a:tcPr>
-                </a:tc>
-              </a:tr>
-              <a:tr h="445769">
-                <a:tc>
-                  <a:txBody>
-                    <a:bodyPr/>
-                    <a:lstStyle/>
-                    <a:p>
-                      <a:pPr>
-                        <a:defRPr sz="1200" b="0">
-                          <a:solidFill>
-                            <a:srgbClr val="173A49"/>
-                          </a:solidFill>
-                          <a:latin typeface="맑은 고딕"/>
-                        </a:defRPr>
-                      </a:pPr>
-                      <a:r>
-                        <a:t>RAG</a:t>
-                      </a:r>
-                    </a:p>
-                  </a:txBody>
-                  <a:tcPr marL="118872" marR="91440" marT="64008" marB="54864" anchor="ctr">
-                    <a:solidFill>
-                      <a:srgbClr val="E8F3F3"/>
-                    </a:solidFill>
-                  </a:tcPr>
-                </a:tc>
-                <a:tc>
-                  <a:txBody>
-                    <a:bodyPr/>
-                    <a:lstStyle/>
-                    <a:p>
-                      <a:pPr>
-                        <a:defRPr sz="1200" b="0">
-                          <a:solidFill>
-                            <a:srgbClr val="173A49"/>
-                          </a:solidFill>
-                          <a:latin typeface="맑은 고딕"/>
-                        </a:defRPr>
-                      </a:pPr>
-                      <a:r>
-                        <a:t>TF-IDF / 선택적 Qwen 임베딩·cosine</a:t>
-                      </a:r>
-                    </a:p>
-                  </a:txBody>
-                  <a:tcPr marL="118872" marR="91440" marT="64008" marB="54864" anchor="ctr">
-                    <a:solidFill>
-                      <a:srgbClr val="E8F3F3"/>
-                    </a:solidFill>
-                  </a:tcPr>
-                </a:tc>
-                <a:tc>
-                  <a:txBody>
-                    <a:bodyPr/>
-                    <a:lstStyle/>
-                    <a:p>
-                      <a:pPr>
-                        <a:defRPr sz="1200" b="0">
-                          <a:solidFill>
-                            <a:srgbClr val="173A49"/>
-                          </a:solidFill>
-                          <a:latin typeface="맑은 고딕"/>
-                        </a:defRPr>
-                      </a:pPr>
-                      <a:r>
-                        <a:t>현재 Windows TF-IDF · 별도 Vector DB 없음</a:t>
-                      </a:r>
-                    </a:p>
-                  </a:txBody>
-                  <a:tcPr marL="118872" marR="91440" marT="64008" marB="54864" anchor="ctr">
-                    <a:solidFill>
-                      <a:srgbClr val="E8F3F3"/>
-                    </a:solidFill>
-                  </a:tcPr>
-                </a:tc>
-              </a:tr>
-              <a:tr h="445769">
-                <a:tc>
-                  <a:txBody>
-                    <a:bodyPr/>
-                    <a:lstStyle/>
-                    <a:p>
-                      <a:pPr>
-                        <a:defRPr sz="1200" b="0">
-                          <a:solidFill>
-                            <a:srgbClr val="173A49"/>
-                          </a:solidFill>
-                          <a:latin typeface="맑은 고딕"/>
-                        </a:defRPr>
-                      </a:pPr>
-                      <a:r>
-                        <a:t>외부 후보 추가</a:t>
-                      </a:r>
-                    </a:p>
-                  </a:txBody>
-                  <a:tcPr marL="118872" marR="91440" marT="64008" marB="54864" anchor="ctr">
-                    <a:solidFill>
-                      <a:srgbClr val="FFFFFF"/>
-                    </a:solidFill>
-                  </a:tcPr>
-                </a:tc>
-                <a:tc>
-                  <a:txBody>
-                    <a:bodyPr/>
-                    <a:lstStyle/>
-                    <a:p>
-                      <a:pPr>
-                        <a:defRPr sz="1200" b="0">
-                          <a:solidFill>
-                            <a:srgbClr val="173A49"/>
-                          </a:solidFill>
-                          <a:latin typeface="맑은 고딕"/>
-                        </a:defRPr>
-                      </a:pPr>
-                      <a:r>
-                        <a:t>공식 문서 검색·ExtraTrees/GaussianNB</a:t>
-                      </a:r>
-                    </a:p>
-                  </a:txBody>
-                  <a:tcPr marL="118872" marR="91440" marT="64008" marB="54864" anchor="ctr">
-                    <a:solidFill>
-                      <a:srgbClr val="FFFFFF"/>
-                    </a:solidFill>
-                  </a:tcPr>
-                </a:tc>
-                <a:tc>
-                  <a:txBody>
-                    <a:bodyPr/>
-                    <a:lstStyle/>
-                    <a:p>
-                      <a:pPr>
-                        <a:defRPr sz="1200" b="0">
-                          <a:solidFill>
-                            <a:srgbClr val="173A49"/>
-                          </a:solidFill>
-                          <a:latin typeface="맑은 고딕"/>
-                        </a:defRPr>
-                      </a:pPr>
-                      <a:r>
-                        <a:t>검토된 두 adapter 지원</a:t>
-                      </a:r>
-                    </a:p>
-                  </a:txBody>
-                  <a:tcPr marL="118872" marR="91440" marT="64008" marB="54864" anchor="ctr">
-                    <a:solidFill>
-                      <a:srgbClr val="FFFFFF"/>
-                    </a:solidFill>
-                  </a:tcPr>
-                </a:tc>
-              </a:tr>
-              <a:tr h="445769">
-                <a:tc>
-                  <a:txBody>
-                    <a:bodyPr/>
-                    <a:lstStyle/>
-                    <a:p>
-                      <a:pPr>
-                        <a:defRPr sz="1200" b="0">
-                          <a:solidFill>
-                            <a:srgbClr val="173A49"/>
-                          </a:solidFill>
-                          <a:latin typeface="맑은 고딕"/>
-                        </a:defRPr>
-                      </a:pPr>
-                      <a:r>
-                        <a:t>MCP</a:t>
-                      </a:r>
-                    </a:p>
-                  </a:txBody>
-                  <a:tcPr marL="118872" marR="91440" marT="64008" marB="54864" anchor="ctr">
-                    <a:solidFill>
-                      <a:srgbClr val="E8F3F3"/>
-                    </a:solidFill>
-                  </a:tcPr>
-                </a:tc>
-                <a:tc>
-                  <a:txBody>
-                    <a:bodyPr/>
-                    <a:lstStyle/>
-                    <a:p>
-                      <a:pPr>
-                        <a:defRPr sz="1200" b="0">
-                          <a:solidFill>
-                            <a:srgbClr val="173A49"/>
-                          </a:solidFill>
-                          <a:latin typeface="맑은 고딕"/>
-                        </a:defRPr>
-                      </a:pPr>
-                      <a:r>
-                        <a:t>stdio 4도구 + 지식 Resource</a:t>
-                      </a:r>
-                    </a:p>
-                  </a:txBody>
-                  <a:tcPr marL="118872" marR="91440" marT="64008" marB="54864" anchor="ctr">
-                    <a:solidFill>
-                      <a:srgbClr val="E8F3F3"/>
-                    </a:solidFill>
-                  </a:tcPr>
-                </a:tc>
-                <a:tc>
-                  <a:txBody>
-                    <a:bodyPr/>
-                    <a:lstStyle/>
-                    <a:p>
-                      <a:pPr>
-                        <a:defRPr sz="1200" b="0">
-                          <a:solidFill>
-                            <a:srgbClr val="173A49"/>
-                          </a:solidFill>
-                          <a:latin typeface="맑은 고딕"/>
-                        </a:defRPr>
-                      </a:pPr>
-                      <a:r>
-                        <a:t>승인·학습 실행은 API에서 처리</a:t>
-                      </a:r>
-                    </a:p>
-                  </a:txBody>
-                  <a:tcPr marL="118872" marR="91440" marT="64008" marB="54864" anchor="ctr">
-                    <a:solidFill>
-                      <a:srgbClr val="E8F3F3"/>
-                    </a:solidFill>
-                  </a:tcPr>
-                </a:tc>
-              </a:tr>
-              <a:tr h="445769">
-                <a:tc>
-                  <a:txBody>
-                    <a:bodyPr/>
-                    <a:lstStyle/>
-                    <a:p>
-                      <a:pPr>
-                        <a:defRPr sz="1200" b="0">
-                          <a:solidFill>
-                            <a:srgbClr val="173A49"/>
-                          </a:solidFill>
-                          <a:latin typeface="맑은 고딕"/>
-                        </a:defRPr>
-                      </a:pPr>
-                      <a:r>
-                        <a:t>코드 품질</a:t>
-                      </a:r>
-                    </a:p>
-                  </a:txBody>
-                  <a:tcPr marL="118872" marR="91440" marT="64008" marB="54864" anchor="ctr">
-                    <a:solidFill>
-                      <a:srgbClr val="FFFFFF"/>
-                    </a:solidFill>
-                  </a:tcPr>
-                </a:tc>
-                <a:tc>
-                  <a:txBody>
-                    <a:bodyPr/>
-                    <a:lstStyle/>
-                    <a:p>
-                      <a:pPr>
-                        <a:defRPr sz="1200" b="0">
-                          <a:solidFill>
-                            <a:srgbClr val="173A49"/>
-                          </a:solidFill>
-                          <a:latin typeface="맑은 고딕"/>
-                        </a:defRPr>
-                      </a:pPr>
-                      <a:r>
-                        <a:t>모듈화·의존성 주입·33개 테스트</a:t>
-                      </a:r>
-                    </a:p>
-                  </a:txBody>
-                  <a:tcPr marL="118872" marR="91440" marT="64008" marB="54864" anchor="ctr">
-                    <a:solidFill>
-                      <a:srgbClr val="FFFFFF"/>
-                    </a:solidFill>
-                  </a:tcPr>
-                </a:tc>
-                <a:tc>
-                  <a:txBody>
-                    <a:bodyPr/>
-                    <a:lstStyle/>
-                    <a:p>
-                      <a:pPr>
-                        <a:defRPr sz="1200" b="0">
-                          <a:solidFill>
-                            <a:srgbClr val="173A49"/>
-                          </a:solidFill>
-                          <a:latin typeface="맑은 고딕"/>
-                        </a:defRPr>
-                      </a:pPr>
-                      <a:r>
-                        <a:t>배포·동시 다중 사용자 미검증</a:t>
-                      </a:r>
-                    </a:p>
-                  </a:txBody>
-                  <a:tcPr marL="118872" marR="91440" marT="64008" marB="54864" anchor="ctr">
-                    <a:solidFill>
-                      <a:srgbClr val="FFFFFF"/>
-                    </a:solidFill>
-                  </a:tcPr>
-                </a:tc>
-              </a:tr>
-              <a:tr h="445769">
-                <a:tc>
-                  <a:txBody>
-                    <a:bodyPr/>
-                    <a:lstStyle/>
-                    <a:p>
-                      <a:pPr>
-                        <a:defRPr sz="1200" b="0">
-                          <a:solidFill>
-                            <a:srgbClr val="173A49"/>
-                          </a:solidFill>
-                          <a:latin typeface="맑은 고딕"/>
-                        </a:defRPr>
-                      </a:pPr>
-                      <a:r>
-                        <a:t>LangSmith</a:t>
-                      </a:r>
-                    </a:p>
-                  </a:txBody>
-                  <a:tcPr marL="118872" marR="91440" marT="64008" marB="54864" anchor="ctr">
-                    <a:solidFill>
-                      <a:srgbClr val="E8F3F3"/>
-                    </a:solidFill>
-                  </a:tcPr>
-                </a:tc>
-                <a:tc>
-                  <a:txBody>
-                    <a:bodyPr/>
-                    <a:lstStyle/>
-                    <a:p>
-                      <a:pPr>
-                        <a:defRPr sz="1200" b="0">
-                          <a:solidFill>
-                            <a:srgbClr val="173A49"/>
-                          </a:solidFill>
-                          <a:latin typeface="맑은 고딕"/>
-                        </a:defRPr>
-                      </a:pPr>
-                      <a:r>
-                        <a:t>실제 root/child 실행 API 재조회</a:t>
-                      </a:r>
-                    </a:p>
-                  </a:txBody>
-                  <a:tcPr marL="118872" marR="91440" marT="64008" marB="54864" anchor="ctr">
-                    <a:solidFill>
-                      <a:srgbClr val="E8F3F3"/>
-                    </a:solidFill>
-                  </a:tcPr>
-                </a:tc>
-                <a:tc>
-                  <a:txBody>
-                    <a:bodyPr/>
-                    <a:lstStyle/>
-                    <a:p>
-                      <a:pPr>
-                        <a:defRPr sz="1200" b="0">
-                          <a:solidFill>
-                            <a:srgbClr val="173A49"/>
-                          </a:solidFill>
-                          <a:latin typeface="맑은 고딕"/>
-                        </a:defRPr>
-                      </a:pPr>
-                      <a:r>
-                        <a:t>공개·합성 자료로 추적 검증</a:t>
-                      </a:r>
-                    </a:p>
-                  </a:txBody>
-                  <a:tcPr marL="118872" marR="91440" marT="64008" marB="54864" anchor="ctr">
-                    <a:solidFill>
-                      <a:srgbClr val="E8F3F3"/>
-                    </a:solidFill>
-                  </a:tcPr>
-                </a:tc>
-              </a:tr>
-              <a:tr h="445776">
-                <a:tc>
-                  <a:txBody>
-                    <a:bodyPr/>
-                    <a:lstStyle/>
-                    <a:p>
-                      <a:pPr>
-                        <a:defRPr sz="1200" b="0">
-                          <a:solidFill>
-                            <a:srgbClr val="173A49"/>
-                          </a:solidFill>
-                          <a:latin typeface="맑은 고딕"/>
-                        </a:defRPr>
-                      </a:pPr>
-                      <a:r>
-                        <a:t>LLM 평가</a:t>
-                      </a:r>
-                    </a:p>
-                  </a:txBody>
-                  <a:tcPr marL="118872" marR="91440" marT="64008" marB="54864" anchor="ctr">
-                    <a:solidFill>
-                      <a:srgbClr val="FFFFFF"/>
-                    </a:solidFill>
-                  </a:tcPr>
-                </a:tc>
-                <a:tc>
-                  <a:txBody>
-                    <a:bodyPr/>
-                    <a:lstStyle/>
-                    <a:p>
-                      <a:pPr>
-                        <a:defRPr sz="1200" b="0">
-                          <a:solidFill>
-                            <a:srgbClr val="173A49"/>
-                          </a:solidFill>
-                          <a:latin typeface="맑은 고딕"/>
-                        </a:defRPr>
-                      </a:pPr>
-                      <a:r>
-                        <a:t>로컬 Qwen으로 설명과 실제 기록 대조</a:t>
-                      </a:r>
-                    </a:p>
-                  </a:txBody>
-                  <a:tcPr marL="118872" marR="91440" marT="64008" marB="54864" anchor="ctr">
-                    <a:solidFill>
-                      <a:srgbClr val="FFFFFF"/>
-                    </a:solidFill>
-                  </a:tcPr>
-                </a:tc>
-                <a:tc>
-                  <a:txBody>
-                    <a:bodyPr/>
-                    <a:lstStyle/>
-                    <a:p>
-                      <a:pPr>
-                        <a:defRPr sz="1200" b="0">
-                          <a:solidFill>
-                            <a:srgbClr val="173A49"/>
-                          </a:solidFill>
-                          <a:latin typeface="맑은 고딕"/>
-                        </a:defRPr>
-                      </a:pPr>
-                      <a:r>
-                        <a:t>작은 자체 개발 예제 · 독립 평가 아님</a:t>
-                      </a:r>
-                    </a:p>
-                  </a:txBody>
-                  <a:tcPr marL="118872" marR="91440" marT="64008" marB="54864" anchor="ctr">
-                    <a:solidFill>
-                      <a:srgbClr val="FFFFFF"/>
-                    </a:solidFill>
-                  </a:tcPr>
-                </a:tc>
-              </a:tr>
-            </a:tbl>
-          </a:graphicData>
-        </a:graphic>
-      </p:graphicFrame>
-    </p:spTree>
-  </p:cSld>
-  <p:clrMapOvr>
-    <a:masterClrMapping/>
-  </p:clrMapOvr>
-</p:sld>
-</file>
-
-<file path=ppt/slides/slide15.xml><?xml version="1.0" encoding="utf-8"?>
-<p:sld xmlns:a="http://schemas.openxmlformats.org/drawingml/2006/main" xmlns:p="http://schemas.openxmlformats.org/presentationml/2006/main" xmlns:r="http://schemas.openxmlformats.org/officeDocument/2006/relationships">
-  <p:cSld>
-    <p:bg>
-      <p:bgPr>
-        <a:solidFill>
-          <a:srgbClr val="F6F8FA"/>
-        </a:solidFill>
-        <a:effectLst/>
-      </p:bgPr>
-    </p:bg>
-    <p:spTree>
-      <p:nvGrpSpPr>
-        <p:cNvPr id="1" name=""/>
-        <p:cNvGrpSpPr/>
-        <p:nvPr/>
-      </p:nvGrpSpPr>
-      <p:grpSpPr/>
-      <p:sp>
-        <p:nvSpPr>
-          <p:cNvPr id="2" name="Rectangle 1"/>
-          <p:cNvSpPr/>
-          <p:nvPr/>
-        </p:nvSpPr>
-        <p:spPr>
-          <a:xfrm>
-            <a:off x="0" y="0"/>
-            <a:ext cx="146304" cy="6858000"/>
-          </a:xfrm>
-          <a:prstGeom prst="rect">
-            <a:avLst/>
-          </a:prstGeom>
-          <a:solidFill>
-            <a:srgbClr val="147D82"/>
-          </a:solidFill>
-          <a:ln>
-            <a:noFill/>
-          </a:ln>
-        </p:spPr>
-        <p:style>
-          <a:lnRef idx="1">
-            <a:schemeClr val="accent1"/>
-          </a:lnRef>
-          <a:fillRef idx="3">
-            <a:schemeClr val="accent1"/>
-          </a:fillRef>
-          <a:effectRef idx="2">
-            <a:schemeClr val="accent1"/>
-          </a:effectRef>
-          <a:fontRef idx="minor">
-            <a:schemeClr val="lt1"/>
-          </a:fontRef>
-        </p:style>
-        <p:txBody>
-          <a:bodyPr rtlCol="0" anchor="ctr"/>
-          <a:lstStyle/>
-          <a:p>
-            <a:pPr algn="ctr"/>
-          </a:p>
-        </p:txBody>
-      </p:sp>
-      <p:sp>
-        <p:nvSpPr>
-          <p:cNvPr id="3" name="TextBox 2"/>
-          <p:cNvSpPr txBox="1"/>
-          <p:nvPr/>
-        </p:nvSpPr>
-        <p:spPr>
-          <a:xfrm>
-            <a:off x="594360" y="292608"/>
-            <a:ext cx="10972800" cy="274320"/>
-          </a:xfrm>
-          <a:prstGeom prst="rect">
-            <a:avLst/>
-          </a:prstGeom>
-          <a:noFill/>
-        </p:spPr>
-        <p:txBody>
-          <a:bodyPr wrap="square" lIns="18288" rIns="18288" tIns="18288" bIns="18288">
-            <a:spAutoFit/>
-          </a:bodyPr>
-          <a:lstStyle/>
-          <a:p>
-            <a:pPr>
-              <a:lnSpc>
-                <a:spcPct val="114000"/>
-              </a:lnSpc>
-              <a:spcAft>
-                <a:spcPts val="800"/>
-              </a:spcAft>
-              <a:defRPr sz="1200" b="1">
-                <a:solidFill>
-                  <a:srgbClr val="147D82"/>
-                </a:solidFill>
-                <a:latin typeface="맑은 고딕"/>
-              </a:defRPr>
-            </a:pPr>
-            <a:r>
-              <a:t>부록 E · 판정 예시와 한계</a:t>
-            </a:r>
-          </a:p>
-        </p:txBody>
-      </p:sp>
-      <p:sp>
-        <p:nvSpPr>
-          <p:cNvPr id="4" name="TextBox 3"/>
-          <p:cNvSpPr txBox="1"/>
-          <p:nvPr/>
-        </p:nvSpPr>
-        <p:spPr>
-          <a:xfrm>
-            <a:off x="594360" y="832104"/>
-            <a:ext cx="10972800" cy="1005840"/>
-          </a:xfrm>
-          <a:prstGeom prst="rect">
-            <a:avLst/>
-          </a:prstGeom>
-          <a:noFill/>
-        </p:spPr>
-        <p:txBody>
-          <a:bodyPr wrap="square" lIns="18288" rIns="18288" tIns="18288" bIns="18288">
-            <a:spAutoFit/>
-          </a:bodyPr>
-          <a:lstStyle/>
-          <a:p>
-            <a:pPr>
-              <a:lnSpc>
-                <a:spcPct val="114000"/>
-              </a:lnSpc>
-              <a:spcAft>
-                <a:spcPts val="800"/>
-              </a:spcAft>
-              <a:defRPr sz="3200" b="1">
-                <a:solidFill>
-                  <a:srgbClr val="173A49"/>
-                </a:solidFill>
-                <a:latin typeface="맑은 고딕"/>
-              </a:defRPr>
-            </a:pPr>
-            <a:r>
-              <a:t>LLM 평가자가 놓친 오류도 보존했습니다</a:t>
-            </a:r>
-          </a:p>
-        </p:txBody>
-      </p:sp>
-      <p:sp>
-        <p:nvSpPr>
-          <p:cNvPr id="5" name="Rectangle 4"/>
-          <p:cNvSpPr/>
-          <p:nvPr/>
-        </p:nvSpPr>
-        <p:spPr>
-          <a:xfrm>
-            <a:off x="594360" y="6318504"/>
-            <a:ext cx="11000232" cy="13716"/>
-          </a:xfrm>
-          <a:prstGeom prst="rect">
-            <a:avLst/>
-          </a:prstGeom>
-          <a:solidFill>
-            <a:srgbClr val="D8E3E7"/>
-          </a:solidFill>
-          <a:ln>
-            <a:noFill/>
-          </a:ln>
-        </p:spPr>
-        <p:style>
-          <a:lnRef idx="1">
-            <a:schemeClr val="accent1"/>
-          </a:lnRef>
-          <a:fillRef idx="3">
-            <a:schemeClr val="accent1"/>
-          </a:fillRef>
-          <a:effectRef idx="2">
-            <a:schemeClr val="accent1"/>
-          </a:effectRef>
-          <a:fontRef idx="minor">
-            <a:schemeClr val="lt1"/>
-          </a:fontRef>
-        </p:style>
-        <p:txBody>
-          <a:bodyPr rtlCol="0" anchor="ctr"/>
-          <a:lstStyle/>
-          <a:p>
-            <a:pPr algn="ctr"/>
-          </a:p>
-        </p:txBody>
-      </p:sp>
-      <p:sp>
-        <p:nvSpPr>
-          <p:cNvPr id="6" name="TextBox 5"/>
-          <p:cNvSpPr txBox="1"/>
-          <p:nvPr/>
-        </p:nvSpPr>
-        <p:spPr>
-          <a:xfrm>
-            <a:off x="594360" y="6419088"/>
-            <a:ext cx="7315200" cy="228600"/>
-          </a:xfrm>
-          <a:prstGeom prst="rect">
-            <a:avLst/>
-          </a:prstGeom>
-          <a:noFill/>
-        </p:spPr>
-        <p:txBody>
-          <a:bodyPr wrap="square" lIns="18288" rIns="18288" tIns="18288" bIns="18288">
-            <a:spAutoFit/>
-          </a:bodyPr>
-          <a:lstStyle/>
-          <a:p>
-            <a:pPr>
-              <a:lnSpc>
-                <a:spcPct val="114000"/>
-              </a:lnSpc>
-              <a:spcAft>
-                <a:spcPts val="800"/>
-              </a:spcAft>
-              <a:defRPr sz="1000" b="0">
-                <a:solidFill>
-                  <a:srgbClr val="617681"/>
-                </a:solidFill>
-                <a:latin typeface="맑은 고딕"/>
-              </a:defRPr>
-            </a:pPr>
-            <a:r>
-              <a:t>SKALA 광주 2반 · G045 김용찬</a:t>
-            </a:r>
-          </a:p>
-        </p:txBody>
-      </p:sp>
-      <p:sp>
-        <p:nvSpPr>
-          <p:cNvPr id="7" name="TextBox 6"/>
-          <p:cNvSpPr txBox="1"/>
-          <p:nvPr/>
-        </p:nvSpPr>
-        <p:spPr>
-          <a:xfrm>
-            <a:off x="10149840" y="6419088"/>
-            <a:ext cx="1463040" cy="228600"/>
-          </a:xfrm>
-          <a:prstGeom prst="rect">
-            <a:avLst/>
-          </a:prstGeom>
-          <a:noFill/>
-        </p:spPr>
-        <p:txBody>
-          <a:bodyPr wrap="square" lIns="18288" rIns="18288" tIns="18288" bIns="18288">
-            <a:spAutoFit/>
-          </a:bodyPr>
-          <a:lstStyle/>
-          <a:p>
-            <a:pPr>
-              <a:lnSpc>
-                <a:spcPct val="114000"/>
-              </a:lnSpc>
-              <a:spcAft>
-                <a:spcPts val="800"/>
-              </a:spcAft>
-              <a:defRPr sz="1000" b="0">
-                <a:solidFill>
-                  <a:srgbClr val="617681"/>
-                </a:solidFill>
-                <a:latin typeface="맑은 고딕"/>
-              </a:defRPr>
-            </a:pPr>
-            <a:r>
-              <a:t>15 / 16  부록</a:t>
-            </a:r>
-          </a:p>
-        </p:txBody>
-      </p:sp>
-      <p:sp>
-        <p:nvSpPr>
-          <p:cNvPr id="8" name="TextBox 7"/>
-          <p:cNvSpPr txBox="1"/>
-          <p:nvPr/>
-        </p:nvSpPr>
-        <p:spPr>
-          <a:xfrm>
-            <a:off x="640080" y="1847088"/>
-            <a:ext cx="10972800" cy="402336"/>
-          </a:xfrm>
-          <a:prstGeom prst="rect">
-            <a:avLst/>
-          </a:prstGeom>
-          <a:noFill/>
-        </p:spPr>
-        <p:txBody>
-          <a:bodyPr wrap="square" lIns="18288" rIns="18288" tIns="18288" bIns="18288">
-            <a:spAutoFit/>
-          </a:bodyPr>
-          <a:lstStyle/>
-          <a:p>
-            <a:pPr>
-              <a:lnSpc>
-                <a:spcPct val="114000"/>
-              </a:lnSpc>
-              <a:spcAft>
-                <a:spcPts val="800"/>
-              </a:spcAft>
-              <a:defRPr sz="1800" b="0">
-                <a:solidFill>
-                  <a:srgbClr val="617681"/>
-                </a:solidFill>
-                <a:latin typeface="맑은 고딕"/>
-              </a:defRPr>
-            </a:pPr>
-            <a:r>
-              <a:t>실제 기록: CatBoost · 불량 27/32개 발견 · 검출률84.4% · 목표90%</a:t>
-            </a:r>
-          </a:p>
-        </p:txBody>
-      </p:sp>
-      <p:sp>
-        <p:nvSpPr>
-          <p:cNvPr id="9" name="TextBox 8"/>
-          <p:cNvSpPr txBox="1"/>
-          <p:nvPr/>
-        </p:nvSpPr>
-        <p:spPr>
-          <a:xfrm>
-            <a:off x="640080" y="2267712"/>
-            <a:ext cx="10972800" cy="402336"/>
-          </a:xfrm>
-          <a:prstGeom prst="rect">
-            <a:avLst/>
-          </a:prstGeom>
-          <a:noFill/>
-        </p:spPr>
-        <p:txBody>
-          <a:bodyPr wrap="square" lIns="18288" rIns="18288" tIns="18288" bIns="18288">
-            <a:spAutoFit/>
-          </a:bodyPr>
-          <a:lstStyle/>
-          <a:p>
-            <a:pPr>
-              <a:lnSpc>
-                <a:spcPct val="114000"/>
-              </a:lnSpc>
-              <a:spcAft>
-                <a:spcPts val="800"/>
-              </a:spcAft>
-              <a:defRPr sz="1800" b="0">
-                <a:solidFill>
-                  <a:srgbClr val="617681"/>
-                </a:solidFill>
-                <a:latin typeface="맑은 고딕"/>
-              </a:defRPr>
-            </a:pPr>
-            <a:r>
-              <a:t>사전 라벨과 판정 일치 6/8 · 잘못된 설명을 통과시킨 사례 2개</a:t>
-            </a:r>
-          </a:p>
-        </p:txBody>
-      </p:sp>
-      <p:sp>
-        <p:nvSpPr>
-          <p:cNvPr id="10" name="TextBox 9"/>
-          <p:cNvSpPr txBox="1"/>
-          <p:nvPr/>
-        </p:nvSpPr>
-        <p:spPr>
-          <a:xfrm>
-            <a:off x="640080" y="2688336"/>
-            <a:ext cx="10972800" cy="402336"/>
-          </a:xfrm>
-          <a:prstGeom prst="rect">
-            <a:avLst/>
-          </a:prstGeom>
-          <a:noFill/>
-        </p:spPr>
-        <p:txBody>
-          <a:bodyPr wrap="square" lIns="18288" rIns="18288" tIns="18288" bIns="18288">
-            <a:spAutoFit/>
-          </a:bodyPr>
-          <a:lstStyle/>
-          <a:p>
-            <a:pPr>
-              <a:lnSpc>
-                <a:spcPct val="114000"/>
-              </a:lnSpc>
-              <a:spcAft>
-                <a:spcPts val="800"/>
-              </a:spcAft>
-              <a:defRPr sz="1800" b="0">
-                <a:solidFill>
-                  <a:srgbClr val="617681"/>
-                </a:solidFill>
-                <a:latin typeface="맑은 고딕"/>
-              </a:defRPr>
-            </a:pPr>
-            <a:r>
-              <a:t>프롬프트 보완에 사용한 자체 개발 예제입니다. 일반 정확도가 아닙니다.</a:t>
-            </a:r>
-          </a:p>
-        </p:txBody>
-      </p:sp>
-      <p:graphicFrame>
-        <p:nvGraphicFramePr>
-          <p:cNvPr id="11" name="Table 10"/>
-          <p:cNvGraphicFramePr>
-            <a:graphicFrameLocks noGrp="1"/>
-          </p:cNvGraphicFramePr>
-          <p:nvPr/>
-        </p:nvGraphicFramePr>
-        <p:xfrm>
-          <a:off x="594360" y="3346704"/>
-          <a:ext cx="11000232" cy="2724911"/>
-        </p:xfrm>
-        <a:graphic>
-          <a:graphicData uri="http://schemas.openxmlformats.org/drawingml/2006/table">
-            <a:tbl>
-              <a:tblPr firstRow="1" bandRow="1">
-                <a:tableStyleId>{5C22544A-7EE6-4342-B048-85BDC9FD1C3A}</a:tableStyleId>
-              </a:tblPr>
-              <a:tblGrid>
-                <a:gridCol w="5212080"/>
-                <a:gridCol w="2862072"/>
-                <a:gridCol w="2926080"/>
-              </a:tblGrid>
-              <a:tr h="681227">
-                <a:tc>
-                  <a:txBody>
-                    <a:bodyPr/>
-                    <a:lstStyle/>
-                    <a:p>
-                      <a:pPr>
-                        <a:defRPr sz="1300" b="1">
-                          <a:solidFill>
-                            <a:srgbClr val="FFFFFF"/>
-                          </a:solidFill>
-                          <a:latin typeface="맑은 고딕"/>
-                        </a:defRPr>
-                      </a:pPr>
-                      <a:r>
-                        <a:t>후보 설명</a:t>
-                      </a:r>
-                    </a:p>
-                  </a:txBody>
-                  <a:tcPr marL="118872" marR="91440" marT="64008" marB="54864" anchor="ctr">
-                    <a:solidFill>
-                      <a:srgbClr val="147D82"/>
-                    </a:solidFill>
-                  </a:tcPr>
-                </a:tc>
-                <a:tc>
-                  <a:txBody>
-                    <a:bodyPr/>
-                    <a:lstStyle/>
-                    <a:p>
-                      <a:pPr>
-                        <a:defRPr sz="1300" b="1">
-                          <a:solidFill>
-                            <a:srgbClr val="FFFFFF"/>
-                          </a:solidFill>
-                          <a:latin typeface="맑은 고딕"/>
-                        </a:defRPr>
-                      </a:pPr>
-                      <a:r>
-                        <a:t>사전 정답</a:t>
-                      </a:r>
-                    </a:p>
-                  </a:txBody>
-                  <a:tcPr marL="118872" marR="91440" marT="64008" marB="54864" anchor="ctr">
-                    <a:solidFill>
-                      <a:srgbClr val="147D82"/>
-                    </a:solidFill>
-                  </a:tcPr>
-                </a:tc>
-                <a:tc>
-                  <a:txBody>
-                    <a:bodyPr/>
-                    <a:lstStyle/>
-                    <a:p>
-                      <a:pPr>
-                        <a:defRPr sz="1300" b="1">
-                          <a:solidFill>
-                            <a:srgbClr val="FFFFFF"/>
-                          </a:solidFill>
-                          <a:latin typeface="맑은 고딕"/>
-                        </a:defRPr>
-                      </a:pPr>
-                      <a:r>
-                        <a:t>실제 Qwen 판정</a:t>
+                        <a:t>LLM의 실제 답</a:t>
                       </a:r>
                     </a:p>
                   </a:txBody>
@@ -11186,7 +10091,7 @@
                     <a:lstStyle/>
                     <a:p>
                       <a:pPr>
-                        <a:defRPr sz="1300" b="0">
+                        <a:defRPr sz="1500" b="0">
                           <a:solidFill>
                             <a:srgbClr val="173A49"/>
                           </a:solidFill>
@@ -11194,7 +10099,7 @@
                         </a:defRPr>
                       </a:pPr>
                       <a:r>
-                        <a:t>“실제 공장 수율 증가가 입증됐다”</a:t>
+                        <a:t>“불량27개를 찾았고 목표에는 미달했다”</a:t>
                       </a:r>
                     </a:p>
                   </a:txBody>
@@ -11210,7 +10115,7 @@
                     <a:lstStyle/>
                     <a:p>
                       <a:pPr>
-                        <a:defRPr sz="1300" b="0">
+                        <a:defRPr sz="1500" b="0">
                           <a:solidFill>
                             <a:srgbClr val="173A49"/>
                           </a:solidFill>
@@ -11218,7 +10123,7 @@
                         </a:defRPr>
                       </a:pPr>
                       <a:r>
-                        <a:t>근거 없음 → 실패</a:t>
+                        <a:t>맞는 설명</a:t>
                       </a:r>
                     </a:p>
                   </a:txBody>
@@ -11234,7 +10139,7 @@
                     <a:lstStyle/>
                     <a:p>
                       <a:pPr>
-                        <a:defRPr sz="1300" b="0">
+                        <a:defRPr sz="1500" b="0">
                           <a:solidFill>
                             <a:srgbClr val="173A49"/>
                           </a:solidFill>
@@ -11242,7 +10147,7 @@
                         </a:defRPr>
                       </a:pPr>
                       <a:r>
-                        <a:t>실패 · 일치</a:t>
+                        <a:t>맞다 · 올바른 검사</a:t>
                       </a:r>
                     </a:p>
                   </a:txBody>
@@ -11260,7 +10165,7 @@
                     <a:lstStyle/>
                     <a:p>
                       <a:pPr>
-                        <a:defRPr sz="1300" b="0">
+                        <a:defRPr sz="1500" b="0">
                           <a:solidFill>
                             <a:srgbClr val="173A49"/>
                           </a:solidFill>
@@ -11268,7 +10173,7 @@
                         </a:defRPr>
                       </a:pPr>
                       <a:r>
-                        <a:t>“불량 30개를 발견했다”</a:t>
+                        <a:t>“실제 공장 수율 증가가 입증됐다”</a:t>
                       </a:r>
                     </a:p>
                   </a:txBody>
@@ -11284,7 +10189,7 @@
                     <a:lstStyle/>
                     <a:p>
                       <a:pPr>
-                        <a:defRPr sz="1300" b="0">
+                        <a:defRPr sz="1500" b="0">
                           <a:solidFill>
                             <a:srgbClr val="173A49"/>
                           </a:solidFill>
@@ -11292,7 +10197,7 @@
                         </a:defRPr>
                       </a:pPr>
                       <a:r>
-                        <a:t>실제 27개 → 실패</a:t>
+                        <a:t>근거 없는 설명</a:t>
                       </a:r>
                     </a:p>
                   </a:txBody>
@@ -11308,7 +10213,7 @@
                     <a:lstStyle/>
                     <a:p>
                       <a:pPr>
-                        <a:defRPr sz="1300" b="0">
+                        <a:defRPr sz="1500" b="0">
                           <a:solidFill>
                             <a:srgbClr val="173A49"/>
                           </a:solidFill>
@@ -11316,7 +10221,7 @@
                         </a:defRPr>
                       </a:pPr>
                       <a:r>
-                        <a:t>통과 · 오판</a:t>
+                        <a:t>틀리다 · 올바른 검사</a:t>
                       </a:r>
                     </a:p>
                   </a:txBody>
@@ -11334,7 +10239,7 @@
                     <a:lstStyle/>
                     <a:p>
                       <a:pPr>
-                        <a:defRPr sz="1300" b="0">
+                        <a:defRPr sz="1500" b="0">
                           <a:solidFill>
                             <a:srgbClr val="173A49"/>
                           </a:solidFill>
@@ -11342,7 +10247,7 @@
                         </a:defRPr>
                       </a:pPr>
                       <a:r>
-                        <a:t>“84.4%가 목표90%를 충족했다”</a:t>
+                        <a:t>“불량30개를 발견했다”</a:t>
                       </a:r>
                     </a:p>
                   </a:txBody>
@@ -11358,7 +10263,7 @@
                     <a:lstStyle/>
                     <a:p>
                       <a:pPr>
-                        <a:defRPr sz="1300" b="0">
+                        <a:defRPr sz="1500" b="0">
                           <a:solidFill>
                             <a:srgbClr val="173A49"/>
                           </a:solidFill>
@@ -11366,7 +10271,7 @@
                         </a:defRPr>
                       </a:pPr>
                       <a:r>
-                        <a:t>목표 미달 → 실패</a:t>
+                        <a:t>실제는27개 → 틀림</a:t>
                       </a:r>
                     </a:p>
                   </a:txBody>
@@ -11382,7 +10287,7 @@
                     <a:lstStyle/>
                     <a:p>
                       <a:pPr>
-                        <a:defRPr sz="1300" b="0">
+                        <a:defRPr sz="1500" b="0">
                           <a:solidFill>
                             <a:srgbClr val="173A49"/>
                           </a:solidFill>
@@ -11390,7 +10295,7 @@
                         </a:defRPr>
                       </a:pPr>
                       <a:r>
-                        <a:t>통과 · 오판</a:t>
+                        <a:t>맞다 · 검사가 틀림</a:t>
                       </a:r>
                     </a:p>
                   </a:txBody>
@@ -11405,711 +10310,6 @@
           </a:graphicData>
         </a:graphic>
       </p:graphicFrame>
-    </p:spTree>
-  </p:cSld>
-  <p:clrMapOvr>
-    <a:masterClrMapping/>
-  </p:clrMapOvr>
-</p:sld>
-</file>
-
-<file path=ppt/slides/slide16.xml><?xml version="1.0" encoding="utf-8"?>
-<p:sld xmlns:a="http://schemas.openxmlformats.org/drawingml/2006/main" xmlns:p="http://schemas.openxmlformats.org/presentationml/2006/main" xmlns:r="http://schemas.openxmlformats.org/officeDocument/2006/relationships">
-  <p:cSld>
-    <p:bg>
-      <p:bgPr>
-        <a:solidFill>
-          <a:srgbClr val="F6F8FA"/>
-        </a:solidFill>
-        <a:effectLst/>
-      </p:bgPr>
-    </p:bg>
-    <p:spTree>
-      <p:nvGrpSpPr>
-        <p:cNvPr id="1" name=""/>
-        <p:cNvGrpSpPr/>
-        <p:nvPr/>
-      </p:nvGrpSpPr>
-      <p:grpSpPr/>
-      <p:sp>
-        <p:nvSpPr>
-          <p:cNvPr id="2" name="Rectangle 1"/>
-          <p:cNvSpPr/>
-          <p:nvPr/>
-        </p:nvSpPr>
-        <p:spPr>
-          <a:xfrm>
-            <a:off x="0" y="0"/>
-            <a:ext cx="146304" cy="6858000"/>
-          </a:xfrm>
-          <a:prstGeom prst="rect">
-            <a:avLst/>
-          </a:prstGeom>
-          <a:solidFill>
-            <a:srgbClr val="147D82"/>
-          </a:solidFill>
-          <a:ln>
-            <a:noFill/>
-          </a:ln>
-        </p:spPr>
-        <p:style>
-          <a:lnRef idx="1">
-            <a:schemeClr val="accent1"/>
-          </a:lnRef>
-          <a:fillRef idx="3">
-            <a:schemeClr val="accent1"/>
-          </a:fillRef>
-          <a:effectRef idx="2">
-            <a:schemeClr val="accent1"/>
-          </a:effectRef>
-          <a:fontRef idx="minor">
-            <a:schemeClr val="lt1"/>
-          </a:fontRef>
-        </p:style>
-        <p:txBody>
-          <a:bodyPr rtlCol="0" anchor="ctr"/>
-          <a:lstStyle/>
-          <a:p>
-            <a:pPr algn="ctr"/>
-          </a:p>
-        </p:txBody>
-      </p:sp>
-      <p:sp>
-        <p:nvSpPr>
-          <p:cNvPr id="3" name="TextBox 2"/>
-          <p:cNvSpPr txBox="1"/>
-          <p:nvPr/>
-        </p:nvSpPr>
-        <p:spPr>
-          <a:xfrm>
-            <a:off x="594360" y="292608"/>
-            <a:ext cx="10972800" cy="274320"/>
-          </a:xfrm>
-          <a:prstGeom prst="rect">
-            <a:avLst/>
-          </a:prstGeom>
-          <a:noFill/>
-        </p:spPr>
-        <p:txBody>
-          <a:bodyPr wrap="square" lIns="18288" rIns="18288" tIns="18288" bIns="18288">
-            <a:spAutoFit/>
-          </a:bodyPr>
-          <a:lstStyle/>
-          <a:p>
-            <a:pPr>
-              <a:lnSpc>
-                <a:spcPct val="114000"/>
-              </a:lnSpc>
-              <a:spcAft>
-                <a:spcPts val="800"/>
-              </a:spcAft>
-              <a:defRPr sz="1200" b="1">
-                <a:solidFill>
-                  <a:srgbClr val="147D82"/>
-                </a:solidFill>
-                <a:latin typeface="맑은 고딕"/>
-              </a:defRPr>
-            </a:pPr>
-            <a:r>
-              <a:t>부록 F · 제출 자료 확인</a:t>
-            </a:r>
-          </a:p>
-        </p:txBody>
-      </p:sp>
-      <p:sp>
-        <p:nvSpPr>
-          <p:cNvPr id="4" name="TextBox 3"/>
-          <p:cNvSpPr txBox="1"/>
-          <p:nvPr/>
-        </p:nvSpPr>
-        <p:spPr>
-          <a:xfrm>
-            <a:off x="594360" y="832104"/>
-            <a:ext cx="10972800" cy="1005840"/>
-          </a:xfrm>
-          <a:prstGeom prst="rect">
-            <a:avLst/>
-          </a:prstGeom>
-          <a:noFill/>
-        </p:spPr>
-        <p:txBody>
-          <a:bodyPr wrap="square" lIns="18288" rIns="18288" tIns="18288" bIns="18288">
-            <a:spAutoFit/>
-          </a:bodyPr>
-          <a:lstStyle/>
-          <a:p>
-            <a:pPr>
-              <a:lnSpc>
-                <a:spcPct val="114000"/>
-              </a:lnSpc>
-              <a:spcAft>
-                <a:spcPts val="800"/>
-              </a:spcAft>
-              <a:defRPr sz="3200" b="1">
-                <a:solidFill>
-                  <a:srgbClr val="173A49"/>
-                </a:solidFill>
-                <a:latin typeface="맑은 고딕"/>
-              </a:defRPr>
-            </a:pPr>
-            <a:r>
-              <a:t>출처·시연 화면·재현 자료</a:t>
-            </a:r>
-          </a:p>
-        </p:txBody>
-      </p:sp>
-      <p:sp>
-        <p:nvSpPr>
-          <p:cNvPr id="5" name="Rectangle 4"/>
-          <p:cNvSpPr/>
-          <p:nvPr/>
-        </p:nvSpPr>
-        <p:spPr>
-          <a:xfrm>
-            <a:off x="594360" y="6318504"/>
-            <a:ext cx="11000232" cy="13716"/>
-          </a:xfrm>
-          <a:prstGeom prst="rect">
-            <a:avLst/>
-          </a:prstGeom>
-          <a:solidFill>
-            <a:srgbClr val="D8E3E7"/>
-          </a:solidFill>
-          <a:ln>
-            <a:noFill/>
-          </a:ln>
-        </p:spPr>
-        <p:style>
-          <a:lnRef idx="1">
-            <a:schemeClr val="accent1"/>
-          </a:lnRef>
-          <a:fillRef idx="3">
-            <a:schemeClr val="accent1"/>
-          </a:fillRef>
-          <a:effectRef idx="2">
-            <a:schemeClr val="accent1"/>
-          </a:effectRef>
-          <a:fontRef idx="minor">
-            <a:schemeClr val="lt1"/>
-          </a:fontRef>
-        </p:style>
-        <p:txBody>
-          <a:bodyPr rtlCol="0" anchor="ctr"/>
-          <a:lstStyle/>
-          <a:p>
-            <a:pPr algn="ctr"/>
-          </a:p>
-        </p:txBody>
-      </p:sp>
-      <p:sp>
-        <p:nvSpPr>
-          <p:cNvPr id="6" name="TextBox 5"/>
-          <p:cNvSpPr txBox="1"/>
-          <p:nvPr/>
-        </p:nvSpPr>
-        <p:spPr>
-          <a:xfrm>
-            <a:off x="594360" y="6419088"/>
-            <a:ext cx="7315200" cy="228600"/>
-          </a:xfrm>
-          <a:prstGeom prst="rect">
-            <a:avLst/>
-          </a:prstGeom>
-          <a:noFill/>
-        </p:spPr>
-        <p:txBody>
-          <a:bodyPr wrap="square" lIns="18288" rIns="18288" tIns="18288" bIns="18288">
-            <a:spAutoFit/>
-          </a:bodyPr>
-          <a:lstStyle/>
-          <a:p>
-            <a:pPr>
-              <a:lnSpc>
-                <a:spcPct val="114000"/>
-              </a:lnSpc>
-              <a:spcAft>
-                <a:spcPts val="800"/>
-              </a:spcAft>
-              <a:defRPr sz="1000" b="0">
-                <a:solidFill>
-                  <a:srgbClr val="617681"/>
-                </a:solidFill>
-                <a:latin typeface="맑은 고딕"/>
-              </a:defRPr>
-            </a:pPr>
-            <a:r>
-              <a:t>SKALA 광주 2반 · G045 김용찬</a:t>
-            </a:r>
-          </a:p>
-        </p:txBody>
-      </p:sp>
-      <p:sp>
-        <p:nvSpPr>
-          <p:cNvPr id="7" name="TextBox 6"/>
-          <p:cNvSpPr txBox="1"/>
-          <p:nvPr/>
-        </p:nvSpPr>
-        <p:spPr>
-          <a:xfrm>
-            <a:off x="10149840" y="6419088"/>
-            <a:ext cx="1463040" cy="228600"/>
-          </a:xfrm>
-          <a:prstGeom prst="rect">
-            <a:avLst/>
-          </a:prstGeom>
-          <a:noFill/>
-        </p:spPr>
-        <p:txBody>
-          <a:bodyPr wrap="square" lIns="18288" rIns="18288" tIns="18288" bIns="18288">
-            <a:spAutoFit/>
-          </a:bodyPr>
-          <a:lstStyle/>
-          <a:p>
-            <a:pPr>
-              <a:lnSpc>
-                <a:spcPct val="114000"/>
-              </a:lnSpc>
-              <a:spcAft>
-                <a:spcPts val="800"/>
-              </a:spcAft>
-              <a:defRPr sz="1000" b="0">
-                <a:solidFill>
-                  <a:srgbClr val="617681"/>
-                </a:solidFill>
-                <a:latin typeface="맑은 고딕"/>
-              </a:defRPr>
-            </a:pPr>
-            <a:r>
-              <a:t>16 / 16  부록</a:t>
-            </a:r>
-          </a:p>
-        </p:txBody>
-      </p:sp>
-      <p:sp>
-        <p:nvSpPr>
-          <p:cNvPr id="8" name="Rectangle 7"/>
-          <p:cNvSpPr/>
-          <p:nvPr/>
-        </p:nvSpPr>
-        <p:spPr>
-          <a:xfrm>
-            <a:off x="640080" y="1975104"/>
-            <a:ext cx="50292" cy="512064"/>
-          </a:xfrm>
-          <a:prstGeom prst="rect">
-            <a:avLst/>
-          </a:prstGeom>
-          <a:solidFill>
-            <a:srgbClr val="147D82"/>
-          </a:solidFill>
-          <a:ln>
-            <a:noFill/>
-          </a:ln>
-        </p:spPr>
-        <p:style>
-          <a:lnRef idx="1">
-            <a:schemeClr val="accent1"/>
-          </a:lnRef>
-          <a:fillRef idx="3">
-            <a:schemeClr val="accent1"/>
-          </a:fillRef>
-          <a:effectRef idx="2">
-            <a:schemeClr val="accent1"/>
-          </a:effectRef>
-          <a:fontRef idx="minor">
-            <a:schemeClr val="lt1"/>
-          </a:fontRef>
-        </p:style>
-        <p:txBody>
-          <a:bodyPr rtlCol="0" anchor="ctr"/>
-          <a:lstStyle/>
-          <a:p>
-            <a:pPr algn="ctr"/>
-          </a:p>
-        </p:txBody>
-      </p:sp>
-      <p:sp>
-        <p:nvSpPr>
-          <p:cNvPr id="9" name="TextBox 8"/>
-          <p:cNvSpPr txBox="1"/>
-          <p:nvPr/>
-        </p:nvSpPr>
-        <p:spPr>
-          <a:xfrm>
-            <a:off x="868680" y="1975104"/>
-            <a:ext cx="10607040" cy="640080"/>
-          </a:xfrm>
-          <a:prstGeom prst="rect">
-            <a:avLst/>
-          </a:prstGeom>
-          <a:noFill/>
-        </p:spPr>
-        <p:txBody>
-          <a:bodyPr wrap="square" lIns="18288" rIns="18288" tIns="18288" bIns="18288">
-            <a:spAutoFit/>
-          </a:bodyPr>
-          <a:lstStyle/>
-          <a:p>
-            <a:pPr>
-              <a:lnSpc>
-                <a:spcPct val="114000"/>
-              </a:lnSpc>
-              <a:spcAft>
-                <a:spcPts val="800"/>
-              </a:spcAft>
-              <a:defRPr sz="1900" b="0">
-                <a:solidFill>
-                  <a:srgbClr val="173A49"/>
-                </a:solidFill>
-                <a:latin typeface="맑은 고딕"/>
-              </a:defRPr>
-            </a:pPr>
-            <a:r>
-              <a:t>모델 참고: 스칼라 9주차 + 15주차 반도체 자료 / 로컬 Qwen: 5주차 참고</a:t>
-            </a:r>
-          </a:p>
-        </p:txBody>
-      </p:sp>
-      <p:sp>
-        <p:nvSpPr>
-          <p:cNvPr id="10" name="Rectangle 9"/>
-          <p:cNvSpPr/>
-          <p:nvPr/>
-        </p:nvSpPr>
-        <p:spPr>
-          <a:xfrm>
-            <a:off x="640080" y="2752344"/>
-            <a:ext cx="50292" cy="512064"/>
-          </a:xfrm>
-          <a:prstGeom prst="rect">
-            <a:avLst/>
-          </a:prstGeom>
-          <a:solidFill>
-            <a:srgbClr val="147D82"/>
-          </a:solidFill>
-          <a:ln>
-            <a:noFill/>
-          </a:ln>
-        </p:spPr>
-        <p:style>
-          <a:lnRef idx="1">
-            <a:schemeClr val="accent1"/>
-          </a:lnRef>
-          <a:fillRef idx="3">
-            <a:schemeClr val="accent1"/>
-          </a:fillRef>
-          <a:effectRef idx="2">
-            <a:schemeClr val="accent1"/>
-          </a:effectRef>
-          <a:fontRef idx="minor">
-            <a:schemeClr val="lt1"/>
-          </a:fontRef>
-        </p:style>
-        <p:txBody>
-          <a:bodyPr rtlCol="0" anchor="ctr"/>
-          <a:lstStyle/>
-          <a:p>
-            <a:pPr algn="ctr"/>
-          </a:p>
-        </p:txBody>
-      </p:sp>
-      <p:sp>
-        <p:nvSpPr>
-          <p:cNvPr id="11" name="TextBox 10"/>
-          <p:cNvSpPr txBox="1"/>
-          <p:nvPr/>
-        </p:nvSpPr>
-        <p:spPr>
-          <a:xfrm>
-            <a:off x="868680" y="2752344"/>
-            <a:ext cx="10607040" cy="640080"/>
-          </a:xfrm>
-          <a:prstGeom prst="rect">
-            <a:avLst/>
-          </a:prstGeom>
-          <a:noFill/>
-        </p:spPr>
-        <p:txBody>
-          <a:bodyPr wrap="square" lIns="18288" rIns="18288" tIns="18288" bIns="18288">
-            <a:spAutoFit/>
-          </a:bodyPr>
-          <a:lstStyle/>
-          <a:p>
-            <a:pPr>
-              <a:lnSpc>
-                <a:spcPct val="114000"/>
-              </a:lnSpc>
-              <a:spcAft>
-                <a:spcPts val="800"/>
-              </a:spcAft>
-              <a:defRPr sz="1900" b="0">
-                <a:solidFill>
-                  <a:srgbClr val="173A49"/>
-                </a:solidFill>
-                <a:latin typeface="맑은 고딕"/>
-              </a:defRPr>
-            </a:pPr>
-            <a:r>
-              <a:t>필수 화면: 4장 입력 / 5장 승인 / 6장 비교 / 7장 결과 / 8장 RAG 근거</a:t>
-            </a:r>
-          </a:p>
-        </p:txBody>
-      </p:sp>
-      <p:sp>
-        <p:nvSpPr>
-          <p:cNvPr id="12" name="Rectangle 11"/>
-          <p:cNvSpPr/>
-          <p:nvPr/>
-        </p:nvSpPr>
-        <p:spPr>
-          <a:xfrm>
-            <a:off x="640080" y="3529584"/>
-            <a:ext cx="50292" cy="512064"/>
-          </a:xfrm>
-          <a:prstGeom prst="rect">
-            <a:avLst/>
-          </a:prstGeom>
-          <a:solidFill>
-            <a:srgbClr val="147D82"/>
-          </a:solidFill>
-          <a:ln>
-            <a:noFill/>
-          </a:ln>
-        </p:spPr>
-        <p:style>
-          <a:lnRef idx="1">
-            <a:schemeClr val="accent1"/>
-          </a:lnRef>
-          <a:fillRef idx="3">
-            <a:schemeClr val="accent1"/>
-          </a:fillRef>
-          <a:effectRef idx="2">
-            <a:schemeClr val="accent1"/>
-          </a:effectRef>
-          <a:fontRef idx="minor">
-            <a:schemeClr val="lt1"/>
-          </a:fontRef>
-        </p:style>
-        <p:txBody>
-          <a:bodyPr rtlCol="0" anchor="ctr"/>
-          <a:lstStyle/>
-          <a:p>
-            <a:pPr algn="ctr"/>
-          </a:p>
-        </p:txBody>
-      </p:sp>
-      <p:sp>
-        <p:nvSpPr>
-          <p:cNvPr id="13" name="TextBox 12"/>
-          <p:cNvSpPr txBox="1"/>
-          <p:nvPr/>
-        </p:nvSpPr>
-        <p:spPr>
-          <a:xfrm>
-            <a:off x="868680" y="3529584"/>
-            <a:ext cx="10607040" cy="640080"/>
-          </a:xfrm>
-          <a:prstGeom prst="rect">
-            <a:avLst/>
-          </a:prstGeom>
-          <a:noFill/>
-        </p:spPr>
-        <p:txBody>
-          <a:bodyPr wrap="square" lIns="18288" rIns="18288" tIns="18288" bIns="18288">
-            <a:spAutoFit/>
-          </a:bodyPr>
-          <a:lstStyle/>
-          <a:p>
-            <a:pPr>
-              <a:lnSpc>
-                <a:spcPct val="114000"/>
-              </a:lnSpc>
-              <a:spcAft>
-                <a:spcPts val="800"/>
-              </a:spcAft>
-              <a:defRPr sz="1900" b="0">
-                <a:solidFill>
-                  <a:srgbClr val="173A49"/>
-                </a:solidFill>
-                <a:latin typeface="맑은 고딕"/>
-              </a:defRPr>
-            </a:pPr>
-            <a:r>
-              <a:t>SECOM: McCann &amp; Johnston (2008), UCI · DOI 10.24432/C54305 · CC BY4.0</a:t>
-            </a:r>
-          </a:p>
-        </p:txBody>
-      </p:sp>
-      <p:sp>
-        <p:nvSpPr>
-          <p:cNvPr id="14" name="Rectangle 13"/>
-          <p:cNvSpPr/>
-          <p:nvPr/>
-        </p:nvSpPr>
-        <p:spPr>
-          <a:xfrm>
-            <a:off x="640080" y="4306824"/>
-            <a:ext cx="50292" cy="512064"/>
-          </a:xfrm>
-          <a:prstGeom prst="rect">
-            <a:avLst/>
-          </a:prstGeom>
-          <a:solidFill>
-            <a:srgbClr val="147D82"/>
-          </a:solidFill>
-          <a:ln>
-            <a:noFill/>
-          </a:ln>
-        </p:spPr>
-        <p:style>
-          <a:lnRef idx="1">
-            <a:schemeClr val="accent1"/>
-          </a:lnRef>
-          <a:fillRef idx="3">
-            <a:schemeClr val="accent1"/>
-          </a:fillRef>
-          <a:effectRef idx="2">
-            <a:schemeClr val="accent1"/>
-          </a:effectRef>
-          <a:fontRef idx="minor">
-            <a:schemeClr val="lt1"/>
-          </a:fontRef>
-        </p:style>
-        <p:txBody>
-          <a:bodyPr rtlCol="0" anchor="ctr"/>
-          <a:lstStyle/>
-          <a:p>
-            <a:pPr algn="ctr"/>
-          </a:p>
-        </p:txBody>
-      </p:sp>
-      <p:sp>
-        <p:nvSpPr>
-          <p:cNvPr id="15" name="TextBox 14"/>
-          <p:cNvSpPr txBox="1"/>
-          <p:nvPr/>
-        </p:nvSpPr>
-        <p:spPr>
-          <a:xfrm>
-            <a:off x="868680" y="4306824"/>
-            <a:ext cx="10607040" cy="640080"/>
-          </a:xfrm>
-          <a:prstGeom prst="rect">
-            <a:avLst/>
-          </a:prstGeom>
-          <a:noFill/>
-        </p:spPr>
-        <p:txBody>
-          <a:bodyPr wrap="square" lIns="18288" rIns="18288" tIns="18288" bIns="18288">
-            <a:spAutoFit/>
-          </a:bodyPr>
-          <a:lstStyle/>
-          <a:p>
-            <a:pPr>
-              <a:lnSpc>
-                <a:spcPct val="114000"/>
-              </a:lnSpc>
-              <a:spcAft>
-                <a:spcPts val="800"/>
-              </a:spcAft>
-              <a:defRPr sz="1900" b="0">
-                <a:solidFill>
-                  <a:srgbClr val="173A49"/>
-                </a:solidFill>
-                <a:latin typeface="맑은 고딕"/>
-              </a:defRPr>
-            </a:pPr>
-            <a:r>
-              <a:t>코드·보고서·실험 기록: github.com/dragonchan95/Semiconductor-AI-Agent</a:t>
-            </a:r>
-          </a:p>
-        </p:txBody>
-      </p:sp>
-      <p:sp>
-        <p:nvSpPr>
-          <p:cNvPr id="16" name="Rectangle 15"/>
-          <p:cNvSpPr/>
-          <p:nvPr/>
-        </p:nvSpPr>
-        <p:spPr>
-          <a:xfrm>
-            <a:off x="640080" y="5084064"/>
-            <a:ext cx="50292" cy="512064"/>
-          </a:xfrm>
-          <a:prstGeom prst="rect">
-            <a:avLst/>
-          </a:prstGeom>
-          <a:solidFill>
-            <a:srgbClr val="147D82"/>
-          </a:solidFill>
-          <a:ln>
-            <a:noFill/>
-          </a:ln>
-        </p:spPr>
-        <p:style>
-          <a:lnRef idx="1">
-            <a:schemeClr val="accent1"/>
-          </a:lnRef>
-          <a:fillRef idx="3">
-            <a:schemeClr val="accent1"/>
-          </a:fillRef>
-          <a:effectRef idx="2">
-            <a:schemeClr val="accent1"/>
-          </a:effectRef>
-          <a:fontRef idx="minor">
-            <a:schemeClr val="lt1"/>
-          </a:fontRef>
-        </p:style>
-        <p:txBody>
-          <a:bodyPr rtlCol="0" anchor="ctr"/>
-          <a:lstStyle/>
-          <a:p>
-            <a:pPr algn="ctr"/>
-          </a:p>
-        </p:txBody>
-      </p:sp>
-      <p:sp>
-        <p:nvSpPr>
-          <p:cNvPr id="17" name="TextBox 16"/>
-          <p:cNvSpPr txBox="1"/>
-          <p:nvPr/>
-        </p:nvSpPr>
-        <p:spPr>
-          <a:xfrm>
-            <a:off x="868680" y="5084064"/>
-            <a:ext cx="10607040" cy="640080"/>
-          </a:xfrm>
-          <a:prstGeom prst="rect">
-            <a:avLst/>
-          </a:prstGeom>
-          <a:noFill/>
-        </p:spPr>
-        <p:txBody>
-          <a:bodyPr wrap="square" lIns="18288" rIns="18288" tIns="18288" bIns="18288">
-            <a:spAutoFit/>
-          </a:bodyPr>
-          <a:lstStyle/>
-          <a:p>
-            <a:pPr>
-              <a:lnSpc>
-                <a:spcPct val="114000"/>
-              </a:lnSpc>
-              <a:spcAft>
-                <a:spcPts val="800"/>
-              </a:spcAft>
-              <a:defRPr sz="1900" b="0">
-                <a:solidFill>
-                  <a:srgbClr val="173A49"/>
-                </a:solidFill>
-                <a:latin typeface="맑은 고딕"/>
-              </a:defRPr>
-            </a:pPr>
-            <a:r>
-              <a:t>Google Slides의 온라인 원본은 최신 PPTX 가져오기가 필요합니다.</a:t>
-            </a:r>
-          </a:p>
-        </p:txBody>
-      </p:sp>
     </p:spTree>
   </p:cSld>
   <p:clrMapOvr>
@@ -12258,7 +10458,7 @@
               </a:defRPr>
             </a:pPr>
             <a:r>
-              <a:t>반복하던 모델 비교와 기록을 한 흐름으로</a:t>
+              <a:t>반복하던 모델·비율 비교를 한 흐름으로</a:t>
             </a:r>
           </a:p>
         </p:txBody>
@@ -12385,7 +10585,7 @@
               </a:defRPr>
             </a:pPr>
             <a:r>
-              <a:t>02 / 16</a:t>
+              <a:t>02 / 14</a:t>
             </a:r>
           </a:p>
         </p:txBody>
@@ -12470,7 +10670,7 @@
               </a:defRPr>
             </a:pPr>
             <a:r>
-              <a:t>사용자: 새 검사 데이터로 정상·불량 분류 모델을 만드는 엔지니어</a:t>
+              <a:t>사용자: 검사 데이터로 정상·불량 분류 모델을 만드는 엔지니어</a:t>
             </a:r>
           </a:p>
         </p:txBody>
@@ -12555,7 +10755,7 @@
               </a:defRPr>
             </a:pPr>
             <a:r>
-              <a:t>반복 업무: 데이터 확인 → 전처리 선택 → 여러 모델 학습 → 비교·기록</a:t>
+              <a:t>반복 업무: 데이터 확인 → 여러 모델 학습 → 혼합 비율 비교 → 근거 기록</a:t>
             </a:r>
           </a:p>
         </p:txBody>
@@ -12640,7 +10840,7 @@
               </a:defRPr>
             </a:pPr>
             <a:r>
-              <a:t>구현: Agent가 근거와 계획을 제시하고, 엔지니어가 승인하면 실행</a:t>
+              <a:t>Agent가 근거와 계획을 제시하고, 엔지니어가 승인하면 실행</a:t>
             </a:r>
           </a:p>
         </p:txBody>
@@ -12725,7 +10925,7 @@
               </a:defRPr>
             </a:pPr>
             <a:r>
-              <a:t>오늘은 숫자 센서 사례 하나로 입력부터 결과까지 보여 드립니다.</a:t>
+              <a:t>센서 사례 하나로 입력부터 선택 결과까지 보여 드립니다.</a:t>
             </a:r>
           </a:p>
         </p:txBody>
@@ -12836,7 +11036,7 @@
               </a:defRPr>
             </a:pPr>
             <a:r>
-              <a:t>03 · 결과를 읽기 위한 두 가지 지표</a:t>
+              <a:t>03 · 결과를 읽기 위한 기준</a:t>
             </a:r>
           </a:p>
         </p:txBody>
@@ -12878,7 +11078,7 @@
               </a:defRPr>
             </a:pPr>
             <a:r>
-              <a:t>비교 전에, 좋은 모델의 기준부터 정합니다</a:t>
+              <a:t>불량을 놓치지 않되, 정상 오판도 제한합니다</a:t>
             </a:r>
           </a:p>
         </p:txBody>
@@ -13005,7 +11205,7 @@
               </a:defRPr>
             </a:pPr>
             <a:r>
-              <a:t>03 / 16</a:t>
+              <a:t>03 / 14</a:t>
             </a:r>
           </a:p>
         </p:txBody>
@@ -13319,7 +11519,7 @@
         <p:spPr>
           <a:xfrm>
             <a:off x="731520" y="4471416"/>
-            <a:ext cx="10698480" cy="594360"/>
+            <a:ext cx="10698480" cy="502920"/>
           </a:xfrm>
           <a:prstGeom prst="rect">
             <a:avLst/>
@@ -13347,7 +11547,7 @@
               </a:defRPr>
             </a:pPr>
             <a:r>
-              <a:t>두 목표 충족 → 검출률 우선 → 동률이면 정상 오판이 적은 후보</a:t>
+              <a:t>정상 오판 한도 준수 → 검출률 최대 → 동률이면 F1</a:t>
             </a:r>
           </a:p>
         </p:txBody>
@@ -13360,8 +11560,8 @@
         </p:nvSpPr>
         <p:spPr>
           <a:xfrm>
-            <a:off x="731520" y="5596128"/>
-            <a:ext cx="10698480" cy="411480"/>
+            <a:off x="731520" y="5102352"/>
+            <a:ext cx="10698480" cy="365760"/>
           </a:xfrm>
           <a:prstGeom prst="rect">
             <a:avLst/>
@@ -13389,7 +11589,49 @@
               </a:defRPr>
             </a:pPr>
             <a:r>
-              <a:t>90%·15%는 교육용 목표입니다. 실제 허용 범위는 현장 담당자와 정합니다.</a:t>
+              <a:t>F1: 불량 검출과 불량 판정의 정확성을 함께 보는 보조 지표</a:t>
+            </a:r>
+          </a:p>
+        </p:txBody>
+      </p:sp>
+      <p:sp>
+        <p:nvSpPr>
+          <p:cNvPr id="17" name="TextBox 16"/>
+          <p:cNvSpPr txBox="1"/>
+          <p:nvPr/>
+        </p:nvSpPr>
+        <p:spPr>
+          <a:xfrm>
+            <a:off x="731520" y="5596128"/>
+            <a:ext cx="10698480" cy="411480"/>
+          </a:xfrm>
+          <a:prstGeom prst="rect">
+            <a:avLst/>
+          </a:prstGeom>
+          <a:noFill/>
+        </p:spPr>
+        <p:txBody>
+          <a:bodyPr wrap="square" lIns="18288" rIns="18288" tIns="18288" bIns="18288">
+            <a:spAutoFit/>
+          </a:bodyPr>
+          <a:lstStyle/>
+          <a:p>
+            <a:pPr>
+              <a:lnSpc>
+                <a:spcPct val="114000"/>
+              </a:lnSpc>
+              <a:spcAft>
+                <a:spcPts val="800"/>
+              </a:spcAft>
+              <a:defRPr sz="1700" b="0">
+                <a:solidFill>
+                  <a:srgbClr val="617681"/>
+                </a:solidFill>
+                <a:latin typeface="맑은 고딕"/>
+              </a:defRPr>
+            </a:pPr>
+            <a:r>
+              <a:t>90%·15%는 교육용 목표입니다. 현장에서는 담당자와 허용 범위를 정합니다.</a:t>
             </a:r>
           </a:p>
         </p:txBody>
@@ -13669,7 +11911,7 @@
               </a:defRPr>
             </a:pPr>
             <a:r>
-              <a:t>04 / 16</a:t>
+              <a:t>04 / 14</a:t>
             </a:r>
           </a:p>
         </p:txBody>
@@ -13795,7 +12037,7 @@
               </a:defRPr>
             </a:pPr>
             <a:r>
-              <a:t>오늘은 센서 예제의 입력부터 결과까지 설명합니다.</a:t>
+              <a:t>오늘은 센서 예제로 모델과 혼합 비율을 비교합니다.</a:t>
             </a:r>
           </a:p>
         </p:txBody>
@@ -13977,7 +12219,7 @@
               </a:defRPr>
             </a:pPr>
             <a:r>
-              <a:t>05 · 실제 화면 | 승인 전에는 학습하지 않습니다</a:t>
+              <a:t>05 · 실제 화면 | 비율 탐색도 승인 후 실행</a:t>
             </a:r>
           </a:p>
         </p:txBody>
@@ -14019,7 +12261,7 @@
               </a:defRPr>
             </a:pPr>
             <a:r>
-              <a:t>② 점검 결과와 비교 계획을 확인하고 승인합니다</a:t>
+              <a:t>② 모델 비교 후, 비율 탐색 계획을 승인합니다</a:t>
             </a:r>
           </a:p>
         </p:txBody>
@@ -14146,7 +12388,7 @@
               </a:defRPr>
             </a:pPr>
             <a:r>
-              <a:t>05 / 16</a:t>
+              <a:t>05 / 14</a:t>
             </a:r>
           </a:p>
         </p:txBody>
@@ -14249,7 +12491,7 @@
               </a:defRPr>
             </a:pPr>
             <a:r>
-              <a:t>학습 60% / 후보 선택 20% / 마지막 확인 20% · 같은 lot은 분리</a:t>
+              <a:t>학습60% / 후보 선택20% / 마지막 확인20% · 같은 lot은 분리</a:t>
             </a:r>
           </a:p>
         </p:txBody>
@@ -14291,7 +12533,7 @@
               </a:defRPr>
             </a:pPr>
             <a:r>
-              <a:t>여러 모델·불균형 설정·제품 조합을 최대 52조건 비교</a:t>
+              <a:t>상위 3개 모델의 확률을 5% 간격으로 혼합 · 합계100%</a:t>
             </a:r>
           </a:p>
         </p:txBody>
@@ -14333,7 +12575,7 @@
               </a:defRPr>
             </a:pPr>
             <a:r>
-              <a:t>엔지니어의 승인 후 실제 학습 시작</a:t>
+              <a:t>232개 비율 비교 · 엔지니어 승인 후 실행</a:t>
             </a:r>
           </a:p>
         </p:txBody>
@@ -14387,7 +12629,7 @@
       </p:sp>
       <p:pic>
         <p:nvPicPr>
-          <p:cNvPr id="13" name="Picture 12" descr="app-plan.jpg"/>
+          <p:cNvPr id="13" name="Picture 12" descr="app-ensemble-plan.jpg"/>
           <p:cNvPicPr>
             <a:picLocks noChangeAspect="1"/>
           </p:cNvPicPr>
@@ -14401,8 +12643,8 @@
         </p:blipFill>
         <p:spPr>
           <a:xfrm>
-            <a:off x="6339588" y="1874519"/>
-            <a:ext cx="4145783" cy="4160520"/>
+            <a:off x="6052002" y="1874519"/>
+            <a:ext cx="4720955" cy="4160520"/>
           </a:xfrm>
           <a:prstGeom prst="rect">
             <a:avLst/>
@@ -14515,7 +12757,7 @@
               </a:defRPr>
             </a:pPr>
             <a:r>
-              <a:t>06 · 실제 화면 | Validation = 후보 선택용 데이터</a:t>
+              <a:t>06 · 실제 화면 | Validation에서 비율과 판정 기준 선택</a:t>
             </a:r>
           </a:p>
         </p:txBody>
@@ -14557,7 +12799,7 @@
               </a:defRPr>
             </a:pPr>
             <a:r>
-              <a:t>③ 후보 선택용 데이터로 모델을 비교합니다</a:t>
+              <a:t>③ 선택 비율: CatBoost 90% + LightGBM 10%</a:t>
             </a:r>
           </a:p>
         </p:txBody>
@@ -14684,7 +12926,7 @@
               </a:defRPr>
             </a:pPr>
             <a:r>
-              <a:t>06 / 16</a:t>
+              <a:t>06 / 14</a:t>
             </a:r>
           </a:p>
         </p:txBody>
@@ -14697,8 +12939,8 @@
         </p:nvSpPr>
         <p:spPr>
           <a:xfrm>
-            <a:off x="640080" y="1892807"/>
-            <a:ext cx="7479792" cy="3986784"/>
+            <a:off x="658368" y="1938528"/>
+            <a:ext cx="10863072" cy="3639312"/>
           </a:xfrm>
           <a:prstGeom prst="roundRect">
             <a:avLst>
@@ -14738,7 +12980,7 @@
       </p:sp>
       <p:pic>
         <p:nvPicPr>
-          <p:cNvPr id="9" name="Picture 8" descr="app-validation-proof.jpg"/>
+          <p:cNvPr id="9" name="Picture 8" descr="app-ensemble-validation.jpg"/>
           <p:cNvPicPr>
             <a:picLocks noChangeAspect="1"/>
           </p:cNvPicPr>
@@ -14752,8 +12994,8 @@
         </p:blipFill>
         <p:spPr>
           <a:xfrm>
-            <a:off x="713232" y="2480737"/>
-            <a:ext cx="7333488" cy="2810924"/>
+            <a:off x="731520" y="2157137"/>
+            <a:ext cx="10716768" cy="3202092"/>
           </a:xfrm>
           <a:prstGeom prst="rect">
             <a:avLst/>
@@ -14768,8 +13010,8 @@
         </p:nvSpPr>
         <p:spPr>
           <a:xfrm>
-            <a:off x="8366760" y="2148840"/>
-            <a:ext cx="3127248" cy="777240"/>
+            <a:off x="777240" y="5596128"/>
+            <a:ext cx="10698480" cy="365760"/>
           </a:xfrm>
           <a:prstGeom prst="rect">
             <a:avLst/>
@@ -14789,15 +13031,15 @@
               <a:spcAft>
                 <a:spcPts val="800"/>
               </a:spcAft>
-              <a:defRPr sz="1800" b="0">
+              <a:defRPr sz="2000" b="1">
                 <a:solidFill>
-                  <a:srgbClr val="173A49"/>
+                  <a:srgbClr val="147D82"/>
                 </a:solidFill>
                 <a:latin typeface="맑은 고딕"/>
               </a:defRPr>
             </a:pPr>
             <a:r>
-              <a:t>같은 조건에서 후보 비교</a:t>
+              <a:t>검출률 100.0% 유지 · F1 0.808 → 0.816</a:t>
             </a:r>
           </a:p>
         </p:txBody>
@@ -14810,8 +13052,8 @@
         </p:nvSpPr>
         <p:spPr>
           <a:xfrm>
-            <a:off x="8366760" y="3099816"/>
-            <a:ext cx="3127248" cy="777240"/>
+            <a:off x="777240" y="6053328"/>
+            <a:ext cx="10698480" cy="219456"/>
           </a:xfrm>
           <a:prstGeom prst="rect">
             <a:avLst/>
@@ -14831,133 +13073,7 @@
               <a:spcAft>
                 <a:spcPts val="800"/>
               </a:spcAft>
-              <a:defRPr sz="1800" b="0">
-                <a:solidFill>
-                  <a:srgbClr val="173A49"/>
-                </a:solidFill>
-                <a:latin typeface="맑은 고딕"/>
-              </a:defRPr>
-            </a:pPr>
-            <a:r>
-              <a:t>검출률·정상 오판 동시 확인</a:t>
-            </a:r>
-          </a:p>
-        </p:txBody>
-      </p:sp>
-      <p:sp>
-        <p:nvSpPr>
-          <p:cNvPr id="12" name="TextBox 11"/>
-          <p:cNvSpPr txBox="1"/>
-          <p:nvPr/>
-        </p:nvSpPr>
-        <p:spPr>
-          <a:xfrm>
-            <a:off x="8366760" y="4050791"/>
-            <a:ext cx="3127248" cy="777240"/>
-          </a:xfrm>
-          <a:prstGeom prst="rect">
-            <a:avLst/>
-          </a:prstGeom>
-          <a:noFill/>
-        </p:spPr>
-        <p:txBody>
-          <a:bodyPr wrap="square" lIns="18288" rIns="18288" tIns="18288" bIns="18288">
-            <a:spAutoFit/>
-          </a:bodyPr>
-          <a:lstStyle/>
-          <a:p>
-            <a:pPr>
-              <a:lnSpc>
-                <a:spcPct val="114000"/>
-              </a:lnSpc>
-              <a:spcAft>
-                <a:spcPts val="800"/>
-              </a:spcAft>
-              <a:defRPr sz="2100" b="1">
-                <a:solidFill>
-                  <a:srgbClr val="147D82"/>
-                </a:solidFill>
-                <a:latin typeface="맑은 고딕"/>
-              </a:defRPr>
-            </a:pPr>
-            <a:r>
-              <a:t>선택: CatBoost · A+B+C</a:t>
-            </a:r>
-          </a:p>
-        </p:txBody>
-      </p:sp>
-      <p:sp>
-        <p:nvSpPr>
-          <p:cNvPr id="13" name="TextBox 12"/>
-          <p:cNvSpPr txBox="1"/>
-          <p:nvPr/>
-        </p:nvSpPr>
-        <p:spPr>
-          <a:xfrm>
-            <a:off x="8366760" y="5001768"/>
-            <a:ext cx="3127248" cy="777240"/>
-          </a:xfrm>
-          <a:prstGeom prst="rect">
-            <a:avLst/>
-          </a:prstGeom>
-          <a:noFill/>
-        </p:spPr>
-        <p:txBody>
-          <a:bodyPr wrap="square" lIns="18288" rIns="18288" tIns="18288" bIns="18288">
-            <a:spAutoFit/>
-          </a:bodyPr>
-          <a:lstStyle/>
-          <a:p>
-            <a:pPr>
-              <a:lnSpc>
-                <a:spcPct val="114000"/>
-              </a:lnSpc>
-              <a:spcAft>
-                <a:spcPts val="800"/>
-              </a:spcAft>
-              <a:defRPr sz="1800" b="0">
-                <a:solidFill>
-                  <a:srgbClr val="173A49"/>
-                </a:solidFill>
-                <a:latin typeface="맑은 고딕"/>
-              </a:defRPr>
-            </a:pPr>
-            <a:r>
-              <a:t>Test는 마지막 확인에 사용</a:t>
-            </a:r>
-          </a:p>
-        </p:txBody>
-      </p:sp>
-      <p:sp>
-        <p:nvSpPr>
-          <p:cNvPr id="14" name="TextBox 13"/>
-          <p:cNvSpPr txBox="1"/>
-          <p:nvPr/>
-        </p:nvSpPr>
-        <p:spPr>
-          <a:xfrm>
-            <a:off x="804672" y="6080760"/>
-            <a:ext cx="10789920" cy="201168"/>
-          </a:xfrm>
-          <a:prstGeom prst="rect">
-            <a:avLst/>
-          </a:prstGeom>
-          <a:noFill/>
-        </p:spPr>
-        <p:txBody>
-          <a:bodyPr wrap="square" lIns="18288" rIns="18288" tIns="18288" bIns="18288">
-            <a:spAutoFit/>
-          </a:bodyPr>
-          <a:lstStyle/>
-          <a:p>
-            <a:pPr>
-              <a:lnSpc>
-                <a:spcPct val="114000"/>
-              </a:lnSpc>
-              <a:spcAft>
-                <a:spcPts val="800"/>
-              </a:spcAft>
-              <a:defRPr sz="1100" b="0">
+              <a:defRPr sz="1200" b="0">
                 <a:solidFill>
                   <a:srgbClr val="617681"/>
                 </a:solidFill>
@@ -14965,7 +13081,7 @@
               </a:defRPr>
             </a:pPr>
             <a:r>
-              <a:t>실제 앱 비교표의 상단 4행 · 전체표는 부록 A</a:t>
+              <a:t>5% 간격과 균등 비율의 232개 비교 · 이 탐색 범위 안의 최선 · Test로 비율 선택하지 않음</a:t>
             </a:r>
           </a:p>
         </p:txBody>
@@ -15118,7 +13234,7 @@
               </a:defRPr>
             </a:pPr>
             <a:r>
-              <a:t>④ 마지막 확인: 더 찾았지만, 오판도 늘었습니다</a:t>
+              <a:t>④ 같은 검출률을 유지하며 정상 오판을 줄였습니다</a:t>
             </a:r>
           </a:p>
         </p:txBody>
@@ -15245,7 +13361,7 @@
               </a:defRPr>
             </a:pPr>
             <a:r>
-              <a:t>07 / 16</a:t>
+              <a:t>07 / 14</a:t>
             </a:r>
           </a:p>
         </p:txBody>
@@ -15287,7 +13403,7 @@
               </a:defRPr>
             </a:pPr>
             <a:r>
-              <a:t>불량 발견 20 → 27개</a:t>
+              <a:t>불량 발견 30 → 30개</a:t>
             </a:r>
           </a:p>
         </p:txBody>
@@ -15329,7 +13445,7 @@
               </a:defRPr>
             </a:pPr>
             <a:r>
-              <a:t>정상 오판 1 → 14개</a:t>
+              <a:t>정상 오판 21 → 19개</a:t>
             </a:r>
           </a:p>
         </p:txBody>
@@ -15371,7 +13487,7 @@
               </a:defRPr>
             </a:pPr>
             <a:r>
-              <a:t>후보 검출률 84.4% &lt; 목표 90%</a:t>
+              <a:t>Test F1 0.723 → 0.741</a:t>
             </a:r>
           </a:p>
         </p:txBody>
@@ -15413,7 +13529,26 @@
               </a:defRPr>
             </a:pPr>
             <a:r>
-              <a:t>화면의 결론: 추가 검증 필요 · 현장 적용 확정은 보류</a:t>
+              <a:t>검출률 93.8% · 시연 목표 충족</a:t>
+            </a:r>
+          </a:p>
+          <a:p>
+            <a:pPr>
+              <a:lnSpc>
+                <a:spcPct val="114000"/>
+              </a:lnSpc>
+              <a:spcAft>
+                <a:spcPts val="800"/>
+              </a:spcAft>
+              <a:defRPr sz="2100" b="1">
+                <a:solidFill>
+                  <a:srgbClr val="173A49"/>
+                </a:solidFill>
+                <a:latin typeface="맑은 고딕"/>
+              </a:defRPr>
+            </a:pPr>
+            <a:r>
+              <a:t>새 독립 데이터 검증 필요</a:t>
             </a:r>
           </a:p>
         </p:txBody>
@@ -15467,7 +13602,7 @@
       </p:sp>
       <p:pic>
         <p:nvPicPr>
-          <p:cNvPr id="13" name="Picture 12" descr="app-test-proof.jpg"/>
+          <p:cNvPr id="13" name="Picture 12" descr="app-ensemble-test.jpg"/>
           <p:cNvPicPr>
             <a:picLocks noChangeAspect="1"/>
           </p:cNvPicPr>
@@ -15481,8 +13616,8 @@
         </p:blipFill>
         <p:spPr>
           <a:xfrm>
-            <a:off x="5458816" y="1920240"/>
-            <a:ext cx="5477558" cy="4160520"/>
+            <a:off x="4983480" y="2167095"/>
+            <a:ext cx="6428232" cy="3666808"/>
           </a:xfrm>
           <a:prstGeom prst="rect">
             <a:avLst/>
@@ -15637,7 +13772,7 @@
               </a:defRPr>
             </a:pPr>
             <a:r>
-              <a:t>⑤ 필요하면, 공식 문서에서 비교 후보를 추가합니다</a:t>
+              <a:t>⑤ 공식 문서에서 비교 후보를 추가할 수 있습니다</a:t>
             </a:r>
           </a:p>
         </p:txBody>
@@ -15764,7 +13899,7 @@
               </a:defRPr>
             </a:pPr>
             <a:r>
-              <a:t>08 / 16</a:t>
+              <a:t>08 / 14</a:t>
             </a:r>
           </a:p>
         </p:txBody>
@@ -15806,7 +13941,7 @@
               </a:defRPr>
             </a:pPr>
             <a:r>
-              <a:t>공식 문서 조회 → 관련 근거 검색 → 후보와 제안 이유 제시</a:t>
+              <a:t>공식 문서 조회 → 근거 검색 → 후보와 제안 이유 제시</a:t>
             </a:r>
           </a:p>
         </p:txBody>
@@ -15848,7 +13983,7 @@
               </a:defRPr>
             </a:pPr>
             <a:r>
-              <a:t>ExtraTrees·GaussianNB를 추가할 수 있습니다.</a:t>
+              <a:t>ExtraTrees·GaussianNB 두 모델을 추가할 수 있습니다.</a:t>
             </a:r>
           </a:p>
         </p:txBody>
@@ -15890,56 +14025,14 @@
               </a:defRPr>
             </a:pPr>
             <a:r>
-              <a:t>근거 확인 → 비교 계획 승인 → 기존 후보와 학습·비교</a:t>
-            </a:r>
-          </a:p>
-        </p:txBody>
-      </p:sp>
-      <p:sp>
-        <p:nvSpPr>
-          <p:cNvPr id="11" name="TextBox 10"/>
-          <p:cNvSpPr txBox="1"/>
-          <p:nvPr/>
-        </p:nvSpPr>
-        <p:spPr>
-          <a:xfrm>
-            <a:off x="658368" y="4690872"/>
-            <a:ext cx="4526280" cy="804672"/>
-          </a:xfrm>
-          <a:prstGeom prst="rect">
-            <a:avLst/>
-          </a:prstGeom>
-          <a:noFill/>
-        </p:spPr>
-        <p:txBody>
-          <a:bodyPr wrap="square" lIns="18288" rIns="18288" tIns="18288" bIns="18288">
-            <a:spAutoFit/>
-          </a:bodyPr>
-          <a:lstStyle/>
-          <a:p>
-            <a:pPr>
-              <a:lnSpc>
-                <a:spcPct val="114000"/>
-              </a:lnSpc>
-              <a:spcAft>
-                <a:spcPts val="800"/>
-              </a:spcAft>
-              <a:defRPr sz="1900" b="0">
-                <a:solidFill>
-                  <a:srgbClr val="617681"/>
-                </a:solidFill>
-                <a:latin typeface="맑은 고딕"/>
-              </a:defRPr>
-            </a:pPr>
-            <a:r>
-              <a:t>현재 연결은 검토된 두 모델입니다. 임의 모델 자동 생성은 아닙니다.</a:t>
-            </a:r>
-          </a:p>
-        </p:txBody>
-      </p:sp>
-      <p:sp>
-        <p:nvSpPr>
-          <p:cNvPr id="12" name="Rounded Rectangle 11"/>
+              <a:t>근거 확인 → 계획 승인 → 기존 후보와 학습·비교</a:t>
+            </a:r>
+          </a:p>
+        </p:txBody>
+      </p:sp>
+      <p:sp>
+        <p:nvSpPr>
+          <p:cNvPr id="11" name="Rounded Rectangle 10"/>
           <p:cNvSpPr/>
           <p:nvPr/>
         </p:nvSpPr>
@@ -15986,7 +14079,7 @@
       </p:sp>
       <p:pic>
         <p:nvPicPr>
-          <p:cNvPr id="13" name="Picture 12" descr="app-rag-proof.jpg"/>
+          <p:cNvPr id="12" name="Picture 11" descr="app-rag-proof.jpg"/>
           <p:cNvPicPr>
             <a:picLocks noChangeAspect="1"/>
           </p:cNvPicPr>
@@ -16114,7 +14207,7 @@
               </a:defRPr>
             </a:pPr>
             <a:r>
-              <a:t>09 · 구현 구조와 검증 | 방금 본 기능의 내부</a:t>
+              <a:t>09 · 구현 구조와 검증</a:t>
             </a:r>
           </a:p>
         </p:txBody>
@@ -16283,7 +14376,7 @@
               </a:defRPr>
             </a:pPr>
             <a:r>
-              <a:t>09 / 16</a:t>
+              <a:t>09 / 14</a:t>
             </a:r>
           </a:p>
         </p:txBody>
@@ -17140,7 +15233,7 @@
               </a:defRPr>
             </a:pPr>
             <a:r>
-              <a:t>LLM 평가: 자체 예제 6/8 일치 · 오판 2개 / 코드 테스트: 33개 통과</a:t>
+              <a:t>설명 검사(LLM-as-a-Judge): 6/8개 올바른 판단 · 코드 테스트 42개 통과</a:t>
             </a:r>
           </a:p>
         </p:txBody>

</xml_diff>

<commit_message>
Restore product training scope comparison and distinguish grouping limits
</commit_message>
<xml_diff>
--- a/docs/G045_Semiconductor_Agent.pptx
+++ b/docs/G045_Semiconductor_Agent.pptx
@@ -743,13 +743,13 @@
           <a:lstStyle/>
           <a:p>
             <a:r>
-              <a:t>SECOM은1,567건 중 불합격104건이며 제조사·제품ID는 제공되지 않습니다. 이미지 Test의 불량15건은 작은 표본입니다. 이 표는 이전 실험 기록이며 앙상블 적용 결과로 해석하지 않습니다.</a:t>
+              <a:t>제품별로 나누면 데이터가 줄고, 합치면 제품 차이를 놓칠 수 있습니다. 이 별도 실험에서는 A의 공통 모델 검출률98.6%가 전용94.2%보다 높았고, C는 전용93.2%가 공통90.9%보다 높았습니다. Validation 선택이 미래 우월성을 보장하지 않아 Test도 따로 확인합니다. 본문 앙상블과 다른 합성 배치의 보존 기록입니다. ABC용 모델과D용 모델처럼 모든 그룹 구성을 자동 최적화한 결과는 아닙니다.</a:t>
             </a:r>
           </a:p>
           <a:p/>
           <a:p>
             <a:r>
-              <a:t>출처: docs/evaluation/summary.json</a:t>
+              <a:t>출처: docs/evaluation/model_management.json; app/monitoring.py; docs/PRODUCT_GROUPING.md</a:t>
             </a:r>
           </a:p>
         </p:txBody>
@@ -971,7 +971,7 @@
           <a:lstStyle/>
           <a:p>
             <a:r>
-              <a:t>대상은 검사 모델을 만드는 엔지니어입니다. 데이터가 바뀌면 어떤 모델을 쓰고 예측을 어떤 비율로 섞을지 비교해야 합니다. 이 반복 작업을 연결했습니다. 스칼라에서 배운 모델과 반도체 자료의 후보를 함께 넣었고, 센서 사례 하나로 설명하겠습니다.</a:t>
+              <a:t>대상은 검사 모델을 만드는 엔지니어입니다. 어떤 제품 데이터를 함께 학습할지, 어떤 모델과 혼합 비율을 쓸지 비교해야 합니다. 이 반복 작업을 연결했습니다. 스칼라에서 배운 모델과 반도체 자료의 후보를 함께 넣었고, 센서 사례 하나로 설명하겠습니다.</a:t>
             </a:r>
           </a:p>
           <a:p/>
@@ -1199,13 +1199,13 @@
           <a:lstStyle/>
           <a:p>
             <a:r>
-              <a:t>먼저 여러 모델을 같은 조건으로 비교하고 상위 세 알고리즘을 고릅니다. 화면은 그 확률을 섞는 비율 탐색 계획입니다. 학습, 후보 선택, 마지막 확인 데이터를 육 대 이 대 이로 나누고 같은 생산 묶음은 섞지 않습니다. 비교 범위를 확인하고 승인하면 실행합니다.</a:t>
+              <a:t>모델뿐 아니라 A만 학습할지, AB나ABC를 합쳐 학습할지도 비교합니다. 오늘 앙상블 사례는 제품ABCD로 고정해 상위 세 모델의 확률을 섞습니다. 학습, 후보 선택, 마지막 확인 데이터를 육 대 이 대 이로 나누고 같은 생산 묶음은 섞지 않습니다. 비율 탐색 계획을 확인하고 승인하면 실행합니다.</a:t>
             </a:r>
           </a:p>
           <a:p/>
           <a:p>
             <a:r>
-              <a:t>출처: app/ensemble.py; docs/evaluation/weighted_ensemble.json</a:t>
+              <a:t>출처: app/experiments.py; app/ensemble.py; docs/evaluation/weighted_ensemble.json</a:t>
             </a:r>
           </a:p>
         </p:txBody>
@@ -8101,7 +8101,7 @@
               </a:defRPr>
             </a:pPr>
             <a:r>
-              <a:t>부록 B · 앙상블 추가 전의 별도 실험 기록</a:t>
+              <a:t>부록 B · 별도 합성 후속 배치의 실제 비교</a:t>
             </a:r>
           </a:p>
         </p:txBody>
@@ -8143,7 +8143,7 @@
               </a:defRPr>
             </a:pPr>
             <a:r>
-              <a:t>공개 센서와 이미지에서도 실행했습니다</a:t>
+              <a:t>제품별 전용 모델이 항상 더 좋지는 않습니다</a:t>
             </a:r>
           </a:p>
         </p:txBody>
@@ -8312,7 +8312,7 @@
               </a:defRPr>
             </a:pPr>
             <a:r>
-              <a:t>본문의 앙상블 결과와 별개입니다. 각 행 안에서만 같은 Test를 비교합니다.</a:t>
+              <a:t>같은 제품의 같은 Validation 행에서 공통·전용 CatBoost를 비교했습니다.</a:t>
             </a:r>
           </a:p>
         </p:txBody>
@@ -8354,7 +8354,7 @@
               </a:defRPr>
             </a:pPr>
             <a:r>
-              <a:t>SECOM은 실제 공개 자료이며, 센서·이미지 예제는 합성 데이터입니다.</a:t>
+              <a:t>A는 공통 모델, C는 전용 모델이 더 높은 검출률을 보였습니다.</a:t>
             </a:r>
           </a:p>
         </p:txBody>
@@ -8378,13 +8378,12 @@
                 <a:tableStyleId>{5C22544A-7EE6-4342-B048-85BDC9FD1C3A}</a:tableStyleId>
               </a:tblPr>
               <a:tblGrid>
-                <a:gridCol w="2200046"/>
-                <a:gridCol w="2200046"/>
-                <a:gridCol w="2200046"/>
-                <a:gridCol w="2200046"/>
-                <a:gridCol w="2200048"/>
+                <a:gridCol w="914400"/>
+                <a:gridCol w="3566160"/>
+                <a:gridCol w="3566160"/>
+                <a:gridCol w="2953512"/>
               </a:tblGrid>
-              <a:tr h="786383">
+              <a:tr h="629107">
                 <a:tc>
                   <a:txBody>
                     <a:bodyPr/>
@@ -8399,7 +8398,7 @@
                         </a:defRPr>
                       </a:pPr>
                       <a:r>
-                        <a:t>데이터</a:t>
+                        <a:t>제품</a:t>
                       </a:r>
                     </a:p>
                   </a:txBody>
@@ -8423,7 +8422,20 @@
                         </a:defRPr>
                       </a:pPr>
                       <a:r>
-                        <a:t>기본 / 선택·참고 후보</a:t>
+                        <a:t>ABCD 공통 모델</a:t>
+                      </a:r>
+                    </a:p>
+                    <a:p>
+                      <a:pPr>
+                        <a:defRPr sz="1300" b="1">
+                          <a:solidFill>
+                            <a:srgbClr val="FFFFFF"/>
+                          </a:solidFill>
+                          <a:latin typeface="맑은 고딕"/>
+                        </a:defRPr>
+                      </a:pPr>
+                      <a:r>
+                        <a:t>검출률 / 정상 오판률</a:t>
                       </a:r>
                     </a:p>
                   </a:txBody>
@@ -8447,7 +8459,20 @@
                         </a:defRPr>
                       </a:pPr>
                       <a:r>
-                        <a:t>불량 발견</a:t>
+                        <a:t>해당 제품 전용 모델</a:t>
+                      </a:r>
+                    </a:p>
+                    <a:p>
+                      <a:pPr>
+                        <a:defRPr sz="1300" b="1">
+                          <a:solidFill>
+                            <a:srgbClr val="FFFFFF"/>
+                          </a:solidFill>
+                          <a:latin typeface="맑은 고딕"/>
+                        </a:defRPr>
+                      </a:pPr>
+                      <a:r>
+                        <a:t>검출률 / 정상 오판률</a:t>
                       </a:r>
                     </a:p>
                   </a:txBody>
@@ -8471,31 +8496,7 @@
                         </a:defRPr>
                       </a:pPr>
                       <a:r>
-                        <a:t>정상 오판</a:t>
-                      </a:r>
-                    </a:p>
-                  </a:txBody>
-                  <a:tcPr marL="118872" marR="91440" marT="64008" marB="54864" anchor="ctr">
-                    <a:solidFill>
-                      <a:srgbClr val="147D82"/>
-                    </a:solidFill>
-                  </a:tcPr>
-                </a:tc>
-                <a:tc>
-                  <a:txBody>
-                    <a:bodyPr/>
-                    <a:lstStyle/>
-                    <a:p>
-                      <a:pPr>
-                        <a:defRPr sz="1300" b="1">
-                          <a:solidFill>
-                            <a:srgbClr val="FFFFFF"/>
-                          </a:solidFill>
-                          <a:latin typeface="맑은 고딕"/>
-                        </a:defRPr>
-                      </a:pPr>
-                      <a:r>
-                        <a:t>판단</a:t>
+                        <a:t>Validation 선택</a:t>
                       </a:r>
                     </a:p>
                   </a:txBody>
@@ -8506,7 +8507,7 @@
                   </a:tcPr>
                 </a:tc>
               </a:tr>
-              <a:tr h="786383">
+              <a:tr h="629107">
                 <a:tc>
                   <a:txBody>
                     <a:bodyPr/>
@@ -8521,7 +8522,7 @@
                         </a:defRPr>
                       </a:pPr>
                       <a:r>
-                        <a:t>합성 센서</a:t>
+                        <a:t>A</a:t>
                       </a:r>
                     </a:p>
                   </a:txBody>
@@ -8545,7 +8546,7 @@
                         </a:defRPr>
                       </a:pPr>
                       <a:r>
-                        <a:t>Logistic / CatBoost</a:t>
+                        <a:t>98.6% / 14.8%</a:t>
                       </a:r>
                     </a:p>
                   </a:txBody>
@@ -8569,7 +8570,7 @@
                         </a:defRPr>
                       </a:pPr>
                       <a:r>
-                        <a:t>20 → 27 / 32</a:t>
+                        <a:t>94.2% / 14.2%</a:t>
                       </a:r>
                     </a:p>
                   </a:txBody>
@@ -8593,7 +8594,131 @@
                         </a:defRPr>
                       </a:pPr>
                       <a:r>
-                        <a:t>1 → 14 / 224</a:t>
+                        <a:t>공통</a:t>
+                      </a:r>
+                    </a:p>
+                  </a:txBody>
+                  <a:tcPr marL="118872" marR="91440" marT="64008" marB="54864" anchor="ctr">
+                    <a:solidFill>
+                      <a:srgbClr val="FFFFFF"/>
+                    </a:solidFill>
+                  </a:tcPr>
+                </a:tc>
+              </a:tr>
+              <a:tr h="629107">
+                <a:tc>
+                  <a:txBody>
+                    <a:bodyPr/>
+                    <a:lstStyle/>
+                    <a:p>
+                      <a:pPr>
+                        <a:defRPr sz="1300" b="0">
+                          <a:solidFill>
+                            <a:srgbClr val="173A49"/>
+                          </a:solidFill>
+                          <a:latin typeface="맑은 고딕"/>
+                        </a:defRPr>
+                      </a:pPr>
+                      <a:r>
+                        <a:t>B</a:t>
+                      </a:r>
+                    </a:p>
+                  </a:txBody>
+                  <a:tcPr marL="118872" marR="91440" marT="64008" marB="54864" anchor="ctr">
+                    <a:solidFill>
+                      <a:srgbClr val="E8F3F3"/>
+                    </a:solidFill>
+                  </a:tcPr>
+                </a:tc>
+                <a:tc>
+                  <a:txBody>
+                    <a:bodyPr/>
+                    <a:lstStyle/>
+                    <a:p>
+                      <a:pPr>
+                        <a:defRPr sz="1300" b="0">
+                          <a:solidFill>
+                            <a:srgbClr val="173A49"/>
+                          </a:solidFill>
+                          <a:latin typeface="맑은 고딕"/>
+                        </a:defRPr>
+                      </a:pPr>
+                      <a:r>
+                        <a:t>89.7% / 13.2%</a:t>
+                      </a:r>
+                    </a:p>
+                  </a:txBody>
+                  <a:tcPr marL="118872" marR="91440" marT="64008" marB="54864" anchor="ctr">
+                    <a:solidFill>
+                      <a:srgbClr val="E8F3F3"/>
+                    </a:solidFill>
+                  </a:tcPr>
+                </a:tc>
+                <a:tc>
+                  <a:txBody>
+                    <a:bodyPr/>
+                    <a:lstStyle/>
+                    <a:p>
+                      <a:pPr>
+                        <a:defRPr sz="1300" b="0">
+                          <a:solidFill>
+                            <a:srgbClr val="173A49"/>
+                          </a:solidFill>
+                          <a:latin typeface="맑은 고딕"/>
+                        </a:defRPr>
+                      </a:pPr>
+                      <a:r>
+                        <a:t>89.7% / 14.9%</a:t>
+                      </a:r>
+                    </a:p>
+                  </a:txBody>
+                  <a:tcPr marL="118872" marR="91440" marT="64008" marB="54864" anchor="ctr">
+                    <a:solidFill>
+                      <a:srgbClr val="E8F3F3"/>
+                    </a:solidFill>
+                  </a:tcPr>
+                </a:tc>
+                <a:tc>
+                  <a:txBody>
+                    <a:bodyPr/>
+                    <a:lstStyle/>
+                    <a:p>
+                      <a:pPr>
+                        <a:defRPr sz="1300" b="0">
+                          <a:solidFill>
+                            <a:srgbClr val="173A49"/>
+                          </a:solidFill>
+                          <a:latin typeface="맑은 고딕"/>
+                        </a:defRPr>
+                      </a:pPr>
+                      <a:r>
+                        <a:t>공통 · 목표 미달</a:t>
+                      </a:r>
+                    </a:p>
+                  </a:txBody>
+                  <a:tcPr marL="118872" marR="91440" marT="64008" marB="54864" anchor="ctr">
+                    <a:solidFill>
+                      <a:srgbClr val="E8F3F3"/>
+                    </a:solidFill>
+                  </a:tcPr>
+                </a:tc>
+              </a:tr>
+              <a:tr h="629107">
+                <a:tc>
+                  <a:txBody>
+                    <a:bodyPr/>
+                    <a:lstStyle/>
+                    <a:p>
+                      <a:pPr>
+                        <a:defRPr sz="1300" b="0">
+                          <a:solidFill>
+                            <a:srgbClr val="173A49"/>
+                          </a:solidFill>
+                          <a:latin typeface="맑은 고딕"/>
+                        </a:defRPr>
+                      </a:pPr>
+                      <a:r>
+                        <a:t>C</a:t>
                       </a:r>
                     </a:p>
                   </a:txBody>
@@ -8617,7 +8742,7 @@
                         </a:defRPr>
                       </a:pPr>
                       <a:r>
-                        <a:t>추가 검증 필요</a:t>
+                        <a:t>90.9% / 14.3%</a:t>
                       </a:r>
                     </a:p>
                   </a:txBody>
@@ -8627,8 +8752,6 @@
                     </a:solidFill>
                   </a:tcPr>
                 </a:tc>
-              </a:tr>
-              <a:tr h="786383">
                 <a:tc>
                   <a:txBody>
                     <a:bodyPr/>
@@ -8643,7 +8766,57 @@
                         </a:defRPr>
                       </a:pPr>
                       <a:r>
-                        <a:t>UCI SECOM</a:t>
+                        <a:t>93.2% / 14.3%</a:t>
+                      </a:r>
+                    </a:p>
+                  </a:txBody>
+                  <a:tcPr marL="118872" marR="91440" marT="64008" marB="54864" anchor="ctr">
+                    <a:solidFill>
+                      <a:srgbClr val="FFFFFF"/>
+                    </a:solidFill>
+                  </a:tcPr>
+                </a:tc>
+                <a:tc>
+                  <a:txBody>
+                    <a:bodyPr/>
+                    <a:lstStyle/>
+                    <a:p>
+                      <a:pPr>
+                        <a:defRPr sz="1300" b="0">
+                          <a:solidFill>
+                            <a:srgbClr val="173A49"/>
+                          </a:solidFill>
+                          <a:latin typeface="맑은 고딕"/>
+                        </a:defRPr>
+                      </a:pPr>
+                      <a:r>
+                        <a:t>전용</a:t>
+                      </a:r>
+                    </a:p>
+                  </a:txBody>
+                  <a:tcPr marL="118872" marR="91440" marT="64008" marB="54864" anchor="ctr">
+                    <a:solidFill>
+                      <a:srgbClr val="FFFFFF"/>
+                    </a:solidFill>
+                  </a:tcPr>
+                </a:tc>
+              </a:tr>
+              <a:tr h="629107">
+                <a:tc>
+                  <a:txBody>
+                    <a:bodyPr/>
+                    <a:lstStyle/>
+                    <a:p>
+                      <a:pPr>
+                        <a:defRPr sz="1300" b="0">
+                          <a:solidFill>
+                            <a:srgbClr val="173A49"/>
+                          </a:solidFill>
+                          <a:latin typeface="맑은 고딕"/>
+                        </a:defRPr>
+                      </a:pPr>
+                      <a:r>
+                        <a:t>D</a:t>
                       </a:r>
                     </a:p>
                   </a:txBody>
@@ -8667,7 +8840,7 @@
                         </a:defRPr>
                       </a:pPr>
                       <a:r>
-                        <a:t>Logistic / XGBoost</a:t>
+                        <a:t>98.2% / 8.3%</a:t>
                       </a:r>
                     </a:p>
                   </a:txBody>
@@ -8691,7 +8864,7 @@
                         </a:defRPr>
                       </a:pPr>
                       <a:r>
-                        <a:t>0 → 5 / 23</a:t>
+                        <a:t>98.2% / 13.9%</a:t>
                       </a:r>
                     </a:p>
                   </a:txBody>
@@ -8715,159 +8888,13 @@
                         </a:defRPr>
                       </a:pPr>
                       <a:r>
-                        <a:t>17 → 87 / 357</a:t>
+                        <a:t>공통</a:t>
                       </a:r>
                     </a:p>
                   </a:txBody>
                   <a:tcPr marL="118872" marR="91440" marT="64008" marB="54864" anchor="ctr">
                     <a:solidFill>
                       <a:srgbClr val="E8F3F3"/>
-                    </a:solidFill>
-                  </a:tcPr>
-                </a:tc>
-                <a:tc>
-                  <a:txBody>
-                    <a:bodyPr/>
-                    <a:lstStyle/>
-                    <a:p>
-                      <a:pPr>
-                        <a:defRPr sz="1300" b="0">
-                          <a:solidFill>
-                            <a:srgbClr val="173A49"/>
-                          </a:solidFill>
-                          <a:latin typeface="맑은 고딕"/>
-                        </a:defRPr>
-                      </a:pPr>
-                      <a:r>
-                        <a:t>목표 충족 후보 없음</a:t>
-                      </a:r>
-                    </a:p>
-                  </a:txBody>
-                  <a:tcPr marL="118872" marR="91440" marT="64008" marB="54864" anchor="ctr">
-                    <a:solidFill>
-                      <a:srgbClr val="E8F3F3"/>
-                    </a:solidFill>
-                  </a:tcPr>
-                </a:tc>
-              </a:tr>
-              <a:tr h="786386">
-                <a:tc>
-                  <a:txBody>
-                    <a:bodyPr/>
-                    <a:lstStyle/>
-                    <a:p>
-                      <a:pPr>
-                        <a:defRPr sz="1300" b="0">
-                          <a:solidFill>
-                            <a:srgbClr val="173A49"/>
-                          </a:solidFill>
-                          <a:latin typeface="맑은 고딕"/>
-                        </a:defRPr>
-                      </a:pPr>
-                      <a:r>
-                        <a:t>합성 이미지</a:t>
-                      </a:r>
-                    </a:p>
-                  </a:txBody>
-                  <a:tcPr marL="118872" marR="91440" marT="64008" marB="54864" anchor="ctr">
-                    <a:solidFill>
-                      <a:srgbClr val="FFFFFF"/>
-                    </a:solidFill>
-                  </a:tcPr>
-                </a:tc>
-                <a:tc>
-                  <a:txBody>
-                    <a:bodyPr/>
-                    <a:lstStyle/>
-                    <a:p>
-                      <a:pPr>
-                        <a:defRPr sz="1300" b="0">
-                          <a:solidFill>
-                            <a:srgbClr val="173A49"/>
-                          </a:solidFill>
-                          <a:latin typeface="맑은 고딕"/>
-                        </a:defRPr>
-                      </a:pPr>
-                      <a:r>
-                        <a:t>축소 ResNet / Autoencoder</a:t>
-                      </a:r>
-                    </a:p>
-                  </a:txBody>
-                  <a:tcPr marL="118872" marR="91440" marT="64008" marB="54864" anchor="ctr">
-                    <a:solidFill>
-                      <a:srgbClr val="FFFFFF"/>
-                    </a:solidFill>
-                  </a:tcPr>
-                </a:tc>
-                <a:tc>
-                  <a:txBody>
-                    <a:bodyPr/>
-                    <a:lstStyle/>
-                    <a:p>
-                      <a:pPr>
-                        <a:defRPr sz="1300" b="0">
-                          <a:solidFill>
-                            <a:srgbClr val="173A49"/>
-                          </a:solidFill>
-                          <a:latin typeface="맑은 고딕"/>
-                        </a:defRPr>
-                      </a:pPr>
-                      <a:r>
-                        <a:t>15 → 14 / 15</a:t>
-                      </a:r>
-                    </a:p>
-                  </a:txBody>
-                  <a:tcPr marL="118872" marR="91440" marT="64008" marB="54864" anchor="ctr">
-                    <a:solidFill>
-                      <a:srgbClr val="FFFFFF"/>
-                    </a:solidFill>
-                  </a:tcPr>
-                </a:tc>
-                <a:tc>
-                  <a:txBody>
-                    <a:bodyPr/>
-                    <a:lstStyle/>
-                    <a:p>
-                      <a:pPr>
-                        <a:defRPr sz="1300" b="0">
-                          <a:solidFill>
-                            <a:srgbClr val="173A49"/>
-                          </a:solidFill>
-                          <a:latin typeface="맑은 고딕"/>
-                        </a:defRPr>
-                      </a:pPr>
-                      <a:r>
-                        <a:t>32 → 0 / 105</a:t>
-                      </a:r>
-                    </a:p>
-                  </a:txBody>
-                  <a:tcPr marL="118872" marR="91440" marT="64008" marB="54864" anchor="ctr">
-                    <a:solidFill>
-                      <a:srgbClr val="FFFFFF"/>
-                    </a:solidFill>
-                  </a:tcPr>
-                </a:tc>
-                <a:tc>
-                  <a:txBody>
-                    <a:bodyPr/>
-                    <a:lstStyle/>
-                    <a:p>
-                      <a:pPr>
-                        <a:defRPr sz="1300" b="0">
-                          <a:solidFill>
-                            <a:srgbClr val="173A49"/>
-                          </a:solidFill>
-                          <a:latin typeface="맑은 고딕"/>
-                        </a:defRPr>
-                      </a:pPr>
-                      <a:r>
-                        <a:t>불량 표본 보강</a:t>
-                      </a:r>
-                    </a:p>
-                  </a:txBody>
-                  <a:tcPr marL="118872" marR="91440" marT="64008" marB="54864" anchor="ctr">
-                    <a:solidFill>
-                      <a:srgbClr val="FFFFFF"/>
                     </a:solidFill>
                   </a:tcPr>
                 </a:tc>
@@ -10755,7 +10782,7 @@
               </a:defRPr>
             </a:pPr>
             <a:r>
-              <a:t>반복 업무: 데이터 확인 → 여러 모델 학습 → 혼합 비율 비교 → 근거 기록</a:t>
+              <a:t>반복 업무: 학습할 제품 묶음 선택 → 모델·혼합 비율 비교 → 근거 기록</a:t>
             </a:r>
           </a:p>
         </p:txBody>
@@ -12533,7 +12560,7 @@
               </a:defRPr>
             </a:pPr>
             <a:r>
-              <a:t>상위 3개 모델의 확률을 5% 간격으로 혼합 · 합계100%</a:t>
+              <a:t>제품 묶음도 비교 · 오늘의 앙상블 사례는 A+B+C+D로 고정</a:t>
             </a:r>
           </a:p>
         </p:txBody>

</xml_diff>

<commit_message>
Compare product partitions and add course-based BGE-M3 FAISS RAG
</commit_message>
<xml_diff>
--- a/docs/G045_Semiconductor_Agent.pptx
+++ b/docs/G045_Semiconductor_Agent.pptx
@@ -515,7 +515,7 @@
           <a:lstStyle/>
           <a:p>
             <a:r>
-              <a:t>안녕하세요. 김용찬입니다. 검사 데이터를 넣으면 모델과 앙상블 비율을 비교하고, 왜 그 비율을 선택했는지 결과와 함께 보여 주는 Agent를 만들었습니다.</a:t>
+              <a:t>안녕하세요. 김용찬입니다. 검사 데이터를 넣으면 학습할 제품 묶음과 모델 예측의 혼합 비율을 비교하고, 선택 근거와 검증 결과를 보여 주는 Agent를 만들었습니다.</a:t>
             </a:r>
           </a:p>
           <a:p/>
@@ -591,7 +591,7 @@
           <a:lstStyle/>
           <a:p>
             <a:r>
-              <a:t>모델 이름뿐 아니라 혼합 비율과 선택 근거까지 보여 주는 흐름을 구현했습니다. F1 하나로 고르기보다 업무의 우선순위를 먼저 정해야 한다는 것을 배웠습니다. 합성 데이터와 작은 표본이 한계이며, 다음에는 현장 기준과 독립 데이터로 검증하겠습니다. 감사합니다.</a:t>
+              <a:t>성과는 제품 묶음과 혼합 비율의 선택 근거, 검증 실패까지 한 흐름에서 보여 준 점입니다. Validation에서 좋았던 그룹도 Test에서 실패할 수 있어 보류 판단이 필요했습니다. 합성 데이터와 작은 표본이 한계이며, 다음에는 현장 기준과 독립 데이터로 검증하겠습니다. 감사합니다.</a:t>
             </a:r>
           </a:p>
           <a:p/>
@@ -743,13 +743,13 @@
           <a:lstStyle/>
           <a:p>
             <a:r>
-              <a:t>제품별로 나누면 데이터가 줄고, 합치면 제품 차이를 놓칠 수 있습니다. 이 별도 실험에서는 A의 공통 모델 검출률98.6%가 전용94.2%보다 높았고, C는 전용93.2%가 공통90.9%보다 높았습니다. Validation 선택이 미래 우월성을 보장하지 않아 Test도 따로 확인합니다. 본문 앙상블과 다른 합성 배치의 보존 기록입니다. ABC용 모델과D용 모델처럼 모든 그룹 구성을 자동 최적화한 결과는 아닙니다.</a:t>
+              <a:t>외부 모델 탐색에는 공식 문서를 BGE-M3로 임베딩하고 FAISS에서 관련 문장을 찾아 로컬 Qwen에 전달하는 RAG를 씁니다. 5주차 실습과 같은 검색 구조이며 이 Windows에서는 Ollama로 임베딩을 실행합니다. FAISS 벡터와 출처를 로컬에 저장하며 별도 서버형 DB는 아닙니다. 학습 연결은 검토한 ExtraTrees와 GaussianNB 두 후보이고 임의 모델 코드를 자동 설치하지 않습니다.</a:t>
             </a:r>
           </a:p>
           <a:p/>
           <a:p>
             <a:r>
-              <a:t>출처: docs/evaluation/model_management.json; app/monitoring.py; docs/PRODUCT_GROUPING.md</a:t>
+              <a:t>출처: app/discovery.py; app/retrieval.py; docs/evaluation/vector_rag.json</a:t>
             </a:r>
           </a:p>
         </p:txBody>
@@ -819,7 +819,7 @@
           <a:lstStyle/>
           <a:p>
             <a:r>
-              <a:t>각 모델의 불량 확률을90대10으로 평균하고 Validation에서 정한 판정값 이상이면 불량으로 봅니다. 단일 모델과 균등 비율도 포함했습니다. 동률이면 적은 모델을 고르므로 단일 모델을 유지할 수도 있습니다. 모든 모델·모든 실수 비율의 전역 최적이라는 뜻은 아닙니다. 정확한 근거는 전체 비율 CSV로 확인할 수 있습니다.</a:t>
+              <a:t>최선이라는 말은 승인한 후보와 조건, Validation 범위 안에서의 선택을 뜻합니다. 제품 그룹 구성과 앙상블 비율은 별도 실험으로 비교했습니다. 둘을 모두 동시에 최적화했다고 주장하지 않습니다. 그룹 구성은 Test에서 목표 미달이었고 적용을 보류했습니다.</a:t>
             </a:r>
           </a:p>
           <a:p/>
@@ -971,7 +971,7 @@
           <a:lstStyle/>
           <a:p>
             <a:r>
-              <a:t>대상은 검사 모델을 만드는 엔지니어입니다. 어떤 제품 데이터를 함께 학습할지, 어떤 모델과 혼합 비율을 쓸지 비교해야 합니다. 이 반복 작업을 연결했습니다. 스칼라에서 배운 모델과 반도체 자료의 후보를 함께 넣었고, 센서 사례 하나로 설명하겠습니다.</a:t>
+              <a:t>이 프로젝트에서 설정한 문제는 엔지니어가 학습할 제품 묶음과 모델, 혼합 비율을 직접 비교하고 근거를 정리해야 한다는 점입니다. 이를 계획부터 승인, 실행, 기록까지 연결했습니다. 스칼라에서 배운 모델도 후보에 넣었고 센서 사례로 설명하겠습니다.</a:t>
             </a:r>
           </a:p>
           <a:p/>
@@ -1199,7 +1199,7 @@
           <a:lstStyle/>
           <a:p>
             <a:r>
-              <a:t>모델뿐 아니라 A만 학습할지, AB나ABC를 합쳐 학습할지도 비교합니다. 오늘 앙상블 사례는 제품ABCD로 고정해 상위 세 모델의 확률을 섞습니다. 학습, 후보 선택, 마지막 확인 데이터를 육 대 이 대 이로 나누고 같은 생산 묶음은 섞지 않습니다. 비율 탐색 계획을 확인하고 승인하면 실행합니다.</a:t>
+              <a:t>먼저 개별 모델을 비교한 뒤 제품 묶음과 혼합 비율을 각각 검토합니다. 화면은 CatBoost 설정을 고정하고 열다섯 그룹 구성을 비교하는 계획입니다. 학습과 평가 데이터를 분리하고, 엔지니어가 비교 범위를 승인한 뒤에만 실행합니다.</a:t>
             </a:r>
           </a:p>
           <a:p/>
@@ -1275,13 +1275,13 @@
           <a:lstStyle/>
           <a:p>
             <a:r>
-              <a:t>후보 선택용 데이터인 Validation에서 비율과 판정 기준을 비교합니다. 다섯 퍼센트 간격과 균등 비율을 포함한 이백서른두 조합 중 CatBoost 구십, LightGBM 십 퍼센트가 선택됐습니다. 단일 모델과 검출률 백 퍼센트는 같지만 정상 오판이 스무 건에서 열아홉 건으로 줄고 F1도 개선됐습니다. 이 탐색 범위 안의 최선이라는 뜻입니다.</a:t>
+              <a:t>첫 실험은 학습 제품 묶음입니다. CatBoost 설정을 고정하고 제품을 나누는 열다섯 구성을 비교했습니다. Validation에서는 ABC 공통 모델과 D 전용 모델이 선택됐습니다. 하지만 Test 검출률은 칠십팔 점 일 퍼센트로 목표에 못 미쳐 적용을 보류합니다. Validation에서 좋다고 마지막 검증까지 좋지는 않았습니다.</a:t>
             </a:r>
           </a:p>
           <a:p/>
           <a:p>
             <a:r>
-              <a:t>출처: docs/evaluation/weighted_ensemble.json; docs/evaluation/ensemble_browser.json</a:t>
+              <a:t>출처: app/grouping.py; docs/evaluation/product_partitions.json; docs/evaluation/grouping_browser.json</a:t>
             </a:r>
           </a:p>
         </p:txBody>
@@ -1351,13 +1351,13 @@
           <a:lstStyle/>
           <a:p>
             <a:r>
-              <a:t>비율을 고른 뒤 같은 Test에서 확인했습니다. 단일 CatBoost와 선택 조합은 둘 다 불량 서른두 개 중 서른 개를 찾았습니다. 정상 오판은 스물한 개에서 열아홉 개로 줄고 F1도 영 점 칠이삼에서 칠사일로 높아졌습니다. 이번 시연 목표는 충족했지만, 기존 Test를 다시 확인한 추가 탐색이므로 새로운 독립 데이터 검증이 필요합니다.</a:t>
+              <a:t>다음은 학습 제품ABCD로 고정한 별도 비율 실험입니다. 다섯 퍼센트 간격과 균등 비율을 포함한 이백서른두 조합 중 CatBoost 구십, LightGBM 십 퍼센트가 선택됐습니다. 단일 모델과 검출률 백 퍼센트는 같지만 정상 오판이 스무 건에서 열아홉 건으로 줄고 F1도 개선됐습니다. 이 탐색 범위 안의 최선이라는 뜻입니다.</a:t>
             </a:r>
           </a:p>
           <a:p/>
           <a:p>
             <a:r>
-              <a:t>출처: docs/evaluation/weighted_ensemble.json</a:t>
+              <a:t>출처: docs/evaluation/weighted_ensemble.json; docs/evaluation/ensemble_browser.json</a:t>
             </a:r>
           </a:p>
         </p:txBody>
@@ -1427,13 +1427,13 @@
           <a:lstStyle/>
           <a:p>
             <a:r>
-              <a:t>후보를 더 비교하고 싶으면 공식 문서를 검색합니다. 저장된 실제 검색 기록을 현재 화면에서 다시 보여 드립니다. 관련 근거와 제안 이유를 연결하는 것이 RAG입니다. 현재는 두 모델을 추가할 수 있고, 이 경우도 승인 후 비교합니다.</a:t>
+              <a:t>비율을 고른 뒤 같은 Test에서 확인했습니다. 단일 CatBoost와 선택 조합은 둘 다 불량 서른두 개 중 서른 개를 찾았습니다. 정상 오판은 스물한 개에서 열아홉 개로 줄고 F1도 영 점 칠이삼에서 칠사일로 높아졌습니다. 이번 시연 목표는 충족했지만, 기존 Test를 다시 확인한 추가 탐색이므로 새로운 독립 데이터 검증이 필요합니다.</a:t>
             </a:r>
           </a:p>
           <a:p/>
           <a:p>
             <a:r>
-              <a:t>출처: app/discovery.py; docs/evaluation/model_discovery.json</a:t>
+              <a:t>출처: docs/evaluation/weighted_ensemble.json</a:t>
             </a:r>
           </a:p>
         </p:txBody>
@@ -1503,7 +1503,7 @@
           <a:lstStyle/>
           <a:p>
             <a:r>
-              <a:t>LangGraph로 점검, 검색, 계획 역할을 연결하고 로컬 Qwen이 설명을 돕습니다. MCP는 조회와 계획 도구를 제공하고, 실제 학습과 비율 비교는 실험 엔진이 계산합니다. LangSmith로 실행 경로를 확인했습니다. 또 설명이 실제 결과와 맞는지 LLM이 검사하게 했습니다. 직접 만든 예제 여덟 개 중 여섯 개는 맞혔지만, 오판도 있어 수치 검사는 코드로 유지합니다.</a:t>
+              <a:t>LangGraph로 점검, 검색, 계획 역할을 연결하고 로컬 Qwen이 설명을 돕습니다. 수업에서 배운 BGE-M3로 문서를 벡터로 바꾸고 FAISS에서 관련 근거를 찾아 전달하는 RAG와 MCP 도구를 적용했습니다. 실험 엔진이 실제 학습과 지표를 계산합니다. LangSmith로 실행 경로를 확인했고 LLM으로 설명도 검사했습니다. 예제 여덟 개 중 여섯 개는 맞게 검사했지만 오판이 있어 숫자는 코드로 확인합니다.</a:t>
             </a:r>
           </a:p>
           <a:p/>
@@ -4833,7 +4833,7 @@
               </a:defRPr>
             </a:pPr>
             <a:r>
-              <a:t>모델과 앙상블 비율을 비교하고, 선택 이유를 보여 주는 Agent</a:t>
+              <a:t>학습 제품 묶음과 앙상블 비율을 비교하고, 선택 근거를 보여 주는 Agent</a:t>
             </a:r>
           </a:p>
         </p:txBody>
@@ -5544,7 +5544,7 @@
               </a:defRPr>
             </a:pPr>
             <a:r>
-              <a:t>추천 비율과 함께, 선택 이유와 한계를 남깁니다</a:t>
+              <a:t>선택 근거와 검증 실패를 함께 남깁니다</a:t>
             </a:r>
           </a:p>
         </p:txBody>
@@ -5841,7 +5841,7 @@
               </a:defRPr>
             </a:pPr>
             <a:r>
-              <a:t>교훈: F1 하나보다 불량 미검출·정상 오판의 우선순위가 먼저입니다.</a:t>
+              <a:t>교훈: Validation에서 좋은 선택이 Test에서도 좋다는 보장은 없습니다.</a:t>
             </a:r>
           </a:p>
         </p:txBody>
@@ -8101,7 +8101,7 @@
               </a:defRPr>
             </a:pPr>
             <a:r>
-              <a:t>부록 B · 별도 합성 후속 배치의 실제 비교</a:t>
+              <a:t>부록 B · 공식 문서 근거 | 저장된 실제 검색 기록의 UI 재현</a:t>
             </a:r>
           </a:p>
         </p:txBody>
@@ -8143,7 +8143,7 @@
               </a:defRPr>
             </a:pPr>
             <a:r>
-              <a:t>제품별 전용 모델이 항상 더 좋지는 않습니다</a:t>
+              <a:t>공식 문서에서 비교 후보를 추가할 수 있습니다</a:t>
             </a:r>
           </a:p>
         </p:txBody>
@@ -8283,8 +8283,8 @@
         </p:nvSpPr>
         <p:spPr>
           <a:xfrm>
-            <a:off x="640080" y="1847088"/>
-            <a:ext cx="10972800" cy="402336"/>
+            <a:off x="658368" y="2057400"/>
+            <a:ext cx="4526280" cy="804672"/>
           </a:xfrm>
           <a:prstGeom prst="rect">
             <a:avLst/>
@@ -8304,15 +8304,15 @@
               <a:spcAft>
                 <a:spcPts val="800"/>
               </a:spcAft>
-              <a:defRPr sz="1800" b="0">
+              <a:defRPr sz="2200" b="1">
                 <a:solidFill>
-                  <a:srgbClr val="617681"/>
+                  <a:srgbClr val="173A49"/>
                 </a:solidFill>
                 <a:latin typeface="맑은 고딕"/>
               </a:defRPr>
             </a:pPr>
             <a:r>
-              <a:t>같은 제품의 같은 Validation 행에서 공통·전용 CatBoost를 비교했습니다.</a:t>
+              <a:t>공식 문서 검색 → 근거를 Qwen에 전달</a:t>
             </a:r>
           </a:p>
         </p:txBody>
@@ -8325,8 +8325,8 @@
         </p:nvSpPr>
         <p:spPr>
           <a:xfrm>
-            <a:off x="640080" y="2267712"/>
-            <a:ext cx="10972800" cy="402336"/>
+            <a:off x="658368" y="2935224"/>
+            <a:ext cx="4526280" cy="804672"/>
           </a:xfrm>
           <a:prstGeom prst="rect">
             <a:avLst/>
@@ -8346,7 +8346,7 @@
               <a:spcAft>
                 <a:spcPts val="800"/>
               </a:spcAft>
-              <a:defRPr sz="1800" b="0">
+              <a:defRPr sz="1900" b="0">
                 <a:solidFill>
                   <a:srgbClr val="617681"/>
                 </a:solidFill>
@@ -8354,555 +8354,124 @@
               </a:defRPr>
             </a:pPr>
             <a:r>
-              <a:t>A는 공통 모델, C는 전용 모델이 더 높은 검출률을 보였습니다.</a:t>
-            </a:r>
-          </a:p>
-        </p:txBody>
-      </p:sp>
-      <p:graphicFrame>
-        <p:nvGraphicFramePr>
-          <p:cNvPr id="10" name="Table 9"/>
-          <p:cNvGraphicFramePr>
-            <a:graphicFrameLocks noGrp="1"/>
-          </p:cNvGraphicFramePr>
-          <p:nvPr/>
-        </p:nvGraphicFramePr>
-        <p:xfrm>
-          <a:off x="594360" y="2926080"/>
-          <a:ext cx="11000232" cy="3145535"/>
-        </p:xfrm>
-        <a:graphic>
-          <a:graphicData uri="http://schemas.openxmlformats.org/drawingml/2006/table">
-            <a:tbl>
-              <a:tblPr firstRow="1" bandRow="1">
-                <a:tableStyleId>{5C22544A-7EE6-4342-B048-85BDC9FD1C3A}</a:tableStyleId>
-              </a:tblPr>
-              <a:tblGrid>
-                <a:gridCol w="914400"/>
-                <a:gridCol w="3566160"/>
-                <a:gridCol w="3566160"/>
-                <a:gridCol w="2953512"/>
-              </a:tblGrid>
-              <a:tr h="629107">
-                <a:tc>
-                  <a:txBody>
-                    <a:bodyPr/>
-                    <a:lstStyle/>
-                    <a:p>
-                      <a:pPr>
-                        <a:defRPr sz="1300" b="1">
-                          <a:solidFill>
-                            <a:srgbClr val="FFFFFF"/>
-                          </a:solidFill>
-                          <a:latin typeface="맑은 고딕"/>
-                        </a:defRPr>
-                      </a:pPr>
-                      <a:r>
-                        <a:t>제품</a:t>
-                      </a:r>
-                    </a:p>
-                  </a:txBody>
-                  <a:tcPr marL="118872" marR="91440" marT="64008" marB="54864" anchor="ctr">
-                    <a:solidFill>
-                      <a:srgbClr val="147D82"/>
-                    </a:solidFill>
-                  </a:tcPr>
-                </a:tc>
-                <a:tc>
-                  <a:txBody>
-                    <a:bodyPr/>
-                    <a:lstStyle/>
-                    <a:p>
-                      <a:pPr>
-                        <a:defRPr sz="1300" b="1">
-                          <a:solidFill>
-                            <a:srgbClr val="FFFFFF"/>
-                          </a:solidFill>
-                          <a:latin typeface="맑은 고딕"/>
-                        </a:defRPr>
-                      </a:pPr>
-                      <a:r>
-                        <a:t>ABCD 공통 모델</a:t>
-                      </a:r>
-                    </a:p>
-                    <a:p>
-                      <a:pPr>
-                        <a:defRPr sz="1300" b="1">
-                          <a:solidFill>
-                            <a:srgbClr val="FFFFFF"/>
-                          </a:solidFill>
-                          <a:latin typeface="맑은 고딕"/>
-                        </a:defRPr>
-                      </a:pPr>
-                      <a:r>
-                        <a:t>검출률 / 정상 오판률</a:t>
-                      </a:r>
-                    </a:p>
-                  </a:txBody>
-                  <a:tcPr marL="118872" marR="91440" marT="64008" marB="54864" anchor="ctr">
-                    <a:solidFill>
-                      <a:srgbClr val="147D82"/>
-                    </a:solidFill>
-                  </a:tcPr>
-                </a:tc>
-                <a:tc>
-                  <a:txBody>
-                    <a:bodyPr/>
-                    <a:lstStyle/>
-                    <a:p>
-                      <a:pPr>
-                        <a:defRPr sz="1300" b="1">
-                          <a:solidFill>
-                            <a:srgbClr val="FFFFFF"/>
-                          </a:solidFill>
-                          <a:latin typeface="맑은 고딕"/>
-                        </a:defRPr>
-                      </a:pPr>
-                      <a:r>
-                        <a:t>해당 제품 전용 모델</a:t>
-                      </a:r>
-                    </a:p>
-                    <a:p>
-                      <a:pPr>
-                        <a:defRPr sz="1300" b="1">
-                          <a:solidFill>
-                            <a:srgbClr val="FFFFFF"/>
-                          </a:solidFill>
-                          <a:latin typeface="맑은 고딕"/>
-                        </a:defRPr>
-                      </a:pPr>
-                      <a:r>
-                        <a:t>검출률 / 정상 오판률</a:t>
-                      </a:r>
-                    </a:p>
-                  </a:txBody>
-                  <a:tcPr marL="118872" marR="91440" marT="64008" marB="54864" anchor="ctr">
-                    <a:solidFill>
-                      <a:srgbClr val="147D82"/>
-                    </a:solidFill>
-                  </a:tcPr>
-                </a:tc>
-                <a:tc>
-                  <a:txBody>
-                    <a:bodyPr/>
-                    <a:lstStyle/>
-                    <a:p>
-                      <a:pPr>
-                        <a:defRPr sz="1300" b="1">
-                          <a:solidFill>
-                            <a:srgbClr val="FFFFFF"/>
-                          </a:solidFill>
-                          <a:latin typeface="맑은 고딕"/>
-                        </a:defRPr>
-                      </a:pPr>
-                      <a:r>
-                        <a:t>Validation 선택</a:t>
-                      </a:r>
-                    </a:p>
-                  </a:txBody>
-                  <a:tcPr marL="118872" marR="91440" marT="64008" marB="54864" anchor="ctr">
-                    <a:solidFill>
-                      <a:srgbClr val="147D82"/>
-                    </a:solidFill>
-                  </a:tcPr>
-                </a:tc>
-              </a:tr>
-              <a:tr h="629107">
-                <a:tc>
-                  <a:txBody>
-                    <a:bodyPr/>
-                    <a:lstStyle/>
-                    <a:p>
-                      <a:pPr>
-                        <a:defRPr sz="1300" b="0">
-                          <a:solidFill>
-                            <a:srgbClr val="173A49"/>
-                          </a:solidFill>
-                          <a:latin typeface="맑은 고딕"/>
-                        </a:defRPr>
-                      </a:pPr>
-                      <a:r>
-                        <a:t>A</a:t>
-                      </a:r>
-                    </a:p>
-                  </a:txBody>
-                  <a:tcPr marL="118872" marR="91440" marT="64008" marB="54864" anchor="ctr">
-                    <a:solidFill>
-                      <a:srgbClr val="FFFFFF"/>
-                    </a:solidFill>
-                  </a:tcPr>
-                </a:tc>
-                <a:tc>
-                  <a:txBody>
-                    <a:bodyPr/>
-                    <a:lstStyle/>
-                    <a:p>
-                      <a:pPr>
-                        <a:defRPr sz="1300" b="0">
-                          <a:solidFill>
-                            <a:srgbClr val="173A49"/>
-                          </a:solidFill>
-                          <a:latin typeface="맑은 고딕"/>
-                        </a:defRPr>
-                      </a:pPr>
-                      <a:r>
-                        <a:t>98.6% / 14.8%</a:t>
-                      </a:r>
-                    </a:p>
-                  </a:txBody>
-                  <a:tcPr marL="118872" marR="91440" marT="64008" marB="54864" anchor="ctr">
-                    <a:solidFill>
-                      <a:srgbClr val="FFFFFF"/>
-                    </a:solidFill>
-                  </a:tcPr>
-                </a:tc>
-                <a:tc>
-                  <a:txBody>
-                    <a:bodyPr/>
-                    <a:lstStyle/>
-                    <a:p>
-                      <a:pPr>
-                        <a:defRPr sz="1300" b="0">
-                          <a:solidFill>
-                            <a:srgbClr val="173A49"/>
-                          </a:solidFill>
-                          <a:latin typeface="맑은 고딕"/>
-                        </a:defRPr>
-                      </a:pPr>
-                      <a:r>
-                        <a:t>94.2% / 14.2%</a:t>
-                      </a:r>
-                    </a:p>
-                  </a:txBody>
-                  <a:tcPr marL="118872" marR="91440" marT="64008" marB="54864" anchor="ctr">
-                    <a:solidFill>
-                      <a:srgbClr val="FFFFFF"/>
-                    </a:solidFill>
-                  </a:tcPr>
-                </a:tc>
-                <a:tc>
-                  <a:txBody>
-                    <a:bodyPr/>
-                    <a:lstStyle/>
-                    <a:p>
-                      <a:pPr>
-                        <a:defRPr sz="1300" b="0">
-                          <a:solidFill>
-                            <a:srgbClr val="173A49"/>
-                          </a:solidFill>
-                          <a:latin typeface="맑은 고딕"/>
-                        </a:defRPr>
-                      </a:pPr>
-                      <a:r>
-                        <a:t>공통</a:t>
-                      </a:r>
-                    </a:p>
-                  </a:txBody>
-                  <a:tcPr marL="118872" marR="91440" marT="64008" marB="54864" anchor="ctr">
-                    <a:solidFill>
-                      <a:srgbClr val="FFFFFF"/>
-                    </a:solidFill>
-                  </a:tcPr>
-                </a:tc>
-              </a:tr>
-              <a:tr h="629107">
-                <a:tc>
-                  <a:txBody>
-                    <a:bodyPr/>
-                    <a:lstStyle/>
-                    <a:p>
-                      <a:pPr>
-                        <a:defRPr sz="1300" b="0">
-                          <a:solidFill>
-                            <a:srgbClr val="173A49"/>
-                          </a:solidFill>
-                          <a:latin typeface="맑은 고딕"/>
-                        </a:defRPr>
-                      </a:pPr>
-                      <a:r>
-                        <a:t>B</a:t>
-                      </a:r>
-                    </a:p>
-                  </a:txBody>
-                  <a:tcPr marL="118872" marR="91440" marT="64008" marB="54864" anchor="ctr">
-                    <a:solidFill>
-                      <a:srgbClr val="E8F3F3"/>
-                    </a:solidFill>
-                  </a:tcPr>
-                </a:tc>
-                <a:tc>
-                  <a:txBody>
-                    <a:bodyPr/>
-                    <a:lstStyle/>
-                    <a:p>
-                      <a:pPr>
-                        <a:defRPr sz="1300" b="0">
-                          <a:solidFill>
-                            <a:srgbClr val="173A49"/>
-                          </a:solidFill>
-                          <a:latin typeface="맑은 고딕"/>
-                        </a:defRPr>
-                      </a:pPr>
-                      <a:r>
-                        <a:t>89.7% / 13.2%</a:t>
-                      </a:r>
-                    </a:p>
-                  </a:txBody>
-                  <a:tcPr marL="118872" marR="91440" marT="64008" marB="54864" anchor="ctr">
-                    <a:solidFill>
-                      <a:srgbClr val="E8F3F3"/>
-                    </a:solidFill>
-                  </a:tcPr>
-                </a:tc>
-                <a:tc>
-                  <a:txBody>
-                    <a:bodyPr/>
-                    <a:lstStyle/>
-                    <a:p>
-                      <a:pPr>
-                        <a:defRPr sz="1300" b="0">
-                          <a:solidFill>
-                            <a:srgbClr val="173A49"/>
-                          </a:solidFill>
-                          <a:latin typeface="맑은 고딕"/>
-                        </a:defRPr>
-                      </a:pPr>
-                      <a:r>
-                        <a:t>89.7% / 14.9%</a:t>
-                      </a:r>
-                    </a:p>
-                  </a:txBody>
-                  <a:tcPr marL="118872" marR="91440" marT="64008" marB="54864" anchor="ctr">
-                    <a:solidFill>
-                      <a:srgbClr val="E8F3F3"/>
-                    </a:solidFill>
-                  </a:tcPr>
-                </a:tc>
-                <a:tc>
-                  <a:txBody>
-                    <a:bodyPr/>
-                    <a:lstStyle/>
-                    <a:p>
-                      <a:pPr>
-                        <a:defRPr sz="1300" b="0">
-                          <a:solidFill>
-                            <a:srgbClr val="173A49"/>
-                          </a:solidFill>
-                          <a:latin typeface="맑은 고딕"/>
-                        </a:defRPr>
-                      </a:pPr>
-                      <a:r>
-                        <a:t>공통 · 목표 미달</a:t>
-                      </a:r>
-                    </a:p>
-                  </a:txBody>
-                  <a:tcPr marL="118872" marR="91440" marT="64008" marB="54864" anchor="ctr">
-                    <a:solidFill>
-                      <a:srgbClr val="E8F3F3"/>
-                    </a:solidFill>
-                  </a:tcPr>
-                </a:tc>
-              </a:tr>
-              <a:tr h="629107">
-                <a:tc>
-                  <a:txBody>
-                    <a:bodyPr/>
-                    <a:lstStyle/>
-                    <a:p>
-                      <a:pPr>
-                        <a:defRPr sz="1300" b="0">
-                          <a:solidFill>
-                            <a:srgbClr val="173A49"/>
-                          </a:solidFill>
-                          <a:latin typeface="맑은 고딕"/>
-                        </a:defRPr>
-                      </a:pPr>
-                      <a:r>
-                        <a:t>C</a:t>
-                      </a:r>
-                    </a:p>
-                  </a:txBody>
-                  <a:tcPr marL="118872" marR="91440" marT="64008" marB="54864" anchor="ctr">
-                    <a:solidFill>
-                      <a:srgbClr val="FFFFFF"/>
-                    </a:solidFill>
-                  </a:tcPr>
-                </a:tc>
-                <a:tc>
-                  <a:txBody>
-                    <a:bodyPr/>
-                    <a:lstStyle/>
-                    <a:p>
-                      <a:pPr>
-                        <a:defRPr sz="1300" b="0">
-                          <a:solidFill>
-                            <a:srgbClr val="173A49"/>
-                          </a:solidFill>
-                          <a:latin typeface="맑은 고딕"/>
-                        </a:defRPr>
-                      </a:pPr>
-                      <a:r>
-                        <a:t>90.9% / 14.3%</a:t>
-                      </a:r>
-                    </a:p>
-                  </a:txBody>
-                  <a:tcPr marL="118872" marR="91440" marT="64008" marB="54864" anchor="ctr">
-                    <a:solidFill>
-                      <a:srgbClr val="FFFFFF"/>
-                    </a:solidFill>
-                  </a:tcPr>
-                </a:tc>
-                <a:tc>
-                  <a:txBody>
-                    <a:bodyPr/>
-                    <a:lstStyle/>
-                    <a:p>
-                      <a:pPr>
-                        <a:defRPr sz="1300" b="0">
-                          <a:solidFill>
-                            <a:srgbClr val="173A49"/>
-                          </a:solidFill>
-                          <a:latin typeface="맑은 고딕"/>
-                        </a:defRPr>
-                      </a:pPr>
-                      <a:r>
-                        <a:t>93.2% / 14.3%</a:t>
-                      </a:r>
-                    </a:p>
-                  </a:txBody>
-                  <a:tcPr marL="118872" marR="91440" marT="64008" marB="54864" anchor="ctr">
-                    <a:solidFill>
-                      <a:srgbClr val="FFFFFF"/>
-                    </a:solidFill>
-                  </a:tcPr>
-                </a:tc>
-                <a:tc>
-                  <a:txBody>
-                    <a:bodyPr/>
-                    <a:lstStyle/>
-                    <a:p>
-                      <a:pPr>
-                        <a:defRPr sz="1300" b="0">
-                          <a:solidFill>
-                            <a:srgbClr val="173A49"/>
-                          </a:solidFill>
-                          <a:latin typeface="맑은 고딕"/>
-                        </a:defRPr>
-                      </a:pPr>
-                      <a:r>
-                        <a:t>전용</a:t>
-                      </a:r>
-                    </a:p>
-                  </a:txBody>
-                  <a:tcPr marL="118872" marR="91440" marT="64008" marB="54864" anchor="ctr">
-                    <a:solidFill>
-                      <a:srgbClr val="FFFFFF"/>
-                    </a:solidFill>
-                  </a:tcPr>
-                </a:tc>
-              </a:tr>
-              <a:tr h="629107">
-                <a:tc>
-                  <a:txBody>
-                    <a:bodyPr/>
-                    <a:lstStyle/>
-                    <a:p>
-                      <a:pPr>
-                        <a:defRPr sz="1300" b="0">
-                          <a:solidFill>
-                            <a:srgbClr val="173A49"/>
-                          </a:solidFill>
-                          <a:latin typeface="맑은 고딕"/>
-                        </a:defRPr>
-                      </a:pPr>
-                      <a:r>
-                        <a:t>D</a:t>
-                      </a:r>
-                    </a:p>
-                  </a:txBody>
-                  <a:tcPr marL="118872" marR="91440" marT="64008" marB="54864" anchor="ctr">
-                    <a:solidFill>
-                      <a:srgbClr val="E8F3F3"/>
-                    </a:solidFill>
-                  </a:tcPr>
-                </a:tc>
-                <a:tc>
-                  <a:txBody>
-                    <a:bodyPr/>
-                    <a:lstStyle/>
-                    <a:p>
-                      <a:pPr>
-                        <a:defRPr sz="1300" b="0">
-                          <a:solidFill>
-                            <a:srgbClr val="173A49"/>
-                          </a:solidFill>
-                          <a:latin typeface="맑은 고딕"/>
-                        </a:defRPr>
-                      </a:pPr>
-                      <a:r>
-                        <a:t>98.2% / 8.3%</a:t>
-                      </a:r>
-                    </a:p>
-                  </a:txBody>
-                  <a:tcPr marL="118872" marR="91440" marT="64008" marB="54864" anchor="ctr">
-                    <a:solidFill>
-                      <a:srgbClr val="E8F3F3"/>
-                    </a:solidFill>
-                  </a:tcPr>
-                </a:tc>
-                <a:tc>
-                  <a:txBody>
-                    <a:bodyPr/>
-                    <a:lstStyle/>
-                    <a:p>
-                      <a:pPr>
-                        <a:defRPr sz="1300" b="0">
-                          <a:solidFill>
-                            <a:srgbClr val="173A49"/>
-                          </a:solidFill>
-                          <a:latin typeface="맑은 고딕"/>
-                        </a:defRPr>
-                      </a:pPr>
-                      <a:r>
-                        <a:t>98.2% / 13.9%</a:t>
-                      </a:r>
-                    </a:p>
-                  </a:txBody>
-                  <a:tcPr marL="118872" marR="91440" marT="64008" marB="54864" anchor="ctr">
-                    <a:solidFill>
-                      <a:srgbClr val="E8F3F3"/>
-                    </a:solidFill>
-                  </a:tcPr>
-                </a:tc>
-                <a:tc>
-                  <a:txBody>
-                    <a:bodyPr/>
-                    <a:lstStyle/>
-                    <a:p>
-                      <a:pPr>
-                        <a:defRPr sz="1300" b="0">
-                          <a:solidFill>
-                            <a:srgbClr val="173A49"/>
-                          </a:solidFill>
-                          <a:latin typeface="맑은 고딕"/>
-                        </a:defRPr>
-                      </a:pPr>
-                      <a:r>
-                        <a:t>공통</a:t>
-                      </a:r>
-                    </a:p>
-                  </a:txBody>
-                  <a:tcPr marL="118872" marR="91440" marT="64008" marB="54864" anchor="ctr">
-                    <a:solidFill>
-                      <a:srgbClr val="E8F3F3"/>
-                    </a:solidFill>
-                  </a:tcPr>
-                </a:tc>
-              </a:tr>
-            </a:tbl>
-          </a:graphicData>
-        </a:graphic>
-      </p:graphicFrame>
+              <a:t>BGE-M3 임베딩 + FAISS 벡터 저장·검색</a:t>
+            </a:r>
+          </a:p>
+        </p:txBody>
+      </p:sp>
+      <p:sp>
+        <p:nvSpPr>
+          <p:cNvPr id="10" name="TextBox 9"/>
+          <p:cNvSpPr txBox="1"/>
+          <p:nvPr/>
+        </p:nvSpPr>
+        <p:spPr>
+          <a:xfrm>
+            <a:off x="658368" y="3813048"/>
+            <a:ext cx="4526280" cy="804672"/>
+          </a:xfrm>
+          <a:prstGeom prst="rect">
+            <a:avLst/>
+          </a:prstGeom>
+          <a:noFill/>
+        </p:spPr>
+        <p:txBody>
+          <a:bodyPr wrap="square" lIns="18288" rIns="18288" tIns="18288" bIns="18288">
+            <a:spAutoFit/>
+          </a:bodyPr>
+          <a:lstStyle/>
+          <a:p>
+            <a:pPr>
+              <a:lnSpc>
+                <a:spcPct val="114000"/>
+              </a:lnSpc>
+              <a:spcAft>
+                <a:spcPts val="800"/>
+              </a:spcAft>
+              <a:defRPr sz="1900" b="0">
+                <a:solidFill>
+                  <a:srgbClr val="617681"/>
+                </a:solidFill>
+                <a:latin typeface="맑은 고딕"/>
+              </a:defRPr>
+            </a:pPr>
+            <a:r>
+              <a:t>실제 학습 연결: ExtraTrees·GaussianNB 두 후보 · 계획 승인 후 비교</a:t>
+            </a:r>
+          </a:p>
+        </p:txBody>
+      </p:sp>
+      <p:sp>
+        <p:nvSpPr>
+          <p:cNvPr id="11" name="Rounded Rectangle 10"/>
+          <p:cNvSpPr/>
+          <p:nvPr/>
+        </p:nvSpPr>
+        <p:spPr>
+          <a:xfrm>
+            <a:off x="5413248" y="1801367"/>
+            <a:ext cx="5998464" cy="4306824"/>
+          </a:xfrm>
+          <a:prstGeom prst="roundRect">
+            <a:avLst>
+              <a:gd name="adj" fmla="val 8000"/>
+            </a:avLst>
+          </a:prstGeom>
+          <a:solidFill>
+            <a:srgbClr val="FFFFFF"/>
+          </a:solidFill>
+          <a:ln>
+            <a:solidFill>
+              <a:srgbClr val="D8E3E7"/>
+            </a:solidFill>
+          </a:ln>
+        </p:spPr>
+        <p:style>
+          <a:lnRef idx="1">
+            <a:schemeClr val="accent1"/>
+          </a:lnRef>
+          <a:fillRef idx="3">
+            <a:schemeClr val="accent1"/>
+          </a:fillRef>
+          <a:effectRef idx="2">
+            <a:schemeClr val="accent1"/>
+          </a:effectRef>
+          <a:fontRef idx="minor">
+            <a:schemeClr val="lt1"/>
+          </a:fontRef>
+        </p:style>
+        <p:txBody>
+          <a:bodyPr rtlCol="0" anchor="ctr"/>
+          <a:lstStyle/>
+          <a:p>
+            <a:pPr algn="ctr"/>
+          </a:p>
+        </p:txBody>
+      </p:sp>
+      <p:pic>
+        <p:nvPicPr>
+          <p:cNvPr id="12" name="Picture 11" descr="app-rag-proof.jpg"/>
+          <p:cNvPicPr>
+            <a:picLocks noChangeAspect="1"/>
+          </p:cNvPicPr>
+          <p:nvPr/>
+        </p:nvPicPr>
+        <p:blipFill>
+          <a:blip r:embed="rId3"/>
+          <a:stretch>
+            <a:fillRect/>
+          </a:stretch>
+        </p:blipFill>
+        <p:spPr>
+          <a:xfrm>
+            <a:off x="6231627" y="1874519"/>
+            <a:ext cx="4361705" cy="4160520"/>
+          </a:xfrm>
+          <a:prstGeom prst="rect">
+            <a:avLst/>
+          </a:prstGeom>
+        </p:spPr>
+      </p:pic>
     </p:spTree>
   </p:cSld>
   <p:clrMapOvr>
@@ -9051,7 +8620,7 @@
               </a:defRPr>
             </a:pPr>
             <a:r>
-              <a:t>왜 이 비율을 선택했나요?</a:t>
+              <a:t>선택이 최적이라는 말은 어디까지인가요?</a:t>
             </a:r>
           </a:p>
         </p:txBody>
@@ -9263,7 +8832,7 @@
               </a:defRPr>
             </a:pPr>
             <a:r>
-              <a:t>Train: 학습 / Validation: 비율·판정 기준 선택 / Test: 선택 후 확인</a:t>
+              <a:t>실험1: 알고리즘·설정 고정 → 제품 그룹15개 구성 비교</a:t>
             </a:r>
           </a:p>
         </p:txBody>
@@ -9348,7 +8917,7 @@
               </a:defRPr>
             </a:pPr>
             <a:r>
-              <a:t>동일 제품 A+B+C+D의 Train 768건으로 세 모델 학습 · 분할768/256/256</a:t>
+              <a:t>실험2: 학습 제품ABCD 고정 → 세 모델의 혼합 비율232개 비교</a:t>
             </a:r>
           </a:p>
         </p:txBody>
@@ -9433,7 +9002,7 @@
               </a:defRPr>
             </a:pPr>
             <a:r>
-              <a:t>합계100% 비율을 5% 간격으로 모두 비교 + 균등 비율 = 232개</a:t>
+              <a:t>두 실험은 각각 조건을 통제했습니다. 그룹과 비율의 공동 전역 최적화가 아닙니다.</a:t>
             </a:r>
           </a:p>
         </p:txBody>
@@ -9518,7 +9087,7 @@
               </a:defRPr>
             </a:pPr>
             <a:r>
-              <a:t>정상 오판률15% 이하에서 Recall 최대 → 동률 F1 → 단순한 조합</a:t>
+              <a:t>선택은 Validation에서, 선택 후 확인은 Test에서 수행했습니다.</a:t>
             </a:r>
           </a:p>
         </p:txBody>
@@ -9603,7 +9172,7 @@
               </a:defRPr>
             </a:pPr>
             <a:r>
-              <a:t>이 후보·간격·Validation 범위의 최선이며, 새 독립 데이터 확인이 필요합니다.</a:t>
+              <a:t>기존 Test 재사용·작은 제품별 불량 표본 → 새 독립 기간 검증 필요</a:t>
             </a:r>
           </a:p>
         </p:txBody>
@@ -10443,7 +10012,7 @@
               </a:defRPr>
             </a:pPr>
             <a:r>
-              <a:t>02 · 사용자와 해결할 문제</a:t>
+              <a:t>02 · 신규 구현 | 프로젝트에서 설정한 업무 문제</a:t>
             </a:r>
           </a:p>
         </p:txBody>
@@ -10485,7 +10054,7 @@
               </a:defRPr>
             </a:pPr>
             <a:r>
-              <a:t>반복하던 모델·비율 비교를 한 흐름으로</a:t>
+              <a:t>모델 실험의 계획·비교·기록을 연결합니다</a:t>
             </a:r>
           </a:p>
         </p:txBody>
@@ -10782,7 +10351,7 @@
               </a:defRPr>
             </a:pPr>
             <a:r>
-              <a:t>반복 업무: 학습할 제품 묶음 선택 → 모델·혼합 비율 비교 → 근거 기록</a:t>
+              <a:t>해결할 업무: 학습할 제품 묶음 선택 → 모델·혼합 비율 비교 → 근거 기록</a:t>
             </a:r>
           </a:p>
         </p:txBody>
@@ -12246,7 +11815,7 @@
               </a:defRPr>
             </a:pPr>
             <a:r>
-              <a:t>05 · 실제 화면 | 비율 탐색도 승인 후 실행</a:t>
+              <a:t>05 · 실제 화면 | 제품 묶음과 혼합 비율을 각각 비교</a:t>
             </a:r>
           </a:p>
         </p:txBody>
@@ -12288,7 +11857,7 @@
               </a:defRPr>
             </a:pPr>
             <a:r>
-              <a:t>② 모델 비교 후, 비율 탐색 계획을 승인합니다</a:t>
+              <a:t>② 비교 범위를 확인하고 승인합니다</a:t>
             </a:r>
           </a:p>
         </p:txBody>
@@ -12457,26 +12026,7 @@
               </a:defRPr>
             </a:pPr>
             <a:r>
-              <a:t>결측·불균형 점검과</a:t>
-            </a:r>
-          </a:p>
-          <a:p>
-            <a:pPr>
-              <a:lnSpc>
-                <a:spcPct val="114000"/>
-              </a:lnSpc>
-              <a:spcAft>
-                <a:spcPts val="800"/>
-              </a:spcAft>
-              <a:defRPr sz="2200" b="1">
-                <a:solidFill>
-                  <a:srgbClr val="173A49"/>
-                </a:solidFill>
-                <a:latin typeface="맑은 고딕"/>
-              </a:defRPr>
-            </a:pPr>
-            <a:r>
-              <a:t>전처리 이유 확인</a:t>
+              <a:t>학습60% / 후보 선택20% / 마지막 확인20%</a:t>
             </a:r>
           </a:p>
         </p:txBody>
@@ -12518,7 +12068,7 @@
               </a:defRPr>
             </a:pPr>
             <a:r>
-              <a:t>학습60% / 후보 선택20% / 마지막 확인20% · 같은 lot은 분리</a:t>
+              <a:t>실험1: 알고리즘 고정 → 제품 그룹 구성15개 비교</a:t>
             </a:r>
           </a:p>
         </p:txBody>
@@ -12560,7 +12110,7 @@
               </a:defRPr>
             </a:pPr>
             <a:r>
-              <a:t>제품 묶음도 비교 · 오늘의 앙상블 사례는 A+B+C+D로 고정</a:t>
+              <a:t>실험2: 학습 제품ABCD 고정 → 혼합 비율232개 비교</a:t>
             </a:r>
           </a:p>
         </p:txBody>
@@ -12602,7 +12152,7 @@
               </a:defRPr>
             </a:pPr>
             <a:r>
-              <a:t>232개 비율 비교 · 엔지니어 승인 후 실행</a:t>
+              <a:t>계획·데이터 확인 → 엔지니어 승인 → 실제 실행</a:t>
             </a:r>
           </a:p>
         </p:txBody>
@@ -12656,7 +12206,7 @@
       </p:sp>
       <p:pic>
         <p:nvPicPr>
-          <p:cNvPr id="13" name="Picture 12" descr="app-ensemble-plan.jpg"/>
+          <p:cNvPr id="13" name="Picture 12" descr="app-grouping-plan.jpg"/>
           <p:cNvPicPr>
             <a:picLocks noChangeAspect="1"/>
           </p:cNvPicPr>
@@ -12670,8 +12220,8 @@
         </p:blipFill>
         <p:spPr>
           <a:xfrm>
-            <a:off x="6052002" y="1874519"/>
-            <a:ext cx="4720955" cy="4160520"/>
+            <a:off x="5848381" y="1874519"/>
+            <a:ext cx="5128197" cy="4160520"/>
           </a:xfrm>
           <a:prstGeom prst="rect">
             <a:avLst/>
@@ -12784,7 +12334,7 @@
               </a:defRPr>
             </a:pPr>
             <a:r>
-              <a:t>06 · 실제 화면 | Validation에서 비율과 판정 기준 선택</a:t>
+              <a:t>06 · 실험1 | CatBoost 설정 고정 · 그룹 구성15개 비교</a:t>
             </a:r>
           </a:p>
         </p:txBody>
@@ -12826,7 +12376,7 @@
               </a:defRPr>
             </a:pPr>
             <a:r>
-              <a:t>③ 선택 비율: CatBoost 90% + LightGBM 10%</a:t>
+              <a:t>③ 제품 묶음 선택: ABC 공통 모델 + D 전용 모델</a:t>
             </a:r>
           </a:p>
         </p:txBody>
@@ -13007,7 +12557,7 @@
       </p:sp>
       <p:pic>
         <p:nvPicPr>
-          <p:cNvPr id="9" name="Picture 8" descr="app-ensemble-validation.jpg"/>
+          <p:cNvPr id="9" name="Picture 8" descr="app-grouping-validation.jpg"/>
           <p:cNvPicPr>
             <a:picLocks noChangeAspect="1"/>
           </p:cNvPicPr>
@@ -13021,8 +12571,8 @@
         </p:blipFill>
         <p:spPr>
           <a:xfrm>
-            <a:off x="731520" y="2157137"/>
-            <a:ext cx="10716768" cy="3202092"/>
+            <a:off x="731519" y="2233816"/>
+            <a:ext cx="10716768" cy="3048735"/>
           </a:xfrm>
           <a:prstGeom prst="rect">
             <a:avLst/>
@@ -13038,7 +12588,7 @@
         <p:spPr>
           <a:xfrm>
             <a:off x="777240" y="5596128"/>
-            <a:ext cx="10698480" cy="365760"/>
+            <a:ext cx="10698480" cy="384048"/>
           </a:xfrm>
           <a:prstGeom prst="rect">
             <a:avLst/>
@@ -13058,15 +12608,15 @@
               <a:spcAft>
                 <a:spcPts val="800"/>
               </a:spcAft>
-              <a:defRPr sz="2000" b="1">
+              <a:defRPr sz="1900" b="1">
                 <a:solidFill>
-                  <a:srgbClr val="147D82"/>
+                  <a:srgbClr val="173A49"/>
                 </a:solidFill>
                 <a:latin typeface="맑은 고딕"/>
               </a:defRPr>
             </a:pPr>
             <a:r>
-              <a:t>검출률 100.0% 유지 · F1 0.808 → 0.816</a:t>
+              <a:t>Test: Recall 78.1% (25/32) · 목표 미달 → 적용 보류</a:t>
             </a:r>
           </a:p>
         </p:txBody>
@@ -13108,7 +12658,7 @@
               </a:defRPr>
             </a:pPr>
             <a:r>
-              <a:t>5% 간격과 균등 비율의 232개 비교 · 이 탐색 범위 안의 최선 · Test로 비율 선택하지 않음</a:t>
+              <a:t>Validation에서는 좋았지만 Test에서는 목표 미달 · 기존 Test 재사용 탐색 · 새 독립 데이터 필요</a:t>
             </a:r>
           </a:p>
         </p:txBody>
@@ -13219,7 +12769,7 @@
               </a:defRPr>
             </a:pPr>
             <a:r>
-              <a:t>07 · 실제 화면 | 같은 Test 256건: 불량32개 · 정상224개</a:t>
+              <a:t>07 · 실험2 | 학습 제품ABCD 고정 · Validation에서 비율 선택</a:t>
             </a:r>
           </a:p>
         </p:txBody>
@@ -13261,7 +12811,7 @@
               </a:defRPr>
             </a:pPr>
             <a:r>
-              <a:t>④ 같은 검출률을 유지하며 정상 오판을 줄였습니다</a:t>
+              <a:t>④ 선택 비율: CatBoost 90% + LightGBM 10%</a:t>
             </a:r>
           </a:p>
         </p:txBody>
@@ -13395,201 +12945,14 @@
       </p:sp>
       <p:sp>
         <p:nvSpPr>
-          <p:cNvPr id="8" name="TextBox 7"/>
-          <p:cNvSpPr txBox="1"/>
-          <p:nvPr/>
-        </p:nvSpPr>
-        <p:spPr>
-          <a:xfrm>
-            <a:off x="713232" y="2103120"/>
-            <a:ext cx="3886200" cy="795528"/>
-          </a:xfrm>
-          <a:prstGeom prst="rect">
-            <a:avLst/>
-          </a:prstGeom>
-          <a:noFill/>
-        </p:spPr>
-        <p:txBody>
-          <a:bodyPr wrap="square" lIns="18288" rIns="18288" tIns="18288" bIns="18288">
-            <a:spAutoFit/>
-          </a:bodyPr>
-          <a:lstStyle/>
-          <a:p>
-            <a:pPr>
-              <a:lnSpc>
-                <a:spcPct val="114000"/>
-              </a:lnSpc>
-              <a:spcAft>
-                <a:spcPts val="800"/>
-              </a:spcAft>
-              <a:defRPr sz="2400" b="1">
-                <a:solidFill>
-                  <a:srgbClr val="147D82"/>
-                </a:solidFill>
-                <a:latin typeface="맑은 고딕"/>
-              </a:defRPr>
-            </a:pPr>
-            <a:r>
-              <a:t>불량 발견 30 → 30개</a:t>
-            </a:r>
-          </a:p>
-        </p:txBody>
-      </p:sp>
-      <p:sp>
-        <p:nvSpPr>
-          <p:cNvPr id="9" name="TextBox 8"/>
-          <p:cNvSpPr txBox="1"/>
-          <p:nvPr/>
-        </p:nvSpPr>
-        <p:spPr>
-          <a:xfrm>
-            <a:off x="713232" y="3054096"/>
-            <a:ext cx="3886200" cy="795528"/>
-          </a:xfrm>
-          <a:prstGeom prst="rect">
-            <a:avLst/>
-          </a:prstGeom>
-          <a:noFill/>
-        </p:spPr>
-        <p:txBody>
-          <a:bodyPr wrap="square" lIns="18288" rIns="18288" tIns="18288" bIns="18288">
-            <a:spAutoFit/>
-          </a:bodyPr>
-          <a:lstStyle/>
-          <a:p>
-            <a:pPr>
-              <a:lnSpc>
-                <a:spcPct val="114000"/>
-              </a:lnSpc>
-              <a:spcAft>
-                <a:spcPts val="800"/>
-              </a:spcAft>
-              <a:defRPr sz="2400" b="1">
-                <a:solidFill>
-                  <a:srgbClr val="147D82"/>
-                </a:solidFill>
-                <a:latin typeface="맑은 고딕"/>
-              </a:defRPr>
-            </a:pPr>
-            <a:r>
-              <a:t>정상 오판 21 → 19개</a:t>
-            </a:r>
-          </a:p>
-        </p:txBody>
-      </p:sp>
-      <p:sp>
-        <p:nvSpPr>
-          <p:cNvPr id="10" name="TextBox 9"/>
-          <p:cNvSpPr txBox="1"/>
-          <p:nvPr/>
-        </p:nvSpPr>
-        <p:spPr>
-          <a:xfrm>
-            <a:off x="713232" y="4005072"/>
-            <a:ext cx="3886200" cy="795528"/>
-          </a:xfrm>
-          <a:prstGeom prst="rect">
-            <a:avLst/>
-          </a:prstGeom>
-          <a:noFill/>
-        </p:spPr>
-        <p:txBody>
-          <a:bodyPr wrap="square" lIns="18288" rIns="18288" tIns="18288" bIns="18288">
-            <a:spAutoFit/>
-          </a:bodyPr>
-          <a:lstStyle/>
-          <a:p>
-            <a:pPr>
-              <a:lnSpc>
-                <a:spcPct val="114000"/>
-              </a:lnSpc>
-              <a:spcAft>
-                <a:spcPts val="800"/>
-              </a:spcAft>
-              <a:defRPr sz="2100" b="1">
-                <a:solidFill>
-                  <a:srgbClr val="173A49"/>
-                </a:solidFill>
-                <a:latin typeface="맑은 고딕"/>
-              </a:defRPr>
-            </a:pPr>
-            <a:r>
-              <a:t>Test F1 0.723 → 0.741</a:t>
-            </a:r>
-          </a:p>
-        </p:txBody>
-      </p:sp>
-      <p:sp>
-        <p:nvSpPr>
-          <p:cNvPr id="11" name="TextBox 10"/>
-          <p:cNvSpPr txBox="1"/>
-          <p:nvPr/>
-        </p:nvSpPr>
-        <p:spPr>
-          <a:xfrm>
-            <a:off x="713232" y="4956048"/>
-            <a:ext cx="3886200" cy="795528"/>
-          </a:xfrm>
-          <a:prstGeom prst="rect">
-            <a:avLst/>
-          </a:prstGeom>
-          <a:noFill/>
-        </p:spPr>
-        <p:txBody>
-          <a:bodyPr wrap="square" lIns="18288" rIns="18288" tIns="18288" bIns="18288">
-            <a:spAutoFit/>
-          </a:bodyPr>
-          <a:lstStyle/>
-          <a:p>
-            <a:pPr>
-              <a:lnSpc>
-                <a:spcPct val="114000"/>
-              </a:lnSpc>
-              <a:spcAft>
-                <a:spcPts val="800"/>
-              </a:spcAft>
-              <a:defRPr sz="2100" b="1">
-                <a:solidFill>
-                  <a:srgbClr val="173A49"/>
-                </a:solidFill>
-                <a:latin typeface="맑은 고딕"/>
-              </a:defRPr>
-            </a:pPr>
-            <a:r>
-              <a:t>검출률 93.8% · 시연 목표 충족</a:t>
-            </a:r>
-          </a:p>
-          <a:p>
-            <a:pPr>
-              <a:lnSpc>
-                <a:spcPct val="114000"/>
-              </a:lnSpc>
-              <a:spcAft>
-                <a:spcPts val="800"/>
-              </a:spcAft>
-              <a:defRPr sz="2100" b="1">
-                <a:solidFill>
-                  <a:srgbClr val="173A49"/>
-                </a:solidFill>
-                <a:latin typeface="맑은 고딕"/>
-              </a:defRPr>
-            </a:pPr>
-            <a:r>
-              <a:t>새 독립 데이터 검증 필요</a:t>
-            </a:r>
-          </a:p>
-        </p:txBody>
-      </p:sp>
-      <p:sp>
-        <p:nvSpPr>
-          <p:cNvPr id="12" name="Rounded Rectangle 11"/>
+          <p:cNvPr id="8" name="Rounded Rectangle 7"/>
           <p:cNvSpPr/>
           <p:nvPr/>
         </p:nvSpPr>
         <p:spPr>
           <a:xfrm>
-            <a:off x="4910328" y="1847088"/>
-            <a:ext cx="6574536" cy="4306824"/>
+            <a:off x="658368" y="1938528"/>
+            <a:ext cx="10863072" cy="3639312"/>
           </a:xfrm>
           <a:prstGeom prst="roundRect">
             <a:avLst>
@@ -13629,7 +12992,7 @@
       </p:sp>
       <p:pic>
         <p:nvPicPr>
-          <p:cNvPr id="13" name="Picture 12" descr="app-ensemble-test.jpg"/>
+          <p:cNvPr id="9" name="Picture 8" descr="app-ensemble-validation.jpg"/>
           <p:cNvPicPr>
             <a:picLocks noChangeAspect="1"/>
           </p:cNvPicPr>
@@ -13643,14 +13006,98 @@
         </p:blipFill>
         <p:spPr>
           <a:xfrm>
-            <a:off x="4983480" y="2167095"/>
-            <a:ext cx="6428232" cy="3666808"/>
+            <a:off x="731520" y="2157137"/>
+            <a:ext cx="10716768" cy="3202092"/>
           </a:xfrm>
           <a:prstGeom prst="rect">
             <a:avLst/>
           </a:prstGeom>
         </p:spPr>
       </p:pic>
+      <p:sp>
+        <p:nvSpPr>
+          <p:cNvPr id="10" name="TextBox 9"/>
+          <p:cNvSpPr txBox="1"/>
+          <p:nvPr/>
+        </p:nvSpPr>
+        <p:spPr>
+          <a:xfrm>
+            <a:off x="777240" y="5596128"/>
+            <a:ext cx="10698480" cy="365760"/>
+          </a:xfrm>
+          <a:prstGeom prst="rect">
+            <a:avLst/>
+          </a:prstGeom>
+          <a:noFill/>
+        </p:spPr>
+        <p:txBody>
+          <a:bodyPr wrap="square" lIns="18288" rIns="18288" tIns="18288" bIns="18288">
+            <a:spAutoFit/>
+          </a:bodyPr>
+          <a:lstStyle/>
+          <a:p>
+            <a:pPr>
+              <a:lnSpc>
+                <a:spcPct val="114000"/>
+              </a:lnSpc>
+              <a:spcAft>
+                <a:spcPts val="800"/>
+              </a:spcAft>
+              <a:defRPr sz="2000" b="1">
+                <a:solidFill>
+                  <a:srgbClr val="147D82"/>
+                </a:solidFill>
+                <a:latin typeface="맑은 고딕"/>
+              </a:defRPr>
+            </a:pPr>
+            <a:r>
+              <a:t>검출률 100.0% 유지 · F1 0.808 → 0.816</a:t>
+            </a:r>
+          </a:p>
+        </p:txBody>
+      </p:sp>
+      <p:sp>
+        <p:nvSpPr>
+          <p:cNvPr id="11" name="TextBox 10"/>
+          <p:cNvSpPr txBox="1"/>
+          <p:nvPr/>
+        </p:nvSpPr>
+        <p:spPr>
+          <a:xfrm>
+            <a:off x="777240" y="6053328"/>
+            <a:ext cx="10698480" cy="219456"/>
+          </a:xfrm>
+          <a:prstGeom prst="rect">
+            <a:avLst/>
+          </a:prstGeom>
+          <a:noFill/>
+        </p:spPr>
+        <p:txBody>
+          <a:bodyPr wrap="square" lIns="18288" rIns="18288" tIns="18288" bIns="18288">
+            <a:spAutoFit/>
+          </a:bodyPr>
+          <a:lstStyle/>
+          <a:p>
+            <a:pPr>
+              <a:lnSpc>
+                <a:spcPct val="114000"/>
+              </a:lnSpc>
+              <a:spcAft>
+                <a:spcPts val="800"/>
+              </a:spcAft>
+              <a:defRPr sz="1200" b="0">
+                <a:solidFill>
+                  <a:srgbClr val="617681"/>
+                </a:solidFill>
+                <a:latin typeface="맑은 고딕"/>
+              </a:defRPr>
+            </a:pPr>
+            <a:r>
+              <a:t>5% 간격과 균등 비율의 232개 비교 · 이 탐색 범위 안의 최선 · Test로 비율 선택하지 않음</a:t>
+            </a:r>
+          </a:p>
+        </p:txBody>
+      </p:sp>
     </p:spTree>
   </p:cSld>
   <p:clrMapOvr>
@@ -13757,7 +13204,7 @@
               </a:defRPr>
             </a:pPr>
             <a:r>
-              <a:t>08 · 실제 검색 기록의 UI 재현 | RAG = 관련 근거 검색</a:t>
+              <a:t>08 · 실험2의 Test 확인 | 불량32개 · 정상224개</a:t>
             </a:r>
           </a:p>
         </p:txBody>
@@ -13799,7 +13246,7 @@
               </a:defRPr>
             </a:pPr>
             <a:r>
-              <a:t>⑤ 공식 문서에서 비교 후보를 추가할 수 있습니다</a:t>
+              <a:t>⑤ 같은 검출률을 유지하며 정상 오판을 줄였습니다</a:t>
             </a:r>
           </a:p>
         </p:txBody>
@@ -13939,8 +13386,8 @@
         </p:nvSpPr>
         <p:spPr>
           <a:xfrm>
-            <a:off x="658368" y="2057400"/>
-            <a:ext cx="4526280" cy="804672"/>
+            <a:off x="713232" y="2103120"/>
+            <a:ext cx="3886200" cy="795528"/>
           </a:xfrm>
           <a:prstGeom prst="rect">
             <a:avLst/>
@@ -13960,15 +13407,15 @@
               <a:spcAft>
                 <a:spcPts val="800"/>
               </a:spcAft>
-              <a:defRPr sz="2200" b="1">
+              <a:defRPr sz="2400" b="1">
                 <a:solidFill>
-                  <a:srgbClr val="173A49"/>
+                  <a:srgbClr val="147D82"/>
                 </a:solidFill>
                 <a:latin typeface="맑은 고딕"/>
               </a:defRPr>
             </a:pPr>
             <a:r>
-              <a:t>공식 문서 조회 → 근거 검색 → 후보와 제안 이유 제시</a:t>
+              <a:t>불량 발견 30 → 30개</a:t>
             </a:r>
           </a:p>
         </p:txBody>
@@ -13981,8 +13428,8 @@
         </p:nvSpPr>
         <p:spPr>
           <a:xfrm>
-            <a:off x="658368" y="2935224"/>
-            <a:ext cx="4526280" cy="804672"/>
+            <a:off x="713232" y="3054096"/>
+            <a:ext cx="3886200" cy="795528"/>
           </a:xfrm>
           <a:prstGeom prst="rect">
             <a:avLst/>
@@ -14002,15 +13449,15 @@
               <a:spcAft>
                 <a:spcPts val="800"/>
               </a:spcAft>
-              <a:defRPr sz="1900" b="0">
+              <a:defRPr sz="2400" b="1">
                 <a:solidFill>
-                  <a:srgbClr val="617681"/>
+                  <a:srgbClr val="147D82"/>
                 </a:solidFill>
                 <a:latin typeface="맑은 고딕"/>
               </a:defRPr>
             </a:pPr>
             <a:r>
-              <a:t>ExtraTrees·GaussianNB 두 모델을 추가할 수 있습니다.</a:t>
+              <a:t>정상 오판 21 → 19개</a:t>
             </a:r>
           </a:p>
         </p:txBody>
@@ -14023,8 +13470,8 @@
         </p:nvSpPr>
         <p:spPr>
           <a:xfrm>
-            <a:off x="658368" y="3813048"/>
-            <a:ext cx="4526280" cy="804672"/>
+            <a:off x="713232" y="4005072"/>
+            <a:ext cx="3886200" cy="795528"/>
           </a:xfrm>
           <a:prstGeom prst="rect">
             <a:avLst/>
@@ -14044,29 +13491,90 @@
               <a:spcAft>
                 <a:spcPts val="800"/>
               </a:spcAft>
-              <a:defRPr sz="1900" b="0">
+              <a:defRPr sz="2100" b="1">
                 <a:solidFill>
-                  <a:srgbClr val="617681"/>
+                  <a:srgbClr val="173A49"/>
                 </a:solidFill>
                 <a:latin typeface="맑은 고딕"/>
               </a:defRPr>
             </a:pPr>
             <a:r>
-              <a:t>근거 확인 → 계획 승인 → 기존 후보와 학습·비교</a:t>
-            </a:r>
-          </a:p>
-        </p:txBody>
-      </p:sp>
-      <p:sp>
-        <p:nvSpPr>
-          <p:cNvPr id="11" name="Rounded Rectangle 10"/>
+              <a:t>Test F1 0.723 → 0.741</a:t>
+            </a:r>
+          </a:p>
+        </p:txBody>
+      </p:sp>
+      <p:sp>
+        <p:nvSpPr>
+          <p:cNvPr id="11" name="TextBox 10"/>
+          <p:cNvSpPr txBox="1"/>
+          <p:nvPr/>
+        </p:nvSpPr>
+        <p:spPr>
+          <a:xfrm>
+            <a:off x="713232" y="4956048"/>
+            <a:ext cx="3886200" cy="795528"/>
+          </a:xfrm>
+          <a:prstGeom prst="rect">
+            <a:avLst/>
+          </a:prstGeom>
+          <a:noFill/>
+        </p:spPr>
+        <p:txBody>
+          <a:bodyPr wrap="square" lIns="18288" rIns="18288" tIns="18288" bIns="18288">
+            <a:spAutoFit/>
+          </a:bodyPr>
+          <a:lstStyle/>
+          <a:p>
+            <a:pPr>
+              <a:lnSpc>
+                <a:spcPct val="114000"/>
+              </a:lnSpc>
+              <a:spcAft>
+                <a:spcPts val="800"/>
+              </a:spcAft>
+              <a:defRPr sz="2100" b="1">
+                <a:solidFill>
+                  <a:srgbClr val="173A49"/>
+                </a:solidFill>
+                <a:latin typeface="맑은 고딕"/>
+              </a:defRPr>
+            </a:pPr>
+            <a:r>
+              <a:t>검출률 93.8% · 시연 목표 충족</a:t>
+            </a:r>
+          </a:p>
+          <a:p>
+            <a:pPr>
+              <a:lnSpc>
+                <a:spcPct val="114000"/>
+              </a:lnSpc>
+              <a:spcAft>
+                <a:spcPts val="800"/>
+              </a:spcAft>
+              <a:defRPr sz="2100" b="1">
+                <a:solidFill>
+                  <a:srgbClr val="173A49"/>
+                </a:solidFill>
+                <a:latin typeface="맑은 고딕"/>
+              </a:defRPr>
+            </a:pPr>
+            <a:r>
+              <a:t>새 독립 데이터 검증 필요</a:t>
+            </a:r>
+          </a:p>
+        </p:txBody>
+      </p:sp>
+      <p:sp>
+        <p:nvSpPr>
+          <p:cNvPr id="12" name="Rounded Rectangle 11"/>
           <p:cNvSpPr/>
           <p:nvPr/>
         </p:nvSpPr>
         <p:spPr>
           <a:xfrm>
-            <a:off x="5413248" y="1801367"/>
-            <a:ext cx="5998464" cy="4306824"/>
+            <a:off x="4910328" y="1847088"/>
+            <a:ext cx="6574536" cy="4306824"/>
           </a:xfrm>
           <a:prstGeom prst="roundRect">
             <a:avLst>
@@ -14106,7 +13614,7 @@
       </p:sp>
       <p:pic>
         <p:nvPicPr>
-          <p:cNvPr id="12" name="Picture 11" descr="app-rag-proof.jpg"/>
+          <p:cNvPr id="13" name="Picture 12" descr="app-ensemble-test.jpg"/>
           <p:cNvPicPr>
             <a:picLocks noChangeAspect="1"/>
           </p:cNvPicPr>
@@ -14120,8 +13628,8 @@
         </p:blipFill>
         <p:spPr>
           <a:xfrm>
-            <a:off x="5486400" y="2447583"/>
-            <a:ext cx="5852160" cy="3014392"/>
+            <a:off x="4983480" y="2167095"/>
+            <a:ext cx="6428232" cy="3666808"/>
           </a:xfrm>
           <a:prstGeom prst="rect">
             <a:avLst/>
@@ -14452,7 +13960,49 @@
       </p:sp>
       <p:sp>
         <p:nvSpPr>
-          <p:cNvPr id="9" name="Rounded Rectangle 8"/>
+          <p:cNvPr id="9" name="TextBox 8"/>
+          <p:cNvSpPr txBox="1"/>
+          <p:nvPr/>
+        </p:nvSpPr>
+        <p:spPr>
+          <a:xfrm>
+            <a:off x="658368" y="2359152"/>
+            <a:ext cx="10881360" cy="228600"/>
+          </a:xfrm>
+          <a:prstGeom prst="rect">
+            <a:avLst/>
+          </a:prstGeom>
+          <a:noFill/>
+        </p:spPr>
+        <p:txBody>
+          <a:bodyPr wrap="square" lIns="18288" rIns="18288" tIns="18288" bIns="18288">
+            <a:spAutoFit/>
+          </a:bodyPr>
+          <a:lstStyle/>
+          <a:p>
+            <a:pPr>
+              <a:lnSpc>
+                <a:spcPct val="114000"/>
+              </a:lnSpc>
+              <a:spcAft>
+                <a:spcPts val="800"/>
+              </a:spcAft>
+              <a:defRPr sz="1300" b="0">
+                <a:solidFill>
+                  <a:srgbClr val="147D82"/>
+                </a:solidFill>
+                <a:latin typeface="맑은 고딕"/>
+              </a:defRPr>
+            </a:pPr>
+            <a:r>
+              <a:t>RAG: 내부 근거·공식 문서 → BGE-M3 임베딩 → FAISS 검색 → Qwen에 근거 전달</a:t>
+            </a:r>
+          </a:p>
+        </p:txBody>
+      </p:sp>
+      <p:sp>
+        <p:nvSpPr>
+          <p:cNvPr id="10" name="Rounded Rectangle 9"/>
           <p:cNvSpPr/>
           <p:nvPr/>
         </p:nvSpPr>
@@ -14497,7 +14047,7 @@
       </p:sp>
       <p:sp>
         <p:nvSpPr>
-          <p:cNvPr id="10" name="TextBox 9"/>
+          <p:cNvPr id="11" name="TextBox 10"/>
           <p:cNvSpPr txBox="1"/>
           <p:nvPr/>
         </p:nvSpPr>
@@ -14539,7 +14089,7 @@
       </p:sp>
       <p:sp>
         <p:nvSpPr>
-          <p:cNvPr id="11" name="TextBox 10"/>
+          <p:cNvPr id="12" name="TextBox 11"/>
           <p:cNvSpPr txBox="1"/>
           <p:nvPr/>
         </p:nvSpPr>
@@ -14581,7 +14131,7 @@
       </p:sp>
       <p:sp>
         <p:nvSpPr>
-          <p:cNvPr id="12" name="TextBox 11"/>
+          <p:cNvPr id="13" name="TextBox 12"/>
           <p:cNvSpPr txBox="1"/>
           <p:nvPr/>
         </p:nvSpPr>
@@ -14623,7 +14173,7 @@
       </p:sp>
       <p:sp>
         <p:nvSpPr>
-          <p:cNvPr id="13" name="Rounded Rectangle 12"/>
+          <p:cNvPr id="14" name="Rounded Rectangle 13"/>
           <p:cNvSpPr/>
           <p:nvPr/>
         </p:nvSpPr>
@@ -14668,7 +14218,7 @@
       </p:sp>
       <p:sp>
         <p:nvSpPr>
-          <p:cNvPr id="14" name="TextBox 13"/>
+          <p:cNvPr id="15" name="TextBox 14"/>
           <p:cNvSpPr txBox="1"/>
           <p:nvPr/>
         </p:nvSpPr>
@@ -14710,7 +14260,7 @@
       </p:sp>
       <p:sp>
         <p:nvSpPr>
-          <p:cNvPr id="15" name="TextBox 14"/>
+          <p:cNvPr id="16" name="TextBox 15"/>
           <p:cNvSpPr txBox="1"/>
           <p:nvPr/>
         </p:nvSpPr>
@@ -14745,14 +14295,14 @@
               </a:defRPr>
             </a:pPr>
             <a:r>
-              <a:t>교육 근거 / 공식 문서</a:t>
-            </a:r>
-          </a:p>
-        </p:txBody>
-      </p:sp>
-      <p:sp>
-        <p:nvSpPr>
-          <p:cNvPr id="16" name="TextBox 15"/>
+              <a:t>BGE-M3 · FAISS</a:t>
+            </a:r>
+          </a:p>
+        </p:txBody>
+      </p:sp>
+      <p:sp>
+        <p:nvSpPr>
+          <p:cNvPr id="17" name="TextBox 16"/>
           <p:cNvSpPr txBox="1"/>
           <p:nvPr/>
         </p:nvSpPr>
@@ -14794,7 +14344,7 @@
       </p:sp>
       <p:sp>
         <p:nvSpPr>
-          <p:cNvPr id="17" name="Rounded Rectangle 16"/>
+          <p:cNvPr id="18" name="Rounded Rectangle 17"/>
           <p:cNvSpPr/>
           <p:nvPr/>
         </p:nvSpPr>
@@ -14839,7 +14389,7 @@
       </p:sp>
       <p:sp>
         <p:nvSpPr>
-          <p:cNvPr id="18" name="TextBox 17"/>
+          <p:cNvPr id="19" name="TextBox 18"/>
           <p:cNvSpPr txBox="1"/>
           <p:nvPr/>
         </p:nvSpPr>
@@ -14881,7 +14431,7 @@
       </p:sp>
       <p:sp>
         <p:nvSpPr>
-          <p:cNvPr id="19" name="TextBox 18"/>
+          <p:cNvPr id="20" name="TextBox 19"/>
           <p:cNvSpPr txBox="1"/>
           <p:nvPr/>
         </p:nvSpPr>
@@ -14923,7 +14473,7 @@
       </p:sp>
       <p:sp>
         <p:nvSpPr>
-          <p:cNvPr id="20" name="TextBox 19"/>
+          <p:cNvPr id="21" name="TextBox 20"/>
           <p:cNvSpPr txBox="1"/>
           <p:nvPr/>
         </p:nvSpPr>
@@ -14965,7 +14515,7 @@
       </p:sp>
       <p:sp>
         <p:nvSpPr>
-          <p:cNvPr id="21" name="Rounded Rectangle 20"/>
+          <p:cNvPr id="22" name="Rounded Rectangle 21"/>
           <p:cNvSpPr/>
           <p:nvPr/>
         </p:nvSpPr>
@@ -15010,7 +14560,7 @@
       </p:sp>
       <p:sp>
         <p:nvSpPr>
-          <p:cNvPr id="22" name="TextBox 21"/>
+          <p:cNvPr id="23" name="TextBox 22"/>
           <p:cNvSpPr txBox="1"/>
           <p:nvPr/>
         </p:nvSpPr>
@@ -15052,7 +14602,7 @@
       </p:sp>
       <p:sp>
         <p:nvSpPr>
-          <p:cNvPr id="23" name="TextBox 22"/>
+          <p:cNvPr id="24" name="TextBox 23"/>
           <p:cNvSpPr txBox="1"/>
           <p:nvPr/>
         </p:nvSpPr>
@@ -15094,7 +14644,7 @@
       </p:sp>
       <p:sp>
         <p:nvSpPr>
-          <p:cNvPr id="24" name="Rounded Rectangle 23"/>
+          <p:cNvPr id="25" name="Rounded Rectangle 24"/>
           <p:cNvSpPr/>
           <p:nvPr/>
         </p:nvSpPr>
@@ -15141,7 +14691,7 @@
       </p:sp>
       <p:sp>
         <p:nvSpPr>
-          <p:cNvPr id="25" name="TextBox 24"/>
+          <p:cNvPr id="26" name="TextBox 25"/>
           <p:cNvSpPr txBox="1"/>
           <p:nvPr/>
         </p:nvSpPr>
@@ -15183,7 +14733,7 @@
       </p:sp>
       <p:sp>
         <p:nvSpPr>
-          <p:cNvPr id="26" name="TextBox 25"/>
+          <p:cNvPr id="27" name="TextBox 26"/>
           <p:cNvSpPr txBox="1"/>
           <p:nvPr/>
         </p:nvSpPr>
@@ -15225,7 +14775,7 @@
       </p:sp>
       <p:sp>
         <p:nvSpPr>
-          <p:cNvPr id="27" name="TextBox 26"/>
+          <p:cNvPr id="28" name="TextBox 27"/>
           <p:cNvSpPr txBox="1"/>
           <p:nvPr/>
         </p:nvSpPr>
@@ -15260,7 +14810,7 @@
               </a:defRPr>
             </a:pPr>
             <a:r>
-              <a:t>설명 검사(LLM-as-a-Judge): 6/8개 올바른 판단 · 코드 테스트 42개 통과</a:t>
+              <a:t>설명 검사(LLM-as-a-Judge): 6/8개 올바른 판단 · 코드 테스트 51개 통과</a:t>
             </a:r>
           </a:p>
         </p:txBody>

</xml_diff>

<commit_message>
Explain defect recall and false alarms for presentation audience
</commit_message>
<xml_diff>
--- a/docs/G045_Semiconductor_Agent.pptx
+++ b/docs/G045_Semiconductor_Agent.pptx
@@ -2,29 +2,29 @@
 <file path=ppt/presentation.xml><?xml version="1.0" encoding="utf-8"?>
 <p:presentation xmlns:p="http://schemas.openxmlformats.org/presentationml/2006/main">
   <p:sldMasterIdLst>
-    <p:sldMasterId xmlns:r="http://schemas.openxmlformats.org/officeDocument/2006/relationships" id="2147483648" r:id="R509db2e84029477c"/>
+    <p:sldMasterId xmlns:r="http://schemas.openxmlformats.org/officeDocument/2006/relationships" id="2147483648" r:id="Rffb7fb2f08e941af"/>
   </p:sldMasterIdLst>
   <p:notesMasterIdLst>
-    <p:notesMasterId xmlns:r="http://schemas.openxmlformats.org/officeDocument/2006/relationships" r:id="R2506aae0ed454e54"/>
+    <p:notesMasterId xmlns:r="http://schemas.openxmlformats.org/officeDocument/2006/relationships" r:id="R258fe2328ae44216"/>
   </p:notesMasterIdLst>
   <p:sldIdLst>
-    <p:sldId xmlns:r="http://schemas.openxmlformats.org/officeDocument/2006/relationships" id="256" r:id="Rf6af80ced9ae4f39"/>
-    <p:sldId xmlns:r="http://schemas.openxmlformats.org/officeDocument/2006/relationships" id="257" r:id="Rd1adbbb9a681424a"/>
-    <p:sldId xmlns:r="http://schemas.openxmlformats.org/officeDocument/2006/relationships" id="258" r:id="Re90fba76140c461b"/>
-    <p:sldId xmlns:r="http://schemas.openxmlformats.org/officeDocument/2006/relationships" id="259" r:id="R2260e114748a4f9c"/>
-    <p:sldId xmlns:r="http://schemas.openxmlformats.org/officeDocument/2006/relationships" id="260" r:id="R57bab63281414f56"/>
-    <p:sldId xmlns:r="http://schemas.openxmlformats.org/officeDocument/2006/relationships" id="261" r:id="R4041fe2ce183499b"/>
-    <p:sldId xmlns:r="http://schemas.openxmlformats.org/officeDocument/2006/relationships" id="262" r:id="R85a450fddf47497b"/>
-    <p:sldId xmlns:r="http://schemas.openxmlformats.org/officeDocument/2006/relationships" id="263" r:id="Ra320be18439d4aff"/>
-    <p:sldId xmlns:r="http://schemas.openxmlformats.org/officeDocument/2006/relationships" id="264" r:id="R0d2f1916346f4d4d"/>
-    <p:sldId xmlns:r="http://schemas.openxmlformats.org/officeDocument/2006/relationships" id="265" r:id="R49517fb02c2c46ad"/>
-    <p:sldId xmlns:r="http://schemas.openxmlformats.org/officeDocument/2006/relationships" id="266" r:id="Rd63235da742e48ee"/>
-    <p:sldId xmlns:r="http://schemas.openxmlformats.org/officeDocument/2006/relationships" id="267" r:id="R2cda8ad1823c4bae"/>
-    <p:sldId xmlns:r="http://schemas.openxmlformats.org/officeDocument/2006/relationships" id="268" r:id="R0d2d05be58aa4262"/>
-    <p:sldId xmlns:r="http://schemas.openxmlformats.org/officeDocument/2006/relationships" id="269" r:id="R51f622ba12f64813"/>
-    <p:sldId xmlns:r="http://schemas.openxmlformats.org/officeDocument/2006/relationships" id="270" r:id="Rc7f3889e21e44b6e"/>
-    <p:sldId xmlns:r="http://schemas.openxmlformats.org/officeDocument/2006/relationships" id="271" r:id="R71905b1895c84abf"/>
-    <p:sldId xmlns:r="http://schemas.openxmlformats.org/officeDocument/2006/relationships" id="272" r:id="Rd28a9a90820645bc"/>
+    <p:sldId xmlns:r="http://schemas.openxmlformats.org/officeDocument/2006/relationships" id="256" r:id="R7aacc9baab57487d"/>
+    <p:sldId xmlns:r="http://schemas.openxmlformats.org/officeDocument/2006/relationships" id="257" r:id="Rc5c511e40ade4ca3"/>
+    <p:sldId xmlns:r="http://schemas.openxmlformats.org/officeDocument/2006/relationships" id="258" r:id="R425e4a622e1d424e"/>
+    <p:sldId xmlns:r="http://schemas.openxmlformats.org/officeDocument/2006/relationships" id="259" r:id="R6241b83016b647f0"/>
+    <p:sldId xmlns:r="http://schemas.openxmlformats.org/officeDocument/2006/relationships" id="260" r:id="R925d91c417e543d5"/>
+    <p:sldId xmlns:r="http://schemas.openxmlformats.org/officeDocument/2006/relationships" id="261" r:id="Rddce758ad28f4ecf"/>
+    <p:sldId xmlns:r="http://schemas.openxmlformats.org/officeDocument/2006/relationships" id="262" r:id="Ref6ad35f67e64eb5"/>
+    <p:sldId xmlns:r="http://schemas.openxmlformats.org/officeDocument/2006/relationships" id="263" r:id="Rdd14bbce99dc40b5"/>
+    <p:sldId xmlns:r="http://schemas.openxmlformats.org/officeDocument/2006/relationships" id="264" r:id="Rd8fabae31c5b4296"/>
+    <p:sldId xmlns:r="http://schemas.openxmlformats.org/officeDocument/2006/relationships" id="265" r:id="Ree58da51ac614631"/>
+    <p:sldId xmlns:r="http://schemas.openxmlformats.org/officeDocument/2006/relationships" id="266" r:id="Rfdf3ad76d0b54b15"/>
+    <p:sldId xmlns:r="http://schemas.openxmlformats.org/officeDocument/2006/relationships" id="267" r:id="Rcfa41cdae4cd4832"/>
+    <p:sldId xmlns:r="http://schemas.openxmlformats.org/officeDocument/2006/relationships" id="268" r:id="Rac5799d49978447a"/>
+    <p:sldId xmlns:r="http://schemas.openxmlformats.org/officeDocument/2006/relationships" id="269" r:id="R91c0da6a81e14e10"/>
+    <p:sldId xmlns:r="http://schemas.openxmlformats.org/officeDocument/2006/relationships" id="270" r:id="R26f7d0864a5547de"/>
+    <p:sldId xmlns:r="http://schemas.openxmlformats.org/officeDocument/2006/relationships" id="271" r:id="R3b988748b3fa4a88"/>
+    <p:sldId xmlns:r="http://schemas.openxmlformats.org/officeDocument/2006/relationships" id="272" r:id="R55f46c76ceb54a4e"/>
   </p:sldIdLst>
   <p:sldSz cx="12191999" cy="6858000"/>
   <p:notesSz cx="6858000" cy="9144000"/>
@@ -585,7 +585,7 @@
           <a:lstStyle xmlns:a="http://schemas.openxmlformats.org/drawingml/2006/main"/>
           <a:p xmlns:a="http://schemas.openxmlformats.org/drawingml/2006/main">
             <a:r>
-              <a:t>안녕하세요. SKALA 광주 2반 G045 김용찬입니다. 반도체 검사 모델을 처음 비교할 때부터 성능 점검과 재학습까지 돕는 Agent를 만들었습니다.</a:t>
+              <a:t>안녕하세요. SKALA 광주 2반 G045 김용찬입니다. 반도체 검사 모델을 비교하고, 이후 성능 점검과 재학습까지 돕는 Agent를 만들었습니다.</a:t>
             </a:r>
           </a:p>
           <a:p xmlns:a="http://schemas.openxmlformats.org/drawingml/2006/main">
@@ -665,7 +665,7 @@
           <a:lstStyle xmlns:a="http://schemas.openxmlformats.org/drawingml/2006/main"/>
           <a:p xmlns:a="http://schemas.openxmlformats.org/drawingml/2006/main">
             <a:r>
-              <a:t>계획을 승인하면 같은 CatBoost로 재학습합니다. 새 배치의 같은 Test에서 불량 발견이 백육십일곱 개 중 마흔세 개에서 백쉰세 개로 늘었고, 정상 오판은 아흔여섯 개에서 일흔아홉 개로 줄었습니다. 후보와 버전 기록을 저장하며 운영 모델은 자동 교체하지 않습니다.</a:t>
+              <a:t>엔지니어가 승인하면 같은 CatBoost로 새 데이터를 다시 학습합니다. 같은 마지막 시험에서 불량 발견이 백육십일곱 개 중 마흔세 개에서 백쉰세 개로 늘었습니다. 정상 오판은 아흔여섯 개에서 일흔아홉 개로 줄었습니다. 재학습 후보를 저장하고, 운영 모델 교체는 엔지니어가 별도로 판단합니다.</a:t>
             </a:r>
           </a:p>
           <a:p xmlns:a="http://schemas.openxmlformats.org/drawingml/2006/main">
@@ -675,7 +675,12 @@
           </a:p>
           <a:p xmlns:a="http://schemas.openxmlformats.org/drawingml/2006/main">
             <a:r>
-              <a:t>출처: app/monitoring.py, docs/evaluation/lifecycle_mac.json</a:t>
+              <a:t>출처: app/monitoring.py</a:t>
+            </a:r>
+          </a:p>
+          <a:p xmlns:a="http://schemas.openxmlformats.org/drawingml/2006/main">
+            <a:r>
+              <a:t>docs/evaluation/lifecycle_mac.json</a:t>
             </a:r>
           </a:p>
         </p:txBody>
@@ -745,7 +750,7 @@
           <a:lstStyle xmlns:a="http://schemas.openxmlformats.org/drawingml/2006/main"/>
           <a:p xmlns:a="http://schemas.openxmlformats.org/drawingml/2006/main">
             <a:r>
-              <a:t>LangGraph로 점검, 검색, 계획 역할을 연결했습니다. RAG는 BGE-M3와 FAISS로 근거를 찾아 Qwen에 전달하며, MCP는 조회와 계획 도구를 제공합니다. 실제 학습과 지표는 코드가 계산합니다. LangSmith 실행 추적과 테스트 쉰두 개를 확인했고, LLM 설명 검사도 실패 사례와 함께 기록했습니다.</a:t>
+              <a:t>설명과 계획은 언어모델이 돕고, 학습과 숫자 계산은 코드가 담당합니다. 역할 분리와 근거 검색, 도구 연결, 실행 추적을 적용했습니다. 테스트 쉰두 개와 설명 검사 결과도 남겼습니다.</a:t>
             </a:r>
           </a:p>
           <a:p xmlns:a="http://schemas.openxmlformats.org/drawingml/2006/main">
@@ -755,7 +760,27 @@
           </a:p>
           <a:p xmlns:a="http://schemas.openxmlformats.org/drawingml/2006/main">
             <a:r>
-              <a:t>출처: app/planner.py, app/ensemble.py, docs/evaluation/langsmith_check.json, docs/evaluation/llm_judge.json, docs/evaluation/tests-windows.txt</a:t>
+              <a:t>출처: app/planner.py</a:t>
+            </a:r>
+          </a:p>
+          <a:p xmlns:a="http://schemas.openxmlformats.org/drawingml/2006/main">
+            <a:r>
+              <a:t>app/ensemble.py</a:t>
+            </a:r>
+          </a:p>
+          <a:p xmlns:a="http://schemas.openxmlformats.org/drawingml/2006/main">
+            <a:r>
+              <a:t>docs/evaluation/langsmith_check.json</a:t>
+            </a:r>
+          </a:p>
+          <a:p xmlns:a="http://schemas.openxmlformats.org/drawingml/2006/main">
+            <a:r>
+              <a:t>docs/evaluation/llm_judge.json</a:t>
+            </a:r>
+          </a:p>
+          <a:p xmlns:a="http://schemas.openxmlformats.org/drawingml/2006/main">
+            <a:r>
+              <a:t>docs/evaluation/tests-windows.txt</a:t>
             </a:r>
           </a:p>
         </p:txBody>
@@ -825,7 +850,7 @@
           <a:lstStyle xmlns:a="http://schemas.openxmlformats.org/drawingml/2006/main"/>
           <a:p xmlns:a="http://schemas.openxmlformats.org/drawingml/2006/main">
             <a:r>
-              <a:t>모델을 고르는 실험과 이후의 성능 점검, 승인 후 재학습을 한 흐름으로 연결했습니다. 높은 Validation 점수가 미래 성능을 보장하지 않는다는 점을 배웠습니다. 합성 데이터와 작은 표본이 한계이며, 현장 기준과 독립 기간 검증 후 상시 감시와 운영 연동을 확장하겠습니다. 감사합니다.</a:t>
+              <a:t>이 Agent는 모델 선택뿐 아니라 성능 점검과 승인 후 재학습까지 돕습니다. 좋은 점수만 보여 주기보다 선택 이유와 실패도 기록했습니다. 합성 데이터 결과이므로 실제 적용 전에는 새 생산 데이터와 현장 기준으로 다시 검증해야 합니다. 감사합니다.</a:t>
             </a:r>
           </a:p>
           <a:p xmlns:a="http://schemas.openxmlformats.org/drawingml/2006/main">
@@ -915,7 +940,12 @@
           </a:p>
           <a:p xmlns:a="http://schemas.openxmlformats.org/drawingml/2006/main">
             <a:r>
-              <a:t>출처: docs/evaluation/synthetic_process.json, docs/evaluation/weighted_ensemble.json</a:t>
+              <a:t>출처: docs/evaluation/synthetic_process.json</a:t>
+            </a:r>
+          </a:p>
+          <a:p xmlns:a="http://schemas.openxmlformats.org/drawingml/2006/main">
+            <a:r>
+              <a:t>docs/evaluation/weighted_ensemble.json</a:t>
             </a:r>
           </a:p>
         </p:txBody>
@@ -995,7 +1025,17 @@
           </a:p>
           <a:p xmlns:a="http://schemas.openxmlformats.org/drawingml/2006/main">
             <a:r>
-              <a:t>출처: app/discovery.py, app/retrieval.py, docs/evaluation/vector_rag.json</a:t>
+              <a:t>출처: app/discovery.py</a:t>
+            </a:r>
+          </a:p>
+          <a:p xmlns:a="http://schemas.openxmlformats.org/drawingml/2006/main">
+            <a:r>
+              <a:t>app/retrieval.py</a:t>
+            </a:r>
+          </a:p>
+          <a:p xmlns:a="http://schemas.openxmlformats.org/drawingml/2006/main">
+            <a:r>
+              <a:t>docs/evaluation/vector_rag.json</a:t>
             </a:r>
           </a:p>
         </p:txBody>
@@ -1075,7 +1115,12 @@
           </a:p>
           <a:p xmlns:a="http://schemas.openxmlformats.org/drawingml/2006/main">
             <a:r>
-              <a:t>출처: app/ensemble.py, docs/evaluation/weighted_ensemble.json</a:t>
+              <a:t>출처: app/ensemble.py</a:t>
+            </a:r>
+          </a:p>
+          <a:p xmlns:a="http://schemas.openxmlformats.org/drawingml/2006/main">
+            <a:r>
+              <a:t>docs/evaluation/weighted_ensemble.json</a:t>
             </a:r>
           </a:p>
         </p:txBody>
@@ -1155,7 +1200,12 @@
           </a:p>
           <a:p xmlns:a="http://schemas.openxmlformats.org/drawingml/2006/main">
             <a:r>
-              <a:t>출처: docs/evaluation/llm_judge.json, docs/EVALUATION.md</a:t>
+              <a:t>출처: docs/evaluation/llm_judge.json</a:t>
+            </a:r>
+          </a:p>
+          <a:p xmlns:a="http://schemas.openxmlformats.org/drawingml/2006/main">
+            <a:r>
+              <a:t>docs/EVALUATION.md</a:t>
             </a:r>
           </a:p>
         </p:txBody>
@@ -1305,7 +1355,7 @@
           <a:lstStyle xmlns:a="http://schemas.openxmlformats.org/drawingml/2006/main"/>
           <a:p xmlns:a="http://schemas.openxmlformats.org/drawingml/2006/main">
             <a:r>
-              <a:t>엔지니어는 새 모델을 고를 때 전처리와 학습 제품 범위, 모델 조합을 반복해서 비교합니다. 이후 데이터가 바뀌면 기존 모델이 여전히 잘 찾는지도 확인해야 합니다. 이 두 업무를 계획, 승인, 실행, 결과 설명으로 연결했습니다.</a:t>
+              <a:t>검사 모델을 만드는 엔지니어는 어떤 데이터를 함께 학습할지, 어떤 모델을 쓸지 반복해서 비교합니다. 만든 뒤에도 성능을 확인해야 합니다. 이 과정을 근거 확인, 승인, 실행으로 연결했습니다.</a:t>
             </a:r>
           </a:p>
           <a:p xmlns:a="http://schemas.openxmlformats.org/drawingml/2006/main">
@@ -1385,7 +1435,7 @@
           <a:lstStyle xmlns:a="http://schemas.openxmlformats.org/drawingml/2006/main"/>
           <a:p xmlns:a="http://schemas.openxmlformats.org/drawingml/2006/main">
             <a:r>
-              <a:t>불량을 실제로 얼마나 찾았는지가 Recall입니다. 모두 불량이라고 해도 Recall은 높아지므로 정상을 불량으로 잘못 보는 비율도 제한합니다. 이번 교육용 목표는 검출률 구십 퍼센트 이상, 정상 오판 십오 퍼센트 이하입니다. 그 안에서 Recall을 먼저, 동률이면 F1을 비교합니다.</a:t>
+              <a:t>불량을 정상으로 놓치면 다음 공정이나 고객에게 넘어가 품질 문제를 일으킬 수 있습니다. 그래서 실제 불량 중 얼마나 찾았는지인 Recall을 우선 봅니다. 하지만 모두 불량이라고 하면 Recall은 백 퍼센트여도 정상 제품까지 전부 잘못 잡습니다. 정상 오판은 불필요한 확인이나 제품 제외로 이어질 수 있어 제한합니다. 이번에는 정상 오판 한도 안에서 Recall을 먼저, 같으면 F1을 비교합니다. 구십 퍼센트와 십오 퍼센트는 교육용 목표입니다.</a:t>
             </a:r>
           </a:p>
           <a:p xmlns:a="http://schemas.openxmlformats.org/drawingml/2006/main">
@@ -1395,7 +1445,37 @@
           </a:p>
           <a:p xmlns:a="http://schemas.openxmlformats.org/drawingml/2006/main">
             <a:r>
-              <a:t>출처: app/ensemble.py, https://scikit-learn.org/stable/modules/model_evaluation.html</a:t>
+              <a:t>발표자 참고: 정상 오판은 FP, 불량 미검출은 FN입니다. Recall=TP/(TP+FN), 정상 오판률=FP/(FP+TN), Precision=TP/(TP+FP), F1은 Precision과 Recall의 조화평균입니다. F1은 정상 오판률 자체와 동일한 지표가 아닙니다. 검사 결과가 바로 폐기 결정이라는 뜻은 아니며 뒤의 확인·보류·제외 정책에 따라 영향이 달라집니다. 90%·15%는 회사 공통 기준이 아닙니다. 사용자 화면의 금액·수율 단정은 인용하지 않았습니다.</a:t>
+            </a:r>
+          </a:p>
+          <a:p xmlns:a="http://schemas.openxmlformats.org/drawingml/2006/main">
+            <a:r>
+              <a:t/>
+            </a:r>
+          </a:p>
+          <a:p xmlns:a="http://schemas.openxmlformats.org/drawingml/2006/main">
+            <a:r>
+              <a:t>출처: app/metrics.py</a:t>
+            </a:r>
+          </a:p>
+          <a:p xmlns:a="http://schemas.openxmlformats.org/drawingml/2006/main">
+            <a:r>
+              <a:t>app/ensemble.py</a:t>
+            </a:r>
+          </a:p>
+          <a:p xmlns:a="http://schemas.openxmlformats.org/drawingml/2006/main">
+            <a:r>
+              <a:t>https://developers.google.com/machine-learning/crash-course/classification/accuracy-precision-recall?hl=en</a:t>
+            </a:r>
+          </a:p>
+          <a:p xmlns:a="http://schemas.openxmlformats.org/drawingml/2006/main">
+            <a:r>
+              <a:t>https://www.kla.com/documents/03_ProcessWatchAutomotive_2018_08.pdf</a:t>
+            </a:r>
+          </a:p>
+          <a:p xmlns:a="http://schemas.openxmlformats.org/drawingml/2006/main">
+            <a:r>
+              <a:t>사용자 제공 바탕화면 스크린샷 2026-10-21 오전 11.08.43.png 및 11.08.48.png (AI 개요 화면으로, 지표 정의·산업 맥락은 공식 출처와 대조)</a:t>
             </a:r>
           </a:p>
         </p:txBody>
@@ -1465,7 +1545,7 @@
           <a:lstStyle xmlns:a="http://schemas.openxmlformats.org/drawingml/2006/main"/>
           <a:p xmlns:a="http://schemas.openxmlformats.org/drawingml/2006/main">
             <a:r>
-              <a:t>제품 A부터 D의 합성 센서 천이백팔십 건을 선택합니다. 실제 공장 데이터는 아닙니다. 내 센서 CSV나 검사 이미지 ZIP을 등록하는 기능도 있습니다.</a:t>
+              <a:t>여러 센서 값으로 정상과 불량을 구분하는 합성 데이터 천이백팔십 건을 선택합니다. A부터 D는 가상 제품이며, 실제 공장 데이터는 아닙니다.</a:t>
             </a:r>
           </a:p>
           <a:p xmlns:a="http://schemas.openxmlformats.org/drawingml/2006/main">
@@ -1545,7 +1625,7 @@
           <a:lstStyle xmlns:a="http://schemas.openxmlformats.org/drawingml/2006/main"/>
           <a:p xmlns:a="http://schemas.openxmlformats.org/drawingml/2006/main">
             <a:r>
-              <a:t>Agent가 결측과 불균형을 확인하고 모델별 전처리 이유를 보여 줍니다. 예를 들어 SVM은 센서 값의 크기 차이에 민감해 Scaling을 사용합니다. 전처리는 Train에만 맞추고 학습, 후보 선택, 마지막 확인을 육 대 이 대 이로 고정했습니다. 엔지니어가 계획을 승인하면 실행합니다.</a:t>
+              <a:t>Agent가 빈값을 어떻게 채우고 숫자 크기를 맞출지 설명합니다. SVM처럼 값의 크기에 민감한 모델에는 Scaling을 씁니다. 데이터는 육십 퍼센트로 학습하고, 이십 퍼센트로 후보를 고릅니다. 마지막 이십 퍼센트는 선택한 모델의 최종 시험용으로 남깁니다. 계획을 승인하면 실제 학습합니다.</a:t>
             </a:r>
           </a:p>
           <a:p xmlns:a="http://schemas.openxmlformats.org/drawingml/2006/main">
@@ -1555,7 +1635,17 @@
           </a:p>
           <a:p xmlns:a="http://schemas.openxmlformats.org/drawingml/2006/main">
             <a:r>
-              <a:t>출처: app/experiments.py, app/ensemble.py, docs/evaluation/weighted_ensemble.json</a:t>
+              <a:t>출처: app/experiments.py</a:t>
+            </a:r>
+          </a:p>
+          <a:p xmlns:a="http://schemas.openxmlformats.org/drawingml/2006/main">
+            <a:r>
+              <a:t>app/ensemble.py</a:t>
+            </a:r>
+          </a:p>
+          <a:p xmlns:a="http://schemas.openxmlformats.org/drawingml/2006/main">
+            <a:r>
+              <a:t>docs/evaluation/weighted_ensemble.json</a:t>
             </a:r>
           </a:p>
         </p:txBody>
@@ -1625,7 +1715,7 @@
           <a:lstStyle xmlns:a="http://schemas.openxmlformats.org/drawingml/2006/main"/>
           <a:p xmlns:a="http://schemas.openxmlformats.org/drawingml/2006/main">
             <a:r>
-              <a:t>첫 실험은 CatBoost를 고정하고 제품 담당 그룹 열다섯 개를 비교합니다. Validation에서는 ABC를 함께, D는 따로 학습한 구성이 선택됐습니다. 하지만 Test 검출률은 칠십팔 점 일 퍼센트로 목표에 미달했습니다. 선택 후보와 현장 적용 가능성을 구분해 보류를 표시합니다.</a:t>
+              <a:t>첫 실험은 제품을 모두 합칠지 나눌지 비교합니다. 같은 CatBoost로 열다섯 구성을 시험했더니, 후보를 고르는 데이터에서는 ABC를 함께, D는 따로 학습한 구성이 좋았습니다. 하지만 마지막 시험의 검출률은 칠십팔 점 일 퍼센트로 목표 미달이었습니다. 그래서 비교 후보로 선택했어도 적용은 보류합니다.</a:t>
             </a:r>
           </a:p>
           <a:p xmlns:a="http://schemas.openxmlformats.org/drawingml/2006/main">
@@ -1635,7 +1725,17 @@
           </a:p>
           <a:p xmlns:a="http://schemas.openxmlformats.org/drawingml/2006/main">
             <a:r>
-              <a:t>출처: app/grouping.py, docs/evaluation/product_partitions.json, docs/evaluation/grouping_browser.json</a:t>
+              <a:t>출처: app/grouping.py</a:t>
+            </a:r>
+          </a:p>
+          <a:p xmlns:a="http://schemas.openxmlformats.org/drawingml/2006/main">
+            <a:r>
+              <a:t>docs/evaluation/product_partitions.json</a:t>
+            </a:r>
+          </a:p>
+          <a:p xmlns:a="http://schemas.openxmlformats.org/drawingml/2006/main">
+            <a:r>
+              <a:t>docs/evaluation/grouping_browser.json</a:t>
             </a:r>
           </a:p>
         </p:txBody>
@@ -1705,7 +1805,7 @@
           <a:lstStyle xmlns:a="http://schemas.openxmlformats.org/drawingml/2006/main"/>
           <a:p xmlns:a="http://schemas.openxmlformats.org/drawingml/2006/main">
             <a:r>
-              <a:t>두 번째 실험은 학습 제품 ABCD를 고정하고 세 모델의 혼합 비율을 비교합니다. 다섯 퍼센트 간격과 균등 비율을 포함한 이백서른두 개 중 CatBoost 구십, LightGBM 십 퍼센트를 골랐습니다. Validation에서 검출률을 유지하면서 정상 오판과 F1이 개선됐습니다.</a:t>
+              <a:t>앙상블은 여러 모델의 예측 점수를 섞는 방법입니다. 두 번째 실험에서는 제품 ABCD를 합쳐 학습한 세 모델의 비율 이백서른두 개를 비교했습니다. 후보 선택용 데이터에서 CatBoost 구십, LightGBM 십 퍼센트를 골랐습니다.</a:t>
             </a:r>
           </a:p>
           <a:p xmlns:a="http://schemas.openxmlformats.org/drawingml/2006/main">
@@ -1715,7 +1815,12 @@
           </a:p>
           <a:p xmlns:a="http://schemas.openxmlformats.org/drawingml/2006/main">
             <a:r>
-              <a:t>출처: docs/evaluation/weighted_ensemble.json, docs/evaluation/ensemble_browser.json</a:t>
+              <a:t>출처: docs/evaluation/weighted_ensemble.json</a:t>
+            </a:r>
+          </a:p>
+          <a:p xmlns:a="http://schemas.openxmlformats.org/drawingml/2006/main">
+            <a:r>
+              <a:t>docs/evaluation/ensemble_browser.json</a:t>
             </a:r>
           </a:p>
         </p:txBody>
@@ -1785,7 +1890,7 @@
           <a:lstStyle xmlns:a="http://schemas.openxmlformats.org/drawingml/2006/main"/>
           <a:p xmlns:a="http://schemas.openxmlformats.org/drawingml/2006/main">
             <a:r>
-              <a:t>선택한 비율을 고정한 뒤 같은 Test에서 확인했습니다. 단일 모델과 혼합 모델 모두 불량 서른두 개 중 서른 개를 찾았습니다. 정상 오판은 스물한 개에서 열아홉 개로 줄었습니다. 합성 데이터의 탐색 결과라 새로운 독립 데이터 검증이 필요합니다.</a:t>
+              <a:t>선택한 비율로 마지막 시험을 봤습니다. 단일 모델과 혼합 모델 모두 불량 서른두 개 중 서른 개를 찾았습니다. 정상 오판은 스물한 개에서 열아홉 개로 줄었습니다. 불량을 찾는 성능을 유지하면서 정상도 덜 잘못 잡은 사례입니다.</a:t>
             </a:r>
           </a:p>
           <a:p xmlns:a="http://schemas.openxmlformats.org/drawingml/2006/main">
@@ -1865,7 +1970,7 @@
           <a:lstStyle xmlns:a="http://schemas.openxmlformats.org/drawingml/2006/main"/>
           <a:p xmlns:a="http://schemas.openxmlformats.org/drawingml/2006/main">
             <a:r>
-              <a:t>사용 중인 모델에는 새 정답 데이터를 선택해 그대로 점검하는 기능을 제공합니다. 이 별도 합성 배치는 결함 발생 규칙을 바꾼 사례입니다. 제품별 검출률과 정상 오판을 확인하고 재학습 비교를 제안합니다. 불량 표본이 부족하면 판단을 보류하며 바로 학습하지 않습니다.</a:t>
+              <a:t>모델을 만든 뒤에는 새 데이터에서도 잘 찾는지 확인합니다. 여기서는 사람이 확인한 정답처럼 정상·불량이 표시된 별도 합성 데이터를 넣었습니다. 기존 모델을 그대로 점검하고 성능이 떨어지면 재학습 비교를 제안합니다. 표본이 부족하면 판단을 보류합니다.</a:t>
             </a:r>
           </a:p>
           <a:p xmlns:a="http://schemas.openxmlformats.org/drawingml/2006/main">
@@ -1875,7 +1980,12 @@
           </a:p>
           <a:p xmlns:a="http://schemas.openxmlformats.org/drawingml/2006/main">
             <a:r>
-              <a:t>출처: app/monitoring.py, docs/evaluation/lifecycle_mac.json</a:t>
+              <a:t>출처: app/monitoring.py</a:t>
+            </a:r>
+          </a:p>
+          <a:p xmlns:a="http://schemas.openxmlformats.org/drawingml/2006/main">
+            <a:r>
+              <a:t>docs/evaluation/lifecycle_mac.json</a:t>
             </a:r>
           </a:p>
         </p:txBody>
@@ -4902,17 +5012,17 @@
   </p:cSld>
   <p:clrMap bg1="lt1" tx1="dk1" bg2="lt2" tx2="dk2" accent1="accent1" accent2="accent2" accent3="accent3" accent4="accent4" accent5="accent5" accent6="accent6" hlink="hlink" folHlink="folHlink"/>
   <p:sldLayoutIdLst>
-    <p:sldLayoutId xmlns:r="http://schemas.openxmlformats.org/officeDocument/2006/relationships" id="2147483649" r:id="Rdc41c480763040b4"/>
-    <p:sldLayoutId xmlns:r="http://schemas.openxmlformats.org/officeDocument/2006/relationships" id="2147483650" r:id="Rd4a283da4f024c6b"/>
-    <p:sldLayoutId xmlns:r="http://schemas.openxmlformats.org/officeDocument/2006/relationships" id="2147483651" r:id="R3ec0719428bc4c39"/>
-    <p:sldLayoutId xmlns:r="http://schemas.openxmlformats.org/officeDocument/2006/relationships" id="2147483652" r:id="R693c21c0d02a4463"/>
-    <p:sldLayoutId xmlns:r="http://schemas.openxmlformats.org/officeDocument/2006/relationships" id="2147483653" r:id="R1efbaaf02a904be5"/>
-    <p:sldLayoutId xmlns:r="http://schemas.openxmlformats.org/officeDocument/2006/relationships" id="2147483654" r:id="R88978b6fb9fe443a"/>
-    <p:sldLayoutId xmlns:r="http://schemas.openxmlformats.org/officeDocument/2006/relationships" id="2147483655" r:id="Rb76647c652624835"/>
-    <p:sldLayoutId xmlns:r="http://schemas.openxmlformats.org/officeDocument/2006/relationships" id="2147483656" r:id="Rd651e7b4b88b4c9c"/>
-    <p:sldLayoutId xmlns:r="http://schemas.openxmlformats.org/officeDocument/2006/relationships" id="2147483657" r:id="Ref2c83e2c22a4c14"/>
-    <p:sldLayoutId xmlns:r="http://schemas.openxmlformats.org/officeDocument/2006/relationships" id="2147483658" r:id="R16c8d3d8e23547f7"/>
-    <p:sldLayoutId xmlns:r="http://schemas.openxmlformats.org/officeDocument/2006/relationships" id="2147483659" r:id="R35bc8eb14b824776"/>
+    <p:sldLayoutId xmlns:r="http://schemas.openxmlformats.org/officeDocument/2006/relationships" id="2147483649" r:id="Rf5ab9915c8dd4941"/>
+    <p:sldLayoutId xmlns:r="http://schemas.openxmlformats.org/officeDocument/2006/relationships" id="2147483650" r:id="R40c012d6f3dd4330"/>
+    <p:sldLayoutId xmlns:r="http://schemas.openxmlformats.org/officeDocument/2006/relationships" id="2147483651" r:id="R628fe837edae4572"/>
+    <p:sldLayoutId xmlns:r="http://schemas.openxmlformats.org/officeDocument/2006/relationships" id="2147483652" r:id="Rba8152b512c6424c"/>
+    <p:sldLayoutId xmlns:r="http://schemas.openxmlformats.org/officeDocument/2006/relationships" id="2147483653" r:id="Rf452d6735ab340c8"/>
+    <p:sldLayoutId xmlns:r="http://schemas.openxmlformats.org/officeDocument/2006/relationships" id="2147483654" r:id="R1d71c346223e4368"/>
+    <p:sldLayoutId xmlns:r="http://schemas.openxmlformats.org/officeDocument/2006/relationships" id="2147483655" r:id="R2c9e912d83fc491f"/>
+    <p:sldLayoutId xmlns:r="http://schemas.openxmlformats.org/officeDocument/2006/relationships" id="2147483656" r:id="R4aa123257f344c7c"/>
+    <p:sldLayoutId xmlns:r="http://schemas.openxmlformats.org/officeDocument/2006/relationships" id="2147483657" r:id="Rc953fb51866842be"/>
+    <p:sldLayoutId xmlns:r="http://schemas.openxmlformats.org/officeDocument/2006/relationships" id="2147483658" r:id="R6a82a63fb13445e8"/>
+    <p:sldLayoutId xmlns:r="http://schemas.openxmlformats.org/officeDocument/2006/relationships" id="2147483659" r:id="Rb57e0d0f0e444a73"/>
   </p:sldLayoutIdLst>
   <p:txStyles>
     <p:titleStyle>
@@ -6545,6 +6655,7 @@
               </a:defRPr>
             </a:defPPr>
             <a:lvl1pPr>
+              <a:buNone/>
               <a:defRPr sz="1650" b="1">
                 <a:solidFill>
                   <a:srgbClr val="173A49"/>
@@ -6555,6 +6666,7 @@
               </a:defRPr>
             </a:lvl1pPr>
             <a:lvl2pPr>
+              <a:buNone/>
               <a:defRPr sz="1650" b="1">
                 <a:solidFill>
                   <a:srgbClr val="173A49"/>
@@ -6565,6 +6677,7 @@
               </a:defRPr>
             </a:lvl2pPr>
             <a:lvl3pPr>
+              <a:buNone/>
               <a:defRPr sz="1650" b="1">
                 <a:solidFill>
                   <a:srgbClr val="173A49"/>
@@ -6575,6 +6688,7 @@
               </a:defRPr>
             </a:lvl3pPr>
             <a:lvl4pPr>
+              <a:buNone/>
               <a:defRPr sz="1650" b="1">
                 <a:solidFill>
                   <a:srgbClr val="173A49"/>
@@ -6585,6 +6699,7 @@
               </a:defRPr>
             </a:lvl4pPr>
             <a:lvl5pPr>
+              <a:buNone/>
               <a:defRPr sz="1650" b="1">
                 <a:solidFill>
                   <a:srgbClr val="173A49"/>
@@ -6595,6 +6710,7 @@
               </a:defRPr>
             </a:lvl5pPr>
             <a:lvl6pPr>
+              <a:buNone/>
               <a:defRPr sz="1650" b="1">
                 <a:solidFill>
                   <a:srgbClr val="173A49"/>
@@ -6605,6 +6721,7 @@
               </a:defRPr>
             </a:lvl6pPr>
             <a:lvl7pPr>
+              <a:buNone/>
               <a:defRPr sz="1650" b="1">
                 <a:solidFill>
                   <a:srgbClr val="173A49"/>
@@ -6615,6 +6732,7 @@
               </a:defRPr>
             </a:lvl7pPr>
             <a:lvl8pPr>
+              <a:buNone/>
               <a:defRPr sz="1650" b="1">
                 <a:solidFill>
                   <a:srgbClr val="173A49"/>
@@ -6625,6 +6743,7 @@
               </a:defRPr>
             </a:lvl8pPr>
             <a:lvl9pPr>
+              <a:buNone/>
               <a:defRPr sz="1650" b="1">
                 <a:solidFill>
                   <a:srgbClr val="173A49"/>
@@ -6737,6 +6856,7 @@
               </a:defRPr>
             </a:defPPr>
             <a:lvl1pPr>
+              <a:buNone/>
               <a:defRPr sz="1200" b="1">
                 <a:solidFill>
                   <a:srgbClr val="147D82"/>
@@ -6747,6 +6867,7 @@
               </a:defRPr>
             </a:lvl1pPr>
             <a:lvl2pPr>
+              <a:buNone/>
               <a:defRPr sz="1200" b="1">
                 <a:solidFill>
                   <a:srgbClr val="147D82"/>
@@ -6757,6 +6878,7 @@
               </a:defRPr>
             </a:lvl2pPr>
             <a:lvl3pPr>
+              <a:buNone/>
               <a:defRPr sz="1200" b="1">
                 <a:solidFill>
                   <a:srgbClr val="147D82"/>
@@ -6767,6 +6889,7 @@
               </a:defRPr>
             </a:lvl3pPr>
             <a:lvl4pPr>
+              <a:buNone/>
               <a:defRPr sz="1200" b="1">
                 <a:solidFill>
                   <a:srgbClr val="147D82"/>
@@ -6777,6 +6900,7 @@
               </a:defRPr>
             </a:lvl4pPr>
             <a:lvl5pPr>
+              <a:buNone/>
               <a:defRPr sz="1200" b="1">
                 <a:solidFill>
                   <a:srgbClr val="147D82"/>
@@ -6787,6 +6911,7 @@
               </a:defRPr>
             </a:lvl5pPr>
             <a:lvl6pPr>
+              <a:buNone/>
               <a:defRPr sz="1200" b="1">
                 <a:solidFill>
                   <a:srgbClr val="147D82"/>
@@ -6797,6 +6922,7 @@
               </a:defRPr>
             </a:lvl6pPr>
             <a:lvl7pPr>
+              <a:buNone/>
               <a:defRPr sz="1200" b="1">
                 <a:solidFill>
                   <a:srgbClr val="147D82"/>
@@ -6807,6 +6933,7 @@
               </a:defRPr>
             </a:lvl7pPr>
             <a:lvl8pPr>
+              <a:buNone/>
               <a:defRPr sz="1200" b="1">
                 <a:solidFill>
                   <a:srgbClr val="147D82"/>
@@ -6817,6 +6944,7 @@
               </a:defRPr>
             </a:lvl8pPr>
             <a:lvl9pPr>
+              <a:buNone/>
               <a:defRPr sz="1200" b="1">
                 <a:solidFill>
                   <a:srgbClr val="147D82"/>
@@ -6829,6 +6957,7 @@
           </a:lstStyle>
           <a:p xmlns:a="http://schemas.openxmlformats.org/drawingml/2006/main">
             <a:pPr>
+              <a:buNone/>
               <a:defRPr sz="1200" b="1">
                 <a:solidFill>
                   <a:srgbClr val="147D82"/>
@@ -6847,7 +6976,7 @@
                 <a:ea typeface="맑은 고딕"/>
                 <a:cs typeface="맑은 고딕"/>
               </a:rPr>
-              <a:t>10 · 모델 관리 | 새 배치 Test 768건 · 불량167개·정상601개</a:t>
+              <a:t>10 · 재학습의 마지막 시험(Test) | 불량167개 · 정상601개</a:t>
             </a:r>
           </a:p>
         </p:txBody>
@@ -6893,6 +7022,7 @@
               </a:defRPr>
             </a:defPPr>
             <a:lvl1pPr>
+              <a:buNone/>
               <a:defRPr sz="2925" b="1">
                 <a:solidFill>
                   <a:srgbClr val="173A49"/>
@@ -6903,6 +7033,7 @@
               </a:defRPr>
             </a:lvl1pPr>
             <a:lvl2pPr>
+              <a:buNone/>
               <a:defRPr sz="2925" b="1">
                 <a:solidFill>
                   <a:srgbClr val="173A49"/>
@@ -6913,6 +7044,7 @@
               </a:defRPr>
             </a:lvl2pPr>
             <a:lvl3pPr>
+              <a:buNone/>
               <a:defRPr sz="2925" b="1">
                 <a:solidFill>
                   <a:srgbClr val="173A49"/>
@@ -6923,6 +7055,7 @@
               </a:defRPr>
             </a:lvl3pPr>
             <a:lvl4pPr>
+              <a:buNone/>
               <a:defRPr sz="2925" b="1">
                 <a:solidFill>
                   <a:srgbClr val="173A49"/>
@@ -6933,6 +7066,7 @@
               </a:defRPr>
             </a:lvl4pPr>
             <a:lvl5pPr>
+              <a:buNone/>
               <a:defRPr sz="2925" b="1">
                 <a:solidFill>
                   <a:srgbClr val="173A49"/>
@@ -6943,6 +7077,7 @@
               </a:defRPr>
             </a:lvl5pPr>
             <a:lvl6pPr>
+              <a:buNone/>
               <a:defRPr sz="2925" b="1">
                 <a:solidFill>
                   <a:srgbClr val="173A49"/>
@@ -6953,6 +7088,7 @@
               </a:defRPr>
             </a:lvl6pPr>
             <a:lvl7pPr>
+              <a:buNone/>
               <a:defRPr sz="2925" b="1">
                 <a:solidFill>
                   <a:srgbClr val="173A49"/>
@@ -6963,6 +7099,7 @@
               </a:defRPr>
             </a:lvl7pPr>
             <a:lvl8pPr>
+              <a:buNone/>
               <a:defRPr sz="2925" b="1">
                 <a:solidFill>
                   <a:srgbClr val="173A49"/>
@@ -6973,6 +7110,7 @@
               </a:defRPr>
             </a:lvl8pPr>
             <a:lvl9pPr>
+              <a:buNone/>
               <a:defRPr sz="2925" b="1">
                 <a:solidFill>
                   <a:srgbClr val="173A49"/>
@@ -6985,6 +7123,7 @@
           </a:lstStyle>
           <a:p xmlns:a="http://schemas.openxmlformats.org/drawingml/2006/main">
             <a:pPr>
+              <a:buNone/>
               <a:defRPr sz="2925" b="1">
                 <a:solidFill>
                   <a:srgbClr val="173A49"/>
@@ -7049,6 +7188,7 @@
               </a:defRPr>
             </a:defPPr>
             <a:lvl1pPr>
+              <a:buNone/>
               <a:defRPr sz="975" b="0">
                 <a:solidFill>
                   <a:srgbClr val="617681"/>
@@ -7059,6 +7199,7 @@
               </a:defRPr>
             </a:lvl1pPr>
             <a:lvl2pPr>
+              <a:buNone/>
               <a:defRPr sz="975" b="0">
                 <a:solidFill>
                   <a:srgbClr val="617681"/>
@@ -7069,6 +7210,7 @@
               </a:defRPr>
             </a:lvl2pPr>
             <a:lvl3pPr>
+              <a:buNone/>
               <a:defRPr sz="975" b="0">
                 <a:solidFill>
                   <a:srgbClr val="617681"/>
@@ -7079,6 +7221,7 @@
               </a:defRPr>
             </a:lvl3pPr>
             <a:lvl4pPr>
+              <a:buNone/>
               <a:defRPr sz="975" b="0">
                 <a:solidFill>
                   <a:srgbClr val="617681"/>
@@ -7089,6 +7232,7 @@
               </a:defRPr>
             </a:lvl4pPr>
             <a:lvl5pPr>
+              <a:buNone/>
               <a:defRPr sz="975" b="0">
                 <a:solidFill>
                   <a:srgbClr val="617681"/>
@@ -7099,6 +7243,7 @@
               </a:defRPr>
             </a:lvl5pPr>
             <a:lvl6pPr>
+              <a:buNone/>
               <a:defRPr sz="975" b="0">
                 <a:solidFill>
                   <a:srgbClr val="617681"/>
@@ -7109,6 +7254,7 @@
               </a:defRPr>
             </a:lvl6pPr>
             <a:lvl7pPr>
+              <a:buNone/>
               <a:defRPr sz="975" b="0">
                 <a:solidFill>
                   <a:srgbClr val="617681"/>
@@ -7119,6 +7265,7 @@
               </a:defRPr>
             </a:lvl7pPr>
             <a:lvl8pPr>
+              <a:buNone/>
               <a:defRPr sz="975" b="0">
                 <a:solidFill>
                   <a:srgbClr val="617681"/>
@@ -7129,6 +7276,7 @@
               </a:defRPr>
             </a:lvl8pPr>
             <a:lvl9pPr>
+              <a:buNone/>
               <a:defRPr sz="975" b="0">
                 <a:solidFill>
                   <a:srgbClr val="617681"/>
@@ -7141,6 +7289,7 @@
           </a:lstStyle>
           <a:p xmlns:a="http://schemas.openxmlformats.org/drawingml/2006/main">
             <a:pPr>
+              <a:buNone/>
               <a:defRPr sz="975" b="0">
                 <a:solidFill>
                   <a:srgbClr val="617681"/>
@@ -7205,6 +7354,7 @@
               </a:defRPr>
             </a:defPPr>
             <a:lvl1pPr>
+              <a:buNone/>
               <a:defRPr sz="975" b="0">
                 <a:solidFill>
                   <a:srgbClr val="617681"/>
@@ -7215,6 +7365,7 @@
               </a:defRPr>
             </a:lvl1pPr>
             <a:lvl2pPr>
+              <a:buNone/>
               <a:defRPr sz="975" b="0">
                 <a:solidFill>
                   <a:srgbClr val="617681"/>
@@ -7225,6 +7376,7 @@
               </a:defRPr>
             </a:lvl2pPr>
             <a:lvl3pPr>
+              <a:buNone/>
               <a:defRPr sz="975" b="0">
                 <a:solidFill>
                   <a:srgbClr val="617681"/>
@@ -7235,6 +7387,7 @@
               </a:defRPr>
             </a:lvl3pPr>
             <a:lvl4pPr>
+              <a:buNone/>
               <a:defRPr sz="975" b="0">
                 <a:solidFill>
                   <a:srgbClr val="617681"/>
@@ -7245,6 +7398,7 @@
               </a:defRPr>
             </a:lvl4pPr>
             <a:lvl5pPr>
+              <a:buNone/>
               <a:defRPr sz="975" b="0">
                 <a:solidFill>
                   <a:srgbClr val="617681"/>
@@ -7255,6 +7409,7 @@
               </a:defRPr>
             </a:lvl5pPr>
             <a:lvl6pPr>
+              <a:buNone/>
               <a:defRPr sz="975" b="0">
                 <a:solidFill>
                   <a:srgbClr val="617681"/>
@@ -7265,6 +7420,7 @@
               </a:defRPr>
             </a:lvl6pPr>
             <a:lvl7pPr>
+              <a:buNone/>
               <a:defRPr sz="975" b="0">
                 <a:solidFill>
                   <a:srgbClr val="617681"/>
@@ -7275,6 +7431,7 @@
               </a:defRPr>
             </a:lvl7pPr>
             <a:lvl8pPr>
+              <a:buNone/>
               <a:defRPr sz="975" b="0">
                 <a:solidFill>
                   <a:srgbClr val="617681"/>
@@ -7285,6 +7442,7 @@
               </a:defRPr>
             </a:lvl8pPr>
             <a:lvl9pPr>
+              <a:buNone/>
               <a:defRPr sz="975" b="0">
                 <a:solidFill>
                   <a:srgbClr val="617681"/>
@@ -7297,6 +7455,7 @@
           </a:lstStyle>
           <a:p xmlns:a="http://schemas.openxmlformats.org/drawingml/2006/main">
             <a:pPr>
+              <a:buNone/>
               <a:defRPr sz="975" b="0">
                 <a:solidFill>
                   <a:srgbClr val="617681"/>
@@ -7325,7 +7484,7 @@
           <p:cNvPr id="5" name="">
             <a:extLst xmlns:a="http://schemas.openxmlformats.org/drawingml/2006/main">
               <a:ext uri="{FF2B5EF4-FFF2-40B4-BE49-F238E27FC236}">
-                <a16:creationId xmlns:a16="http://schemas.microsoft.com/office/drawing/2014/main" id="{756734BD-E9F1-4229-A477-64E420C208CF}"/>
+                <a16:creationId xmlns:a16="http://schemas.microsoft.com/office/drawing/2014/main" id="{100717AF-CC0F-46E7-A1A7-50C283B51698}"/>
               </a:ext>
             </a:extLst>
           </p:cNvPr>
@@ -7335,7 +7494,7 @@
           <p:nvPr/>
         </p:nvPicPr>
         <p:blipFill>
-          <a:blip xmlns:r="http://schemas.openxmlformats.org/officeDocument/2006/relationships" xmlns:a="http://schemas.openxmlformats.org/drawingml/2006/main" r:embed="R0e828addebec4040"/>
+          <a:blip xmlns:r="http://schemas.openxmlformats.org/officeDocument/2006/relationships" xmlns:a="http://schemas.openxmlformats.org/drawingml/2006/main" r:embed="R8b3430a6e76f4677"/>
           <a:stretch xmlns:a="http://schemas.openxmlformats.org/drawingml/2006/main"/>
         </p:blipFill>
         <p:spPr>
@@ -7389,6 +7548,7 @@
               </a:defRPr>
             </a:defPPr>
             <a:lvl1pPr>
+              <a:buNone/>
               <a:defRPr sz="2325" b="1">
                 <a:solidFill>
                   <a:srgbClr val="173A49"/>
@@ -7399,6 +7559,7 @@
               </a:defRPr>
             </a:lvl1pPr>
             <a:lvl2pPr>
+              <a:buNone/>
               <a:defRPr sz="2325" b="1">
                 <a:solidFill>
                   <a:srgbClr val="173A49"/>
@@ -7409,6 +7570,7 @@
               </a:defRPr>
             </a:lvl2pPr>
             <a:lvl3pPr>
+              <a:buNone/>
               <a:defRPr sz="2325" b="1">
                 <a:solidFill>
                   <a:srgbClr val="173A49"/>
@@ -7419,6 +7581,7 @@
               </a:defRPr>
             </a:lvl3pPr>
             <a:lvl4pPr>
+              <a:buNone/>
               <a:defRPr sz="2325" b="1">
                 <a:solidFill>
                   <a:srgbClr val="173A49"/>
@@ -7429,6 +7592,7 @@
               </a:defRPr>
             </a:lvl4pPr>
             <a:lvl5pPr>
+              <a:buNone/>
               <a:defRPr sz="2325" b="1">
                 <a:solidFill>
                   <a:srgbClr val="173A49"/>
@@ -7439,6 +7603,7 @@
               </a:defRPr>
             </a:lvl5pPr>
             <a:lvl6pPr>
+              <a:buNone/>
               <a:defRPr sz="2325" b="1">
                 <a:solidFill>
                   <a:srgbClr val="173A49"/>
@@ -7449,6 +7614,7 @@
               </a:defRPr>
             </a:lvl6pPr>
             <a:lvl7pPr>
+              <a:buNone/>
               <a:defRPr sz="2325" b="1">
                 <a:solidFill>
                   <a:srgbClr val="173A49"/>
@@ -7459,6 +7625,7 @@
               </a:defRPr>
             </a:lvl7pPr>
             <a:lvl8pPr>
+              <a:buNone/>
               <a:defRPr sz="2325" b="1">
                 <a:solidFill>
                   <a:srgbClr val="173A49"/>
@@ -7469,6 +7636,7 @@
               </a:defRPr>
             </a:lvl8pPr>
             <a:lvl9pPr>
+              <a:buNone/>
               <a:defRPr sz="2325" b="1">
                 <a:solidFill>
                   <a:srgbClr val="173A49"/>
@@ -7481,6 +7649,7 @@
           </a:lstStyle>
           <a:p xmlns:a="http://schemas.openxmlformats.org/drawingml/2006/main">
             <a:pPr>
+              <a:buNone/>
               <a:defRPr sz="2325" b="1">
                 <a:solidFill>
                   <a:srgbClr val="173A49"/>
@@ -7504,6 +7673,7 @@
           </a:p>
           <a:p xmlns:a="http://schemas.openxmlformats.org/drawingml/2006/main">
             <a:pPr>
+              <a:buNone/>
               <a:defRPr sz="2325" b="1">
                 <a:solidFill>
                   <a:srgbClr val="173A49"/>
@@ -7568,6 +7738,7 @@
               </a:defRPr>
             </a:defPPr>
             <a:lvl1pPr>
+              <a:buNone/>
               <a:defRPr sz="2175" b="1">
                 <a:solidFill>
                   <a:srgbClr val="147D82"/>
@@ -7578,6 +7749,7 @@
               </a:defRPr>
             </a:lvl1pPr>
             <a:lvl2pPr>
+              <a:buNone/>
               <a:defRPr sz="2175" b="1">
                 <a:solidFill>
                   <a:srgbClr val="147D82"/>
@@ -7588,6 +7760,7 @@
               </a:defRPr>
             </a:lvl2pPr>
             <a:lvl3pPr>
+              <a:buNone/>
               <a:defRPr sz="2175" b="1">
                 <a:solidFill>
                   <a:srgbClr val="147D82"/>
@@ -7598,6 +7771,7 @@
               </a:defRPr>
             </a:lvl3pPr>
             <a:lvl4pPr>
+              <a:buNone/>
               <a:defRPr sz="2175" b="1">
                 <a:solidFill>
                   <a:srgbClr val="147D82"/>
@@ -7608,6 +7782,7 @@
               </a:defRPr>
             </a:lvl4pPr>
             <a:lvl5pPr>
+              <a:buNone/>
               <a:defRPr sz="2175" b="1">
                 <a:solidFill>
                   <a:srgbClr val="147D82"/>
@@ -7618,6 +7793,7 @@
               </a:defRPr>
             </a:lvl5pPr>
             <a:lvl6pPr>
+              <a:buNone/>
               <a:defRPr sz="2175" b="1">
                 <a:solidFill>
                   <a:srgbClr val="147D82"/>
@@ -7628,6 +7804,7 @@
               </a:defRPr>
             </a:lvl6pPr>
             <a:lvl7pPr>
+              <a:buNone/>
               <a:defRPr sz="2175" b="1">
                 <a:solidFill>
                   <a:srgbClr val="147D82"/>
@@ -7638,6 +7815,7 @@
               </a:defRPr>
             </a:lvl7pPr>
             <a:lvl8pPr>
+              <a:buNone/>
               <a:defRPr sz="2175" b="1">
                 <a:solidFill>
                   <a:srgbClr val="147D82"/>
@@ -7648,6 +7826,7 @@
               </a:defRPr>
             </a:lvl8pPr>
             <a:lvl9pPr>
+              <a:buNone/>
               <a:defRPr sz="2175" b="1">
                 <a:solidFill>
                   <a:srgbClr val="147D82"/>
@@ -7660,6 +7839,7 @@
           </a:lstStyle>
           <a:p xmlns:a="http://schemas.openxmlformats.org/drawingml/2006/main">
             <a:pPr>
+              <a:buNone/>
               <a:defRPr sz="2175" b="1">
                 <a:solidFill>
                   <a:srgbClr val="147D82"/>
@@ -7683,6 +7863,7 @@
           </a:p>
           <a:p xmlns:a="http://schemas.openxmlformats.org/drawingml/2006/main">
             <a:pPr>
+              <a:buNone/>
               <a:defRPr sz="2175" b="1">
                 <a:solidFill>
                   <a:srgbClr val="147D82"/>
@@ -7747,6 +7928,7 @@
               </a:defRPr>
             </a:defPPr>
             <a:lvl1pPr>
+              <a:buNone/>
               <a:defRPr sz="2100" b="0">
                 <a:solidFill>
                   <a:srgbClr val="173A49"/>
@@ -7757,6 +7939,7 @@
               </a:defRPr>
             </a:lvl1pPr>
             <a:lvl2pPr>
+              <a:buNone/>
               <a:defRPr sz="2100" b="0">
                 <a:solidFill>
                   <a:srgbClr val="173A49"/>
@@ -7767,6 +7950,7 @@
               </a:defRPr>
             </a:lvl2pPr>
             <a:lvl3pPr>
+              <a:buNone/>
               <a:defRPr sz="2100" b="0">
                 <a:solidFill>
                   <a:srgbClr val="173A49"/>
@@ -7777,6 +7961,7 @@
               </a:defRPr>
             </a:lvl3pPr>
             <a:lvl4pPr>
+              <a:buNone/>
               <a:defRPr sz="2100" b="0">
                 <a:solidFill>
                   <a:srgbClr val="173A49"/>
@@ -7787,6 +7972,7 @@
               </a:defRPr>
             </a:lvl4pPr>
             <a:lvl5pPr>
+              <a:buNone/>
               <a:defRPr sz="2100" b="0">
                 <a:solidFill>
                   <a:srgbClr val="173A49"/>
@@ -7797,6 +7983,7 @@
               </a:defRPr>
             </a:lvl5pPr>
             <a:lvl6pPr>
+              <a:buNone/>
               <a:defRPr sz="2100" b="0">
                 <a:solidFill>
                   <a:srgbClr val="173A49"/>
@@ -7807,6 +7994,7 @@
               </a:defRPr>
             </a:lvl6pPr>
             <a:lvl7pPr>
+              <a:buNone/>
               <a:defRPr sz="2100" b="0">
                 <a:solidFill>
                   <a:srgbClr val="173A49"/>
@@ -7817,6 +8005,7 @@
               </a:defRPr>
             </a:lvl7pPr>
             <a:lvl8pPr>
+              <a:buNone/>
               <a:defRPr sz="2100" b="0">
                 <a:solidFill>
                   <a:srgbClr val="173A49"/>
@@ -7827,6 +8016,7 @@
               </a:defRPr>
             </a:lvl8pPr>
             <a:lvl9pPr>
+              <a:buNone/>
               <a:defRPr sz="2100" b="0">
                 <a:solidFill>
                   <a:srgbClr val="173A49"/>
@@ -7839,6 +8029,7 @@
           </a:lstStyle>
           <a:p xmlns:a="http://schemas.openxmlformats.org/drawingml/2006/main">
             <a:pPr>
+              <a:buNone/>
               <a:defRPr sz="2100" b="0">
                 <a:solidFill>
                   <a:srgbClr val="173A49"/>
@@ -7862,6 +8053,7 @@
           </a:p>
           <a:p xmlns:a="http://schemas.openxmlformats.org/drawingml/2006/main">
             <a:pPr>
+              <a:buNone/>
               <a:defRPr sz="2100" b="0">
                 <a:solidFill>
                   <a:srgbClr val="173A49"/>
@@ -7926,6 +8118,7 @@
               </a:defRPr>
             </a:defPPr>
             <a:lvl1pPr>
+              <a:buNone/>
               <a:defRPr sz="1425" b="0">
                 <a:solidFill>
                   <a:srgbClr val="617681"/>
@@ -7936,6 +8129,7 @@
               </a:defRPr>
             </a:lvl1pPr>
             <a:lvl2pPr>
+              <a:buNone/>
               <a:defRPr sz="1425" b="0">
                 <a:solidFill>
                   <a:srgbClr val="617681"/>
@@ -7946,6 +8140,7 @@
               </a:defRPr>
             </a:lvl2pPr>
             <a:lvl3pPr>
+              <a:buNone/>
               <a:defRPr sz="1425" b="0">
                 <a:solidFill>
                   <a:srgbClr val="617681"/>
@@ -7956,6 +8151,7 @@
               </a:defRPr>
             </a:lvl3pPr>
             <a:lvl4pPr>
+              <a:buNone/>
               <a:defRPr sz="1425" b="0">
                 <a:solidFill>
                   <a:srgbClr val="617681"/>
@@ -7966,6 +8162,7 @@
               </a:defRPr>
             </a:lvl4pPr>
             <a:lvl5pPr>
+              <a:buNone/>
               <a:defRPr sz="1425" b="0">
                 <a:solidFill>
                   <a:srgbClr val="617681"/>
@@ -7976,6 +8173,7 @@
               </a:defRPr>
             </a:lvl5pPr>
             <a:lvl6pPr>
+              <a:buNone/>
               <a:defRPr sz="1425" b="0">
                 <a:solidFill>
                   <a:srgbClr val="617681"/>
@@ -7986,6 +8184,7 @@
               </a:defRPr>
             </a:lvl6pPr>
             <a:lvl7pPr>
+              <a:buNone/>
               <a:defRPr sz="1425" b="0">
                 <a:solidFill>
                   <a:srgbClr val="617681"/>
@@ -7996,6 +8195,7 @@
               </a:defRPr>
             </a:lvl7pPr>
             <a:lvl8pPr>
+              <a:buNone/>
               <a:defRPr sz="1425" b="0">
                 <a:solidFill>
                   <a:srgbClr val="617681"/>
@@ -8006,6 +8206,7 @@
               </a:defRPr>
             </a:lvl8pPr>
             <a:lvl9pPr>
+              <a:buNone/>
               <a:defRPr sz="1425" b="0">
                 <a:solidFill>
                   <a:srgbClr val="617681"/>
@@ -8018,6 +8219,7 @@
           </a:lstStyle>
           <a:p xmlns:a="http://schemas.openxmlformats.org/drawingml/2006/main">
             <a:pPr>
+              <a:buNone/>
               <a:defRPr sz="1425" b="0">
                 <a:solidFill>
                   <a:srgbClr val="617681"/>
@@ -10045,7 +10247,7 @@
         <p:spPr>
           <a:xfrm xmlns:a="http://schemas.openxmlformats.org/drawingml/2006/main">
             <a:off x="868680" y="2752344"/>
-            <a:ext cx="10607040" cy="640080"/>
+            <a:ext cx="10607040" cy="401422"/>
           </a:xfrm>
           <a:prstGeom xmlns:a="http://schemas.openxmlformats.org/drawingml/2006/main" prst="rect">
             <a:avLst/>
@@ -10076,7 +10278,7 @@
               </a:defRPr>
             </a:pPr>
             <a:r>
-              <a:t>교훈: Validation에서 좋은 선택이 Test에서도 좋다는 보장은 없습니다.</a:t>
+              <a:t>교훈: 후보 선택 때 좋아도, 마지막 시험에서는 실패할 수 있습니다.</a:t>
             </a:r>
           </a:p>
         </p:txBody>
@@ -10751,7 +10953,7 @@
           <p:cNvPr id="10" name="Table 9">
             <a:extLst xmlns:a="http://schemas.openxmlformats.org/drawingml/2006/main">
               <a:ext uri="{FF2B5EF4-FFF2-40B4-BE49-F238E27FC236}">
-                <a16:creationId xmlns:a16="http://schemas.microsoft.com/office/drawing/2014/main" id="{BD138B2A-BDC7-410E-972A-08A372DABB19}"/>
+                <a16:creationId xmlns:a16="http://schemas.microsoft.com/office/drawing/2014/main" id="{12FEF8F8-1C47-4B43-B348-2F1B5E1A446E}"/>
               </a:ext>
             </a:extLst>
           </p:cNvPr>
@@ -13128,7 +13330,7 @@
           <p:cNvPr id="12" name="Picture 11">
             <a:extLst xmlns:a="http://schemas.openxmlformats.org/drawingml/2006/main">
               <a:ext uri="{FF2B5EF4-FFF2-40B4-BE49-F238E27FC236}">
-                <a16:creationId xmlns:a16="http://schemas.microsoft.com/office/drawing/2014/main" id="{5B3AFBBD-499A-42FB-B675-A29F8EBB1F33}"/>
+                <a16:creationId xmlns:a16="http://schemas.microsoft.com/office/drawing/2014/main" id="{474A136D-86D5-419C-9040-18A02C5ADB2F}"/>
               </a:ext>
             </a:extLst>
           </p:cNvPr>
@@ -13138,7 +13340,7 @@
           <p:nvPr/>
         </p:nvPicPr>
         <p:blipFill>
-          <a:blip xmlns:r="http://schemas.openxmlformats.org/officeDocument/2006/relationships" xmlns:a="http://schemas.openxmlformats.org/drawingml/2006/main" r:embed="Reaf301caf9864591"/>
+          <a:blip xmlns:r="http://schemas.openxmlformats.org/officeDocument/2006/relationships" xmlns:a="http://schemas.openxmlformats.org/drawingml/2006/main" r:embed="R49cd04c69c0f4590"/>
           <a:stretch xmlns:a="http://schemas.openxmlformats.org/drawingml/2006/main">
             <a:fillRect l="0" t="0" r="0" b="0"/>
           </a:stretch>
@@ -14541,7 +14743,7 @@
           <p:cNvPr id="11" name="Table 10">
             <a:extLst xmlns:a="http://schemas.openxmlformats.org/drawingml/2006/main">
               <a:ext uri="{FF2B5EF4-FFF2-40B4-BE49-F238E27FC236}">
-                <a16:creationId xmlns:a16="http://schemas.microsoft.com/office/drawing/2014/main" id="{A28F10C0-7EA8-4AB5-A811-096B7E286CB6}"/>
+                <a16:creationId xmlns:a16="http://schemas.microsoft.com/office/drawing/2014/main" id="{4BFF90A9-01CF-4CBF-857B-DB4BA20353DB}"/>
               </a:ext>
             </a:extLst>
           </p:cNvPr>
@@ -14969,6 +15171,7 @@
               </a:defRPr>
             </a:defPPr>
             <a:lvl1pPr>
+              <a:buNone/>
               <a:defRPr sz="1200" b="1">
                 <a:solidFill>
                   <a:srgbClr val="147D82"/>
@@ -14979,6 +15182,7 @@
               </a:defRPr>
             </a:lvl1pPr>
             <a:lvl2pPr>
+              <a:buNone/>
               <a:defRPr sz="1200" b="1">
                 <a:solidFill>
                   <a:srgbClr val="147D82"/>
@@ -14989,6 +15193,7 @@
               </a:defRPr>
             </a:lvl2pPr>
             <a:lvl3pPr>
+              <a:buNone/>
               <a:defRPr sz="1200" b="1">
                 <a:solidFill>
                   <a:srgbClr val="147D82"/>
@@ -14999,6 +15204,7 @@
               </a:defRPr>
             </a:lvl3pPr>
             <a:lvl4pPr>
+              <a:buNone/>
               <a:defRPr sz="1200" b="1">
                 <a:solidFill>
                   <a:srgbClr val="147D82"/>
@@ -15009,6 +15215,7 @@
               </a:defRPr>
             </a:lvl4pPr>
             <a:lvl5pPr>
+              <a:buNone/>
               <a:defRPr sz="1200" b="1">
                 <a:solidFill>
                   <a:srgbClr val="147D82"/>
@@ -15019,6 +15226,7 @@
               </a:defRPr>
             </a:lvl5pPr>
             <a:lvl6pPr>
+              <a:buNone/>
               <a:defRPr sz="1200" b="1">
                 <a:solidFill>
                   <a:srgbClr val="147D82"/>
@@ -15029,6 +15237,7 @@
               </a:defRPr>
             </a:lvl6pPr>
             <a:lvl7pPr>
+              <a:buNone/>
               <a:defRPr sz="1200" b="1">
                 <a:solidFill>
                   <a:srgbClr val="147D82"/>
@@ -15039,6 +15248,7 @@
               </a:defRPr>
             </a:lvl7pPr>
             <a:lvl8pPr>
+              <a:buNone/>
               <a:defRPr sz="1200" b="1">
                 <a:solidFill>
                   <a:srgbClr val="147D82"/>
@@ -15049,6 +15259,7 @@
               </a:defRPr>
             </a:lvl8pPr>
             <a:lvl9pPr>
+              <a:buNone/>
               <a:defRPr sz="1200" b="1">
                 <a:solidFill>
                   <a:srgbClr val="147D82"/>
@@ -15061,6 +15272,7 @@
           </a:lstStyle>
           <a:p xmlns:a="http://schemas.openxmlformats.org/drawingml/2006/main">
             <a:pPr>
+              <a:buNone/>
               <a:defRPr sz="1200" b="1">
                 <a:solidFill>
                   <a:srgbClr val="147D82"/>
@@ -15125,6 +15337,7 @@
               </a:defRPr>
             </a:defPPr>
             <a:lvl1pPr>
+              <a:buNone/>
               <a:defRPr sz="2925" b="1">
                 <a:solidFill>
                   <a:srgbClr val="173A49"/>
@@ -15135,6 +15348,7 @@
               </a:defRPr>
             </a:lvl1pPr>
             <a:lvl2pPr>
+              <a:buNone/>
               <a:defRPr sz="2925" b="1">
                 <a:solidFill>
                   <a:srgbClr val="173A49"/>
@@ -15145,6 +15359,7 @@
               </a:defRPr>
             </a:lvl2pPr>
             <a:lvl3pPr>
+              <a:buNone/>
               <a:defRPr sz="2925" b="1">
                 <a:solidFill>
                   <a:srgbClr val="173A49"/>
@@ -15155,6 +15370,7 @@
               </a:defRPr>
             </a:lvl3pPr>
             <a:lvl4pPr>
+              <a:buNone/>
               <a:defRPr sz="2925" b="1">
                 <a:solidFill>
                   <a:srgbClr val="173A49"/>
@@ -15165,6 +15381,7 @@
               </a:defRPr>
             </a:lvl4pPr>
             <a:lvl5pPr>
+              <a:buNone/>
               <a:defRPr sz="2925" b="1">
                 <a:solidFill>
                   <a:srgbClr val="173A49"/>
@@ -15175,6 +15392,7 @@
               </a:defRPr>
             </a:lvl5pPr>
             <a:lvl6pPr>
+              <a:buNone/>
               <a:defRPr sz="2925" b="1">
                 <a:solidFill>
                   <a:srgbClr val="173A49"/>
@@ -15185,6 +15403,7 @@
               </a:defRPr>
             </a:lvl6pPr>
             <a:lvl7pPr>
+              <a:buNone/>
               <a:defRPr sz="2925" b="1">
                 <a:solidFill>
                   <a:srgbClr val="173A49"/>
@@ -15195,6 +15414,7 @@
               </a:defRPr>
             </a:lvl7pPr>
             <a:lvl8pPr>
+              <a:buNone/>
               <a:defRPr sz="2925" b="1">
                 <a:solidFill>
                   <a:srgbClr val="173A49"/>
@@ -15205,6 +15425,7 @@
               </a:defRPr>
             </a:lvl8pPr>
             <a:lvl9pPr>
+              <a:buNone/>
               <a:defRPr sz="2925" b="1">
                 <a:solidFill>
                   <a:srgbClr val="173A49"/>
@@ -15217,6 +15438,7 @@
           </a:lstStyle>
           <a:p xmlns:a="http://schemas.openxmlformats.org/drawingml/2006/main">
             <a:pPr>
+              <a:buNone/>
               <a:defRPr sz="2925" b="1">
                 <a:solidFill>
                   <a:srgbClr val="173A49"/>
@@ -15281,6 +15503,7 @@
               </a:defRPr>
             </a:defPPr>
             <a:lvl1pPr>
+              <a:buNone/>
               <a:defRPr sz="975" b="0">
                 <a:solidFill>
                   <a:srgbClr val="617681"/>
@@ -15291,6 +15514,7 @@
               </a:defRPr>
             </a:lvl1pPr>
             <a:lvl2pPr>
+              <a:buNone/>
               <a:defRPr sz="975" b="0">
                 <a:solidFill>
                   <a:srgbClr val="617681"/>
@@ -15301,6 +15525,7 @@
               </a:defRPr>
             </a:lvl2pPr>
             <a:lvl3pPr>
+              <a:buNone/>
               <a:defRPr sz="975" b="0">
                 <a:solidFill>
                   <a:srgbClr val="617681"/>
@@ -15311,6 +15536,7 @@
               </a:defRPr>
             </a:lvl3pPr>
             <a:lvl4pPr>
+              <a:buNone/>
               <a:defRPr sz="975" b="0">
                 <a:solidFill>
                   <a:srgbClr val="617681"/>
@@ -15321,6 +15547,7 @@
               </a:defRPr>
             </a:lvl4pPr>
             <a:lvl5pPr>
+              <a:buNone/>
               <a:defRPr sz="975" b="0">
                 <a:solidFill>
                   <a:srgbClr val="617681"/>
@@ -15331,6 +15558,7 @@
               </a:defRPr>
             </a:lvl5pPr>
             <a:lvl6pPr>
+              <a:buNone/>
               <a:defRPr sz="975" b="0">
                 <a:solidFill>
                   <a:srgbClr val="617681"/>
@@ -15341,6 +15569,7 @@
               </a:defRPr>
             </a:lvl6pPr>
             <a:lvl7pPr>
+              <a:buNone/>
               <a:defRPr sz="975" b="0">
                 <a:solidFill>
                   <a:srgbClr val="617681"/>
@@ -15351,6 +15580,7 @@
               </a:defRPr>
             </a:lvl7pPr>
             <a:lvl8pPr>
+              <a:buNone/>
               <a:defRPr sz="975" b="0">
                 <a:solidFill>
                   <a:srgbClr val="617681"/>
@@ -15361,6 +15591,7 @@
               </a:defRPr>
             </a:lvl8pPr>
             <a:lvl9pPr>
+              <a:buNone/>
               <a:defRPr sz="975" b="0">
                 <a:solidFill>
                   <a:srgbClr val="617681"/>
@@ -15373,6 +15604,7 @@
           </a:lstStyle>
           <a:p xmlns:a="http://schemas.openxmlformats.org/drawingml/2006/main">
             <a:pPr>
+              <a:buNone/>
               <a:defRPr sz="975" b="0">
                 <a:solidFill>
                   <a:srgbClr val="617681"/>
@@ -15437,6 +15669,7 @@
               </a:defRPr>
             </a:defPPr>
             <a:lvl1pPr>
+              <a:buNone/>
               <a:defRPr sz="975" b="0">
                 <a:solidFill>
                   <a:srgbClr val="617681"/>
@@ -15447,6 +15680,7 @@
               </a:defRPr>
             </a:lvl1pPr>
             <a:lvl2pPr>
+              <a:buNone/>
               <a:defRPr sz="975" b="0">
                 <a:solidFill>
                   <a:srgbClr val="617681"/>
@@ -15457,6 +15691,7 @@
               </a:defRPr>
             </a:lvl2pPr>
             <a:lvl3pPr>
+              <a:buNone/>
               <a:defRPr sz="975" b="0">
                 <a:solidFill>
                   <a:srgbClr val="617681"/>
@@ -15467,6 +15702,7 @@
               </a:defRPr>
             </a:lvl3pPr>
             <a:lvl4pPr>
+              <a:buNone/>
               <a:defRPr sz="975" b="0">
                 <a:solidFill>
                   <a:srgbClr val="617681"/>
@@ -15477,6 +15713,7 @@
               </a:defRPr>
             </a:lvl4pPr>
             <a:lvl5pPr>
+              <a:buNone/>
               <a:defRPr sz="975" b="0">
                 <a:solidFill>
                   <a:srgbClr val="617681"/>
@@ -15487,6 +15724,7 @@
               </a:defRPr>
             </a:lvl5pPr>
             <a:lvl6pPr>
+              <a:buNone/>
               <a:defRPr sz="975" b="0">
                 <a:solidFill>
                   <a:srgbClr val="617681"/>
@@ -15497,6 +15735,7 @@
               </a:defRPr>
             </a:lvl6pPr>
             <a:lvl7pPr>
+              <a:buNone/>
               <a:defRPr sz="975" b="0">
                 <a:solidFill>
                   <a:srgbClr val="617681"/>
@@ -15507,6 +15746,7 @@
               </a:defRPr>
             </a:lvl7pPr>
             <a:lvl8pPr>
+              <a:buNone/>
               <a:defRPr sz="975" b="0">
                 <a:solidFill>
                   <a:srgbClr val="617681"/>
@@ -15517,6 +15757,7 @@
               </a:defRPr>
             </a:lvl8pPr>
             <a:lvl9pPr>
+              <a:buNone/>
               <a:defRPr sz="975" b="0">
                 <a:solidFill>
                   <a:srgbClr val="617681"/>
@@ -15529,6 +15770,7 @@
           </a:lstStyle>
           <a:p xmlns:a="http://schemas.openxmlformats.org/drawingml/2006/main">
             <a:pPr>
+              <a:buNone/>
               <a:defRPr sz="975" b="0">
                 <a:solidFill>
                   <a:srgbClr val="617681"/>
@@ -15557,7 +15799,7 @@
           <p:cNvPr id="5" name="">
             <a:extLst xmlns:a="http://schemas.openxmlformats.org/drawingml/2006/main">
               <a:ext uri="{FF2B5EF4-FFF2-40B4-BE49-F238E27FC236}">
-                <a16:creationId xmlns:a16="http://schemas.microsoft.com/office/drawing/2014/main" id="{1FB297B4-86E9-4C85-A28D-E6FAF5275EB0}"/>
+                <a16:creationId xmlns:a16="http://schemas.microsoft.com/office/drawing/2014/main" id="{6F802FA7-0EE7-452E-B2AB-A518857F0AF6}"/>
               </a:ext>
             </a:extLst>
           </p:cNvPr>
@@ -17102,7 +17344,7 @@
         <p:spPr>
           <a:xfrm xmlns:a="http://schemas.openxmlformats.org/drawingml/2006/main">
             <a:off x="594360" y="292608"/>
-            <a:ext cx="10972800" cy="274320"/>
+            <a:ext cx="10972800" cy="245059"/>
           </a:xfrm>
           <a:prstGeom xmlns:a="http://schemas.openxmlformats.org/drawingml/2006/main" prst="rect">
             <a:avLst/>
@@ -17133,7 +17375,7 @@
               </a:defRPr>
             </a:pPr>
             <a:r>
-              <a:t>03 · 결과를 읽기 위한 기준</a:t>
+              <a:t>03 · 모델 선택 기준 | 두 가지 실수의 영향을 함께 봅니다</a:t>
             </a:r>
           </a:p>
         </p:txBody>
@@ -17155,7 +17397,7 @@
         <p:spPr>
           <a:xfrm xmlns:a="http://schemas.openxmlformats.org/drawingml/2006/main">
             <a:off x="594360" y="832104"/>
-            <a:ext cx="10972800" cy="1005840"/>
+            <a:ext cx="10972800" cy="592531"/>
           </a:xfrm>
           <a:prstGeom xmlns:a="http://schemas.openxmlformats.org/drawingml/2006/main" prst="rect">
             <a:avLst/>
@@ -17186,7 +17428,7 @@
               </a:defRPr>
             </a:pPr>
             <a:r>
-              <a:t>불량을 놓치지 않되, 정상 오판도 제한합니다</a:t>
+              <a:t>불량을 놓치지 않으면서, 정상도 지킵니다</a:t>
             </a:r>
           </a:p>
         </p:txBody>
@@ -17366,8 +17608,8 @@
         </p:nvSpPr>
         <p:spPr>
           <a:xfrm xmlns:a="http://schemas.openxmlformats.org/drawingml/2006/main">
-            <a:off x="658368" y="1965960"/>
-            <a:ext cx="5321808" cy="1307592"/>
+            <a:off x="658368" y="1885950"/>
+            <a:ext cx="5321808" cy="2286000"/>
           </a:xfrm>
           <a:prstGeom xmlns:a="http://schemas.openxmlformats.org/drawingml/2006/main" prst="roundRect">
             <a:avLst>
@@ -17421,8 +17663,8 @@
         </p:nvSpPr>
         <p:spPr>
           <a:xfrm xmlns:a="http://schemas.openxmlformats.org/drawingml/2006/main">
-            <a:off x="859536" y="2139696"/>
-            <a:ext cx="4892040" cy="411480"/>
+            <a:off x="859536" y="2057400"/>
+            <a:ext cx="4892040" cy="453542"/>
           </a:xfrm>
           <a:prstGeom xmlns:a="http://schemas.openxmlformats.org/drawingml/2006/main" prst="rect">
             <a:avLst/>
@@ -17433,9 +17675,110 @@
           <a:bodyPr xmlns:a="http://schemas.openxmlformats.org/drawingml/2006/main" wrap="square" lIns="18288" tIns="18288" rIns="18288" bIns="18288">
             <a:spAutoFit/>
           </a:bodyPr>
-          <a:lstStyle xmlns:a="http://schemas.openxmlformats.org/drawingml/2006/main"/>
-          <a:p xmlns:a="http://schemas.openxmlformats.org/drawingml/2006/main">
-            <a:pPr>
+          <a:lstStyle xmlns:a="http://schemas.openxmlformats.org/drawingml/2006/main">
+            <a:defPPr algn="l">
+              <a:defRPr sz="2400" b="1">
+                <a:solidFill>
+                  <a:srgbClr val="147D82"/>
+                </a:solidFill>
+                <a:latin typeface="맑은 고딕"/>
+                <a:ea typeface="맑은 고딕"/>
+                <a:cs typeface="맑은 고딕"/>
+              </a:defRPr>
+            </a:defPPr>
+            <a:lvl1pPr algn="l">
+              <a:defRPr sz="2400" b="1">
+                <a:solidFill>
+                  <a:srgbClr val="147D82"/>
+                </a:solidFill>
+                <a:latin typeface="맑은 고딕"/>
+                <a:ea typeface="맑은 고딕"/>
+                <a:cs typeface="맑은 고딕"/>
+              </a:defRPr>
+            </a:lvl1pPr>
+            <a:lvl2pPr algn="l">
+              <a:defRPr sz="2400" b="1">
+                <a:solidFill>
+                  <a:srgbClr val="147D82"/>
+                </a:solidFill>
+                <a:latin typeface="맑은 고딕"/>
+                <a:ea typeface="맑은 고딕"/>
+                <a:cs typeface="맑은 고딕"/>
+              </a:defRPr>
+            </a:lvl2pPr>
+            <a:lvl3pPr algn="l">
+              <a:defRPr sz="2400" b="1">
+                <a:solidFill>
+                  <a:srgbClr val="147D82"/>
+                </a:solidFill>
+                <a:latin typeface="맑은 고딕"/>
+                <a:ea typeface="맑은 고딕"/>
+                <a:cs typeface="맑은 고딕"/>
+              </a:defRPr>
+            </a:lvl3pPr>
+            <a:lvl4pPr algn="l">
+              <a:defRPr sz="2400" b="1">
+                <a:solidFill>
+                  <a:srgbClr val="147D82"/>
+                </a:solidFill>
+                <a:latin typeface="맑은 고딕"/>
+                <a:ea typeface="맑은 고딕"/>
+                <a:cs typeface="맑은 고딕"/>
+              </a:defRPr>
+            </a:lvl4pPr>
+            <a:lvl5pPr algn="l">
+              <a:defRPr sz="2400" b="1">
+                <a:solidFill>
+                  <a:srgbClr val="147D82"/>
+                </a:solidFill>
+                <a:latin typeface="맑은 고딕"/>
+                <a:ea typeface="맑은 고딕"/>
+                <a:cs typeface="맑은 고딕"/>
+              </a:defRPr>
+            </a:lvl5pPr>
+            <a:lvl6pPr algn="l">
+              <a:defRPr sz="2400" b="1">
+                <a:solidFill>
+                  <a:srgbClr val="147D82"/>
+                </a:solidFill>
+                <a:latin typeface="맑은 고딕"/>
+                <a:ea typeface="맑은 고딕"/>
+                <a:cs typeface="맑은 고딕"/>
+              </a:defRPr>
+            </a:lvl6pPr>
+            <a:lvl7pPr algn="l">
+              <a:defRPr sz="2400" b="1">
+                <a:solidFill>
+                  <a:srgbClr val="147D82"/>
+                </a:solidFill>
+                <a:latin typeface="맑은 고딕"/>
+                <a:ea typeface="맑은 고딕"/>
+                <a:cs typeface="맑은 고딕"/>
+              </a:defRPr>
+            </a:lvl7pPr>
+            <a:lvl8pPr algn="l">
+              <a:defRPr sz="2400" b="1">
+                <a:solidFill>
+                  <a:srgbClr val="147D82"/>
+                </a:solidFill>
+                <a:latin typeface="맑은 고딕"/>
+                <a:ea typeface="맑은 고딕"/>
+                <a:cs typeface="맑은 고딕"/>
+              </a:defRPr>
+            </a:lvl8pPr>
+            <a:lvl9pPr algn="l">
+              <a:defRPr sz="2400" b="1">
+                <a:solidFill>
+                  <a:srgbClr val="147D82"/>
+                </a:solidFill>
+                <a:latin typeface="맑은 고딕"/>
+                <a:ea typeface="맑은 고딕"/>
+                <a:cs typeface="맑은 고딕"/>
+              </a:defRPr>
+            </a:lvl9pPr>
+          </a:lstStyle>
+          <a:p xmlns:a="http://schemas.openxmlformats.org/drawingml/2006/main">
+            <a:pPr algn="l">
               <a:lnSpc>
                 <a:spcPct val="114000"/>
               </a:lnSpc>
@@ -17443,7 +17786,7 @@
                 <a:spcPts val="800"/>
               </a:spcAft>
               <a:buNone/>
-              <a:defRPr sz="2500" b="1">
+              <a:defRPr sz="2400" b="1">
                 <a:solidFill>
                   <a:srgbClr val="147D82"/>
                 </a:solidFill>
@@ -17453,7 +17796,15 @@
               </a:defRPr>
             </a:pPr>
             <a:r>
-              <a:t>불량 검출률 · Recall</a:t>
+              <a:rPr sz="2400" b="1">
+                <a:solidFill>
+                  <a:srgbClr val="147D82"/>
+                </a:solidFill>
+                <a:latin typeface="맑은 고딕"/>
+                <a:ea typeface="맑은 고딕"/>
+                <a:cs typeface="맑은 고딕"/>
+              </a:rPr>
+              <a:t>불량을 정상으로 놓침</a:t>
             </a:r>
           </a:p>
         </p:txBody>
@@ -17474,8 +17825,8 @@
         </p:nvSpPr>
         <p:spPr>
           <a:xfrm xmlns:a="http://schemas.openxmlformats.org/drawingml/2006/main">
-            <a:off x="859536" y="2715768"/>
-            <a:ext cx="4892040" cy="365760"/>
+            <a:off x="859536" y="2609850"/>
+            <a:ext cx="4892040" cy="1217041"/>
           </a:xfrm>
           <a:prstGeom xmlns:a="http://schemas.openxmlformats.org/drawingml/2006/main" prst="rect">
             <a:avLst/>
@@ -17486,9 +17837,110 @@
           <a:bodyPr xmlns:a="http://schemas.openxmlformats.org/drawingml/2006/main" wrap="square" lIns="18288" tIns="18288" rIns="18288" bIns="18288">
             <a:spAutoFit/>
           </a:bodyPr>
-          <a:lstStyle xmlns:a="http://schemas.openxmlformats.org/drawingml/2006/main"/>
-          <a:p xmlns:a="http://schemas.openxmlformats.org/drawingml/2006/main">
-            <a:pPr>
+          <a:lstStyle xmlns:a="http://schemas.openxmlformats.org/drawingml/2006/main">
+            <a:defPPr algn="l">
+              <a:defRPr sz="1875">
+                <a:solidFill>
+                  <a:srgbClr val="173A49"/>
+                </a:solidFill>
+                <a:latin typeface="맑은 고딕"/>
+                <a:ea typeface="맑은 고딕"/>
+                <a:cs typeface="맑은 고딕"/>
+              </a:defRPr>
+            </a:defPPr>
+            <a:lvl1pPr algn="l">
+              <a:defRPr sz="1875">
+                <a:solidFill>
+                  <a:srgbClr val="173A49"/>
+                </a:solidFill>
+                <a:latin typeface="맑은 고딕"/>
+                <a:ea typeface="맑은 고딕"/>
+                <a:cs typeface="맑은 고딕"/>
+              </a:defRPr>
+            </a:lvl1pPr>
+            <a:lvl2pPr algn="l">
+              <a:defRPr sz="1875">
+                <a:solidFill>
+                  <a:srgbClr val="173A49"/>
+                </a:solidFill>
+                <a:latin typeface="맑은 고딕"/>
+                <a:ea typeface="맑은 고딕"/>
+                <a:cs typeface="맑은 고딕"/>
+              </a:defRPr>
+            </a:lvl2pPr>
+            <a:lvl3pPr algn="l">
+              <a:defRPr sz="1875">
+                <a:solidFill>
+                  <a:srgbClr val="173A49"/>
+                </a:solidFill>
+                <a:latin typeface="맑은 고딕"/>
+                <a:ea typeface="맑은 고딕"/>
+                <a:cs typeface="맑은 고딕"/>
+              </a:defRPr>
+            </a:lvl3pPr>
+            <a:lvl4pPr algn="l">
+              <a:defRPr sz="1875">
+                <a:solidFill>
+                  <a:srgbClr val="173A49"/>
+                </a:solidFill>
+                <a:latin typeface="맑은 고딕"/>
+                <a:ea typeface="맑은 고딕"/>
+                <a:cs typeface="맑은 고딕"/>
+              </a:defRPr>
+            </a:lvl4pPr>
+            <a:lvl5pPr algn="l">
+              <a:defRPr sz="1875">
+                <a:solidFill>
+                  <a:srgbClr val="173A49"/>
+                </a:solidFill>
+                <a:latin typeface="맑은 고딕"/>
+                <a:ea typeface="맑은 고딕"/>
+                <a:cs typeface="맑은 고딕"/>
+              </a:defRPr>
+            </a:lvl5pPr>
+            <a:lvl6pPr algn="l">
+              <a:defRPr sz="1875">
+                <a:solidFill>
+                  <a:srgbClr val="173A49"/>
+                </a:solidFill>
+                <a:latin typeface="맑은 고딕"/>
+                <a:ea typeface="맑은 고딕"/>
+                <a:cs typeface="맑은 고딕"/>
+              </a:defRPr>
+            </a:lvl6pPr>
+            <a:lvl7pPr algn="l">
+              <a:defRPr sz="1875">
+                <a:solidFill>
+                  <a:srgbClr val="173A49"/>
+                </a:solidFill>
+                <a:latin typeface="맑은 고딕"/>
+                <a:ea typeface="맑은 고딕"/>
+                <a:cs typeface="맑은 고딕"/>
+              </a:defRPr>
+            </a:lvl7pPr>
+            <a:lvl8pPr algn="l">
+              <a:defRPr sz="1875">
+                <a:solidFill>
+                  <a:srgbClr val="173A49"/>
+                </a:solidFill>
+                <a:latin typeface="맑은 고딕"/>
+                <a:ea typeface="맑은 고딕"/>
+                <a:cs typeface="맑은 고딕"/>
+              </a:defRPr>
+            </a:lvl8pPr>
+            <a:lvl9pPr algn="l">
+              <a:defRPr sz="1875">
+                <a:solidFill>
+                  <a:srgbClr val="173A49"/>
+                </a:solidFill>
+                <a:latin typeface="맑은 고딕"/>
+                <a:ea typeface="맑은 고딕"/>
+                <a:cs typeface="맑은 고딕"/>
+              </a:defRPr>
+            </a:lvl9pPr>
+          </a:lstStyle>
+          <a:p xmlns:a="http://schemas.openxmlformats.org/drawingml/2006/main">
+            <a:pPr algn="l">
               <a:lnSpc>
                 <a:spcPct val="114000"/>
               </a:lnSpc>
@@ -17496,7 +17948,7 @@
                 <a:spcPts val="800"/>
               </a:spcAft>
               <a:buNone/>
-              <a:defRPr sz="1900" b="0">
+              <a:defRPr sz="1875" b="0">
                 <a:solidFill>
                   <a:srgbClr val="173A49"/>
                 </a:solidFill>
@@ -17506,7 +17958,75 @@
               </a:defRPr>
             </a:pPr>
             <a:r>
-              <a:t>불량 100개 중 몇 개를 찾았나요?</a:t>
+              <a:rPr sz="1875">
+                <a:solidFill>
+                  <a:srgbClr val="173A49"/>
+                </a:solidFill>
+                <a:latin typeface="맑은 고딕"/>
+                <a:ea typeface="맑은 고딕"/>
+                <a:cs typeface="맑은 고딕"/>
+              </a:rPr>
+              <a:t>불량이 다음 공정·고객으로</a:t>
+            </a:r>
+          </a:p>
+          <a:p xmlns:a="http://schemas.openxmlformats.org/drawingml/2006/main">
+            <a:pPr algn="l">
+              <a:lnSpc>
+                <a:spcPct val="114000"/>
+              </a:lnSpc>
+              <a:spcAft>
+                <a:spcPts val="800"/>
+              </a:spcAft>
+              <a:buNone/>
+              <a:defRPr sz="1875" b="0">
+                <a:solidFill>
+                  <a:srgbClr val="173A49"/>
+                </a:solidFill>
+                <a:latin typeface="맑은 고딕"/>
+                <a:ea typeface="맑은 고딕"/>
+                <a:cs typeface="맑은 고딕"/>
+              </a:defRPr>
+            </a:pPr>
+            <a:r>
+              <a:rPr sz="1875" b="0">
+                <a:solidFill>
+                  <a:srgbClr val="173A49"/>
+                </a:solidFill>
+                <a:latin typeface="맑은 고딕"/>
+                <a:ea typeface="맑은 고딕"/>
+                <a:cs typeface="맑은 고딕"/>
+              </a:rPr>
+              <a:t>넘어갈 위험이 있습니다.</a:t>
+            </a:r>
+          </a:p>
+          <a:p xmlns:a="http://schemas.openxmlformats.org/drawingml/2006/main">
+            <a:pPr algn="l">
+              <a:lnSpc>
+                <a:spcPct val="114000"/>
+              </a:lnSpc>
+              <a:spcAft>
+                <a:spcPts val="800"/>
+              </a:spcAft>
+              <a:buNone/>
+              <a:defRPr sz="1875" b="0">
+                <a:solidFill>
+                  <a:srgbClr val="173A49"/>
+                </a:solidFill>
+                <a:latin typeface="맑은 고딕"/>
+                <a:ea typeface="맑은 고딕"/>
+                <a:cs typeface="맑은 고딕"/>
+              </a:defRPr>
+            </a:pPr>
+            <a:r>
+              <a:rPr sz="1875" b="0">
+                <a:solidFill>
+                  <a:srgbClr val="173A49"/>
+                </a:solidFill>
+                <a:latin typeface="맑은 고딕"/>
+                <a:ea typeface="맑은 고딕"/>
+                <a:cs typeface="맑은 고딕"/>
+              </a:rPr>
+              <a:t>Recall: 불량100개 중 찾아낸 비율</a:t>
             </a:r>
           </a:p>
         </p:txBody>
@@ -17527,8 +18047,8 @@
         </p:nvSpPr>
         <p:spPr>
           <a:xfrm xmlns:a="http://schemas.openxmlformats.org/drawingml/2006/main">
-            <a:off x="6217920" y="1965960"/>
-            <a:ext cx="5321808" cy="1307592"/>
+            <a:off x="6217920" y="1885950"/>
+            <a:ext cx="5321808" cy="2286000"/>
           </a:xfrm>
           <a:prstGeom xmlns:a="http://schemas.openxmlformats.org/drawingml/2006/main" prst="roundRect">
             <a:avLst>
@@ -17582,8 +18102,8 @@
         </p:nvSpPr>
         <p:spPr>
           <a:xfrm xmlns:a="http://schemas.openxmlformats.org/drawingml/2006/main">
-            <a:off x="6419088" y="2139696"/>
-            <a:ext cx="4892040" cy="411480"/>
+            <a:off x="6419088" y="2057400"/>
+            <a:ext cx="4892040" cy="453542"/>
           </a:xfrm>
           <a:prstGeom xmlns:a="http://schemas.openxmlformats.org/drawingml/2006/main" prst="rect">
             <a:avLst/>
@@ -17594,9 +18114,110 @@
           <a:bodyPr xmlns:a="http://schemas.openxmlformats.org/drawingml/2006/main" wrap="square" lIns="18288" tIns="18288" rIns="18288" bIns="18288">
             <a:spAutoFit/>
           </a:bodyPr>
-          <a:lstStyle xmlns:a="http://schemas.openxmlformats.org/drawingml/2006/main"/>
-          <a:p xmlns:a="http://schemas.openxmlformats.org/drawingml/2006/main">
-            <a:pPr>
+          <a:lstStyle xmlns:a="http://schemas.openxmlformats.org/drawingml/2006/main">
+            <a:defPPr algn="l">
+              <a:defRPr sz="2400" b="1">
+                <a:solidFill>
+                  <a:srgbClr val="173A49"/>
+                </a:solidFill>
+                <a:latin typeface="맑은 고딕"/>
+                <a:ea typeface="맑은 고딕"/>
+                <a:cs typeface="맑은 고딕"/>
+              </a:defRPr>
+            </a:defPPr>
+            <a:lvl1pPr algn="l">
+              <a:defRPr sz="2400" b="1">
+                <a:solidFill>
+                  <a:srgbClr val="173A49"/>
+                </a:solidFill>
+                <a:latin typeface="맑은 고딕"/>
+                <a:ea typeface="맑은 고딕"/>
+                <a:cs typeface="맑은 고딕"/>
+              </a:defRPr>
+            </a:lvl1pPr>
+            <a:lvl2pPr algn="l">
+              <a:defRPr sz="2400" b="1">
+                <a:solidFill>
+                  <a:srgbClr val="173A49"/>
+                </a:solidFill>
+                <a:latin typeface="맑은 고딕"/>
+                <a:ea typeface="맑은 고딕"/>
+                <a:cs typeface="맑은 고딕"/>
+              </a:defRPr>
+            </a:lvl2pPr>
+            <a:lvl3pPr algn="l">
+              <a:defRPr sz="2400" b="1">
+                <a:solidFill>
+                  <a:srgbClr val="173A49"/>
+                </a:solidFill>
+                <a:latin typeface="맑은 고딕"/>
+                <a:ea typeface="맑은 고딕"/>
+                <a:cs typeface="맑은 고딕"/>
+              </a:defRPr>
+            </a:lvl3pPr>
+            <a:lvl4pPr algn="l">
+              <a:defRPr sz="2400" b="1">
+                <a:solidFill>
+                  <a:srgbClr val="173A49"/>
+                </a:solidFill>
+                <a:latin typeface="맑은 고딕"/>
+                <a:ea typeface="맑은 고딕"/>
+                <a:cs typeface="맑은 고딕"/>
+              </a:defRPr>
+            </a:lvl4pPr>
+            <a:lvl5pPr algn="l">
+              <a:defRPr sz="2400" b="1">
+                <a:solidFill>
+                  <a:srgbClr val="173A49"/>
+                </a:solidFill>
+                <a:latin typeface="맑은 고딕"/>
+                <a:ea typeface="맑은 고딕"/>
+                <a:cs typeface="맑은 고딕"/>
+              </a:defRPr>
+            </a:lvl5pPr>
+            <a:lvl6pPr algn="l">
+              <a:defRPr sz="2400" b="1">
+                <a:solidFill>
+                  <a:srgbClr val="173A49"/>
+                </a:solidFill>
+                <a:latin typeface="맑은 고딕"/>
+                <a:ea typeface="맑은 고딕"/>
+                <a:cs typeface="맑은 고딕"/>
+              </a:defRPr>
+            </a:lvl6pPr>
+            <a:lvl7pPr algn="l">
+              <a:defRPr sz="2400" b="1">
+                <a:solidFill>
+                  <a:srgbClr val="173A49"/>
+                </a:solidFill>
+                <a:latin typeface="맑은 고딕"/>
+                <a:ea typeface="맑은 고딕"/>
+                <a:cs typeface="맑은 고딕"/>
+              </a:defRPr>
+            </a:lvl7pPr>
+            <a:lvl8pPr algn="l">
+              <a:defRPr sz="2400" b="1">
+                <a:solidFill>
+                  <a:srgbClr val="173A49"/>
+                </a:solidFill>
+                <a:latin typeface="맑은 고딕"/>
+                <a:ea typeface="맑은 고딕"/>
+                <a:cs typeface="맑은 고딕"/>
+              </a:defRPr>
+            </a:lvl8pPr>
+            <a:lvl9pPr algn="l">
+              <a:defRPr sz="2400" b="1">
+                <a:solidFill>
+                  <a:srgbClr val="173A49"/>
+                </a:solidFill>
+                <a:latin typeface="맑은 고딕"/>
+                <a:ea typeface="맑은 고딕"/>
+                <a:cs typeface="맑은 고딕"/>
+              </a:defRPr>
+            </a:lvl9pPr>
+          </a:lstStyle>
+          <a:p xmlns:a="http://schemas.openxmlformats.org/drawingml/2006/main">
+            <a:pPr algn="l">
               <a:lnSpc>
                 <a:spcPct val="114000"/>
               </a:lnSpc>
@@ -17604,7 +18225,7 @@
                 <a:spcPts val="800"/>
               </a:spcAft>
               <a:buNone/>
-              <a:defRPr sz="2500" b="1">
+              <a:defRPr sz="2400" b="1">
                 <a:solidFill>
                   <a:srgbClr val="173A49"/>
                 </a:solidFill>
@@ -17614,7 +18235,15 @@
               </a:defRPr>
             </a:pPr>
             <a:r>
-              <a:t>정상 오판률</a:t>
+              <a:rPr sz="2400" b="1">
+                <a:solidFill>
+                  <a:srgbClr val="173A49"/>
+                </a:solidFill>
+                <a:latin typeface="맑은 고딕"/>
+                <a:ea typeface="맑은 고딕"/>
+                <a:cs typeface="맑은 고딕"/>
+              </a:rPr>
+              <a:t>정상을 불량으로 오판</a:t>
             </a:r>
           </a:p>
         </p:txBody>
@@ -17635,8 +18264,8 @@
         </p:nvSpPr>
         <p:spPr>
           <a:xfrm xmlns:a="http://schemas.openxmlformats.org/drawingml/2006/main">
-            <a:off x="6419088" y="2715768"/>
-            <a:ext cx="4892040" cy="365760"/>
+            <a:off x="6419088" y="2609850"/>
+            <a:ext cx="4892040" cy="1177950"/>
           </a:xfrm>
           <a:prstGeom xmlns:a="http://schemas.openxmlformats.org/drawingml/2006/main" prst="rect">
             <a:avLst/>
@@ -17647,9 +18276,110 @@
           <a:bodyPr xmlns:a="http://schemas.openxmlformats.org/drawingml/2006/main" wrap="square" lIns="18288" tIns="18288" rIns="18288" bIns="18288">
             <a:spAutoFit/>
           </a:bodyPr>
-          <a:lstStyle xmlns:a="http://schemas.openxmlformats.org/drawingml/2006/main"/>
-          <a:p xmlns:a="http://schemas.openxmlformats.org/drawingml/2006/main">
-            <a:pPr>
+          <a:lstStyle xmlns:a="http://schemas.openxmlformats.org/drawingml/2006/main">
+            <a:defPPr algn="l">
+              <a:defRPr sz="1800">
+                <a:solidFill>
+                  <a:srgbClr val="173A49"/>
+                </a:solidFill>
+                <a:latin typeface="맑은 고딕"/>
+                <a:ea typeface="맑은 고딕"/>
+                <a:cs typeface="맑은 고딕"/>
+              </a:defRPr>
+            </a:defPPr>
+            <a:lvl1pPr algn="l">
+              <a:defRPr sz="1800">
+                <a:solidFill>
+                  <a:srgbClr val="173A49"/>
+                </a:solidFill>
+                <a:latin typeface="맑은 고딕"/>
+                <a:ea typeface="맑은 고딕"/>
+                <a:cs typeface="맑은 고딕"/>
+              </a:defRPr>
+            </a:lvl1pPr>
+            <a:lvl2pPr algn="l">
+              <a:defRPr sz="1800">
+                <a:solidFill>
+                  <a:srgbClr val="173A49"/>
+                </a:solidFill>
+                <a:latin typeface="맑은 고딕"/>
+                <a:ea typeface="맑은 고딕"/>
+                <a:cs typeface="맑은 고딕"/>
+              </a:defRPr>
+            </a:lvl2pPr>
+            <a:lvl3pPr algn="l">
+              <a:defRPr sz="1800">
+                <a:solidFill>
+                  <a:srgbClr val="173A49"/>
+                </a:solidFill>
+                <a:latin typeface="맑은 고딕"/>
+                <a:ea typeface="맑은 고딕"/>
+                <a:cs typeface="맑은 고딕"/>
+              </a:defRPr>
+            </a:lvl3pPr>
+            <a:lvl4pPr algn="l">
+              <a:defRPr sz="1800">
+                <a:solidFill>
+                  <a:srgbClr val="173A49"/>
+                </a:solidFill>
+                <a:latin typeface="맑은 고딕"/>
+                <a:ea typeface="맑은 고딕"/>
+                <a:cs typeface="맑은 고딕"/>
+              </a:defRPr>
+            </a:lvl4pPr>
+            <a:lvl5pPr algn="l">
+              <a:defRPr sz="1800">
+                <a:solidFill>
+                  <a:srgbClr val="173A49"/>
+                </a:solidFill>
+                <a:latin typeface="맑은 고딕"/>
+                <a:ea typeface="맑은 고딕"/>
+                <a:cs typeface="맑은 고딕"/>
+              </a:defRPr>
+            </a:lvl5pPr>
+            <a:lvl6pPr algn="l">
+              <a:defRPr sz="1800">
+                <a:solidFill>
+                  <a:srgbClr val="173A49"/>
+                </a:solidFill>
+                <a:latin typeface="맑은 고딕"/>
+                <a:ea typeface="맑은 고딕"/>
+                <a:cs typeface="맑은 고딕"/>
+              </a:defRPr>
+            </a:lvl6pPr>
+            <a:lvl7pPr algn="l">
+              <a:defRPr sz="1800">
+                <a:solidFill>
+                  <a:srgbClr val="173A49"/>
+                </a:solidFill>
+                <a:latin typeface="맑은 고딕"/>
+                <a:ea typeface="맑은 고딕"/>
+                <a:cs typeface="맑은 고딕"/>
+              </a:defRPr>
+            </a:lvl7pPr>
+            <a:lvl8pPr algn="l">
+              <a:defRPr sz="1800">
+                <a:solidFill>
+                  <a:srgbClr val="173A49"/>
+                </a:solidFill>
+                <a:latin typeface="맑은 고딕"/>
+                <a:ea typeface="맑은 고딕"/>
+                <a:cs typeface="맑은 고딕"/>
+              </a:defRPr>
+            </a:lvl8pPr>
+            <a:lvl9pPr algn="l">
+              <a:defRPr sz="1800">
+                <a:solidFill>
+                  <a:srgbClr val="173A49"/>
+                </a:solidFill>
+                <a:latin typeface="맑은 고딕"/>
+                <a:ea typeface="맑은 고딕"/>
+                <a:cs typeface="맑은 고딕"/>
+              </a:defRPr>
+            </a:lvl9pPr>
+          </a:lstStyle>
+          <a:p xmlns:a="http://schemas.openxmlformats.org/drawingml/2006/main">
+            <a:pPr algn="l">
               <a:lnSpc>
                 <a:spcPct val="114000"/>
               </a:lnSpc>
@@ -17657,7 +18387,7 @@
                 <a:spcPts val="800"/>
               </a:spcAft>
               <a:buNone/>
-              <a:defRPr sz="1900" b="0">
+              <a:defRPr sz="1800" b="0">
                 <a:solidFill>
                   <a:srgbClr val="173A49"/>
                 </a:solidFill>
@@ -17667,42 +18397,19 @@
               </a:defRPr>
             </a:pPr>
             <a:r>
-              <a:t>정상 100개 중 몇 개를 잘못 잡았나요?</a:t>
-            </a:r>
-          </a:p>
-        </p:txBody>
-      </p:sp>
-      <p:sp>
-        <p:nvSpPr>
-          <p:cNvPr id="14" name="TextBox 13">
-            <a:extLst xmlns:a="http://schemas.openxmlformats.org/drawingml/2006/main">
-              <a:ext uri="{FF2B5EF4-FFF2-40B4-BE49-F238E27FC236}">
-                <a16:creationId xmlns:a16="http://schemas.microsoft.com/office/drawing/2014/main" id="{5D36A391-BA26-4980-8CDE-3AB17EAB27B3}"/>
-              </a:ext>
-            </a:extLst>
-          </p:cNvPr>
-          <p:cNvSpPr>
-            <a:spLocks xmlns:a="http://schemas.openxmlformats.org/drawingml/2006/main" noGrp="1"/>
-          </p:cNvSpPr>
-          <p:nvPr/>
-        </p:nvSpPr>
-        <p:spPr>
-          <a:xfrm xmlns:a="http://schemas.openxmlformats.org/drawingml/2006/main">
-            <a:off x="731520" y="3648456"/>
-            <a:ext cx="10698480" cy="502920"/>
-          </a:xfrm>
-          <a:prstGeom xmlns:a="http://schemas.openxmlformats.org/drawingml/2006/main" prst="rect">
-            <a:avLst/>
-          </a:prstGeom>
-          <a:noFill xmlns:a="http://schemas.openxmlformats.org/drawingml/2006/main"/>
-        </p:spPr>
-        <p:txBody>
-          <a:bodyPr xmlns:a="http://schemas.openxmlformats.org/drawingml/2006/main" wrap="square" lIns="18288" tIns="18288" rIns="18288" bIns="18288">
-            <a:spAutoFit/>
-          </a:bodyPr>
-          <a:lstStyle xmlns:a="http://schemas.openxmlformats.org/drawingml/2006/main"/>
-          <a:p xmlns:a="http://schemas.openxmlformats.org/drawingml/2006/main">
-            <a:pPr>
+              <a:rPr sz="1800">
+                <a:solidFill>
+                  <a:srgbClr val="173A49"/>
+                </a:solidFill>
+                <a:latin typeface="맑은 고딕"/>
+                <a:ea typeface="맑은 고딕"/>
+                <a:cs typeface="맑은 고딕"/>
+              </a:rPr>
+              <a:t>불필요한 확인·보류가 늘고</a:t>
+            </a:r>
+          </a:p>
+          <a:p xmlns:a="http://schemas.openxmlformats.org/drawingml/2006/main">
+            <a:pPr algn="l">
               <a:lnSpc>
                 <a:spcPct val="114000"/>
               </a:lnSpc>
@@ -17710,7 +18417,7 @@
                 <a:spcPts val="800"/>
               </a:spcAft>
               <a:buNone/>
-              <a:defRPr sz="2300" b="1">
+              <a:defRPr sz="1800" b="0">
                 <a:solidFill>
                   <a:srgbClr val="173A49"/>
                 </a:solidFill>
@@ -17720,42 +18427,19 @@
               </a:defRPr>
             </a:pPr>
             <a:r>
-              <a:t>시연 목표: 불량 검출률 90% 이상 · 정상 오판률 15% 이하</a:t>
-            </a:r>
-          </a:p>
-        </p:txBody>
-      </p:sp>
-      <p:sp>
-        <p:nvSpPr>
-          <p:cNvPr id="15" name="TextBox 14">
-            <a:extLst xmlns:a="http://schemas.openxmlformats.org/drawingml/2006/main">
-              <a:ext uri="{FF2B5EF4-FFF2-40B4-BE49-F238E27FC236}">
-                <a16:creationId xmlns:a16="http://schemas.microsoft.com/office/drawing/2014/main" id="{50418AAC-605E-41FF-AF16-DBA9CA75A8C5}"/>
-              </a:ext>
-            </a:extLst>
-          </p:cNvPr>
-          <p:cNvSpPr>
-            <a:spLocks xmlns:a="http://schemas.openxmlformats.org/drawingml/2006/main" noGrp="1"/>
-          </p:cNvSpPr>
-          <p:nvPr/>
-        </p:nvSpPr>
-        <p:spPr>
-          <a:xfrm xmlns:a="http://schemas.openxmlformats.org/drawingml/2006/main">
-            <a:off x="731520" y="4471416"/>
-            <a:ext cx="10698480" cy="502920"/>
-          </a:xfrm>
-          <a:prstGeom xmlns:a="http://schemas.openxmlformats.org/drawingml/2006/main" prst="rect">
-            <a:avLst/>
-          </a:prstGeom>
-          <a:noFill xmlns:a="http://schemas.openxmlformats.org/drawingml/2006/main"/>
-        </p:spPr>
-        <p:txBody>
-          <a:bodyPr xmlns:a="http://schemas.openxmlformats.org/drawingml/2006/main" wrap="square" lIns="18288" tIns="18288" rIns="18288" bIns="18288">
-            <a:spAutoFit/>
-          </a:bodyPr>
-          <a:lstStyle xmlns:a="http://schemas.openxmlformats.org/drawingml/2006/main"/>
-          <a:p xmlns:a="http://schemas.openxmlformats.org/drawingml/2006/main">
-            <a:pPr>
+              <a:rPr sz="1800" b="0">
+                <a:solidFill>
+                  <a:srgbClr val="173A49"/>
+                </a:solidFill>
+                <a:latin typeface="맑은 고딕"/>
+                <a:ea typeface="맑은 고딕"/>
+                <a:cs typeface="맑은 고딕"/>
+              </a:rPr>
+              <a:t>정상 제품을 제외할 위험이 있습니다.</a:t>
+            </a:r>
+          </a:p>
+          <a:p xmlns:a="http://schemas.openxmlformats.org/drawingml/2006/main">
+            <a:pPr algn="l">
               <a:lnSpc>
                 <a:spcPct val="114000"/>
               </a:lnSpc>
@@ -17763,27 +18447,35 @@
                 <a:spcPts val="800"/>
               </a:spcAft>
               <a:buNone/>
-              <a:defRPr sz="2200" b="1">
-                <a:solidFill>
-                  <a:srgbClr val="147D82"/>
-                </a:solidFill>
-                <a:latin typeface="맑은 고딕"/>
-                <a:ea typeface="맑은 고딕"/>
-                <a:cs typeface="맑은 고딕"/>
-              </a:defRPr>
-            </a:pPr>
-            <a:r>
-              <a:t>정상 오판 한도 준수 → 검출률 최대 → 동률이면 F1</a:t>
-            </a:r>
-          </a:p>
-        </p:txBody>
-      </p:sp>
-      <p:sp>
-        <p:nvSpPr>
-          <p:cNvPr id="16" name="TextBox 15">
-            <a:extLst xmlns:a="http://schemas.openxmlformats.org/drawingml/2006/main">
-              <a:ext uri="{FF2B5EF4-FFF2-40B4-BE49-F238E27FC236}">
-                <a16:creationId xmlns:a16="http://schemas.microsoft.com/office/drawing/2014/main" id="{9C50AF9B-0CD5-48D5-914F-A5796F3A20CB}"/>
+              <a:defRPr sz="1800" b="0">
+                <a:solidFill>
+                  <a:srgbClr val="173A49"/>
+                </a:solidFill>
+                <a:latin typeface="맑은 고딕"/>
+                <a:ea typeface="맑은 고딕"/>
+                <a:cs typeface="맑은 고딕"/>
+              </a:defRPr>
+            </a:pPr>
+            <a:r>
+              <a:rPr sz="1800" b="0">
+                <a:solidFill>
+                  <a:srgbClr val="173A49"/>
+                </a:solidFill>
+                <a:latin typeface="맑은 고딕"/>
+                <a:ea typeface="맑은 고딕"/>
+                <a:cs typeface="맑은 고딕"/>
+              </a:rPr>
+              <a:t>정상 오판률: 정상100개 중 잘못 잡은 비율</a:t>
+            </a:r>
+          </a:p>
+        </p:txBody>
+      </p:sp>
+      <p:sp>
+        <p:nvSpPr>
+          <p:cNvPr id="14" name="TextBox 13">
+            <a:extLst xmlns:a="http://schemas.openxmlformats.org/drawingml/2006/main">
+              <a:ext uri="{FF2B5EF4-FFF2-40B4-BE49-F238E27FC236}">
+                <a16:creationId xmlns:a16="http://schemas.microsoft.com/office/drawing/2014/main" id="{5D36A391-BA26-4980-8CDE-3AB17EAB27B3}"/>
               </a:ext>
             </a:extLst>
           </p:cNvPr>
@@ -17794,8 +18486,8 @@
         </p:nvSpPr>
         <p:spPr>
           <a:xfrm xmlns:a="http://schemas.openxmlformats.org/drawingml/2006/main">
-            <a:off x="731520" y="5102352"/>
-            <a:ext cx="10698480" cy="365760"/>
+            <a:off x="731520" y="5353050"/>
+            <a:ext cx="10698480" cy="362331"/>
           </a:xfrm>
           <a:prstGeom xmlns:a="http://schemas.openxmlformats.org/drawingml/2006/main" prst="rect">
             <a:avLst/>
@@ -17806,9 +18498,110 @@
           <a:bodyPr xmlns:a="http://schemas.openxmlformats.org/drawingml/2006/main" wrap="square" lIns="18288" tIns="18288" rIns="18288" bIns="18288">
             <a:spAutoFit/>
           </a:bodyPr>
-          <a:lstStyle xmlns:a="http://schemas.openxmlformats.org/drawingml/2006/main"/>
-          <a:p xmlns:a="http://schemas.openxmlformats.org/drawingml/2006/main">
-            <a:pPr>
+          <a:lstStyle xmlns:a="http://schemas.openxmlformats.org/drawingml/2006/main">
+            <a:defPPr algn="l">
+              <a:defRPr sz="1875" b="1">
+                <a:solidFill>
+                  <a:srgbClr val="173A49"/>
+                </a:solidFill>
+                <a:latin typeface="맑은 고딕"/>
+                <a:ea typeface="맑은 고딕"/>
+                <a:cs typeface="맑은 고딕"/>
+              </a:defRPr>
+            </a:defPPr>
+            <a:lvl1pPr algn="l">
+              <a:defRPr sz="1875" b="1">
+                <a:solidFill>
+                  <a:srgbClr val="173A49"/>
+                </a:solidFill>
+                <a:latin typeface="맑은 고딕"/>
+                <a:ea typeface="맑은 고딕"/>
+                <a:cs typeface="맑은 고딕"/>
+              </a:defRPr>
+            </a:lvl1pPr>
+            <a:lvl2pPr algn="l">
+              <a:defRPr sz="1875" b="1">
+                <a:solidFill>
+                  <a:srgbClr val="173A49"/>
+                </a:solidFill>
+                <a:latin typeface="맑은 고딕"/>
+                <a:ea typeface="맑은 고딕"/>
+                <a:cs typeface="맑은 고딕"/>
+              </a:defRPr>
+            </a:lvl2pPr>
+            <a:lvl3pPr algn="l">
+              <a:defRPr sz="1875" b="1">
+                <a:solidFill>
+                  <a:srgbClr val="173A49"/>
+                </a:solidFill>
+                <a:latin typeface="맑은 고딕"/>
+                <a:ea typeface="맑은 고딕"/>
+                <a:cs typeface="맑은 고딕"/>
+              </a:defRPr>
+            </a:lvl3pPr>
+            <a:lvl4pPr algn="l">
+              <a:defRPr sz="1875" b="1">
+                <a:solidFill>
+                  <a:srgbClr val="173A49"/>
+                </a:solidFill>
+                <a:latin typeface="맑은 고딕"/>
+                <a:ea typeface="맑은 고딕"/>
+                <a:cs typeface="맑은 고딕"/>
+              </a:defRPr>
+            </a:lvl4pPr>
+            <a:lvl5pPr algn="l">
+              <a:defRPr sz="1875" b="1">
+                <a:solidFill>
+                  <a:srgbClr val="173A49"/>
+                </a:solidFill>
+                <a:latin typeface="맑은 고딕"/>
+                <a:ea typeface="맑은 고딕"/>
+                <a:cs typeface="맑은 고딕"/>
+              </a:defRPr>
+            </a:lvl5pPr>
+            <a:lvl6pPr algn="l">
+              <a:defRPr sz="1875" b="1">
+                <a:solidFill>
+                  <a:srgbClr val="173A49"/>
+                </a:solidFill>
+                <a:latin typeface="맑은 고딕"/>
+                <a:ea typeface="맑은 고딕"/>
+                <a:cs typeface="맑은 고딕"/>
+              </a:defRPr>
+            </a:lvl6pPr>
+            <a:lvl7pPr algn="l">
+              <a:defRPr sz="1875" b="1">
+                <a:solidFill>
+                  <a:srgbClr val="173A49"/>
+                </a:solidFill>
+                <a:latin typeface="맑은 고딕"/>
+                <a:ea typeface="맑은 고딕"/>
+                <a:cs typeface="맑은 고딕"/>
+              </a:defRPr>
+            </a:lvl7pPr>
+            <a:lvl8pPr algn="l">
+              <a:defRPr sz="1875" b="1">
+                <a:solidFill>
+                  <a:srgbClr val="173A49"/>
+                </a:solidFill>
+                <a:latin typeface="맑은 고딕"/>
+                <a:ea typeface="맑은 고딕"/>
+                <a:cs typeface="맑은 고딕"/>
+              </a:defRPr>
+            </a:lvl8pPr>
+            <a:lvl9pPr algn="l">
+              <a:defRPr sz="1875" b="1">
+                <a:solidFill>
+                  <a:srgbClr val="173A49"/>
+                </a:solidFill>
+                <a:latin typeface="맑은 고딕"/>
+                <a:ea typeface="맑은 고딕"/>
+                <a:cs typeface="맑은 고딕"/>
+              </a:defRPr>
+            </a:lvl9pPr>
+          </a:lstStyle>
+          <a:p xmlns:a="http://schemas.openxmlformats.org/drawingml/2006/main">
+            <a:pPr algn="l">
               <a:lnSpc>
                 <a:spcPct val="114000"/>
               </a:lnSpc>
@@ -17816,27 +18609,35 @@
                 <a:spcPts val="800"/>
               </a:spcAft>
               <a:buNone/>
-              <a:defRPr sz="1700" b="0">
-                <a:solidFill>
-                  <a:srgbClr val="617681"/>
-                </a:solidFill>
-                <a:latin typeface="맑은 고딕"/>
-                <a:ea typeface="맑은 고딕"/>
-                <a:cs typeface="맑은 고딕"/>
-              </a:defRPr>
-            </a:pPr>
-            <a:r>
-              <a:t>F1: 불량 검출과 불량 판정의 정확성을 함께 보는 보조 지표</a:t>
-            </a:r>
-          </a:p>
-        </p:txBody>
-      </p:sp>
-      <p:sp>
-        <p:nvSpPr>
-          <p:cNvPr id="17" name="TextBox 16">
-            <a:extLst xmlns:a="http://schemas.openxmlformats.org/drawingml/2006/main">
-              <a:ext uri="{FF2B5EF4-FFF2-40B4-BE49-F238E27FC236}">
-                <a16:creationId xmlns:a16="http://schemas.microsoft.com/office/drawing/2014/main" id="{7943FE2D-746C-4CC5-9AE0-D0C59DC384D3}"/>
+              <a:defRPr sz="1875" b="1">
+                <a:solidFill>
+                  <a:srgbClr val="173A49"/>
+                </a:solidFill>
+                <a:latin typeface="맑은 고딕"/>
+                <a:ea typeface="맑은 고딕"/>
+                <a:cs typeface="맑은 고딕"/>
+              </a:defRPr>
+            </a:pPr>
+            <a:r>
+              <a:rPr sz="1875" b="1">
+                <a:solidFill>
+                  <a:srgbClr val="173A49"/>
+                </a:solidFill>
+                <a:latin typeface="맑은 고딕"/>
+                <a:ea typeface="맑은 고딕"/>
+                <a:cs typeface="맑은 고딕"/>
+              </a:rPr>
+              <a:t>시연 목표: Recall90% 이상 · 정상 오판률15% 이하 (교육용 수치)</a:t>
+            </a:r>
+          </a:p>
+        </p:txBody>
+      </p:sp>
+      <p:sp>
+        <p:nvSpPr>
+          <p:cNvPr id="15" name="TextBox 14">
+            <a:extLst xmlns:a="http://schemas.openxmlformats.org/drawingml/2006/main">
+              <a:ext uri="{FF2B5EF4-FFF2-40B4-BE49-F238E27FC236}">
+                <a16:creationId xmlns:a16="http://schemas.microsoft.com/office/drawing/2014/main" id="{50418AAC-605E-41FF-AF16-DBA9CA75A8C5}"/>
               </a:ext>
             </a:extLst>
           </p:cNvPr>
@@ -17847,8 +18648,8 @@
         </p:nvSpPr>
         <p:spPr>
           <a:xfrm xmlns:a="http://schemas.openxmlformats.org/drawingml/2006/main">
-            <a:off x="731520" y="5596128"/>
-            <a:ext cx="10698480" cy="411480"/>
+            <a:off x="731520" y="4391025"/>
+            <a:ext cx="10698480" cy="401422"/>
           </a:xfrm>
           <a:prstGeom xmlns:a="http://schemas.openxmlformats.org/drawingml/2006/main" prst="rect">
             <a:avLst/>
@@ -17859,9 +18660,110 @@
           <a:bodyPr xmlns:a="http://schemas.openxmlformats.org/drawingml/2006/main" wrap="square" lIns="18288" tIns="18288" rIns="18288" bIns="18288">
             <a:spAutoFit/>
           </a:bodyPr>
-          <a:lstStyle xmlns:a="http://schemas.openxmlformats.org/drawingml/2006/main"/>
-          <a:p xmlns:a="http://schemas.openxmlformats.org/drawingml/2006/main">
-            <a:pPr>
+          <a:lstStyle xmlns:a="http://schemas.openxmlformats.org/drawingml/2006/main">
+            <a:defPPr algn="l">
+              <a:defRPr sz="2100" b="1">
+                <a:solidFill>
+                  <a:srgbClr val="147D82"/>
+                </a:solidFill>
+                <a:latin typeface="맑은 고딕"/>
+                <a:ea typeface="맑은 고딕"/>
+                <a:cs typeface="맑은 고딕"/>
+              </a:defRPr>
+            </a:defPPr>
+            <a:lvl1pPr algn="l">
+              <a:defRPr sz="2100" b="1">
+                <a:solidFill>
+                  <a:srgbClr val="147D82"/>
+                </a:solidFill>
+                <a:latin typeface="맑은 고딕"/>
+                <a:ea typeface="맑은 고딕"/>
+                <a:cs typeface="맑은 고딕"/>
+              </a:defRPr>
+            </a:lvl1pPr>
+            <a:lvl2pPr algn="l">
+              <a:defRPr sz="2100" b="1">
+                <a:solidFill>
+                  <a:srgbClr val="147D82"/>
+                </a:solidFill>
+                <a:latin typeface="맑은 고딕"/>
+                <a:ea typeface="맑은 고딕"/>
+                <a:cs typeface="맑은 고딕"/>
+              </a:defRPr>
+            </a:lvl2pPr>
+            <a:lvl3pPr algn="l">
+              <a:defRPr sz="2100" b="1">
+                <a:solidFill>
+                  <a:srgbClr val="147D82"/>
+                </a:solidFill>
+                <a:latin typeface="맑은 고딕"/>
+                <a:ea typeface="맑은 고딕"/>
+                <a:cs typeface="맑은 고딕"/>
+              </a:defRPr>
+            </a:lvl3pPr>
+            <a:lvl4pPr algn="l">
+              <a:defRPr sz="2100" b="1">
+                <a:solidFill>
+                  <a:srgbClr val="147D82"/>
+                </a:solidFill>
+                <a:latin typeface="맑은 고딕"/>
+                <a:ea typeface="맑은 고딕"/>
+                <a:cs typeface="맑은 고딕"/>
+              </a:defRPr>
+            </a:lvl4pPr>
+            <a:lvl5pPr algn="l">
+              <a:defRPr sz="2100" b="1">
+                <a:solidFill>
+                  <a:srgbClr val="147D82"/>
+                </a:solidFill>
+                <a:latin typeface="맑은 고딕"/>
+                <a:ea typeface="맑은 고딕"/>
+                <a:cs typeface="맑은 고딕"/>
+              </a:defRPr>
+            </a:lvl5pPr>
+            <a:lvl6pPr algn="l">
+              <a:defRPr sz="2100" b="1">
+                <a:solidFill>
+                  <a:srgbClr val="147D82"/>
+                </a:solidFill>
+                <a:latin typeface="맑은 고딕"/>
+                <a:ea typeface="맑은 고딕"/>
+                <a:cs typeface="맑은 고딕"/>
+              </a:defRPr>
+            </a:lvl6pPr>
+            <a:lvl7pPr algn="l">
+              <a:defRPr sz="2100" b="1">
+                <a:solidFill>
+                  <a:srgbClr val="147D82"/>
+                </a:solidFill>
+                <a:latin typeface="맑은 고딕"/>
+                <a:ea typeface="맑은 고딕"/>
+                <a:cs typeface="맑은 고딕"/>
+              </a:defRPr>
+            </a:lvl7pPr>
+            <a:lvl8pPr algn="l">
+              <a:defRPr sz="2100" b="1">
+                <a:solidFill>
+                  <a:srgbClr val="147D82"/>
+                </a:solidFill>
+                <a:latin typeface="맑은 고딕"/>
+                <a:ea typeface="맑은 고딕"/>
+                <a:cs typeface="맑은 고딕"/>
+              </a:defRPr>
+            </a:lvl8pPr>
+            <a:lvl9pPr algn="l">
+              <a:defRPr sz="2100" b="1">
+                <a:solidFill>
+                  <a:srgbClr val="147D82"/>
+                </a:solidFill>
+                <a:latin typeface="맑은 고딕"/>
+                <a:ea typeface="맑은 고딕"/>
+                <a:cs typeface="맑은 고딕"/>
+              </a:defRPr>
+            </a:lvl9pPr>
+          </a:lstStyle>
+          <a:p xmlns:a="http://schemas.openxmlformats.org/drawingml/2006/main">
+            <a:pPr algn="l">
               <a:lnSpc>
                 <a:spcPct val="114000"/>
               </a:lnSpc>
@@ -17869,7 +18771,60 @@
                 <a:spcPts val="800"/>
               </a:spcAft>
               <a:buNone/>
-              <a:defRPr sz="1700" b="0">
+              <a:defRPr sz="2100" b="1">
+                <a:solidFill>
+                  <a:srgbClr val="147D82"/>
+                </a:solidFill>
+                <a:latin typeface="맑은 고딕"/>
+                <a:ea typeface="맑은 고딕"/>
+                <a:cs typeface="맑은 고딕"/>
+              </a:defRPr>
+            </a:pPr>
+            <a:r>
+              <a:rPr sz="2100" b="1">
+                <a:solidFill>
+                  <a:srgbClr val="147D82"/>
+                </a:solidFill>
+                <a:latin typeface="맑은 고딕"/>
+                <a:ea typeface="맑은 고딕"/>
+                <a:cs typeface="맑은 고딕"/>
+              </a:rPr>
+              <a:t>정상 오판을 제한한 뒤, 불량을 가장 많이 찾는 모델 선택</a:t>
+            </a:r>
+          </a:p>
+        </p:txBody>
+      </p:sp>
+      <p:sp>
+        <p:nvSpPr>
+          <p:cNvPr id="16" name="TextBox 15">
+            <a:extLst xmlns:a="http://schemas.openxmlformats.org/drawingml/2006/main">
+              <a:ext uri="{FF2B5EF4-FFF2-40B4-BE49-F238E27FC236}">
+                <a16:creationId xmlns:a16="http://schemas.microsoft.com/office/drawing/2014/main" id="{9C50AF9B-0CD5-48D5-914F-A5796F3A20CB}"/>
+              </a:ext>
+            </a:extLst>
+          </p:cNvPr>
+          <p:cNvSpPr>
+            <a:spLocks xmlns:a="http://schemas.openxmlformats.org/drawingml/2006/main" noGrp="1"/>
+          </p:cNvSpPr>
+          <p:nvPr/>
+        </p:nvSpPr>
+        <p:spPr>
+          <a:xfrm xmlns:a="http://schemas.openxmlformats.org/drawingml/2006/main">
+            <a:off x="731520" y="4886325"/>
+            <a:ext cx="10698480" cy="336271"/>
+          </a:xfrm>
+          <a:prstGeom xmlns:a="http://schemas.openxmlformats.org/drawingml/2006/main" prst="rect">
+            <a:avLst/>
+          </a:prstGeom>
+          <a:noFill xmlns:a="http://schemas.openxmlformats.org/drawingml/2006/main"/>
+        </p:spPr>
+        <p:txBody>
+          <a:bodyPr xmlns:a="http://schemas.openxmlformats.org/drawingml/2006/main" wrap="square" lIns="18288" tIns="18288" rIns="18288" bIns="18288">
+            <a:spAutoFit/>
+          </a:bodyPr>
+          <a:lstStyle xmlns:a="http://schemas.openxmlformats.org/drawingml/2006/main">
+            <a:defPPr algn="l">
+              <a:defRPr sz="1725">
                 <a:solidFill>
                   <a:srgbClr val="617681"/>
                 </a:solidFill>
@@ -17877,9 +18832,288 @@
                 <a:ea typeface="맑은 고딕"/>
                 <a:cs typeface="맑은 고딕"/>
               </a:defRPr>
-            </a:pPr>
-            <a:r>
-              <a:t>90%·15%는 교육용 목표입니다. 현장에서는 담당자와 허용 범위를 정합니다.</a:t>
+            </a:defPPr>
+            <a:lvl1pPr algn="l">
+              <a:defRPr sz="1725">
+                <a:solidFill>
+                  <a:srgbClr val="617681"/>
+                </a:solidFill>
+                <a:latin typeface="맑은 고딕"/>
+                <a:ea typeface="맑은 고딕"/>
+                <a:cs typeface="맑은 고딕"/>
+              </a:defRPr>
+            </a:lvl1pPr>
+            <a:lvl2pPr algn="l">
+              <a:defRPr sz="1725">
+                <a:solidFill>
+                  <a:srgbClr val="617681"/>
+                </a:solidFill>
+                <a:latin typeface="맑은 고딕"/>
+                <a:ea typeface="맑은 고딕"/>
+                <a:cs typeface="맑은 고딕"/>
+              </a:defRPr>
+            </a:lvl2pPr>
+            <a:lvl3pPr algn="l">
+              <a:defRPr sz="1725">
+                <a:solidFill>
+                  <a:srgbClr val="617681"/>
+                </a:solidFill>
+                <a:latin typeface="맑은 고딕"/>
+                <a:ea typeface="맑은 고딕"/>
+                <a:cs typeface="맑은 고딕"/>
+              </a:defRPr>
+            </a:lvl3pPr>
+            <a:lvl4pPr algn="l">
+              <a:defRPr sz="1725">
+                <a:solidFill>
+                  <a:srgbClr val="617681"/>
+                </a:solidFill>
+                <a:latin typeface="맑은 고딕"/>
+                <a:ea typeface="맑은 고딕"/>
+                <a:cs typeface="맑은 고딕"/>
+              </a:defRPr>
+            </a:lvl4pPr>
+            <a:lvl5pPr algn="l">
+              <a:defRPr sz="1725">
+                <a:solidFill>
+                  <a:srgbClr val="617681"/>
+                </a:solidFill>
+                <a:latin typeface="맑은 고딕"/>
+                <a:ea typeface="맑은 고딕"/>
+                <a:cs typeface="맑은 고딕"/>
+              </a:defRPr>
+            </a:lvl5pPr>
+            <a:lvl6pPr algn="l">
+              <a:defRPr sz="1725">
+                <a:solidFill>
+                  <a:srgbClr val="617681"/>
+                </a:solidFill>
+                <a:latin typeface="맑은 고딕"/>
+                <a:ea typeface="맑은 고딕"/>
+                <a:cs typeface="맑은 고딕"/>
+              </a:defRPr>
+            </a:lvl6pPr>
+            <a:lvl7pPr algn="l">
+              <a:defRPr sz="1725">
+                <a:solidFill>
+                  <a:srgbClr val="617681"/>
+                </a:solidFill>
+                <a:latin typeface="맑은 고딕"/>
+                <a:ea typeface="맑은 고딕"/>
+                <a:cs typeface="맑은 고딕"/>
+              </a:defRPr>
+            </a:lvl7pPr>
+            <a:lvl8pPr algn="l">
+              <a:defRPr sz="1725">
+                <a:solidFill>
+                  <a:srgbClr val="617681"/>
+                </a:solidFill>
+                <a:latin typeface="맑은 고딕"/>
+                <a:ea typeface="맑은 고딕"/>
+                <a:cs typeface="맑은 고딕"/>
+              </a:defRPr>
+            </a:lvl8pPr>
+            <a:lvl9pPr algn="l">
+              <a:defRPr sz="1725">
+                <a:solidFill>
+                  <a:srgbClr val="617681"/>
+                </a:solidFill>
+                <a:latin typeface="맑은 고딕"/>
+                <a:ea typeface="맑은 고딕"/>
+                <a:cs typeface="맑은 고딕"/>
+              </a:defRPr>
+            </a:lvl9pPr>
+          </a:lstStyle>
+          <a:p xmlns:a="http://schemas.openxmlformats.org/drawingml/2006/main">
+            <a:pPr algn="l">
+              <a:lnSpc>
+                <a:spcPct val="114000"/>
+              </a:lnSpc>
+              <a:spcAft>
+                <a:spcPts val="800"/>
+              </a:spcAft>
+              <a:buNone/>
+              <a:defRPr sz="1725" b="0">
+                <a:solidFill>
+                  <a:srgbClr val="617681"/>
+                </a:solidFill>
+                <a:latin typeface="맑은 고딕"/>
+                <a:ea typeface="맑은 고딕"/>
+                <a:cs typeface="맑은 고딕"/>
+              </a:defRPr>
+            </a:pPr>
+            <a:r>
+              <a:rPr sz="1725">
+                <a:solidFill>
+                  <a:srgbClr val="617681"/>
+                </a:solidFill>
+                <a:latin typeface="맑은 고딕"/>
+                <a:ea typeface="맑은 고딕"/>
+                <a:cs typeface="맑은 고딕"/>
+              </a:rPr>
+              <a:t>동률이면 F1: 불량을 잘 찾고, 불량 판정도 정확한지 함께 확인</a:t>
+            </a:r>
+          </a:p>
+        </p:txBody>
+      </p:sp>
+      <p:sp>
+        <p:nvSpPr>
+          <p:cNvPr id="17" name="TextBox 16">
+            <a:extLst xmlns:a="http://schemas.openxmlformats.org/drawingml/2006/main">
+              <a:ext uri="{FF2B5EF4-FFF2-40B4-BE49-F238E27FC236}">
+                <a16:creationId xmlns:a16="http://schemas.microsoft.com/office/drawing/2014/main" id="{7943FE2D-746C-4CC5-9AE0-D0C59DC384D3}"/>
+              </a:ext>
+            </a:extLst>
+          </p:cNvPr>
+          <p:cNvSpPr>
+            <a:spLocks xmlns:a="http://schemas.openxmlformats.org/drawingml/2006/main" noGrp="1"/>
+          </p:cNvSpPr>
+          <p:nvPr/>
+        </p:nvSpPr>
+        <p:spPr>
+          <a:xfrm xmlns:a="http://schemas.openxmlformats.org/drawingml/2006/main">
+            <a:off x="731520" y="5800725"/>
+            <a:ext cx="10698480" cy="310210"/>
+          </a:xfrm>
+          <a:prstGeom xmlns:a="http://schemas.openxmlformats.org/drawingml/2006/main" prst="rect">
+            <a:avLst/>
+          </a:prstGeom>
+          <a:noFill xmlns:a="http://schemas.openxmlformats.org/drawingml/2006/main"/>
+        </p:spPr>
+        <p:txBody>
+          <a:bodyPr xmlns:a="http://schemas.openxmlformats.org/drawingml/2006/main" wrap="square" lIns="18288" tIns="18288" rIns="18288" bIns="18288">
+            <a:spAutoFit/>
+          </a:bodyPr>
+          <a:lstStyle xmlns:a="http://schemas.openxmlformats.org/drawingml/2006/main">
+            <a:defPPr algn="l">
+              <a:defRPr sz="1575">
+                <a:solidFill>
+                  <a:srgbClr val="617681"/>
+                </a:solidFill>
+                <a:latin typeface="맑은 고딕"/>
+                <a:ea typeface="맑은 고딕"/>
+                <a:cs typeface="맑은 고딕"/>
+              </a:defRPr>
+            </a:defPPr>
+            <a:lvl1pPr algn="l">
+              <a:defRPr sz="1575">
+                <a:solidFill>
+                  <a:srgbClr val="617681"/>
+                </a:solidFill>
+                <a:latin typeface="맑은 고딕"/>
+                <a:ea typeface="맑은 고딕"/>
+                <a:cs typeface="맑은 고딕"/>
+              </a:defRPr>
+            </a:lvl1pPr>
+            <a:lvl2pPr algn="l">
+              <a:defRPr sz="1575">
+                <a:solidFill>
+                  <a:srgbClr val="617681"/>
+                </a:solidFill>
+                <a:latin typeface="맑은 고딕"/>
+                <a:ea typeface="맑은 고딕"/>
+                <a:cs typeface="맑은 고딕"/>
+              </a:defRPr>
+            </a:lvl2pPr>
+            <a:lvl3pPr algn="l">
+              <a:defRPr sz="1575">
+                <a:solidFill>
+                  <a:srgbClr val="617681"/>
+                </a:solidFill>
+                <a:latin typeface="맑은 고딕"/>
+                <a:ea typeface="맑은 고딕"/>
+                <a:cs typeface="맑은 고딕"/>
+              </a:defRPr>
+            </a:lvl3pPr>
+            <a:lvl4pPr algn="l">
+              <a:defRPr sz="1575">
+                <a:solidFill>
+                  <a:srgbClr val="617681"/>
+                </a:solidFill>
+                <a:latin typeface="맑은 고딕"/>
+                <a:ea typeface="맑은 고딕"/>
+                <a:cs typeface="맑은 고딕"/>
+              </a:defRPr>
+            </a:lvl4pPr>
+            <a:lvl5pPr algn="l">
+              <a:defRPr sz="1575">
+                <a:solidFill>
+                  <a:srgbClr val="617681"/>
+                </a:solidFill>
+                <a:latin typeface="맑은 고딕"/>
+                <a:ea typeface="맑은 고딕"/>
+                <a:cs typeface="맑은 고딕"/>
+              </a:defRPr>
+            </a:lvl5pPr>
+            <a:lvl6pPr algn="l">
+              <a:defRPr sz="1575">
+                <a:solidFill>
+                  <a:srgbClr val="617681"/>
+                </a:solidFill>
+                <a:latin typeface="맑은 고딕"/>
+                <a:ea typeface="맑은 고딕"/>
+                <a:cs typeface="맑은 고딕"/>
+              </a:defRPr>
+            </a:lvl6pPr>
+            <a:lvl7pPr algn="l">
+              <a:defRPr sz="1575">
+                <a:solidFill>
+                  <a:srgbClr val="617681"/>
+                </a:solidFill>
+                <a:latin typeface="맑은 고딕"/>
+                <a:ea typeface="맑은 고딕"/>
+                <a:cs typeface="맑은 고딕"/>
+              </a:defRPr>
+            </a:lvl7pPr>
+            <a:lvl8pPr algn="l">
+              <a:defRPr sz="1575">
+                <a:solidFill>
+                  <a:srgbClr val="617681"/>
+                </a:solidFill>
+                <a:latin typeface="맑은 고딕"/>
+                <a:ea typeface="맑은 고딕"/>
+                <a:cs typeface="맑은 고딕"/>
+              </a:defRPr>
+            </a:lvl8pPr>
+            <a:lvl9pPr algn="l">
+              <a:defRPr sz="1575">
+                <a:solidFill>
+                  <a:srgbClr val="617681"/>
+                </a:solidFill>
+                <a:latin typeface="맑은 고딕"/>
+                <a:ea typeface="맑은 고딕"/>
+                <a:cs typeface="맑은 고딕"/>
+              </a:defRPr>
+            </a:lvl9pPr>
+          </a:lstStyle>
+          <a:p xmlns:a="http://schemas.openxmlformats.org/drawingml/2006/main">
+            <a:pPr algn="l">
+              <a:lnSpc>
+                <a:spcPct val="114000"/>
+              </a:lnSpc>
+              <a:spcAft>
+                <a:spcPts val="800"/>
+              </a:spcAft>
+              <a:buNone/>
+              <a:defRPr sz="1575" b="0">
+                <a:solidFill>
+                  <a:srgbClr val="617681"/>
+                </a:solidFill>
+                <a:latin typeface="맑은 고딕"/>
+                <a:ea typeface="맑은 고딕"/>
+                <a:cs typeface="맑은 고딕"/>
+              </a:defRPr>
+            </a:pPr>
+            <a:r>
+              <a:rPr sz="1575">
+                <a:solidFill>
+                  <a:srgbClr val="617681"/>
+                </a:solidFill>
+                <a:latin typeface="맑은 고딕"/>
+                <a:ea typeface="맑은 고딕"/>
+                <a:cs typeface="맑은 고딕"/>
+              </a:rPr>
+              <a:t>전부 불량으로 판정하면 Recall100%지만, 정상 오판도100%입니다.</a:t>
             </a:r>
           </a:p>
         </p:txBody>
@@ -18452,7 +19686,7 @@
           <p:cNvPr id="12" name="Picture 11">
             <a:extLst xmlns:a="http://schemas.openxmlformats.org/drawingml/2006/main">
               <a:ext uri="{FF2B5EF4-FFF2-40B4-BE49-F238E27FC236}">
-                <a16:creationId xmlns:a16="http://schemas.microsoft.com/office/drawing/2014/main" id="{AC748A47-270B-42DE-8EF3-B6730AAA4CD0}"/>
+                <a16:creationId xmlns:a16="http://schemas.microsoft.com/office/drawing/2014/main" id="{BEE9D3B9-7F92-450D-9EF8-A8B6BA38BFEA}"/>
               </a:ext>
             </a:extLst>
           </p:cNvPr>
@@ -18462,7 +19696,7 @@
           <p:nvPr/>
         </p:nvPicPr>
         <p:blipFill>
-          <a:blip xmlns:r="http://schemas.openxmlformats.org/officeDocument/2006/relationships" xmlns:a="http://schemas.openxmlformats.org/drawingml/2006/main" r:embed="Raf0642164da54f44"/>
+          <a:blip xmlns:r="http://schemas.openxmlformats.org/officeDocument/2006/relationships" xmlns:a="http://schemas.openxmlformats.org/drawingml/2006/main" r:embed="R32c76f1760e74f4f"/>
           <a:stretch xmlns:a="http://schemas.openxmlformats.org/drawingml/2006/main">
             <a:fillRect l="0" t="0" r="0" b="0"/>
           </a:stretch>
@@ -18872,7 +20106,7 @@
               </a:defRPr>
             </a:pPr>
             <a:r>
-              <a:t>결측 1.9% 확인 · 결측 대체와 필요한 Scaling은 Train에만 fit</a:t>
+              <a:t>빈값 처리·필요한 Scaling은 학습용 데이터로만 준비</a:t>
             </a:r>
           </a:p>
         </p:txBody>
@@ -18894,7 +20128,7 @@
         <p:spPr>
           <a:xfrm xmlns:a="http://schemas.openxmlformats.org/drawingml/2006/main">
             <a:off x="658368" y="2935224"/>
-            <a:ext cx="4526280" cy="804672"/>
+            <a:ext cx="4526280" cy="366674"/>
           </a:xfrm>
           <a:prstGeom xmlns:a="http://schemas.openxmlformats.org/drawingml/2006/main" prst="rect">
             <a:avLst/>
@@ -18925,7 +20159,7 @@
               </a:defRPr>
             </a:pPr>
             <a:r>
-              <a:t>실험1: 알고리즘 고정 → 제품 그룹 구성15개 비교</a:t>
+              <a:t>학습60% · 후보 선택20% · 마지막 시험20%</a:t>
             </a:r>
           </a:p>
         </p:txBody>
@@ -18947,7 +20181,7 @@
         <p:spPr>
           <a:xfrm xmlns:a="http://schemas.openxmlformats.org/drawingml/2006/main">
             <a:off x="658368" y="3813048"/>
-            <a:ext cx="4526280" cy="804672"/>
+            <a:ext cx="4526280" cy="696773"/>
           </a:xfrm>
           <a:prstGeom xmlns:a="http://schemas.openxmlformats.org/drawingml/2006/main" prst="rect">
             <a:avLst/>
@@ -18978,7 +20212,7 @@
               </a:defRPr>
             </a:pPr>
             <a:r>
-              <a:t>실험2: 학습 제품ABCD 고정 → 혼합 비율232개 비교</a:t>
+              <a:t>제품 묶음15개와 예측 혼합 비율232개를 각각 비교</a:t>
             </a:r>
           </a:p>
         </p:txBody>
@@ -19000,7 +20234,7 @@
         <p:spPr>
           <a:xfrm xmlns:a="http://schemas.openxmlformats.org/drawingml/2006/main">
             <a:off x="658368" y="4690872"/>
-            <a:ext cx="4526280" cy="804672"/>
+            <a:ext cx="4526280" cy="366674"/>
           </a:xfrm>
           <a:prstGeom xmlns:a="http://schemas.openxmlformats.org/drawingml/2006/main" prst="rect">
             <a:avLst/>
@@ -19031,7 +20265,7 @@
               </a:defRPr>
             </a:pPr>
             <a:r>
-              <a:t>계획·데이터 확인 → 엔지니어 승인 → 실제 실행</a:t>
+              <a:t>계획과 데이터를 확인하고 승인한 뒤 실제 학습</a:t>
             </a:r>
           </a:p>
         </p:txBody>
@@ -19098,7 +20332,7 @@
           <p:cNvPr id="13" name="Picture 12">
             <a:extLst xmlns:a="http://schemas.openxmlformats.org/drawingml/2006/main">
               <a:ext uri="{FF2B5EF4-FFF2-40B4-BE49-F238E27FC236}">
-                <a16:creationId xmlns:a16="http://schemas.microsoft.com/office/drawing/2014/main" id="{F563FE85-F27B-49C0-A530-1F66302A83A6}"/>
+                <a16:creationId xmlns:a16="http://schemas.microsoft.com/office/drawing/2014/main" id="{2521125F-FA25-4442-A70E-B42A94926747}"/>
               </a:ext>
             </a:extLst>
           </p:cNvPr>
@@ -19108,7 +20342,7 @@
           <p:nvPr/>
         </p:nvPicPr>
         <p:blipFill>
-          <a:blip xmlns:r="http://schemas.openxmlformats.org/officeDocument/2006/relationships" xmlns:a="http://schemas.openxmlformats.org/drawingml/2006/main" r:embed="R80a38dcc89904064"/>
+          <a:blip xmlns:r="http://schemas.openxmlformats.org/officeDocument/2006/relationships" xmlns:a="http://schemas.openxmlformats.org/drawingml/2006/main" r:embed="Redf3f3ca23e74f4c"/>
           <a:stretch xmlns:a="http://schemas.openxmlformats.org/drawingml/2006/main">
             <a:fillRect l="0" t="0" r="0" b="0"/>
           </a:stretch>
@@ -19222,7 +20456,7 @@
         <p:spPr>
           <a:xfrm xmlns:a="http://schemas.openxmlformats.org/drawingml/2006/main">
             <a:off x="594360" y="292608"/>
-            <a:ext cx="10972800" cy="274320"/>
+            <a:ext cx="10972800" cy="245059"/>
           </a:xfrm>
           <a:prstGeom xmlns:a="http://schemas.openxmlformats.org/drawingml/2006/main" prst="rect">
             <a:avLst/>
@@ -19253,7 +20487,7 @@
               </a:defRPr>
             </a:pPr>
             <a:r>
-              <a:t>06 · 실험1 | CatBoost 설정 고정 · 그룹 구성15개 비교</a:t>
+              <a:t>06 · 실험1 | 같은 CatBoost로 제품 묶음15개 비교</a:t>
             </a:r>
           </a:p>
         </p:txBody>
@@ -19275,7 +20509,7 @@
         <p:spPr>
           <a:xfrm xmlns:a="http://schemas.openxmlformats.org/drawingml/2006/main">
             <a:off x="594360" y="832104"/>
-            <a:ext cx="10972800" cy="1005840"/>
+            <a:ext cx="10972800" cy="592531"/>
           </a:xfrm>
           <a:prstGeom xmlns:a="http://schemas.openxmlformats.org/drawingml/2006/main" prst="rect">
             <a:avLst/>
@@ -19306,7 +20540,7 @@
               </a:defRPr>
             </a:pPr>
             <a:r>
-              <a:t>③ 제품 묶음 선택: ABC 공통 모델 + D 전용 모델</a:t>
+              <a:t>③ 제품 묶음 비교: ABC는 함께, D는 따로 학습</a:t>
             </a:r>
           </a:p>
         </p:txBody>
@@ -19532,7 +20766,7 @@
           <p:cNvPr id="9" name="Picture 8">
             <a:extLst xmlns:a="http://schemas.openxmlformats.org/drawingml/2006/main">
               <a:ext uri="{FF2B5EF4-FFF2-40B4-BE49-F238E27FC236}">
-                <a16:creationId xmlns:a16="http://schemas.microsoft.com/office/drawing/2014/main" id="{C84A00D1-10FE-4A6C-B257-5101D48EF764}"/>
+                <a16:creationId xmlns:a16="http://schemas.microsoft.com/office/drawing/2014/main" id="{CF713BEF-940A-4FD5-8DA0-9019120CE7C8}"/>
               </a:ext>
             </a:extLst>
           </p:cNvPr>
@@ -19542,7 +20776,7 @@
           <p:nvPr/>
         </p:nvPicPr>
         <p:blipFill>
-          <a:blip xmlns:r="http://schemas.openxmlformats.org/officeDocument/2006/relationships" xmlns:a="http://schemas.openxmlformats.org/drawingml/2006/main" r:embed="R2a5346cd1aef497e"/>
+          <a:blip xmlns:r="http://schemas.openxmlformats.org/officeDocument/2006/relationships" xmlns:a="http://schemas.openxmlformats.org/drawingml/2006/main" r:embed="R9ab6fa6f086445e6"/>
           <a:stretch xmlns:a="http://schemas.openxmlformats.org/drawingml/2006/main">
             <a:fillRect l="0" t="0" r="0" b="0"/>
           </a:stretch>
@@ -19762,7 +20996,7 @@
         <p:spPr>
           <a:xfrm xmlns:a="http://schemas.openxmlformats.org/drawingml/2006/main">
             <a:off x="594360" y="292608"/>
-            <a:ext cx="10972800" cy="274320"/>
+            <a:ext cx="10972800" cy="245059"/>
           </a:xfrm>
           <a:prstGeom xmlns:a="http://schemas.openxmlformats.org/drawingml/2006/main" prst="rect">
             <a:avLst/>
@@ -19793,7 +21027,7 @@
               </a:defRPr>
             </a:pPr>
             <a:r>
-              <a:t>07 · 실험2 | 학습 제품ABCD 고정 · Validation에서 비율 선택</a:t>
+              <a:t>07 · 실험2 | 학습 제품ABCD 고정 · 후보 선택용 데이터에서 비율 선택</a:t>
             </a:r>
           </a:p>
         </p:txBody>
@@ -20072,7 +21306,7 @@
           <p:cNvPr id="9" name="Picture 8">
             <a:extLst xmlns:a="http://schemas.openxmlformats.org/drawingml/2006/main">
               <a:ext uri="{FF2B5EF4-FFF2-40B4-BE49-F238E27FC236}">
-                <a16:creationId xmlns:a16="http://schemas.microsoft.com/office/drawing/2014/main" id="{225FD67A-AC95-4D93-A3D6-C64DBAD21DD1}"/>
+                <a16:creationId xmlns:a16="http://schemas.microsoft.com/office/drawing/2014/main" id="{EEC958AD-FDB8-4618-8845-5613FEFB7DFA}"/>
               </a:ext>
             </a:extLst>
           </p:cNvPr>
@@ -20082,7 +21316,7 @@
           <p:nvPr/>
         </p:nvPicPr>
         <p:blipFill>
-          <a:blip xmlns:r="http://schemas.openxmlformats.org/officeDocument/2006/relationships" xmlns:a="http://schemas.openxmlformats.org/drawingml/2006/main" r:embed="R05e81d5f79eb445f"/>
+          <a:blip xmlns:r="http://schemas.openxmlformats.org/officeDocument/2006/relationships" xmlns:a="http://schemas.openxmlformats.org/drawingml/2006/main" r:embed="Ra0385764df0e42ae"/>
           <a:stretch xmlns:a="http://schemas.openxmlformats.org/drawingml/2006/main">
             <a:fillRect l="0" t="0" r="0" b="0"/>
           </a:stretch>
@@ -20302,7 +21536,7 @@
         <p:spPr>
           <a:xfrm xmlns:a="http://schemas.openxmlformats.org/drawingml/2006/main">
             <a:off x="594360" y="292608"/>
-            <a:ext cx="10972800" cy="274320"/>
+            <a:ext cx="10972800" cy="245059"/>
           </a:xfrm>
           <a:prstGeom xmlns:a="http://schemas.openxmlformats.org/drawingml/2006/main" prst="rect">
             <a:avLst/>
@@ -20333,7 +21567,7 @@
               </a:defRPr>
             </a:pPr>
             <a:r>
-              <a:t>08 · 실험2의 Test 확인 | 불량32개 · 정상224개</a:t>
+              <a:t>08 · 실험2의 마지막 시험(Test) | 불량32개 · 정상224개</a:t>
             </a:r>
           </a:p>
         </p:txBody>
@@ -20846,7 +22080,7 @@
           <p:cNvPr id="13" name="Picture 12">
             <a:extLst xmlns:a="http://schemas.openxmlformats.org/drawingml/2006/main">
               <a:ext uri="{FF2B5EF4-FFF2-40B4-BE49-F238E27FC236}">
-                <a16:creationId xmlns:a16="http://schemas.microsoft.com/office/drawing/2014/main" id="{428471B7-25F5-4E0A-9EA0-98A647E8A0BF}"/>
+                <a16:creationId xmlns:a16="http://schemas.microsoft.com/office/drawing/2014/main" id="{D76D33B3-B52E-47E1-9BEC-097AC874EDF1}"/>
               </a:ext>
             </a:extLst>
           </p:cNvPr>
@@ -20856,7 +22090,7 @@
           <p:nvPr/>
         </p:nvPicPr>
         <p:blipFill>
-          <a:blip xmlns:r="http://schemas.openxmlformats.org/officeDocument/2006/relationships" xmlns:a="http://schemas.openxmlformats.org/drawingml/2006/main" r:embed="R40550796979a48be"/>
+          <a:blip xmlns:r="http://schemas.openxmlformats.org/officeDocument/2006/relationships" xmlns:a="http://schemas.openxmlformats.org/drawingml/2006/main" r:embed="Rd58ce083c1364d0f"/>
           <a:stretch xmlns:a="http://schemas.openxmlformats.org/drawingml/2006/main">
             <a:fillRect l="0" t="0" r="0" b="0"/>
           </a:stretch>
@@ -20941,6 +22175,7 @@
               </a:defRPr>
             </a:defPPr>
             <a:lvl1pPr>
+              <a:buNone/>
               <a:defRPr sz="1200" b="1">
                 <a:solidFill>
                   <a:srgbClr val="147D82"/>
@@ -20951,6 +22186,7 @@
               </a:defRPr>
             </a:lvl1pPr>
             <a:lvl2pPr>
+              <a:buNone/>
               <a:defRPr sz="1200" b="1">
                 <a:solidFill>
                   <a:srgbClr val="147D82"/>
@@ -20961,6 +22197,7 @@
               </a:defRPr>
             </a:lvl2pPr>
             <a:lvl3pPr>
+              <a:buNone/>
               <a:defRPr sz="1200" b="1">
                 <a:solidFill>
                   <a:srgbClr val="147D82"/>
@@ -20971,6 +22208,7 @@
               </a:defRPr>
             </a:lvl3pPr>
             <a:lvl4pPr>
+              <a:buNone/>
               <a:defRPr sz="1200" b="1">
                 <a:solidFill>
                   <a:srgbClr val="147D82"/>
@@ -20981,6 +22219,7 @@
               </a:defRPr>
             </a:lvl4pPr>
             <a:lvl5pPr>
+              <a:buNone/>
               <a:defRPr sz="1200" b="1">
                 <a:solidFill>
                   <a:srgbClr val="147D82"/>
@@ -20991,6 +22230,7 @@
               </a:defRPr>
             </a:lvl5pPr>
             <a:lvl6pPr>
+              <a:buNone/>
               <a:defRPr sz="1200" b="1">
                 <a:solidFill>
                   <a:srgbClr val="147D82"/>
@@ -21001,6 +22241,7 @@
               </a:defRPr>
             </a:lvl6pPr>
             <a:lvl7pPr>
+              <a:buNone/>
               <a:defRPr sz="1200" b="1">
                 <a:solidFill>
                   <a:srgbClr val="147D82"/>
@@ -21011,6 +22252,7 @@
               </a:defRPr>
             </a:lvl7pPr>
             <a:lvl8pPr>
+              <a:buNone/>
               <a:defRPr sz="1200" b="1">
                 <a:solidFill>
                   <a:srgbClr val="147D82"/>
@@ -21021,6 +22263,7 @@
               </a:defRPr>
             </a:lvl8pPr>
             <a:lvl9pPr>
+              <a:buNone/>
               <a:defRPr sz="1200" b="1">
                 <a:solidFill>
                   <a:srgbClr val="147D82"/>
@@ -21033,6 +22276,7 @@
           </a:lstStyle>
           <a:p xmlns:a="http://schemas.openxmlformats.org/drawingml/2006/main">
             <a:pPr>
+              <a:buNone/>
               <a:defRPr sz="1200" b="1">
                 <a:solidFill>
                   <a:srgbClr val="147D82"/>
@@ -21051,7 +22295,7 @@
                 <a:ea typeface="맑은 고딕"/>
                 <a:cs typeface="맑은 고딕"/>
               </a:rPr>
-              <a:t>09 · 모델 관리 | 별도 변화 합성 배치의 성능 점검</a:t>
+              <a:t>09 · 모델 관리 | 다른 합성 데이터에서 기존 성능 점검</a:t>
             </a:r>
           </a:p>
         </p:txBody>
@@ -21097,6 +22341,7 @@
               </a:defRPr>
             </a:defPPr>
             <a:lvl1pPr>
+              <a:buNone/>
               <a:defRPr sz="2925" b="1">
                 <a:solidFill>
                   <a:srgbClr val="173A49"/>
@@ -21107,6 +22352,7 @@
               </a:defRPr>
             </a:lvl1pPr>
             <a:lvl2pPr>
+              <a:buNone/>
               <a:defRPr sz="2925" b="1">
                 <a:solidFill>
                   <a:srgbClr val="173A49"/>
@@ -21117,6 +22363,7 @@
               </a:defRPr>
             </a:lvl2pPr>
             <a:lvl3pPr>
+              <a:buNone/>
               <a:defRPr sz="2925" b="1">
                 <a:solidFill>
                   <a:srgbClr val="173A49"/>
@@ -21127,6 +22374,7 @@
               </a:defRPr>
             </a:lvl3pPr>
             <a:lvl4pPr>
+              <a:buNone/>
               <a:defRPr sz="2925" b="1">
                 <a:solidFill>
                   <a:srgbClr val="173A49"/>
@@ -21137,6 +22385,7 @@
               </a:defRPr>
             </a:lvl4pPr>
             <a:lvl5pPr>
+              <a:buNone/>
               <a:defRPr sz="2925" b="1">
                 <a:solidFill>
                   <a:srgbClr val="173A49"/>
@@ -21147,6 +22396,7 @@
               </a:defRPr>
             </a:lvl5pPr>
             <a:lvl6pPr>
+              <a:buNone/>
               <a:defRPr sz="2925" b="1">
                 <a:solidFill>
                   <a:srgbClr val="173A49"/>
@@ -21157,6 +22407,7 @@
               </a:defRPr>
             </a:lvl6pPr>
             <a:lvl7pPr>
+              <a:buNone/>
               <a:defRPr sz="2925" b="1">
                 <a:solidFill>
                   <a:srgbClr val="173A49"/>
@@ -21167,6 +22418,7 @@
               </a:defRPr>
             </a:lvl7pPr>
             <a:lvl8pPr>
+              <a:buNone/>
               <a:defRPr sz="2925" b="1">
                 <a:solidFill>
                   <a:srgbClr val="173A49"/>
@@ -21177,6 +22429,7 @@
               </a:defRPr>
             </a:lvl8pPr>
             <a:lvl9pPr>
+              <a:buNone/>
               <a:defRPr sz="2925" b="1">
                 <a:solidFill>
                   <a:srgbClr val="173A49"/>
@@ -21189,6 +22442,7 @@
           </a:lstStyle>
           <a:p xmlns:a="http://schemas.openxmlformats.org/drawingml/2006/main">
             <a:pPr>
+              <a:buNone/>
               <a:defRPr sz="2925" b="1">
                 <a:solidFill>
                   <a:srgbClr val="173A49"/>
@@ -21253,6 +22507,7 @@
               </a:defRPr>
             </a:defPPr>
             <a:lvl1pPr>
+              <a:buNone/>
               <a:defRPr sz="975" b="0">
                 <a:solidFill>
                   <a:srgbClr val="617681"/>
@@ -21263,6 +22518,7 @@
               </a:defRPr>
             </a:lvl1pPr>
             <a:lvl2pPr>
+              <a:buNone/>
               <a:defRPr sz="975" b="0">
                 <a:solidFill>
                   <a:srgbClr val="617681"/>
@@ -21273,6 +22529,7 @@
               </a:defRPr>
             </a:lvl2pPr>
             <a:lvl3pPr>
+              <a:buNone/>
               <a:defRPr sz="975" b="0">
                 <a:solidFill>
                   <a:srgbClr val="617681"/>
@@ -21283,6 +22540,7 @@
               </a:defRPr>
             </a:lvl3pPr>
             <a:lvl4pPr>
+              <a:buNone/>
               <a:defRPr sz="975" b="0">
                 <a:solidFill>
                   <a:srgbClr val="617681"/>
@@ -21293,6 +22551,7 @@
               </a:defRPr>
             </a:lvl4pPr>
             <a:lvl5pPr>
+              <a:buNone/>
               <a:defRPr sz="975" b="0">
                 <a:solidFill>
                   <a:srgbClr val="617681"/>
@@ -21303,6 +22562,7 @@
               </a:defRPr>
             </a:lvl5pPr>
             <a:lvl6pPr>
+              <a:buNone/>
               <a:defRPr sz="975" b="0">
                 <a:solidFill>
                   <a:srgbClr val="617681"/>
@@ -21313,6 +22573,7 @@
               </a:defRPr>
             </a:lvl6pPr>
             <a:lvl7pPr>
+              <a:buNone/>
               <a:defRPr sz="975" b="0">
                 <a:solidFill>
                   <a:srgbClr val="617681"/>
@@ -21323,6 +22584,7 @@
               </a:defRPr>
             </a:lvl7pPr>
             <a:lvl8pPr>
+              <a:buNone/>
               <a:defRPr sz="975" b="0">
                 <a:solidFill>
                   <a:srgbClr val="617681"/>
@@ -21333,6 +22595,7 @@
               </a:defRPr>
             </a:lvl8pPr>
             <a:lvl9pPr>
+              <a:buNone/>
               <a:defRPr sz="975" b="0">
                 <a:solidFill>
                   <a:srgbClr val="617681"/>
@@ -21345,6 +22608,7 @@
           </a:lstStyle>
           <a:p xmlns:a="http://schemas.openxmlformats.org/drawingml/2006/main">
             <a:pPr>
+              <a:buNone/>
               <a:defRPr sz="975" b="0">
                 <a:solidFill>
                   <a:srgbClr val="617681"/>
@@ -21409,6 +22673,7 @@
               </a:defRPr>
             </a:defPPr>
             <a:lvl1pPr>
+              <a:buNone/>
               <a:defRPr sz="975" b="0">
                 <a:solidFill>
                   <a:srgbClr val="617681"/>
@@ -21419,6 +22684,7 @@
               </a:defRPr>
             </a:lvl1pPr>
             <a:lvl2pPr>
+              <a:buNone/>
               <a:defRPr sz="975" b="0">
                 <a:solidFill>
                   <a:srgbClr val="617681"/>
@@ -21429,6 +22695,7 @@
               </a:defRPr>
             </a:lvl2pPr>
             <a:lvl3pPr>
+              <a:buNone/>
               <a:defRPr sz="975" b="0">
                 <a:solidFill>
                   <a:srgbClr val="617681"/>
@@ -21439,6 +22706,7 @@
               </a:defRPr>
             </a:lvl3pPr>
             <a:lvl4pPr>
+              <a:buNone/>
               <a:defRPr sz="975" b="0">
                 <a:solidFill>
                   <a:srgbClr val="617681"/>
@@ -21449,6 +22717,7 @@
               </a:defRPr>
             </a:lvl4pPr>
             <a:lvl5pPr>
+              <a:buNone/>
               <a:defRPr sz="975" b="0">
                 <a:solidFill>
                   <a:srgbClr val="617681"/>
@@ -21459,6 +22728,7 @@
               </a:defRPr>
             </a:lvl5pPr>
             <a:lvl6pPr>
+              <a:buNone/>
               <a:defRPr sz="975" b="0">
                 <a:solidFill>
                   <a:srgbClr val="617681"/>
@@ -21469,6 +22739,7 @@
               </a:defRPr>
             </a:lvl6pPr>
             <a:lvl7pPr>
+              <a:buNone/>
               <a:defRPr sz="975" b="0">
                 <a:solidFill>
                   <a:srgbClr val="617681"/>
@@ -21479,6 +22750,7 @@
               </a:defRPr>
             </a:lvl7pPr>
             <a:lvl8pPr>
+              <a:buNone/>
               <a:defRPr sz="975" b="0">
                 <a:solidFill>
                   <a:srgbClr val="617681"/>
@@ -21489,6 +22761,7 @@
               </a:defRPr>
             </a:lvl8pPr>
             <a:lvl9pPr>
+              <a:buNone/>
               <a:defRPr sz="975" b="0">
                 <a:solidFill>
                   <a:srgbClr val="617681"/>
@@ -21501,6 +22774,7 @@
           </a:lstStyle>
           <a:p xmlns:a="http://schemas.openxmlformats.org/drawingml/2006/main">
             <a:pPr>
+              <a:buNone/>
               <a:defRPr sz="975" b="0">
                 <a:solidFill>
                   <a:srgbClr val="617681"/>
@@ -21529,7 +22803,7 @@
           <p:cNvPr id="5" name="">
             <a:extLst xmlns:a="http://schemas.openxmlformats.org/drawingml/2006/main">
               <a:ext uri="{FF2B5EF4-FFF2-40B4-BE49-F238E27FC236}">
-                <a16:creationId xmlns:a16="http://schemas.microsoft.com/office/drawing/2014/main" id="{C0BFCCE3-218E-4300-915F-9AE74E350242}"/>
+                <a16:creationId xmlns:a16="http://schemas.microsoft.com/office/drawing/2014/main" id="{33457954-2839-42D8-B22D-7197AA3D1514}"/>
               </a:ext>
             </a:extLst>
           </p:cNvPr>
@@ -21539,7 +22813,7 @@
           <p:nvPr/>
         </p:nvPicPr>
         <p:blipFill>
-          <a:blip xmlns:r="http://schemas.openxmlformats.org/officeDocument/2006/relationships" xmlns:a="http://schemas.openxmlformats.org/drawingml/2006/main" r:embed="Rf8c40cfb107c44c6"/>
+          <a:blip xmlns:r="http://schemas.openxmlformats.org/officeDocument/2006/relationships" xmlns:a="http://schemas.openxmlformats.org/drawingml/2006/main" r:embed="R9958178c524c42e9"/>
           <a:stretch xmlns:a="http://schemas.openxmlformats.org/drawingml/2006/main"/>
         </p:blipFill>
         <p:spPr>
@@ -21593,6 +22867,7 @@
               </a:defRPr>
             </a:defPPr>
             <a:lvl1pPr>
+              <a:buNone/>
               <a:defRPr sz="2175" b="1">
                 <a:solidFill>
                   <a:srgbClr val="173A49"/>
@@ -21603,6 +22878,7 @@
               </a:defRPr>
             </a:lvl1pPr>
             <a:lvl2pPr>
+              <a:buNone/>
               <a:defRPr sz="2175" b="1">
                 <a:solidFill>
                   <a:srgbClr val="173A49"/>
@@ -21613,6 +22889,7 @@
               </a:defRPr>
             </a:lvl2pPr>
             <a:lvl3pPr>
+              <a:buNone/>
               <a:defRPr sz="2175" b="1">
                 <a:solidFill>
                   <a:srgbClr val="173A49"/>
@@ -21623,6 +22900,7 @@
               </a:defRPr>
             </a:lvl3pPr>
             <a:lvl4pPr>
+              <a:buNone/>
               <a:defRPr sz="2175" b="1">
                 <a:solidFill>
                   <a:srgbClr val="173A49"/>
@@ -21633,6 +22911,7 @@
               </a:defRPr>
             </a:lvl4pPr>
             <a:lvl5pPr>
+              <a:buNone/>
               <a:defRPr sz="2175" b="1">
                 <a:solidFill>
                   <a:srgbClr val="173A49"/>
@@ -21643,6 +22922,7 @@
               </a:defRPr>
             </a:lvl5pPr>
             <a:lvl6pPr>
+              <a:buNone/>
               <a:defRPr sz="2175" b="1">
                 <a:solidFill>
                   <a:srgbClr val="173A49"/>
@@ -21653,6 +22933,7 @@
               </a:defRPr>
             </a:lvl6pPr>
             <a:lvl7pPr>
+              <a:buNone/>
               <a:defRPr sz="2175" b="1">
                 <a:solidFill>
                   <a:srgbClr val="173A49"/>
@@ -21663,6 +22944,7 @@
               </a:defRPr>
             </a:lvl7pPr>
             <a:lvl8pPr>
+              <a:buNone/>
               <a:defRPr sz="2175" b="1">
                 <a:solidFill>
                   <a:srgbClr val="173A49"/>
@@ -21673,6 +22955,7 @@
               </a:defRPr>
             </a:lvl8pPr>
             <a:lvl9pPr>
+              <a:buNone/>
               <a:defRPr sz="2175" b="1">
                 <a:solidFill>
                   <a:srgbClr val="173A49"/>
@@ -21685,6 +22968,7 @@
           </a:lstStyle>
           <a:p xmlns:a="http://schemas.openxmlformats.org/drawingml/2006/main">
             <a:pPr>
+              <a:buNone/>
               <a:defRPr sz="2175" b="1">
                 <a:solidFill>
                   <a:srgbClr val="173A49"/>
@@ -21708,6 +22992,7 @@
           </a:p>
           <a:p xmlns:a="http://schemas.openxmlformats.org/drawingml/2006/main">
             <a:pPr>
+              <a:buNone/>
               <a:defRPr sz="2175" b="1">
                 <a:solidFill>
                   <a:srgbClr val="173A49"/>
@@ -21772,6 +23057,7 @@
               </a:defRPr>
             </a:defPPr>
             <a:lvl1pPr>
+              <a:buNone/>
               <a:defRPr sz="2100" b="0">
                 <a:solidFill>
                   <a:srgbClr val="147D82"/>
@@ -21782,6 +23068,7 @@
               </a:defRPr>
             </a:lvl1pPr>
             <a:lvl2pPr>
+              <a:buNone/>
               <a:defRPr sz="2100" b="0">
                 <a:solidFill>
                   <a:srgbClr val="147D82"/>
@@ -21792,6 +23079,7 @@
               </a:defRPr>
             </a:lvl2pPr>
             <a:lvl3pPr>
+              <a:buNone/>
               <a:defRPr sz="2100" b="0">
                 <a:solidFill>
                   <a:srgbClr val="147D82"/>
@@ -21802,6 +23090,7 @@
               </a:defRPr>
             </a:lvl3pPr>
             <a:lvl4pPr>
+              <a:buNone/>
               <a:defRPr sz="2100" b="0">
                 <a:solidFill>
                   <a:srgbClr val="147D82"/>
@@ -21812,6 +23101,7 @@
               </a:defRPr>
             </a:lvl4pPr>
             <a:lvl5pPr>
+              <a:buNone/>
               <a:defRPr sz="2100" b="0">
                 <a:solidFill>
                   <a:srgbClr val="147D82"/>
@@ -21822,6 +23112,7 @@
               </a:defRPr>
             </a:lvl5pPr>
             <a:lvl6pPr>
+              <a:buNone/>
               <a:defRPr sz="2100" b="0">
                 <a:solidFill>
                   <a:srgbClr val="147D82"/>
@@ -21832,6 +23123,7 @@
               </a:defRPr>
             </a:lvl6pPr>
             <a:lvl7pPr>
+              <a:buNone/>
               <a:defRPr sz="2100" b="0">
                 <a:solidFill>
                   <a:srgbClr val="147D82"/>
@@ -21842,6 +23134,7 @@
               </a:defRPr>
             </a:lvl7pPr>
             <a:lvl8pPr>
+              <a:buNone/>
               <a:defRPr sz="2100" b="0">
                 <a:solidFill>
                   <a:srgbClr val="147D82"/>
@@ -21852,6 +23145,7 @@
               </a:defRPr>
             </a:lvl8pPr>
             <a:lvl9pPr>
+              <a:buNone/>
               <a:defRPr sz="2100" b="0">
                 <a:solidFill>
                   <a:srgbClr val="147D82"/>
@@ -21864,6 +23158,7 @@
           </a:lstStyle>
           <a:p xmlns:a="http://schemas.openxmlformats.org/drawingml/2006/main">
             <a:pPr>
+              <a:buNone/>
               <a:defRPr sz="2100" b="0">
                 <a:solidFill>
                   <a:srgbClr val="147D82"/>
@@ -21887,6 +23182,7 @@
           </a:p>
           <a:p xmlns:a="http://schemas.openxmlformats.org/drawingml/2006/main">
             <a:pPr>
+              <a:buNone/>
               <a:defRPr sz="2100" b="0">
                 <a:solidFill>
                   <a:srgbClr val="147D82"/>
@@ -21951,6 +23247,7 @@
               </a:defRPr>
             </a:defPPr>
             <a:lvl1pPr>
+              <a:buNone/>
               <a:defRPr sz="1950" b="0">
                 <a:solidFill>
                   <a:srgbClr val="173A49"/>
@@ -21961,6 +23258,7 @@
               </a:defRPr>
             </a:lvl1pPr>
             <a:lvl2pPr>
+              <a:buNone/>
               <a:defRPr sz="1950" b="0">
                 <a:solidFill>
                   <a:srgbClr val="173A49"/>
@@ -21971,6 +23269,7 @@
               </a:defRPr>
             </a:lvl2pPr>
             <a:lvl3pPr>
+              <a:buNone/>
               <a:defRPr sz="1950" b="0">
                 <a:solidFill>
                   <a:srgbClr val="173A49"/>
@@ -21981,6 +23280,7 @@
               </a:defRPr>
             </a:lvl3pPr>
             <a:lvl4pPr>
+              <a:buNone/>
               <a:defRPr sz="1950" b="0">
                 <a:solidFill>
                   <a:srgbClr val="173A49"/>
@@ -21991,6 +23291,7 @@
               </a:defRPr>
             </a:lvl4pPr>
             <a:lvl5pPr>
+              <a:buNone/>
               <a:defRPr sz="1950" b="0">
                 <a:solidFill>
                   <a:srgbClr val="173A49"/>
@@ -22001,6 +23302,7 @@
               </a:defRPr>
             </a:lvl5pPr>
             <a:lvl6pPr>
+              <a:buNone/>
               <a:defRPr sz="1950" b="0">
                 <a:solidFill>
                   <a:srgbClr val="173A49"/>
@@ -22011,6 +23313,7 @@
               </a:defRPr>
             </a:lvl6pPr>
             <a:lvl7pPr>
+              <a:buNone/>
               <a:defRPr sz="1950" b="0">
                 <a:solidFill>
                   <a:srgbClr val="173A49"/>
@@ -22021,6 +23324,7 @@
               </a:defRPr>
             </a:lvl7pPr>
             <a:lvl8pPr>
+              <a:buNone/>
               <a:defRPr sz="1950" b="0">
                 <a:solidFill>
                   <a:srgbClr val="173A49"/>
@@ -22031,6 +23335,7 @@
               </a:defRPr>
             </a:lvl8pPr>
             <a:lvl9pPr>
+              <a:buNone/>
               <a:defRPr sz="1950" b="0">
                 <a:solidFill>
                   <a:srgbClr val="173A49"/>
@@ -22043,6 +23348,7 @@
           </a:lstStyle>
           <a:p xmlns:a="http://schemas.openxmlformats.org/drawingml/2006/main">
             <a:pPr>
+              <a:buNone/>
               <a:defRPr sz="1950" b="0">
                 <a:solidFill>
                   <a:srgbClr val="173A49"/>
@@ -22066,6 +23372,7 @@
           </a:p>
           <a:p xmlns:a="http://schemas.openxmlformats.org/drawingml/2006/main">
             <a:pPr>
+              <a:buNone/>
               <a:defRPr sz="1950" b="0">
                 <a:solidFill>
                   <a:srgbClr val="173A49"/>
@@ -22130,6 +23437,7 @@
               </a:defRPr>
             </a:defPPr>
             <a:lvl1pPr>
+              <a:buNone/>
               <a:defRPr sz="1425" b="0">
                 <a:solidFill>
                   <a:srgbClr val="617681"/>
@@ -22140,6 +23448,7 @@
               </a:defRPr>
             </a:lvl1pPr>
             <a:lvl2pPr>
+              <a:buNone/>
               <a:defRPr sz="1425" b="0">
                 <a:solidFill>
                   <a:srgbClr val="617681"/>
@@ -22150,6 +23459,7 @@
               </a:defRPr>
             </a:lvl2pPr>
             <a:lvl3pPr>
+              <a:buNone/>
               <a:defRPr sz="1425" b="0">
                 <a:solidFill>
                   <a:srgbClr val="617681"/>
@@ -22160,6 +23470,7 @@
               </a:defRPr>
             </a:lvl3pPr>
             <a:lvl4pPr>
+              <a:buNone/>
               <a:defRPr sz="1425" b="0">
                 <a:solidFill>
                   <a:srgbClr val="617681"/>
@@ -22170,6 +23481,7 @@
               </a:defRPr>
             </a:lvl4pPr>
             <a:lvl5pPr>
+              <a:buNone/>
               <a:defRPr sz="1425" b="0">
                 <a:solidFill>
                   <a:srgbClr val="617681"/>
@@ -22180,6 +23492,7 @@
               </a:defRPr>
             </a:lvl5pPr>
             <a:lvl6pPr>
+              <a:buNone/>
               <a:defRPr sz="1425" b="0">
                 <a:solidFill>
                   <a:srgbClr val="617681"/>
@@ -22190,6 +23503,7 @@
               </a:defRPr>
             </a:lvl6pPr>
             <a:lvl7pPr>
+              <a:buNone/>
               <a:defRPr sz="1425" b="0">
                 <a:solidFill>
                   <a:srgbClr val="617681"/>
@@ -22200,6 +23514,7 @@
               </a:defRPr>
             </a:lvl7pPr>
             <a:lvl8pPr>
+              <a:buNone/>
               <a:defRPr sz="1425" b="0">
                 <a:solidFill>
                   <a:srgbClr val="617681"/>
@@ -22210,6 +23525,7 @@
               </a:defRPr>
             </a:lvl8pPr>
             <a:lvl9pPr>
+              <a:buNone/>
               <a:defRPr sz="1425" b="0">
                 <a:solidFill>
                   <a:srgbClr val="617681"/>
@@ -22222,6 +23538,7 @@
           </a:lstStyle>
           <a:p xmlns:a="http://schemas.openxmlformats.org/drawingml/2006/main">
             <a:pPr>
+              <a:buNone/>
               <a:defRPr sz="1425" b="0">
                 <a:solidFill>
                   <a:srgbClr val="617681"/>

</xml_diff>

<commit_message>
Explain false alarm percentages in slide six script
</commit_message>
<xml_diff>
--- a/docs/G045_Semiconductor_Agent.pptx
+++ b/docs/G045_Semiconductor_Agent.pptx
@@ -2,29 +2,29 @@
 <file path=ppt/presentation.xml><?xml version="1.0" encoding="utf-8"?>
 <p:presentation xmlns:p="http://schemas.openxmlformats.org/presentationml/2006/main">
   <p:sldMasterIdLst>
-    <p:sldMasterId xmlns:r="http://schemas.openxmlformats.org/officeDocument/2006/relationships" id="2147483648" r:id="R890bd17a185a4321"/>
+    <p:sldMasterId xmlns:r="http://schemas.openxmlformats.org/officeDocument/2006/relationships" id="2147483648" r:id="R7ae946cfdec443d3"/>
   </p:sldMasterIdLst>
   <p:notesMasterIdLst>
-    <p:notesMasterId xmlns:r="http://schemas.openxmlformats.org/officeDocument/2006/relationships" r:id="R4edbcfcaf0994d33"/>
+    <p:notesMasterId xmlns:r="http://schemas.openxmlformats.org/officeDocument/2006/relationships" r:id="Rdeacfb151ca64dc1"/>
   </p:notesMasterIdLst>
   <p:sldIdLst>
-    <p:sldId xmlns:r="http://schemas.openxmlformats.org/officeDocument/2006/relationships" id="256" r:id="Ra5bf5e85242a49d1"/>
-    <p:sldId xmlns:r="http://schemas.openxmlformats.org/officeDocument/2006/relationships" id="257" r:id="R6735613b9fbb41a4"/>
-    <p:sldId xmlns:r="http://schemas.openxmlformats.org/officeDocument/2006/relationships" id="258" r:id="R6b0ccccacea24736"/>
-    <p:sldId xmlns:r="http://schemas.openxmlformats.org/officeDocument/2006/relationships" id="259" r:id="R8f17c12aa7054e11"/>
-    <p:sldId xmlns:r="http://schemas.openxmlformats.org/officeDocument/2006/relationships" id="260" r:id="R2ada29aaf24a4ded"/>
-    <p:sldId xmlns:r="http://schemas.openxmlformats.org/officeDocument/2006/relationships" id="261" r:id="R34928c81e57a4e8d"/>
-    <p:sldId xmlns:r="http://schemas.openxmlformats.org/officeDocument/2006/relationships" id="262" r:id="R35a9b7fbbc5b4459"/>
-    <p:sldId xmlns:r="http://schemas.openxmlformats.org/officeDocument/2006/relationships" id="263" r:id="Ra8b0db7cef2d4780"/>
-    <p:sldId xmlns:r="http://schemas.openxmlformats.org/officeDocument/2006/relationships" id="264" r:id="R102ae3a252934e30"/>
-    <p:sldId xmlns:r="http://schemas.openxmlformats.org/officeDocument/2006/relationships" id="265" r:id="R4a32138836d544f5"/>
-    <p:sldId xmlns:r="http://schemas.openxmlformats.org/officeDocument/2006/relationships" id="266" r:id="Rcbb729178cb74197"/>
-    <p:sldId xmlns:r="http://schemas.openxmlformats.org/officeDocument/2006/relationships" id="267" r:id="R7ff06f40b1984e38"/>
-    <p:sldId xmlns:r="http://schemas.openxmlformats.org/officeDocument/2006/relationships" id="268" r:id="Reb6db29d1e084928"/>
-    <p:sldId xmlns:r="http://schemas.openxmlformats.org/officeDocument/2006/relationships" id="269" r:id="R86f07d18e691405c"/>
-    <p:sldId xmlns:r="http://schemas.openxmlformats.org/officeDocument/2006/relationships" id="270" r:id="Rf04a4a8f2f4a496d"/>
-    <p:sldId xmlns:r="http://schemas.openxmlformats.org/officeDocument/2006/relationships" id="271" r:id="Rfac6dee4a3c447f2"/>
-    <p:sldId xmlns:r="http://schemas.openxmlformats.org/officeDocument/2006/relationships" id="272" r:id="R5f4ab947b8e04c5b"/>
+    <p:sldId xmlns:r="http://schemas.openxmlformats.org/officeDocument/2006/relationships" id="256" r:id="Rad24fbdbd6d94df5"/>
+    <p:sldId xmlns:r="http://schemas.openxmlformats.org/officeDocument/2006/relationships" id="257" r:id="R712e059464d14b11"/>
+    <p:sldId xmlns:r="http://schemas.openxmlformats.org/officeDocument/2006/relationships" id="258" r:id="Rb73fa6e327f4469a"/>
+    <p:sldId xmlns:r="http://schemas.openxmlformats.org/officeDocument/2006/relationships" id="259" r:id="R7812a2c3baba44cd"/>
+    <p:sldId xmlns:r="http://schemas.openxmlformats.org/officeDocument/2006/relationships" id="260" r:id="R6b55d6e0acdb4900"/>
+    <p:sldId xmlns:r="http://schemas.openxmlformats.org/officeDocument/2006/relationships" id="261" r:id="Rd2a49790cc464b43"/>
+    <p:sldId xmlns:r="http://schemas.openxmlformats.org/officeDocument/2006/relationships" id="262" r:id="R59ebded40e45414a"/>
+    <p:sldId xmlns:r="http://schemas.openxmlformats.org/officeDocument/2006/relationships" id="263" r:id="R4b54e7d0559a4743"/>
+    <p:sldId xmlns:r="http://schemas.openxmlformats.org/officeDocument/2006/relationships" id="264" r:id="R00609e1f2e5b4661"/>
+    <p:sldId xmlns:r="http://schemas.openxmlformats.org/officeDocument/2006/relationships" id="265" r:id="R5f1902d12d4a4bd4"/>
+    <p:sldId xmlns:r="http://schemas.openxmlformats.org/officeDocument/2006/relationships" id="266" r:id="Rb16f19d010aa4fe6"/>
+    <p:sldId xmlns:r="http://schemas.openxmlformats.org/officeDocument/2006/relationships" id="267" r:id="R33908ef714084d42"/>
+    <p:sldId xmlns:r="http://schemas.openxmlformats.org/officeDocument/2006/relationships" id="268" r:id="Rd68ff811219d4d35"/>
+    <p:sldId xmlns:r="http://schemas.openxmlformats.org/officeDocument/2006/relationships" id="269" r:id="Rc199fa9e8a154a99"/>
+    <p:sldId xmlns:r="http://schemas.openxmlformats.org/officeDocument/2006/relationships" id="270" r:id="Rd9d30587d8b24d3b"/>
+    <p:sldId xmlns:r="http://schemas.openxmlformats.org/officeDocument/2006/relationships" id="271" r:id="Rccf1b157b4154acc"/>
+    <p:sldId xmlns:r="http://schemas.openxmlformats.org/officeDocument/2006/relationships" id="272" r:id="R16215c49a47841bd"/>
   </p:sldIdLst>
   <p:sldSz cx="12191999" cy="6858000"/>
   <p:notesSz cx="6858000" cy="9144000"/>
@@ -1785,7 +1785,7 @@
           <a:lstStyle xmlns:a="http://schemas.openxmlformats.org/drawingml/2006/main"/>
           <a:p xmlns:a="http://schemas.openxmlformats.org/drawingml/2006/main">
             <a:r>
-              <a:t>개별 센서 모델의 실제 비교입니다. F1은 AdaBoost가 더 높지만 Recall은 CatBoost가 높습니다. 이번에는 정상 오판 한도 안에서 Recall을 먼저 보는 기준이라 CatBoost를 골랐습니다.</a:t>
+              <a:t>CatBoost의 정상 오판률은 9.3%로 한도 15% 이내입니다. AdaBoost는 6.1%로 오판이 적고 F1도 높지만, Recall은 CatBoost가 100%로 더 높아 이번 기준에서 선택했습니다.</a:t>
             </a:r>
           </a:p>
           <a:p xmlns:a="http://schemas.openxmlformats.org/drawingml/2006/main">
@@ -5092,17 +5092,17 @@
   </p:cSld>
   <p:clrMap bg1="lt1" tx1="dk1" bg2="lt2" tx2="dk2" accent1="accent1" accent2="accent2" accent3="accent3" accent4="accent4" accent5="accent5" accent6="accent6" hlink="hlink" folHlink="folHlink"/>
   <p:sldLayoutIdLst>
-    <p:sldLayoutId xmlns:r="http://schemas.openxmlformats.org/officeDocument/2006/relationships" id="2147483649" r:id="R265d51914ea24f4b"/>
-    <p:sldLayoutId xmlns:r="http://schemas.openxmlformats.org/officeDocument/2006/relationships" id="2147483650" r:id="R6966c55449e6470c"/>
-    <p:sldLayoutId xmlns:r="http://schemas.openxmlformats.org/officeDocument/2006/relationships" id="2147483651" r:id="R04b2cd255a8f4fef"/>
-    <p:sldLayoutId xmlns:r="http://schemas.openxmlformats.org/officeDocument/2006/relationships" id="2147483652" r:id="R000a627affdf48cd"/>
-    <p:sldLayoutId xmlns:r="http://schemas.openxmlformats.org/officeDocument/2006/relationships" id="2147483653" r:id="Rd03451e12ff34523"/>
-    <p:sldLayoutId xmlns:r="http://schemas.openxmlformats.org/officeDocument/2006/relationships" id="2147483654" r:id="R1d8b0707ecb74461"/>
-    <p:sldLayoutId xmlns:r="http://schemas.openxmlformats.org/officeDocument/2006/relationships" id="2147483655" r:id="R0a2551bfc34f4c19"/>
-    <p:sldLayoutId xmlns:r="http://schemas.openxmlformats.org/officeDocument/2006/relationships" id="2147483656" r:id="R5a7c2656183d4cab"/>
-    <p:sldLayoutId xmlns:r="http://schemas.openxmlformats.org/officeDocument/2006/relationships" id="2147483657" r:id="R7fcb3e881d8e4534"/>
-    <p:sldLayoutId xmlns:r="http://schemas.openxmlformats.org/officeDocument/2006/relationships" id="2147483658" r:id="R23d2a06b83a54ba8"/>
-    <p:sldLayoutId xmlns:r="http://schemas.openxmlformats.org/officeDocument/2006/relationships" id="2147483659" r:id="R7aba031e2be14225"/>
+    <p:sldLayoutId xmlns:r="http://schemas.openxmlformats.org/officeDocument/2006/relationships" id="2147483649" r:id="R6991388213e243a8"/>
+    <p:sldLayoutId xmlns:r="http://schemas.openxmlformats.org/officeDocument/2006/relationships" id="2147483650" r:id="Rb521613415f547e5"/>
+    <p:sldLayoutId xmlns:r="http://schemas.openxmlformats.org/officeDocument/2006/relationships" id="2147483651" r:id="R83cd0ac0746e4425"/>
+    <p:sldLayoutId xmlns:r="http://schemas.openxmlformats.org/officeDocument/2006/relationships" id="2147483652" r:id="Rdd4776bd57b546ba"/>
+    <p:sldLayoutId xmlns:r="http://schemas.openxmlformats.org/officeDocument/2006/relationships" id="2147483653" r:id="R2ced5313b6c94ecb"/>
+    <p:sldLayoutId xmlns:r="http://schemas.openxmlformats.org/officeDocument/2006/relationships" id="2147483654" r:id="Re1c1624dbc6b4ff8"/>
+    <p:sldLayoutId xmlns:r="http://schemas.openxmlformats.org/officeDocument/2006/relationships" id="2147483655" r:id="Re0a49835ad6b41bf"/>
+    <p:sldLayoutId xmlns:r="http://schemas.openxmlformats.org/officeDocument/2006/relationships" id="2147483656" r:id="R1b3e6689a63a4b36"/>
+    <p:sldLayoutId xmlns:r="http://schemas.openxmlformats.org/officeDocument/2006/relationships" id="2147483657" r:id="R3fb8cbb31dd8492a"/>
+    <p:sldLayoutId xmlns:r="http://schemas.openxmlformats.org/officeDocument/2006/relationships" id="2147483658" r:id="R613bb738deba49e1"/>
+    <p:sldLayoutId xmlns:r="http://schemas.openxmlformats.org/officeDocument/2006/relationships" id="2147483659" r:id="R2cd8a3f721384ac8"/>
   </p:sldLayoutIdLst>
   <p:txStyles>
     <p:titleStyle>
@@ -5985,6 +5985,7 @@
               </a:defRPr>
             </a:defPPr>
             <a:lvl1pPr algn="l">
+              <a:buNone/>
               <a:defRPr sz="1000">
                 <a:solidFill>
                   <a:srgbClr val="617681"/>
@@ -5995,6 +5996,7 @@
               </a:defRPr>
             </a:lvl1pPr>
             <a:lvl2pPr algn="l">
+              <a:buNone/>
               <a:defRPr sz="1000">
                 <a:solidFill>
                   <a:srgbClr val="617681"/>
@@ -6005,6 +6007,7 @@
               </a:defRPr>
             </a:lvl2pPr>
             <a:lvl3pPr algn="l">
+              <a:buNone/>
               <a:defRPr sz="1000">
                 <a:solidFill>
                   <a:srgbClr val="617681"/>
@@ -6015,6 +6018,7 @@
               </a:defRPr>
             </a:lvl3pPr>
             <a:lvl4pPr algn="l">
+              <a:buNone/>
               <a:defRPr sz="1000">
                 <a:solidFill>
                   <a:srgbClr val="617681"/>
@@ -6025,6 +6029,7 @@
               </a:defRPr>
             </a:lvl4pPr>
             <a:lvl5pPr algn="l">
+              <a:buNone/>
               <a:defRPr sz="1000">
                 <a:solidFill>
                   <a:srgbClr val="617681"/>
@@ -6035,6 +6040,7 @@
               </a:defRPr>
             </a:lvl5pPr>
             <a:lvl6pPr algn="l">
+              <a:buNone/>
               <a:defRPr sz="1000">
                 <a:solidFill>
                   <a:srgbClr val="617681"/>
@@ -6045,6 +6051,7 @@
               </a:defRPr>
             </a:lvl6pPr>
             <a:lvl7pPr algn="l">
+              <a:buNone/>
               <a:defRPr sz="1000">
                 <a:solidFill>
                   <a:srgbClr val="617681"/>
@@ -6055,6 +6062,7 @@
               </a:defRPr>
             </a:lvl7pPr>
             <a:lvl8pPr algn="l">
+              <a:buNone/>
               <a:defRPr sz="1000">
                 <a:solidFill>
                   <a:srgbClr val="617681"/>
@@ -6065,6 +6073,7 @@
               </a:defRPr>
             </a:lvl8pPr>
             <a:lvl9pPr algn="l">
+              <a:buNone/>
               <a:defRPr sz="1000">
                 <a:solidFill>
                   <a:srgbClr val="617681"/>
@@ -7673,7 +7682,7 @@
           <p:cNvPr id="5" name="">
             <a:extLst xmlns:a="http://schemas.openxmlformats.org/drawingml/2006/main">
               <a:ext uri="{FF2B5EF4-FFF2-40B4-BE49-F238E27FC236}">
-                <a16:creationId xmlns:a16="http://schemas.microsoft.com/office/drawing/2014/main" id="{462E8EDB-D064-44F7-A230-F612D7D5048C}"/>
+                <a16:creationId xmlns:a16="http://schemas.microsoft.com/office/drawing/2014/main" id="{9BFF3DF5-4160-498A-8524-F9B2E9165B30}"/>
               </a:ext>
             </a:extLst>
           </p:cNvPr>
@@ -7683,7 +7692,7 @@
           <p:nvPr/>
         </p:nvPicPr>
         <p:blipFill>
-          <a:blip xmlns:r="http://schemas.openxmlformats.org/officeDocument/2006/relationships" xmlns:a="http://schemas.openxmlformats.org/drawingml/2006/main" r:embed="R0bbb6fb82ed547ea"/>
+          <a:blip xmlns:r="http://schemas.openxmlformats.org/officeDocument/2006/relationships" xmlns:a="http://schemas.openxmlformats.org/drawingml/2006/main" r:embed="R69ccad2f5bd8486c"/>
           <a:stretch xmlns:a="http://schemas.openxmlformats.org/drawingml/2006/main"/>
         </p:blipFill>
         <p:spPr>
@@ -9130,7 +9139,7 @@
           <p:cNvPr id="5" name="">
             <a:extLst xmlns:a="http://schemas.openxmlformats.org/drawingml/2006/main">
               <a:ext uri="{FF2B5EF4-FFF2-40B4-BE49-F238E27FC236}">
-                <a16:creationId xmlns:a16="http://schemas.microsoft.com/office/drawing/2014/main" id="{8063117F-83EC-455E-93BD-30A2514351EC}"/>
+                <a16:creationId xmlns:a16="http://schemas.microsoft.com/office/drawing/2014/main" id="{9574B569-8EE5-44B6-B4BF-C2917CEC4D4D}"/>
               </a:ext>
             </a:extLst>
           </p:cNvPr>
@@ -9140,7 +9149,7 @@
           <p:nvPr/>
         </p:nvPicPr>
         <p:blipFill>
-          <a:blip xmlns:r="http://schemas.openxmlformats.org/officeDocument/2006/relationships" xmlns:a="http://schemas.openxmlformats.org/drawingml/2006/main" r:embed="R35cfdf74d26f4b5a"/>
+          <a:blip xmlns:r="http://schemas.openxmlformats.org/officeDocument/2006/relationships" xmlns:a="http://schemas.openxmlformats.org/drawingml/2006/main" r:embed="R7df6ca6b79764a90"/>
           <a:stretch xmlns:a="http://schemas.openxmlformats.org/drawingml/2006/main"/>
         </p:blipFill>
         <p:spPr>
@@ -10011,6 +10020,7 @@
               </a:defRPr>
             </a:defPPr>
             <a:lvl1pPr algn="l">
+              <a:buNone/>
               <a:defRPr sz="1200" b="1">
                 <a:solidFill>
                   <a:srgbClr val="147D82"/>
@@ -10021,6 +10031,7 @@
               </a:defRPr>
             </a:lvl1pPr>
             <a:lvl2pPr algn="l">
+              <a:buNone/>
               <a:defRPr sz="1200" b="1">
                 <a:solidFill>
                   <a:srgbClr val="147D82"/>
@@ -10031,6 +10042,7 @@
               </a:defRPr>
             </a:lvl2pPr>
             <a:lvl3pPr algn="l">
+              <a:buNone/>
               <a:defRPr sz="1200" b="1">
                 <a:solidFill>
                   <a:srgbClr val="147D82"/>
@@ -10041,6 +10053,7 @@
               </a:defRPr>
             </a:lvl3pPr>
             <a:lvl4pPr algn="l">
+              <a:buNone/>
               <a:defRPr sz="1200" b="1">
                 <a:solidFill>
                   <a:srgbClr val="147D82"/>
@@ -10051,6 +10064,7 @@
               </a:defRPr>
             </a:lvl4pPr>
             <a:lvl5pPr algn="l">
+              <a:buNone/>
               <a:defRPr sz="1200" b="1">
                 <a:solidFill>
                   <a:srgbClr val="147D82"/>
@@ -10061,6 +10075,7 @@
               </a:defRPr>
             </a:lvl5pPr>
             <a:lvl6pPr algn="l">
+              <a:buNone/>
               <a:defRPr sz="1200" b="1">
                 <a:solidFill>
                   <a:srgbClr val="147D82"/>
@@ -10071,6 +10086,7 @@
               </a:defRPr>
             </a:lvl6pPr>
             <a:lvl7pPr algn="l">
+              <a:buNone/>
               <a:defRPr sz="1200" b="1">
                 <a:solidFill>
                   <a:srgbClr val="147D82"/>
@@ -10081,6 +10097,7 @@
               </a:defRPr>
             </a:lvl7pPr>
             <a:lvl8pPr algn="l">
+              <a:buNone/>
               <a:defRPr sz="1200" b="1">
                 <a:solidFill>
                   <a:srgbClr val="147D82"/>
@@ -10091,6 +10108,7 @@
               </a:defRPr>
             </a:lvl8pPr>
             <a:lvl9pPr algn="l">
+              <a:buNone/>
               <a:defRPr sz="1200" b="1">
                 <a:solidFill>
                   <a:srgbClr val="147D82"/>
@@ -10173,6 +10191,7 @@
               </a:defRPr>
             </a:defPPr>
             <a:lvl1pPr algn="l">
+              <a:buNone/>
               <a:defRPr sz="3200" b="1">
                 <a:solidFill>
                   <a:srgbClr val="173A49"/>
@@ -10183,6 +10202,7 @@
               </a:defRPr>
             </a:lvl1pPr>
             <a:lvl2pPr algn="l">
+              <a:buNone/>
               <a:defRPr sz="3200" b="1">
                 <a:solidFill>
                   <a:srgbClr val="173A49"/>
@@ -10193,6 +10213,7 @@
               </a:defRPr>
             </a:lvl2pPr>
             <a:lvl3pPr algn="l">
+              <a:buNone/>
               <a:defRPr sz="3200" b="1">
                 <a:solidFill>
                   <a:srgbClr val="173A49"/>
@@ -10203,6 +10224,7 @@
               </a:defRPr>
             </a:lvl3pPr>
             <a:lvl4pPr algn="l">
+              <a:buNone/>
               <a:defRPr sz="3200" b="1">
                 <a:solidFill>
                   <a:srgbClr val="173A49"/>
@@ -10213,6 +10235,7 @@
               </a:defRPr>
             </a:lvl4pPr>
             <a:lvl5pPr algn="l">
+              <a:buNone/>
               <a:defRPr sz="3200" b="1">
                 <a:solidFill>
                   <a:srgbClr val="173A49"/>
@@ -10223,6 +10246,7 @@
               </a:defRPr>
             </a:lvl5pPr>
             <a:lvl6pPr algn="l">
+              <a:buNone/>
               <a:defRPr sz="3200" b="1">
                 <a:solidFill>
                   <a:srgbClr val="173A49"/>
@@ -10233,6 +10257,7 @@
               </a:defRPr>
             </a:lvl6pPr>
             <a:lvl7pPr algn="l">
+              <a:buNone/>
               <a:defRPr sz="3200" b="1">
                 <a:solidFill>
                   <a:srgbClr val="173A49"/>
@@ -10243,6 +10268,7 @@
               </a:defRPr>
             </a:lvl7pPr>
             <a:lvl8pPr algn="l">
+              <a:buNone/>
               <a:defRPr sz="3200" b="1">
                 <a:solidFill>
                   <a:srgbClr val="173A49"/>
@@ -10253,6 +10279,7 @@
               </a:defRPr>
             </a:lvl8pPr>
             <a:lvl9pPr algn="l">
+              <a:buNone/>
               <a:defRPr sz="3200" b="1">
                 <a:solidFill>
                   <a:srgbClr val="173A49"/>
@@ -10441,6 +10468,7 @@
               </a:defRPr>
             </a:defPPr>
             <a:lvl1pPr algn="l">
+              <a:buNone/>
               <a:defRPr sz="1000">
                 <a:solidFill>
                   <a:srgbClr val="617681"/>
@@ -10451,6 +10479,7 @@
               </a:defRPr>
             </a:lvl1pPr>
             <a:lvl2pPr algn="l">
+              <a:buNone/>
               <a:defRPr sz="1000">
                 <a:solidFill>
                   <a:srgbClr val="617681"/>
@@ -10461,6 +10490,7 @@
               </a:defRPr>
             </a:lvl2pPr>
             <a:lvl3pPr algn="l">
+              <a:buNone/>
               <a:defRPr sz="1000">
                 <a:solidFill>
                   <a:srgbClr val="617681"/>
@@ -10471,6 +10501,7 @@
               </a:defRPr>
             </a:lvl3pPr>
             <a:lvl4pPr algn="l">
+              <a:buNone/>
               <a:defRPr sz="1000">
                 <a:solidFill>
                   <a:srgbClr val="617681"/>
@@ -10481,6 +10512,7 @@
               </a:defRPr>
             </a:lvl4pPr>
             <a:lvl5pPr algn="l">
+              <a:buNone/>
               <a:defRPr sz="1000">
                 <a:solidFill>
                   <a:srgbClr val="617681"/>
@@ -10491,6 +10523,7 @@
               </a:defRPr>
             </a:lvl5pPr>
             <a:lvl6pPr algn="l">
+              <a:buNone/>
               <a:defRPr sz="1000">
                 <a:solidFill>
                   <a:srgbClr val="617681"/>
@@ -10501,6 +10534,7 @@
               </a:defRPr>
             </a:lvl6pPr>
             <a:lvl7pPr algn="l">
+              <a:buNone/>
               <a:defRPr sz="1000">
                 <a:solidFill>
                   <a:srgbClr val="617681"/>
@@ -10511,6 +10545,7 @@
               </a:defRPr>
             </a:lvl7pPr>
             <a:lvl8pPr algn="l">
+              <a:buNone/>
               <a:defRPr sz="1000">
                 <a:solidFill>
                   <a:srgbClr val="617681"/>
@@ -10521,6 +10556,7 @@
               </a:defRPr>
             </a:lvl8pPr>
             <a:lvl9pPr algn="l">
+              <a:buNone/>
               <a:defRPr sz="1000">
                 <a:solidFill>
                   <a:srgbClr val="617681"/>
@@ -10654,6 +10690,7 @@
               </a:defRPr>
             </a:defPPr>
             <a:lvl1pPr algn="l">
+              <a:buNone/>
               <a:defRPr sz="1800">
                 <a:solidFill>
                   <a:srgbClr val="173A49"/>
@@ -10664,6 +10701,7 @@
               </a:defRPr>
             </a:lvl1pPr>
             <a:lvl2pPr algn="l">
+              <a:buNone/>
               <a:defRPr sz="1800">
                 <a:solidFill>
                   <a:srgbClr val="173A49"/>
@@ -10674,6 +10712,7 @@
               </a:defRPr>
             </a:lvl2pPr>
             <a:lvl3pPr algn="l">
+              <a:buNone/>
               <a:defRPr sz="1800">
                 <a:solidFill>
                   <a:srgbClr val="173A49"/>
@@ -10684,6 +10723,7 @@
               </a:defRPr>
             </a:lvl3pPr>
             <a:lvl4pPr algn="l">
+              <a:buNone/>
               <a:defRPr sz="1800">
                 <a:solidFill>
                   <a:srgbClr val="173A49"/>
@@ -10694,6 +10734,7 @@
               </a:defRPr>
             </a:lvl4pPr>
             <a:lvl5pPr algn="l">
+              <a:buNone/>
               <a:defRPr sz="1800">
                 <a:solidFill>
                   <a:srgbClr val="173A49"/>
@@ -10704,6 +10745,7 @@
               </a:defRPr>
             </a:lvl5pPr>
             <a:lvl6pPr algn="l">
+              <a:buNone/>
               <a:defRPr sz="1800">
                 <a:solidFill>
                   <a:srgbClr val="173A49"/>
@@ -10714,6 +10756,7 @@
               </a:defRPr>
             </a:lvl6pPr>
             <a:lvl7pPr algn="l">
+              <a:buNone/>
               <a:defRPr sz="1800">
                 <a:solidFill>
                   <a:srgbClr val="173A49"/>
@@ -10724,6 +10767,7 @@
               </a:defRPr>
             </a:lvl7pPr>
             <a:lvl8pPr algn="l">
+              <a:buNone/>
               <a:defRPr sz="1800">
                 <a:solidFill>
                   <a:srgbClr val="173A49"/>
@@ -10734,6 +10778,7 @@
               </a:defRPr>
             </a:lvl8pPr>
             <a:lvl9pPr algn="l">
+              <a:buNone/>
               <a:defRPr sz="1800">
                 <a:solidFill>
                   <a:srgbClr val="173A49"/>
@@ -10867,6 +10912,7 @@
               </a:defRPr>
             </a:defPPr>
             <a:lvl1pPr algn="l">
+              <a:buNone/>
               <a:defRPr sz="1500">
                 <a:solidFill>
                   <a:srgbClr val="173A49"/>
@@ -10877,6 +10923,7 @@
               </a:defRPr>
             </a:lvl1pPr>
             <a:lvl2pPr algn="l">
+              <a:buNone/>
               <a:defRPr sz="1500">
                 <a:solidFill>
                   <a:srgbClr val="173A49"/>
@@ -10887,6 +10934,7 @@
               </a:defRPr>
             </a:lvl2pPr>
             <a:lvl3pPr algn="l">
+              <a:buNone/>
               <a:defRPr sz="1500">
                 <a:solidFill>
                   <a:srgbClr val="173A49"/>
@@ -10897,6 +10945,7 @@
               </a:defRPr>
             </a:lvl3pPr>
             <a:lvl4pPr algn="l">
+              <a:buNone/>
               <a:defRPr sz="1500">
                 <a:solidFill>
                   <a:srgbClr val="173A49"/>
@@ -10907,6 +10956,7 @@
               </a:defRPr>
             </a:lvl4pPr>
             <a:lvl5pPr algn="l">
+              <a:buNone/>
               <a:defRPr sz="1500">
                 <a:solidFill>
                   <a:srgbClr val="173A49"/>
@@ -10917,6 +10967,7 @@
               </a:defRPr>
             </a:lvl5pPr>
             <a:lvl6pPr algn="l">
+              <a:buNone/>
               <a:defRPr sz="1500">
                 <a:solidFill>
                   <a:srgbClr val="173A49"/>
@@ -10927,6 +10978,7 @@
               </a:defRPr>
             </a:lvl6pPr>
             <a:lvl7pPr algn="l">
+              <a:buNone/>
               <a:defRPr sz="1500">
                 <a:solidFill>
                   <a:srgbClr val="173A49"/>
@@ -10937,6 +10989,7 @@
               </a:defRPr>
             </a:lvl7pPr>
             <a:lvl8pPr algn="l">
+              <a:buNone/>
               <a:defRPr sz="1500">
                 <a:solidFill>
                   <a:srgbClr val="173A49"/>
@@ -10947,6 +11000,7 @@
               </a:defRPr>
             </a:lvl8pPr>
             <a:lvl9pPr algn="l">
+              <a:buNone/>
               <a:defRPr sz="1500">
                 <a:solidFill>
                   <a:srgbClr val="173A49"/>
@@ -11080,6 +11134,7 @@
               </a:defRPr>
             </a:defPPr>
             <a:lvl1pPr algn="l">
+              <a:buNone/>
               <a:defRPr sz="1900">
                 <a:solidFill>
                   <a:srgbClr val="173A49"/>
@@ -11090,6 +11145,7 @@
               </a:defRPr>
             </a:lvl1pPr>
             <a:lvl2pPr algn="l">
+              <a:buNone/>
               <a:defRPr sz="1900">
                 <a:solidFill>
                   <a:srgbClr val="173A49"/>
@@ -11100,6 +11156,7 @@
               </a:defRPr>
             </a:lvl2pPr>
             <a:lvl3pPr algn="l">
+              <a:buNone/>
               <a:defRPr sz="1900">
                 <a:solidFill>
                   <a:srgbClr val="173A49"/>
@@ -11110,6 +11167,7 @@
               </a:defRPr>
             </a:lvl3pPr>
             <a:lvl4pPr algn="l">
+              <a:buNone/>
               <a:defRPr sz="1900">
                 <a:solidFill>
                   <a:srgbClr val="173A49"/>
@@ -11120,6 +11178,7 @@
               </a:defRPr>
             </a:lvl4pPr>
             <a:lvl5pPr algn="l">
+              <a:buNone/>
               <a:defRPr sz="1900">
                 <a:solidFill>
                   <a:srgbClr val="173A49"/>
@@ -11130,6 +11189,7 @@
               </a:defRPr>
             </a:lvl5pPr>
             <a:lvl6pPr algn="l">
+              <a:buNone/>
               <a:defRPr sz="1900">
                 <a:solidFill>
                   <a:srgbClr val="173A49"/>
@@ -11140,6 +11200,7 @@
               </a:defRPr>
             </a:lvl6pPr>
             <a:lvl7pPr algn="l">
+              <a:buNone/>
               <a:defRPr sz="1900">
                 <a:solidFill>
                   <a:srgbClr val="173A49"/>
@@ -11150,6 +11211,7 @@
               </a:defRPr>
             </a:lvl7pPr>
             <a:lvl8pPr algn="l">
+              <a:buNone/>
               <a:defRPr sz="1900">
                 <a:solidFill>
                   <a:srgbClr val="173A49"/>
@@ -11160,6 +11222,7 @@
               </a:defRPr>
             </a:lvl8pPr>
             <a:lvl9pPr algn="l">
+              <a:buNone/>
               <a:defRPr sz="1900">
                 <a:solidFill>
                   <a:srgbClr val="173A49"/>
@@ -11285,6 +11348,7 @@
               </a:defRPr>
             </a:defPPr>
             <a:lvl1pPr algn="l">
+              <a:buNone/>
               <a:defRPr sz="1900">
                 <a:solidFill>
                   <a:srgbClr val="173A49"/>
@@ -11295,6 +11359,7 @@
               </a:defRPr>
             </a:lvl1pPr>
             <a:lvl2pPr algn="l">
+              <a:buNone/>
               <a:defRPr sz="1900">
                 <a:solidFill>
                   <a:srgbClr val="173A49"/>
@@ -11305,6 +11370,7 @@
               </a:defRPr>
             </a:lvl2pPr>
             <a:lvl3pPr algn="l">
+              <a:buNone/>
               <a:defRPr sz="1900">
                 <a:solidFill>
                   <a:srgbClr val="173A49"/>
@@ -11315,6 +11381,7 @@
               </a:defRPr>
             </a:lvl3pPr>
             <a:lvl4pPr algn="l">
+              <a:buNone/>
               <a:defRPr sz="1900">
                 <a:solidFill>
                   <a:srgbClr val="173A49"/>
@@ -11325,6 +11392,7 @@
               </a:defRPr>
             </a:lvl4pPr>
             <a:lvl5pPr algn="l">
+              <a:buNone/>
               <a:defRPr sz="1900">
                 <a:solidFill>
                   <a:srgbClr val="173A49"/>
@@ -11335,6 +11403,7 @@
               </a:defRPr>
             </a:lvl5pPr>
             <a:lvl6pPr algn="l">
+              <a:buNone/>
               <a:defRPr sz="1900">
                 <a:solidFill>
                   <a:srgbClr val="173A49"/>
@@ -11345,6 +11414,7 @@
               </a:defRPr>
             </a:lvl6pPr>
             <a:lvl7pPr algn="l">
+              <a:buNone/>
               <a:defRPr sz="1900">
                 <a:solidFill>
                   <a:srgbClr val="173A49"/>
@@ -11355,6 +11425,7 @@
               </a:defRPr>
             </a:lvl7pPr>
             <a:lvl8pPr algn="l">
+              <a:buNone/>
               <a:defRPr sz="1900">
                 <a:solidFill>
                   <a:srgbClr val="173A49"/>
@@ -11365,6 +11436,7 @@
               </a:defRPr>
             </a:lvl8pPr>
             <a:lvl9pPr algn="l">
+              <a:buNone/>
               <a:defRPr sz="1900">
                 <a:solidFill>
                   <a:srgbClr val="173A49"/>
@@ -11490,6 +11562,7 @@
               </a:defRPr>
             </a:defPPr>
             <a:lvl1pPr algn="l">
+              <a:buNone/>
               <a:defRPr sz="1900">
                 <a:solidFill>
                   <a:srgbClr val="173A49"/>
@@ -11500,6 +11573,7 @@
               </a:defRPr>
             </a:lvl1pPr>
             <a:lvl2pPr algn="l">
+              <a:buNone/>
               <a:defRPr sz="1900">
                 <a:solidFill>
                   <a:srgbClr val="173A49"/>
@@ -11510,6 +11584,7 @@
               </a:defRPr>
             </a:lvl2pPr>
             <a:lvl3pPr algn="l">
+              <a:buNone/>
               <a:defRPr sz="1900">
                 <a:solidFill>
                   <a:srgbClr val="173A49"/>
@@ -11520,6 +11595,7 @@
               </a:defRPr>
             </a:lvl3pPr>
             <a:lvl4pPr algn="l">
+              <a:buNone/>
               <a:defRPr sz="1900">
                 <a:solidFill>
                   <a:srgbClr val="173A49"/>
@@ -11530,6 +11606,7 @@
               </a:defRPr>
             </a:lvl4pPr>
             <a:lvl5pPr algn="l">
+              <a:buNone/>
               <a:defRPr sz="1900">
                 <a:solidFill>
                   <a:srgbClr val="173A49"/>
@@ -11540,6 +11617,7 @@
               </a:defRPr>
             </a:lvl5pPr>
             <a:lvl6pPr algn="l">
+              <a:buNone/>
               <a:defRPr sz="1900">
                 <a:solidFill>
                   <a:srgbClr val="173A49"/>
@@ -11550,6 +11628,7 @@
               </a:defRPr>
             </a:lvl6pPr>
             <a:lvl7pPr algn="l">
+              <a:buNone/>
               <a:defRPr sz="1900">
                 <a:solidFill>
                   <a:srgbClr val="173A49"/>
@@ -11560,6 +11639,7 @@
               </a:defRPr>
             </a:lvl7pPr>
             <a:lvl8pPr algn="l">
+              <a:buNone/>
               <a:defRPr sz="1900">
                 <a:solidFill>
                   <a:srgbClr val="173A49"/>
@@ -11570,6 +11650,7 @@
               </a:defRPr>
             </a:lvl8pPr>
             <a:lvl9pPr algn="l">
+              <a:buNone/>
               <a:defRPr sz="1900">
                 <a:solidFill>
                   <a:srgbClr val="173A49"/>
@@ -11609,7 +11690,7 @@
           <p:cNvPr id="18" name="">
             <a:extLst xmlns:a="http://schemas.openxmlformats.org/drawingml/2006/main">
               <a:ext uri="{FF2B5EF4-FFF2-40B4-BE49-F238E27FC236}">
-                <a16:creationId xmlns:a16="http://schemas.microsoft.com/office/drawing/2014/main" id="{28BD480E-F818-42B5-A123-FA1FD593DFA4}"/>
+                <a16:creationId xmlns:a16="http://schemas.microsoft.com/office/drawing/2014/main" id="{EF6B491D-E567-4402-A15E-12B30B893726}"/>
               </a:ext>
             </a:extLst>
           </p:cNvPr>
@@ -11637,7 +11718,9 @@
                     <a:bodyPr/>
                     <a:lstStyle/>
                     <a:p>
-                      <a:pPr algn="l"/>
+                      <a:pPr algn="l">
+                        <a:buNone/>
+                      </a:pPr>
                       <a:r>
                         <a:rPr sz="1725" b="1">
                           <a:solidFill>
@@ -11686,7 +11769,9 @@
                     <a:bodyPr/>
                     <a:lstStyle/>
                     <a:p>
-                      <a:pPr algn="l"/>
+                      <a:pPr algn="l">
+                        <a:buNone/>
+                      </a:pPr>
                       <a:r>
                         <a:rPr sz="1725" b="1">
                           <a:solidFill>
@@ -11729,7 +11814,9 @@
                     <a:bodyPr/>
                     <a:lstStyle/>
                     <a:p>
-                      <a:pPr algn="l"/>
+                      <a:pPr algn="l">
+                        <a:buNone/>
+                      </a:pPr>
                       <a:r>
                         <a:rPr sz="1725" b="1">
                           <a:solidFill>
@@ -11772,7 +11859,9 @@
                     <a:bodyPr/>
                     <a:lstStyle/>
                     <a:p>
-                      <a:pPr algn="l"/>
+                      <a:pPr algn="l">
+                        <a:buNone/>
+                      </a:pPr>
                       <a:r>
                         <a:rPr sz="1725" b="1">
                           <a:solidFill>
@@ -11815,7 +11904,9 @@
                     <a:bodyPr/>
                     <a:lstStyle/>
                     <a:p>
-                      <a:pPr algn="l"/>
+                      <a:pPr algn="l">
+                        <a:buNone/>
+                      </a:pPr>
                       <a:r>
                         <a:rPr sz="1725" b="1">
                           <a:solidFill>
@@ -11860,7 +11951,9 @@
                     <a:bodyPr/>
                     <a:lstStyle/>
                     <a:p>
-                      <a:pPr algn="l"/>
+                      <a:pPr algn="l">
+                        <a:buNone/>
+                      </a:pPr>
                       <a:r>
                         <a:rPr sz="1650" b="0">
                           <a:solidFill>
@@ -11903,7 +11996,9 @@
                     <a:bodyPr/>
                     <a:lstStyle/>
                     <a:p>
-                      <a:pPr algn="l"/>
+                      <a:pPr algn="l">
+                        <a:buNone/>
+                      </a:pPr>
                       <a:r>
                         <a:rPr sz="1650" b="0">
                           <a:solidFill>
@@ -11940,7 +12035,9 @@
                     <a:bodyPr/>
                     <a:lstStyle/>
                     <a:p>
-                      <a:pPr algn="l"/>
+                      <a:pPr algn="l">
+                        <a:buNone/>
+                      </a:pPr>
                       <a:r>
                         <a:rPr sz="1650" b="0">
                           <a:solidFill>
@@ -11977,7 +12074,9 @@
                     <a:bodyPr/>
                     <a:lstStyle/>
                     <a:p>
-                      <a:pPr algn="l"/>
+                      <a:pPr algn="l">
+                        <a:buNone/>
+                      </a:pPr>
                       <a:r>
                         <a:rPr sz="1650" b="0">
                           <a:solidFill>
@@ -12014,7 +12113,9 @@
                     <a:bodyPr/>
                     <a:lstStyle/>
                     <a:p>
-                      <a:pPr algn="l"/>
+                      <a:pPr algn="l">
+                        <a:buNone/>
+                      </a:pPr>
                       <a:r>
                         <a:rPr sz="1650" b="0">
                           <a:solidFill>
@@ -12053,7 +12154,9 @@
                     <a:bodyPr/>
                     <a:lstStyle/>
                     <a:p>
-                      <a:pPr algn="l"/>
+                      <a:pPr algn="l">
+                        <a:buNone/>
+                      </a:pPr>
                       <a:r>
                         <a:rPr sz="1650" b="0">
                           <a:solidFill>
@@ -12096,7 +12199,9 @@
                     <a:bodyPr/>
                     <a:lstStyle/>
                     <a:p>
-                      <a:pPr algn="l"/>
+                      <a:pPr algn="l">
+                        <a:buNone/>
+                      </a:pPr>
                       <a:r>
                         <a:rPr sz="1650" b="0">
                           <a:solidFill>
@@ -12133,7 +12238,9 @@
                     <a:bodyPr/>
                     <a:lstStyle/>
                     <a:p>
-                      <a:pPr algn="l"/>
+                      <a:pPr algn="l">
+                        <a:buNone/>
+                      </a:pPr>
                       <a:r>
                         <a:rPr sz="1650" b="0">
                           <a:solidFill>
@@ -12170,7 +12277,9 @@
                     <a:bodyPr/>
                     <a:lstStyle/>
                     <a:p>
-                      <a:pPr algn="l"/>
+                      <a:pPr algn="l">
+                        <a:buNone/>
+                      </a:pPr>
                       <a:r>
                         <a:rPr sz="1650" b="0">
                           <a:solidFill>
@@ -12207,7 +12316,9 @@
                     <a:bodyPr/>
                     <a:lstStyle/>
                     <a:p>
-                      <a:pPr algn="l"/>
+                      <a:pPr algn="l">
+                        <a:buNone/>
+                      </a:pPr>
                       <a:r>
                         <a:rPr sz="1650" b="0">
                           <a:solidFill>
@@ -12246,7 +12357,9 @@
                     <a:bodyPr/>
                     <a:lstStyle/>
                     <a:p>
-                      <a:pPr algn="l"/>
+                      <a:pPr algn="l">
+                        <a:buNone/>
+                      </a:pPr>
                       <a:r>
                         <a:rPr sz="1650" b="0">
                           <a:solidFill>
@@ -12289,7 +12402,9 @@
                     <a:bodyPr/>
                     <a:lstStyle/>
                     <a:p>
-                      <a:pPr algn="l"/>
+                      <a:pPr algn="l">
+                        <a:buNone/>
+                      </a:pPr>
                       <a:r>
                         <a:rPr sz="1650" b="0">
                           <a:solidFill>
@@ -12326,7 +12441,9 @@
                     <a:bodyPr/>
                     <a:lstStyle/>
                     <a:p>
-                      <a:pPr algn="l"/>
+                      <a:pPr algn="l">
+                        <a:buNone/>
+                      </a:pPr>
                       <a:r>
                         <a:rPr sz="1650" b="0">
                           <a:solidFill>
@@ -12363,7 +12480,9 @@
                     <a:bodyPr/>
                     <a:lstStyle/>
                     <a:p>
-                      <a:pPr algn="l"/>
+                      <a:pPr algn="l">
+                        <a:buNone/>
+                      </a:pPr>
                       <a:r>
                         <a:rPr sz="1650" b="0">
                           <a:solidFill>
@@ -12400,7 +12519,9 @@
                     <a:bodyPr/>
                     <a:lstStyle/>
                     <a:p>
-                      <a:pPr algn="l"/>
+                      <a:pPr algn="l">
+                        <a:buNone/>
+                      </a:pPr>
                       <a:r>
                         <a:rPr sz="1650" b="0">
                           <a:solidFill>
@@ -12439,7 +12560,9 @@
                     <a:bodyPr/>
                     <a:lstStyle/>
                     <a:p>
-                      <a:pPr algn="l"/>
+                      <a:pPr algn="l">
+                        <a:buNone/>
+                      </a:pPr>
                       <a:r>
                         <a:rPr sz="1650" b="0">
                           <a:solidFill>
@@ -12482,7 +12605,9 @@
                     <a:bodyPr/>
                     <a:lstStyle/>
                     <a:p>
-                      <a:pPr algn="l"/>
+                      <a:pPr algn="l">
+                        <a:buNone/>
+                      </a:pPr>
                       <a:r>
                         <a:rPr sz="1650" b="0">
                           <a:solidFill>
@@ -12519,7 +12644,9 @@
                     <a:bodyPr/>
                     <a:lstStyle/>
                     <a:p>
-                      <a:pPr algn="l"/>
+                      <a:pPr algn="l">
+                        <a:buNone/>
+                      </a:pPr>
                       <a:r>
                         <a:rPr sz="1650" b="0">
                           <a:solidFill>
@@ -12556,7 +12683,9 @@
                     <a:bodyPr/>
                     <a:lstStyle/>
                     <a:p>
-                      <a:pPr algn="l"/>
+                      <a:pPr algn="l">
+                        <a:buNone/>
+                      </a:pPr>
                       <a:r>
                         <a:rPr sz="1650" b="0">
                           <a:solidFill>
@@ -12593,7 +12722,9 @@
                     <a:bodyPr/>
                     <a:lstStyle/>
                     <a:p>
-                      <a:pPr algn="l"/>
+                      <a:pPr algn="l">
+                        <a:buNone/>
+                      </a:pPr>
                       <a:r>
                         <a:rPr sz="1650" b="0">
                           <a:solidFill>
@@ -12752,6 +12883,7 @@
               </a:defRPr>
             </a:defPPr>
             <a:lvl1pPr algn="l">
+              <a:buNone/>
               <a:defRPr sz="1200" b="1">
                 <a:solidFill>
                   <a:srgbClr val="147D82"/>
@@ -12762,6 +12894,7 @@
               </a:defRPr>
             </a:lvl1pPr>
             <a:lvl2pPr algn="l">
+              <a:buNone/>
               <a:defRPr sz="1200" b="1">
                 <a:solidFill>
                   <a:srgbClr val="147D82"/>
@@ -12772,6 +12905,7 @@
               </a:defRPr>
             </a:lvl2pPr>
             <a:lvl3pPr algn="l">
+              <a:buNone/>
               <a:defRPr sz="1200" b="1">
                 <a:solidFill>
                   <a:srgbClr val="147D82"/>
@@ -12782,6 +12916,7 @@
               </a:defRPr>
             </a:lvl3pPr>
             <a:lvl4pPr algn="l">
+              <a:buNone/>
               <a:defRPr sz="1200" b="1">
                 <a:solidFill>
                   <a:srgbClr val="147D82"/>
@@ -12792,6 +12927,7 @@
               </a:defRPr>
             </a:lvl4pPr>
             <a:lvl5pPr algn="l">
+              <a:buNone/>
               <a:defRPr sz="1200" b="1">
                 <a:solidFill>
                   <a:srgbClr val="147D82"/>
@@ -12802,6 +12938,7 @@
               </a:defRPr>
             </a:lvl5pPr>
             <a:lvl6pPr algn="l">
+              <a:buNone/>
               <a:defRPr sz="1200" b="1">
                 <a:solidFill>
                   <a:srgbClr val="147D82"/>
@@ -12812,6 +12949,7 @@
               </a:defRPr>
             </a:lvl6pPr>
             <a:lvl7pPr algn="l">
+              <a:buNone/>
               <a:defRPr sz="1200" b="1">
                 <a:solidFill>
                   <a:srgbClr val="147D82"/>
@@ -12822,6 +12960,7 @@
               </a:defRPr>
             </a:lvl7pPr>
             <a:lvl8pPr algn="l">
+              <a:buNone/>
               <a:defRPr sz="1200" b="1">
                 <a:solidFill>
                   <a:srgbClr val="147D82"/>
@@ -12832,6 +12971,7 @@
               </a:defRPr>
             </a:lvl8pPr>
             <a:lvl9pPr algn="l">
+              <a:buNone/>
               <a:defRPr sz="1200" b="1">
                 <a:solidFill>
                   <a:srgbClr val="147D82"/>
@@ -13073,6 +13213,7 @@
               </a:defRPr>
             </a:defPPr>
             <a:lvl1pPr algn="l">
+              <a:buNone/>
               <a:defRPr sz="1000">
                 <a:solidFill>
                   <a:srgbClr val="617681"/>
@@ -13083,6 +13224,7 @@
               </a:defRPr>
             </a:lvl1pPr>
             <a:lvl2pPr algn="l">
+              <a:buNone/>
               <a:defRPr sz="1000">
                 <a:solidFill>
                   <a:srgbClr val="617681"/>
@@ -13093,6 +13235,7 @@
               </a:defRPr>
             </a:lvl2pPr>
             <a:lvl3pPr algn="l">
+              <a:buNone/>
               <a:defRPr sz="1000">
                 <a:solidFill>
                   <a:srgbClr val="617681"/>
@@ -13103,6 +13246,7 @@
               </a:defRPr>
             </a:lvl3pPr>
             <a:lvl4pPr algn="l">
+              <a:buNone/>
               <a:defRPr sz="1000">
                 <a:solidFill>
                   <a:srgbClr val="617681"/>
@@ -13113,6 +13257,7 @@
               </a:defRPr>
             </a:lvl4pPr>
             <a:lvl5pPr algn="l">
+              <a:buNone/>
               <a:defRPr sz="1000">
                 <a:solidFill>
                   <a:srgbClr val="617681"/>
@@ -13123,6 +13268,7 @@
               </a:defRPr>
             </a:lvl5pPr>
             <a:lvl6pPr algn="l">
+              <a:buNone/>
               <a:defRPr sz="1000">
                 <a:solidFill>
                   <a:srgbClr val="617681"/>
@@ -13133,6 +13279,7 @@
               </a:defRPr>
             </a:lvl6pPr>
             <a:lvl7pPr algn="l">
+              <a:buNone/>
               <a:defRPr sz="1000">
                 <a:solidFill>
                   <a:srgbClr val="617681"/>
@@ -13143,6 +13290,7 @@
               </a:defRPr>
             </a:lvl7pPr>
             <a:lvl8pPr algn="l">
+              <a:buNone/>
               <a:defRPr sz="1000">
                 <a:solidFill>
                   <a:srgbClr val="617681"/>
@@ -13153,6 +13301,7 @@
               </a:defRPr>
             </a:lvl8pPr>
             <a:lvl9pPr algn="l">
+              <a:buNone/>
               <a:defRPr sz="1000">
                 <a:solidFill>
                   <a:srgbClr val="617681"/>
@@ -13416,7 +13565,7 @@
           <p:cNvPr id="12" name="Picture 11">
             <a:extLst xmlns:a="http://schemas.openxmlformats.org/drawingml/2006/main">
               <a:ext uri="{FF2B5EF4-FFF2-40B4-BE49-F238E27FC236}">
-                <a16:creationId xmlns:a16="http://schemas.microsoft.com/office/drawing/2014/main" id="{1BD85AB8-66AA-45B7-9F77-A8CCC6D414D2}"/>
+                <a16:creationId xmlns:a16="http://schemas.microsoft.com/office/drawing/2014/main" id="{97A99B2E-6A13-45C2-9E33-D4239C3A484B}"/>
               </a:ext>
             </a:extLst>
           </p:cNvPr>
@@ -13426,7 +13575,7 @@
           <p:nvPr/>
         </p:nvPicPr>
         <p:blipFill>
-          <a:blip xmlns:r="http://schemas.openxmlformats.org/officeDocument/2006/relationships" xmlns:a="http://schemas.openxmlformats.org/drawingml/2006/main" r:embed="Rc0835237d4264c99"/>
+          <a:blip xmlns:r="http://schemas.openxmlformats.org/officeDocument/2006/relationships" xmlns:a="http://schemas.openxmlformats.org/drawingml/2006/main" r:embed="R795520bc3d9d43f3"/>
           <a:stretch xmlns:a="http://schemas.openxmlformats.org/drawingml/2006/main">
             <a:fillRect l="0" t="0" r="0" b="0"/>
           </a:stretch>
@@ -13563,6 +13712,7 @@
               </a:defRPr>
             </a:defPPr>
             <a:lvl1pPr algn="l">
+              <a:buNone/>
               <a:defRPr sz="1200" b="1">
                 <a:solidFill>
                   <a:srgbClr val="147D82"/>
@@ -13573,6 +13723,7 @@
               </a:defRPr>
             </a:lvl1pPr>
             <a:lvl2pPr algn="l">
+              <a:buNone/>
               <a:defRPr sz="1200" b="1">
                 <a:solidFill>
                   <a:srgbClr val="147D82"/>
@@ -13583,6 +13734,7 @@
               </a:defRPr>
             </a:lvl2pPr>
             <a:lvl3pPr algn="l">
+              <a:buNone/>
               <a:defRPr sz="1200" b="1">
                 <a:solidFill>
                   <a:srgbClr val="147D82"/>
@@ -13593,6 +13745,7 @@
               </a:defRPr>
             </a:lvl3pPr>
             <a:lvl4pPr algn="l">
+              <a:buNone/>
               <a:defRPr sz="1200" b="1">
                 <a:solidFill>
                   <a:srgbClr val="147D82"/>
@@ -13603,6 +13756,7 @@
               </a:defRPr>
             </a:lvl4pPr>
             <a:lvl5pPr algn="l">
+              <a:buNone/>
               <a:defRPr sz="1200" b="1">
                 <a:solidFill>
                   <a:srgbClr val="147D82"/>
@@ -13613,6 +13767,7 @@
               </a:defRPr>
             </a:lvl5pPr>
             <a:lvl6pPr algn="l">
+              <a:buNone/>
               <a:defRPr sz="1200" b="1">
                 <a:solidFill>
                   <a:srgbClr val="147D82"/>
@@ -13623,6 +13778,7 @@
               </a:defRPr>
             </a:lvl6pPr>
             <a:lvl7pPr algn="l">
+              <a:buNone/>
               <a:defRPr sz="1200" b="1">
                 <a:solidFill>
                   <a:srgbClr val="147D82"/>
@@ -13633,6 +13789,7 @@
               </a:defRPr>
             </a:lvl7pPr>
             <a:lvl8pPr algn="l">
+              <a:buNone/>
               <a:defRPr sz="1200" b="1">
                 <a:solidFill>
                   <a:srgbClr val="147D82"/>
@@ -13643,6 +13800,7 @@
               </a:defRPr>
             </a:lvl8pPr>
             <a:lvl9pPr algn="l">
+              <a:buNone/>
               <a:defRPr sz="1200" b="1">
                 <a:solidFill>
                   <a:srgbClr val="147D82"/>
@@ -13884,6 +14042,7 @@
               </a:defRPr>
             </a:defPPr>
             <a:lvl1pPr algn="l">
+              <a:buNone/>
               <a:defRPr sz="1000">
                 <a:solidFill>
                   <a:srgbClr val="617681"/>
@@ -13894,6 +14053,7 @@
               </a:defRPr>
             </a:lvl1pPr>
             <a:lvl2pPr algn="l">
+              <a:buNone/>
               <a:defRPr sz="1000">
                 <a:solidFill>
                   <a:srgbClr val="617681"/>
@@ -13904,6 +14064,7 @@
               </a:defRPr>
             </a:lvl2pPr>
             <a:lvl3pPr algn="l">
+              <a:buNone/>
               <a:defRPr sz="1000">
                 <a:solidFill>
                   <a:srgbClr val="617681"/>
@@ -13914,6 +14075,7 @@
               </a:defRPr>
             </a:lvl3pPr>
             <a:lvl4pPr algn="l">
+              <a:buNone/>
               <a:defRPr sz="1000">
                 <a:solidFill>
                   <a:srgbClr val="617681"/>
@@ -13924,6 +14086,7 @@
               </a:defRPr>
             </a:lvl4pPr>
             <a:lvl5pPr algn="l">
+              <a:buNone/>
               <a:defRPr sz="1000">
                 <a:solidFill>
                   <a:srgbClr val="617681"/>
@@ -13934,6 +14097,7 @@
               </a:defRPr>
             </a:lvl5pPr>
             <a:lvl6pPr algn="l">
+              <a:buNone/>
               <a:defRPr sz="1000">
                 <a:solidFill>
                   <a:srgbClr val="617681"/>
@@ -13944,6 +14108,7 @@
               </a:defRPr>
             </a:lvl6pPr>
             <a:lvl7pPr algn="l">
+              <a:buNone/>
               <a:defRPr sz="1000">
                 <a:solidFill>
                   <a:srgbClr val="617681"/>
@@ -13954,6 +14119,7 @@
               </a:defRPr>
             </a:lvl7pPr>
             <a:lvl8pPr algn="l">
+              <a:buNone/>
               <a:defRPr sz="1000">
                 <a:solidFill>
                   <a:srgbClr val="617681"/>
@@ -13964,6 +14130,7 @@
               </a:defRPr>
             </a:lvl8pPr>
             <a:lvl9pPr algn="l">
+              <a:buNone/>
               <a:defRPr sz="1000">
                 <a:solidFill>
                   <a:srgbClr val="617681"/>
@@ -15262,6 +15429,7 @@
               </a:defRPr>
             </a:defPPr>
             <a:lvl1pPr algn="l">
+              <a:buNone/>
               <a:defRPr sz="1200" b="1">
                 <a:solidFill>
                   <a:srgbClr val="147D82"/>
@@ -15272,6 +15440,7 @@
               </a:defRPr>
             </a:lvl1pPr>
             <a:lvl2pPr algn="l">
+              <a:buNone/>
               <a:defRPr sz="1200" b="1">
                 <a:solidFill>
                   <a:srgbClr val="147D82"/>
@@ -15282,6 +15451,7 @@
               </a:defRPr>
             </a:lvl2pPr>
             <a:lvl3pPr algn="l">
+              <a:buNone/>
               <a:defRPr sz="1200" b="1">
                 <a:solidFill>
                   <a:srgbClr val="147D82"/>
@@ -15292,6 +15462,7 @@
               </a:defRPr>
             </a:lvl3pPr>
             <a:lvl4pPr algn="l">
+              <a:buNone/>
               <a:defRPr sz="1200" b="1">
                 <a:solidFill>
                   <a:srgbClr val="147D82"/>
@@ -15302,6 +15473,7 @@
               </a:defRPr>
             </a:lvl4pPr>
             <a:lvl5pPr algn="l">
+              <a:buNone/>
               <a:defRPr sz="1200" b="1">
                 <a:solidFill>
                   <a:srgbClr val="147D82"/>
@@ -15312,6 +15484,7 @@
               </a:defRPr>
             </a:lvl5pPr>
             <a:lvl6pPr algn="l">
+              <a:buNone/>
               <a:defRPr sz="1200" b="1">
                 <a:solidFill>
                   <a:srgbClr val="147D82"/>
@@ -15322,6 +15495,7 @@
               </a:defRPr>
             </a:lvl6pPr>
             <a:lvl7pPr algn="l">
+              <a:buNone/>
               <a:defRPr sz="1200" b="1">
                 <a:solidFill>
                   <a:srgbClr val="147D82"/>
@@ -15332,6 +15506,7 @@
               </a:defRPr>
             </a:lvl7pPr>
             <a:lvl8pPr algn="l">
+              <a:buNone/>
               <a:defRPr sz="1200" b="1">
                 <a:solidFill>
                   <a:srgbClr val="147D82"/>
@@ -15342,6 +15517,7 @@
               </a:defRPr>
             </a:lvl8pPr>
             <a:lvl9pPr algn="l">
+              <a:buNone/>
               <a:defRPr sz="1200" b="1">
                 <a:solidFill>
                   <a:srgbClr val="147D82"/>
@@ -15583,6 +15759,7 @@
               </a:defRPr>
             </a:defPPr>
             <a:lvl1pPr algn="l">
+              <a:buNone/>
               <a:defRPr sz="1000">
                 <a:solidFill>
                   <a:srgbClr val="617681"/>
@@ -15593,6 +15770,7 @@
               </a:defRPr>
             </a:lvl1pPr>
             <a:lvl2pPr algn="l">
+              <a:buNone/>
               <a:defRPr sz="1000">
                 <a:solidFill>
                   <a:srgbClr val="617681"/>
@@ -15603,6 +15781,7 @@
               </a:defRPr>
             </a:lvl2pPr>
             <a:lvl3pPr algn="l">
+              <a:buNone/>
               <a:defRPr sz="1000">
                 <a:solidFill>
                   <a:srgbClr val="617681"/>
@@ -15613,6 +15792,7 @@
               </a:defRPr>
             </a:lvl3pPr>
             <a:lvl4pPr algn="l">
+              <a:buNone/>
               <a:defRPr sz="1000">
                 <a:solidFill>
                   <a:srgbClr val="617681"/>
@@ -15623,6 +15803,7 @@
               </a:defRPr>
             </a:lvl4pPr>
             <a:lvl5pPr algn="l">
+              <a:buNone/>
               <a:defRPr sz="1000">
                 <a:solidFill>
                   <a:srgbClr val="617681"/>
@@ -15633,6 +15814,7 @@
               </a:defRPr>
             </a:lvl5pPr>
             <a:lvl6pPr algn="l">
+              <a:buNone/>
               <a:defRPr sz="1000">
                 <a:solidFill>
                   <a:srgbClr val="617681"/>
@@ -15643,6 +15825,7 @@
               </a:defRPr>
             </a:lvl6pPr>
             <a:lvl7pPr algn="l">
+              <a:buNone/>
               <a:defRPr sz="1000">
                 <a:solidFill>
                   <a:srgbClr val="617681"/>
@@ -15653,6 +15836,7 @@
               </a:defRPr>
             </a:lvl7pPr>
             <a:lvl8pPr algn="l">
+              <a:buNone/>
               <a:defRPr sz="1000">
                 <a:solidFill>
                   <a:srgbClr val="617681"/>
@@ -15663,6 +15847,7 @@
               </a:defRPr>
             </a:lvl8pPr>
             <a:lvl9pPr algn="l">
+              <a:buNone/>
               <a:defRPr sz="1000">
                 <a:solidFill>
                   <a:srgbClr val="617681"/>
@@ -15869,7 +16054,7 @@
           <p:cNvPr id="11" name="Table 10">
             <a:extLst xmlns:a="http://schemas.openxmlformats.org/drawingml/2006/main">
               <a:ext uri="{FF2B5EF4-FFF2-40B4-BE49-F238E27FC236}">
-                <a16:creationId xmlns:a16="http://schemas.microsoft.com/office/drawing/2014/main" id="{C6DE9DC6-A692-469C-B500-C9AE2316370C}"/>
+                <a16:creationId xmlns:a16="http://schemas.microsoft.com/office/drawing/2014/main" id="{5A0DCE42-382A-4348-B4D7-D3B085AB7F36}"/>
               </a:ext>
             </a:extLst>
           </p:cNvPr>
@@ -16349,6 +16534,7 @@
               </a:defRPr>
             </a:defPPr>
             <a:lvl1pPr algn="l">
+              <a:buNone/>
               <a:defRPr sz="1200" b="1">
                 <a:solidFill>
                   <a:srgbClr val="147D82"/>
@@ -16359,6 +16545,7 @@
               </a:defRPr>
             </a:lvl1pPr>
             <a:lvl2pPr algn="l">
+              <a:buNone/>
               <a:defRPr sz="1200" b="1">
                 <a:solidFill>
                   <a:srgbClr val="147D82"/>
@@ -16369,6 +16556,7 @@
               </a:defRPr>
             </a:lvl2pPr>
             <a:lvl3pPr algn="l">
+              <a:buNone/>
               <a:defRPr sz="1200" b="1">
                 <a:solidFill>
                   <a:srgbClr val="147D82"/>
@@ -16379,6 +16567,7 @@
               </a:defRPr>
             </a:lvl3pPr>
             <a:lvl4pPr algn="l">
+              <a:buNone/>
               <a:defRPr sz="1200" b="1">
                 <a:solidFill>
                   <a:srgbClr val="147D82"/>
@@ -16389,6 +16578,7 @@
               </a:defRPr>
             </a:lvl4pPr>
             <a:lvl5pPr algn="l">
+              <a:buNone/>
               <a:defRPr sz="1200" b="1">
                 <a:solidFill>
                   <a:srgbClr val="147D82"/>
@@ -16399,6 +16589,7 @@
               </a:defRPr>
             </a:lvl5pPr>
             <a:lvl6pPr algn="l">
+              <a:buNone/>
               <a:defRPr sz="1200" b="1">
                 <a:solidFill>
                   <a:srgbClr val="147D82"/>
@@ -16409,6 +16600,7 @@
               </a:defRPr>
             </a:lvl6pPr>
             <a:lvl7pPr algn="l">
+              <a:buNone/>
               <a:defRPr sz="1200" b="1">
                 <a:solidFill>
                   <a:srgbClr val="147D82"/>
@@ -16419,6 +16611,7 @@
               </a:defRPr>
             </a:lvl7pPr>
             <a:lvl8pPr algn="l">
+              <a:buNone/>
               <a:defRPr sz="1200" b="1">
                 <a:solidFill>
                   <a:srgbClr val="147D82"/>
@@ -16429,6 +16622,7 @@
               </a:defRPr>
             </a:lvl8pPr>
             <a:lvl9pPr algn="l">
+              <a:buNone/>
               <a:defRPr sz="1200" b="1">
                 <a:solidFill>
                   <a:srgbClr val="147D82"/>
@@ -16511,6 +16705,7 @@
               </a:defRPr>
             </a:defPPr>
             <a:lvl1pPr algn="l">
+              <a:buNone/>
               <a:defRPr sz="3200" b="1">
                 <a:solidFill>
                   <a:srgbClr val="173A49"/>
@@ -16521,6 +16716,7 @@
               </a:defRPr>
             </a:lvl1pPr>
             <a:lvl2pPr algn="l">
+              <a:buNone/>
               <a:defRPr sz="3200" b="1">
                 <a:solidFill>
                   <a:srgbClr val="173A49"/>
@@ -16531,6 +16727,7 @@
               </a:defRPr>
             </a:lvl2pPr>
             <a:lvl3pPr algn="l">
+              <a:buNone/>
               <a:defRPr sz="3200" b="1">
                 <a:solidFill>
                   <a:srgbClr val="173A49"/>
@@ -16541,6 +16738,7 @@
               </a:defRPr>
             </a:lvl3pPr>
             <a:lvl4pPr algn="l">
+              <a:buNone/>
               <a:defRPr sz="3200" b="1">
                 <a:solidFill>
                   <a:srgbClr val="173A49"/>
@@ -16551,6 +16749,7 @@
               </a:defRPr>
             </a:lvl4pPr>
             <a:lvl5pPr algn="l">
+              <a:buNone/>
               <a:defRPr sz="3200" b="1">
                 <a:solidFill>
                   <a:srgbClr val="173A49"/>
@@ -16561,6 +16760,7 @@
               </a:defRPr>
             </a:lvl5pPr>
             <a:lvl6pPr algn="l">
+              <a:buNone/>
               <a:defRPr sz="3200" b="1">
                 <a:solidFill>
                   <a:srgbClr val="173A49"/>
@@ -16571,6 +16771,7 @@
               </a:defRPr>
             </a:lvl6pPr>
             <a:lvl7pPr algn="l">
+              <a:buNone/>
               <a:defRPr sz="3200" b="1">
                 <a:solidFill>
                   <a:srgbClr val="173A49"/>
@@ -16581,6 +16782,7 @@
               </a:defRPr>
             </a:lvl7pPr>
             <a:lvl8pPr algn="l">
+              <a:buNone/>
               <a:defRPr sz="3200" b="1">
                 <a:solidFill>
                   <a:srgbClr val="173A49"/>
@@ -16591,6 +16793,7 @@
               </a:defRPr>
             </a:lvl8pPr>
             <a:lvl9pPr algn="l">
+              <a:buNone/>
               <a:defRPr sz="3200" b="1">
                 <a:solidFill>
                   <a:srgbClr val="173A49"/>
@@ -16779,6 +16982,7 @@
               </a:defRPr>
             </a:defPPr>
             <a:lvl1pPr algn="l">
+              <a:buNone/>
               <a:defRPr sz="1000">
                 <a:solidFill>
                   <a:srgbClr val="617681"/>
@@ -16789,6 +16993,7 @@
               </a:defRPr>
             </a:lvl1pPr>
             <a:lvl2pPr algn="l">
+              <a:buNone/>
               <a:defRPr sz="1000">
                 <a:solidFill>
                   <a:srgbClr val="617681"/>
@@ -16799,6 +17004,7 @@
               </a:defRPr>
             </a:lvl2pPr>
             <a:lvl3pPr algn="l">
+              <a:buNone/>
               <a:defRPr sz="1000">
                 <a:solidFill>
                   <a:srgbClr val="617681"/>
@@ -16809,6 +17015,7 @@
               </a:defRPr>
             </a:lvl3pPr>
             <a:lvl4pPr algn="l">
+              <a:buNone/>
               <a:defRPr sz="1000">
                 <a:solidFill>
                   <a:srgbClr val="617681"/>
@@ -16819,6 +17026,7 @@
               </a:defRPr>
             </a:lvl4pPr>
             <a:lvl5pPr algn="l">
+              <a:buNone/>
               <a:defRPr sz="1000">
                 <a:solidFill>
                   <a:srgbClr val="617681"/>
@@ -16829,6 +17037,7 @@
               </a:defRPr>
             </a:lvl5pPr>
             <a:lvl6pPr algn="l">
+              <a:buNone/>
               <a:defRPr sz="1000">
                 <a:solidFill>
                   <a:srgbClr val="617681"/>
@@ -16839,6 +17048,7 @@
               </a:defRPr>
             </a:lvl6pPr>
             <a:lvl7pPr algn="l">
+              <a:buNone/>
               <a:defRPr sz="1000">
                 <a:solidFill>
                   <a:srgbClr val="617681"/>
@@ -16849,6 +17059,7 @@
               </a:defRPr>
             </a:lvl7pPr>
             <a:lvl8pPr algn="l">
+              <a:buNone/>
               <a:defRPr sz="1000">
                 <a:solidFill>
                   <a:srgbClr val="617681"/>
@@ -16859,6 +17070,7 @@
               </a:defRPr>
             </a:lvl8pPr>
             <a:lvl9pPr algn="l">
+              <a:buNone/>
               <a:defRPr sz="1000">
                 <a:solidFill>
                   <a:srgbClr val="617681"/>
@@ -16994,6 +17206,7 @@
               </a:defRPr>
             </a:defPPr>
             <a:lvl1pPr algn="l">
+              <a:buNone/>
               <a:defRPr sz="2100">
                 <a:solidFill>
                   <a:srgbClr val="173A49"/>
@@ -17004,6 +17217,7 @@
               </a:defRPr>
             </a:lvl1pPr>
             <a:lvl2pPr algn="l">
+              <a:buNone/>
               <a:defRPr sz="2100">
                 <a:solidFill>
                   <a:srgbClr val="173A49"/>
@@ -17014,6 +17228,7 @@
               </a:defRPr>
             </a:lvl2pPr>
             <a:lvl3pPr algn="l">
+              <a:buNone/>
               <a:defRPr sz="2100">
                 <a:solidFill>
                   <a:srgbClr val="173A49"/>
@@ -17024,6 +17239,7 @@
               </a:defRPr>
             </a:lvl3pPr>
             <a:lvl4pPr algn="l">
+              <a:buNone/>
               <a:defRPr sz="2100">
                 <a:solidFill>
                   <a:srgbClr val="173A49"/>
@@ -17034,6 +17250,7 @@
               </a:defRPr>
             </a:lvl4pPr>
             <a:lvl5pPr algn="l">
+              <a:buNone/>
               <a:defRPr sz="2100">
                 <a:solidFill>
                   <a:srgbClr val="173A49"/>
@@ -17044,6 +17261,7 @@
               </a:defRPr>
             </a:lvl5pPr>
             <a:lvl6pPr algn="l">
+              <a:buNone/>
               <a:defRPr sz="2100">
                 <a:solidFill>
                   <a:srgbClr val="173A49"/>
@@ -17054,6 +17272,7 @@
               </a:defRPr>
             </a:lvl6pPr>
             <a:lvl7pPr algn="l">
+              <a:buNone/>
               <a:defRPr sz="2100">
                 <a:solidFill>
                   <a:srgbClr val="173A49"/>
@@ -17064,6 +17283,7 @@
               </a:defRPr>
             </a:lvl7pPr>
             <a:lvl8pPr algn="l">
+              <a:buNone/>
               <a:defRPr sz="2100">
                 <a:solidFill>
                   <a:srgbClr val="173A49"/>
@@ -17074,6 +17294,7 @@
               </a:defRPr>
             </a:lvl8pPr>
             <a:lvl9pPr algn="l">
+              <a:buNone/>
               <a:defRPr sz="2100">
                 <a:solidFill>
                   <a:srgbClr val="173A49"/>
@@ -17209,6 +17430,7 @@
               </a:defRPr>
             </a:defPPr>
             <a:lvl1pPr algn="l">
+              <a:buNone/>
               <a:defRPr sz="2100">
                 <a:solidFill>
                   <a:srgbClr val="173A49"/>
@@ -17219,6 +17441,7 @@
               </a:defRPr>
             </a:lvl1pPr>
             <a:lvl2pPr algn="l">
+              <a:buNone/>
               <a:defRPr sz="2100">
                 <a:solidFill>
                   <a:srgbClr val="173A49"/>
@@ -17229,6 +17452,7 @@
               </a:defRPr>
             </a:lvl2pPr>
             <a:lvl3pPr algn="l">
+              <a:buNone/>
               <a:defRPr sz="2100">
                 <a:solidFill>
                   <a:srgbClr val="173A49"/>
@@ -17239,6 +17463,7 @@
               </a:defRPr>
             </a:lvl3pPr>
             <a:lvl4pPr algn="l">
+              <a:buNone/>
               <a:defRPr sz="2100">
                 <a:solidFill>
                   <a:srgbClr val="173A49"/>
@@ -17249,6 +17474,7 @@
               </a:defRPr>
             </a:lvl4pPr>
             <a:lvl5pPr algn="l">
+              <a:buNone/>
               <a:defRPr sz="2100">
                 <a:solidFill>
                   <a:srgbClr val="173A49"/>
@@ -17259,6 +17485,7 @@
               </a:defRPr>
             </a:lvl5pPr>
             <a:lvl6pPr algn="l">
+              <a:buNone/>
               <a:defRPr sz="2100">
                 <a:solidFill>
                   <a:srgbClr val="173A49"/>
@@ -17269,6 +17496,7 @@
               </a:defRPr>
             </a:lvl6pPr>
             <a:lvl7pPr algn="l">
+              <a:buNone/>
               <a:defRPr sz="2100">
                 <a:solidFill>
                   <a:srgbClr val="173A49"/>
@@ -17279,6 +17507,7 @@
               </a:defRPr>
             </a:lvl7pPr>
             <a:lvl8pPr algn="l">
+              <a:buNone/>
               <a:defRPr sz="2100">
                 <a:solidFill>
                   <a:srgbClr val="173A49"/>
@@ -17289,6 +17518,7 @@
               </a:defRPr>
             </a:lvl8pPr>
             <a:lvl9pPr algn="l">
+              <a:buNone/>
               <a:defRPr sz="2100">
                 <a:solidFill>
                   <a:srgbClr val="173A49"/>
@@ -17424,6 +17654,7 @@
               </a:defRPr>
             </a:defPPr>
             <a:lvl1pPr algn="l">
+              <a:buNone/>
               <a:defRPr sz="2100">
                 <a:solidFill>
                   <a:srgbClr val="173A49"/>
@@ -17434,6 +17665,7 @@
               </a:defRPr>
             </a:lvl1pPr>
             <a:lvl2pPr algn="l">
+              <a:buNone/>
               <a:defRPr sz="2100">
                 <a:solidFill>
                   <a:srgbClr val="173A49"/>
@@ -17444,6 +17676,7 @@
               </a:defRPr>
             </a:lvl2pPr>
             <a:lvl3pPr algn="l">
+              <a:buNone/>
               <a:defRPr sz="2100">
                 <a:solidFill>
                   <a:srgbClr val="173A49"/>
@@ -17454,6 +17687,7 @@
               </a:defRPr>
             </a:lvl3pPr>
             <a:lvl4pPr algn="l">
+              <a:buNone/>
               <a:defRPr sz="2100">
                 <a:solidFill>
                   <a:srgbClr val="173A49"/>
@@ -17464,6 +17698,7 @@
               </a:defRPr>
             </a:lvl4pPr>
             <a:lvl5pPr algn="l">
+              <a:buNone/>
               <a:defRPr sz="2100">
                 <a:solidFill>
                   <a:srgbClr val="173A49"/>
@@ -17474,6 +17709,7 @@
               </a:defRPr>
             </a:lvl5pPr>
             <a:lvl6pPr algn="l">
+              <a:buNone/>
               <a:defRPr sz="2100">
                 <a:solidFill>
                   <a:srgbClr val="173A49"/>
@@ -17484,6 +17720,7 @@
               </a:defRPr>
             </a:lvl6pPr>
             <a:lvl7pPr algn="l">
+              <a:buNone/>
               <a:defRPr sz="2100">
                 <a:solidFill>
                   <a:srgbClr val="173A49"/>
@@ -17494,6 +17731,7 @@
               </a:defRPr>
             </a:lvl7pPr>
             <a:lvl8pPr algn="l">
+              <a:buNone/>
               <a:defRPr sz="2100">
                 <a:solidFill>
                   <a:srgbClr val="173A49"/>
@@ -17504,6 +17742,7 @@
               </a:defRPr>
             </a:lvl8pPr>
             <a:lvl9pPr algn="l">
+              <a:buNone/>
               <a:defRPr sz="2100">
                 <a:solidFill>
                   <a:srgbClr val="173A49"/>
@@ -17639,6 +17878,7 @@
               </a:defRPr>
             </a:defPPr>
             <a:lvl1pPr algn="l">
+              <a:buNone/>
               <a:defRPr sz="2100">
                 <a:solidFill>
                   <a:srgbClr val="173A49"/>
@@ -17649,6 +17889,7 @@
               </a:defRPr>
             </a:lvl1pPr>
             <a:lvl2pPr algn="l">
+              <a:buNone/>
               <a:defRPr sz="2100">
                 <a:solidFill>
                   <a:srgbClr val="173A49"/>
@@ -17659,6 +17900,7 @@
               </a:defRPr>
             </a:lvl2pPr>
             <a:lvl3pPr algn="l">
+              <a:buNone/>
               <a:defRPr sz="2100">
                 <a:solidFill>
                   <a:srgbClr val="173A49"/>
@@ -17669,6 +17911,7 @@
               </a:defRPr>
             </a:lvl3pPr>
             <a:lvl4pPr algn="l">
+              <a:buNone/>
               <a:defRPr sz="2100">
                 <a:solidFill>
                   <a:srgbClr val="173A49"/>
@@ -17679,6 +17922,7 @@
               </a:defRPr>
             </a:lvl4pPr>
             <a:lvl5pPr algn="l">
+              <a:buNone/>
               <a:defRPr sz="2100">
                 <a:solidFill>
                   <a:srgbClr val="173A49"/>
@@ -17689,6 +17933,7 @@
               </a:defRPr>
             </a:lvl5pPr>
             <a:lvl6pPr algn="l">
+              <a:buNone/>
               <a:defRPr sz="2100">
                 <a:solidFill>
                   <a:srgbClr val="173A49"/>
@@ -17699,6 +17944,7 @@
               </a:defRPr>
             </a:lvl6pPr>
             <a:lvl7pPr algn="l">
+              <a:buNone/>
               <a:defRPr sz="2100">
                 <a:solidFill>
                   <a:srgbClr val="173A49"/>
@@ -17709,6 +17955,7 @@
               </a:defRPr>
             </a:lvl7pPr>
             <a:lvl8pPr algn="l">
+              <a:buNone/>
               <a:defRPr sz="2100">
                 <a:solidFill>
                   <a:srgbClr val="173A49"/>
@@ -17719,6 +17966,7 @@
               </a:defRPr>
             </a:lvl8pPr>
             <a:lvl9pPr algn="l">
+              <a:buNone/>
               <a:defRPr sz="2100">
                 <a:solidFill>
                   <a:srgbClr val="173A49"/>
@@ -18459,7 +18707,7 @@
           <p:cNvPr id="5" name="">
             <a:extLst xmlns:a="http://schemas.openxmlformats.org/drawingml/2006/main">
               <a:ext uri="{FF2B5EF4-FFF2-40B4-BE49-F238E27FC236}">
-                <a16:creationId xmlns:a16="http://schemas.microsoft.com/office/drawing/2014/main" id="{FE9C38BD-C5EB-491E-915F-78366B9C610E}"/>
+                <a16:creationId xmlns:a16="http://schemas.microsoft.com/office/drawing/2014/main" id="{CFCB7120-B93B-4E4B-A1D2-2D7F2C12B40C}"/>
               </a:ext>
             </a:extLst>
           </p:cNvPr>
@@ -19256,6 +19504,7 @@
               </a:defRPr>
             </a:defPPr>
             <a:lvl1pPr algn="l">
+              <a:buNone/>
               <a:defRPr sz="1200" b="1">
                 <a:solidFill>
                   <a:srgbClr val="147D82"/>
@@ -19266,6 +19515,7 @@
               </a:defRPr>
             </a:lvl1pPr>
             <a:lvl2pPr algn="l">
+              <a:buNone/>
               <a:defRPr sz="1200" b="1">
                 <a:solidFill>
                   <a:srgbClr val="147D82"/>
@@ -19276,6 +19526,7 @@
               </a:defRPr>
             </a:lvl2pPr>
             <a:lvl3pPr algn="l">
+              <a:buNone/>
               <a:defRPr sz="1200" b="1">
                 <a:solidFill>
                   <a:srgbClr val="147D82"/>
@@ -19286,6 +19537,7 @@
               </a:defRPr>
             </a:lvl3pPr>
             <a:lvl4pPr algn="l">
+              <a:buNone/>
               <a:defRPr sz="1200" b="1">
                 <a:solidFill>
                   <a:srgbClr val="147D82"/>
@@ -19296,6 +19548,7 @@
               </a:defRPr>
             </a:lvl4pPr>
             <a:lvl5pPr algn="l">
+              <a:buNone/>
               <a:defRPr sz="1200" b="1">
                 <a:solidFill>
                   <a:srgbClr val="147D82"/>
@@ -19306,6 +19559,7 @@
               </a:defRPr>
             </a:lvl5pPr>
             <a:lvl6pPr algn="l">
+              <a:buNone/>
               <a:defRPr sz="1200" b="1">
                 <a:solidFill>
                   <a:srgbClr val="147D82"/>
@@ -19316,6 +19570,7 @@
               </a:defRPr>
             </a:lvl6pPr>
             <a:lvl7pPr algn="l">
+              <a:buNone/>
               <a:defRPr sz="1200" b="1">
                 <a:solidFill>
                   <a:srgbClr val="147D82"/>
@@ -19326,6 +19581,7 @@
               </a:defRPr>
             </a:lvl7pPr>
             <a:lvl8pPr algn="l">
+              <a:buNone/>
               <a:defRPr sz="1200" b="1">
                 <a:solidFill>
                   <a:srgbClr val="147D82"/>
@@ -19336,6 +19592,7 @@
               </a:defRPr>
             </a:lvl8pPr>
             <a:lvl9pPr algn="l">
+              <a:buNone/>
               <a:defRPr sz="1200" b="1">
                 <a:solidFill>
                   <a:srgbClr val="147D82"/>
@@ -19418,6 +19675,7 @@
               </a:defRPr>
             </a:defPPr>
             <a:lvl1pPr algn="l">
+              <a:buNone/>
               <a:defRPr sz="3200" b="1">
                 <a:solidFill>
                   <a:srgbClr val="173A49"/>
@@ -19428,6 +19686,7 @@
               </a:defRPr>
             </a:lvl1pPr>
             <a:lvl2pPr algn="l">
+              <a:buNone/>
               <a:defRPr sz="3200" b="1">
                 <a:solidFill>
                   <a:srgbClr val="173A49"/>
@@ -19438,6 +19697,7 @@
               </a:defRPr>
             </a:lvl2pPr>
             <a:lvl3pPr algn="l">
+              <a:buNone/>
               <a:defRPr sz="3200" b="1">
                 <a:solidFill>
                   <a:srgbClr val="173A49"/>
@@ -19448,6 +19708,7 @@
               </a:defRPr>
             </a:lvl3pPr>
             <a:lvl4pPr algn="l">
+              <a:buNone/>
               <a:defRPr sz="3200" b="1">
                 <a:solidFill>
                   <a:srgbClr val="173A49"/>
@@ -19458,6 +19719,7 @@
               </a:defRPr>
             </a:lvl4pPr>
             <a:lvl5pPr algn="l">
+              <a:buNone/>
               <a:defRPr sz="3200" b="1">
                 <a:solidFill>
                   <a:srgbClr val="173A49"/>
@@ -19468,6 +19730,7 @@
               </a:defRPr>
             </a:lvl5pPr>
             <a:lvl6pPr algn="l">
+              <a:buNone/>
               <a:defRPr sz="3200" b="1">
                 <a:solidFill>
                   <a:srgbClr val="173A49"/>
@@ -19478,6 +19741,7 @@
               </a:defRPr>
             </a:lvl6pPr>
             <a:lvl7pPr algn="l">
+              <a:buNone/>
               <a:defRPr sz="3200" b="1">
                 <a:solidFill>
                   <a:srgbClr val="173A49"/>
@@ -19488,6 +19752,7 @@
               </a:defRPr>
             </a:lvl7pPr>
             <a:lvl8pPr algn="l">
+              <a:buNone/>
               <a:defRPr sz="3200" b="1">
                 <a:solidFill>
                   <a:srgbClr val="173A49"/>
@@ -19498,6 +19763,7 @@
               </a:defRPr>
             </a:lvl8pPr>
             <a:lvl9pPr algn="l">
+              <a:buNone/>
               <a:defRPr sz="3200" b="1">
                 <a:solidFill>
                   <a:srgbClr val="173A49"/>
@@ -19686,6 +19952,7 @@
               </a:defRPr>
             </a:defPPr>
             <a:lvl1pPr algn="l">
+              <a:buNone/>
               <a:defRPr sz="1000">
                 <a:solidFill>
                   <a:srgbClr val="617681"/>
@@ -19696,6 +19963,7 @@
               </a:defRPr>
             </a:lvl1pPr>
             <a:lvl2pPr algn="l">
+              <a:buNone/>
               <a:defRPr sz="1000">
                 <a:solidFill>
                   <a:srgbClr val="617681"/>
@@ -19706,6 +19974,7 @@
               </a:defRPr>
             </a:lvl2pPr>
             <a:lvl3pPr algn="l">
+              <a:buNone/>
               <a:defRPr sz="1000">
                 <a:solidFill>
                   <a:srgbClr val="617681"/>
@@ -19716,6 +19985,7 @@
               </a:defRPr>
             </a:lvl3pPr>
             <a:lvl4pPr algn="l">
+              <a:buNone/>
               <a:defRPr sz="1000">
                 <a:solidFill>
                   <a:srgbClr val="617681"/>
@@ -19726,6 +19996,7 @@
               </a:defRPr>
             </a:lvl4pPr>
             <a:lvl5pPr algn="l">
+              <a:buNone/>
               <a:defRPr sz="1000">
                 <a:solidFill>
                   <a:srgbClr val="617681"/>
@@ -19736,6 +20007,7 @@
               </a:defRPr>
             </a:lvl5pPr>
             <a:lvl6pPr algn="l">
+              <a:buNone/>
               <a:defRPr sz="1000">
                 <a:solidFill>
                   <a:srgbClr val="617681"/>
@@ -19746,6 +20018,7 @@
               </a:defRPr>
             </a:lvl6pPr>
             <a:lvl7pPr algn="l">
+              <a:buNone/>
               <a:defRPr sz="1000">
                 <a:solidFill>
                   <a:srgbClr val="617681"/>
@@ -19756,6 +20029,7 @@
               </a:defRPr>
             </a:lvl7pPr>
             <a:lvl8pPr algn="l">
+              <a:buNone/>
               <a:defRPr sz="1000">
                 <a:solidFill>
                   <a:srgbClr val="617681"/>
@@ -19766,6 +20040,7 @@
               </a:defRPr>
             </a:lvl8pPr>
             <a:lvl9pPr algn="l">
+              <a:buNone/>
               <a:defRPr sz="1000">
                 <a:solidFill>
                   <a:srgbClr val="617681"/>
@@ -19899,6 +20174,7 @@
               </a:defRPr>
             </a:defPPr>
             <a:lvl1pPr algn="l">
+              <a:buNone/>
               <a:defRPr sz="1800">
                 <a:solidFill>
                   <a:srgbClr val="173A49"/>
@@ -19909,6 +20185,7 @@
               </a:defRPr>
             </a:lvl1pPr>
             <a:lvl2pPr algn="l">
+              <a:buNone/>
               <a:defRPr sz="1800">
                 <a:solidFill>
                   <a:srgbClr val="173A49"/>
@@ -19919,6 +20196,7 @@
               </a:defRPr>
             </a:lvl2pPr>
             <a:lvl3pPr algn="l">
+              <a:buNone/>
               <a:defRPr sz="1800">
                 <a:solidFill>
                   <a:srgbClr val="173A49"/>
@@ -19929,6 +20207,7 @@
               </a:defRPr>
             </a:lvl3pPr>
             <a:lvl4pPr algn="l">
+              <a:buNone/>
               <a:defRPr sz="1800">
                 <a:solidFill>
                   <a:srgbClr val="173A49"/>
@@ -19939,6 +20218,7 @@
               </a:defRPr>
             </a:lvl4pPr>
             <a:lvl5pPr algn="l">
+              <a:buNone/>
               <a:defRPr sz="1800">
                 <a:solidFill>
                   <a:srgbClr val="173A49"/>
@@ -19949,6 +20229,7 @@
               </a:defRPr>
             </a:lvl5pPr>
             <a:lvl6pPr algn="l">
+              <a:buNone/>
               <a:defRPr sz="1800">
                 <a:solidFill>
                   <a:srgbClr val="173A49"/>
@@ -19959,6 +20240,7 @@
               </a:defRPr>
             </a:lvl6pPr>
             <a:lvl7pPr algn="l">
+              <a:buNone/>
               <a:defRPr sz="1800">
                 <a:solidFill>
                   <a:srgbClr val="173A49"/>
@@ -19969,6 +20251,7 @@
               </a:defRPr>
             </a:lvl7pPr>
             <a:lvl8pPr algn="l">
+              <a:buNone/>
               <a:defRPr sz="1800">
                 <a:solidFill>
                   <a:srgbClr val="173A49"/>
@@ -19979,6 +20262,7 @@
               </a:defRPr>
             </a:lvl8pPr>
             <a:lvl9pPr algn="l">
+              <a:buNone/>
               <a:defRPr sz="1800">
                 <a:solidFill>
                   <a:srgbClr val="173A49"/>
@@ -20112,6 +20396,7 @@
               </a:defRPr>
             </a:defPPr>
             <a:lvl1pPr algn="l">
+              <a:buNone/>
               <a:defRPr sz="1500">
                 <a:solidFill>
                   <a:srgbClr val="173A49"/>
@@ -20122,6 +20407,7 @@
               </a:defRPr>
             </a:lvl1pPr>
             <a:lvl2pPr algn="l">
+              <a:buNone/>
               <a:defRPr sz="1500">
                 <a:solidFill>
                   <a:srgbClr val="173A49"/>
@@ -20132,6 +20418,7 @@
               </a:defRPr>
             </a:lvl2pPr>
             <a:lvl3pPr algn="l">
+              <a:buNone/>
               <a:defRPr sz="1500">
                 <a:solidFill>
                   <a:srgbClr val="173A49"/>
@@ -20142,6 +20429,7 @@
               </a:defRPr>
             </a:lvl3pPr>
             <a:lvl4pPr algn="l">
+              <a:buNone/>
               <a:defRPr sz="1500">
                 <a:solidFill>
                   <a:srgbClr val="173A49"/>
@@ -20152,6 +20440,7 @@
               </a:defRPr>
             </a:lvl4pPr>
             <a:lvl5pPr algn="l">
+              <a:buNone/>
               <a:defRPr sz="1500">
                 <a:solidFill>
                   <a:srgbClr val="173A49"/>
@@ -20162,6 +20451,7 @@
               </a:defRPr>
             </a:lvl5pPr>
             <a:lvl6pPr algn="l">
+              <a:buNone/>
               <a:defRPr sz="1500">
                 <a:solidFill>
                   <a:srgbClr val="173A49"/>
@@ -20172,6 +20462,7 @@
               </a:defRPr>
             </a:lvl6pPr>
             <a:lvl7pPr algn="l">
+              <a:buNone/>
               <a:defRPr sz="1500">
                 <a:solidFill>
                   <a:srgbClr val="173A49"/>
@@ -20182,6 +20473,7 @@
               </a:defRPr>
             </a:lvl7pPr>
             <a:lvl8pPr algn="l">
+              <a:buNone/>
               <a:defRPr sz="1500">
                 <a:solidFill>
                   <a:srgbClr val="173A49"/>
@@ -20192,6 +20484,7 @@
               </a:defRPr>
             </a:lvl8pPr>
             <a:lvl9pPr algn="l">
+              <a:buNone/>
               <a:defRPr sz="1500">
                 <a:solidFill>
                   <a:srgbClr val="173A49"/>
@@ -20325,6 +20618,7 @@
               </a:defRPr>
             </a:defPPr>
             <a:lvl1pPr algn="l">
+              <a:buNone/>
               <a:defRPr sz="2100">
                 <a:solidFill>
                   <a:srgbClr val="173A49"/>
@@ -20335,6 +20629,7 @@
               </a:defRPr>
             </a:lvl1pPr>
             <a:lvl2pPr algn="l">
+              <a:buNone/>
               <a:defRPr sz="2100">
                 <a:solidFill>
                   <a:srgbClr val="173A49"/>
@@ -20345,6 +20640,7 @@
               </a:defRPr>
             </a:lvl2pPr>
             <a:lvl3pPr algn="l">
+              <a:buNone/>
               <a:defRPr sz="2100">
                 <a:solidFill>
                   <a:srgbClr val="173A49"/>
@@ -20355,6 +20651,7 @@
               </a:defRPr>
             </a:lvl3pPr>
             <a:lvl4pPr algn="l">
+              <a:buNone/>
               <a:defRPr sz="2100">
                 <a:solidFill>
                   <a:srgbClr val="173A49"/>
@@ -20365,6 +20662,7 @@
               </a:defRPr>
             </a:lvl4pPr>
             <a:lvl5pPr algn="l">
+              <a:buNone/>
               <a:defRPr sz="2100">
                 <a:solidFill>
                   <a:srgbClr val="173A49"/>
@@ -20375,6 +20673,7 @@
               </a:defRPr>
             </a:lvl5pPr>
             <a:lvl6pPr algn="l">
+              <a:buNone/>
               <a:defRPr sz="2100">
                 <a:solidFill>
                   <a:srgbClr val="173A49"/>
@@ -20385,6 +20684,7 @@
               </a:defRPr>
             </a:lvl6pPr>
             <a:lvl7pPr algn="l">
+              <a:buNone/>
               <a:defRPr sz="2100">
                 <a:solidFill>
                   <a:srgbClr val="173A49"/>
@@ -20395,6 +20695,7 @@
               </a:defRPr>
             </a:lvl7pPr>
             <a:lvl8pPr algn="l">
+              <a:buNone/>
               <a:defRPr sz="2100">
                 <a:solidFill>
                   <a:srgbClr val="173A49"/>
@@ -20405,6 +20706,7 @@
               </a:defRPr>
             </a:lvl8pPr>
             <a:lvl9pPr algn="l">
+              <a:buNone/>
               <a:defRPr sz="2100">
                 <a:solidFill>
                   <a:srgbClr val="173A49"/>
@@ -20530,6 +20832,7 @@
               </a:defRPr>
             </a:defPPr>
             <a:lvl1pPr algn="l">
+              <a:buNone/>
               <a:defRPr sz="2100">
                 <a:solidFill>
                   <a:srgbClr val="173A49"/>
@@ -20540,6 +20843,7 @@
               </a:defRPr>
             </a:lvl1pPr>
             <a:lvl2pPr algn="l">
+              <a:buNone/>
               <a:defRPr sz="2100">
                 <a:solidFill>
                   <a:srgbClr val="173A49"/>
@@ -20550,6 +20854,7 @@
               </a:defRPr>
             </a:lvl2pPr>
             <a:lvl3pPr algn="l">
+              <a:buNone/>
               <a:defRPr sz="2100">
                 <a:solidFill>
                   <a:srgbClr val="173A49"/>
@@ -20560,6 +20865,7 @@
               </a:defRPr>
             </a:lvl3pPr>
             <a:lvl4pPr algn="l">
+              <a:buNone/>
               <a:defRPr sz="2100">
                 <a:solidFill>
                   <a:srgbClr val="173A49"/>
@@ -20570,6 +20876,7 @@
               </a:defRPr>
             </a:lvl4pPr>
             <a:lvl5pPr algn="l">
+              <a:buNone/>
               <a:defRPr sz="2100">
                 <a:solidFill>
                   <a:srgbClr val="173A49"/>
@@ -20580,6 +20887,7 @@
               </a:defRPr>
             </a:lvl5pPr>
             <a:lvl6pPr algn="l">
+              <a:buNone/>
               <a:defRPr sz="2100">
                 <a:solidFill>
                   <a:srgbClr val="173A49"/>
@@ -20590,6 +20898,7 @@
               </a:defRPr>
             </a:lvl6pPr>
             <a:lvl7pPr algn="l">
+              <a:buNone/>
               <a:defRPr sz="2100">
                 <a:solidFill>
                   <a:srgbClr val="173A49"/>
@@ -20600,6 +20909,7 @@
               </a:defRPr>
             </a:lvl7pPr>
             <a:lvl8pPr algn="l">
+              <a:buNone/>
               <a:defRPr sz="2100">
                 <a:solidFill>
                   <a:srgbClr val="173A49"/>
@@ -20610,6 +20920,7 @@
               </a:defRPr>
             </a:lvl8pPr>
             <a:lvl9pPr algn="l">
+              <a:buNone/>
               <a:defRPr sz="2100">
                 <a:solidFill>
                   <a:srgbClr val="173A49"/>
@@ -20649,7 +20960,7 @@
           <p:cNvPr id="16" name="">
             <a:extLst xmlns:a="http://schemas.openxmlformats.org/drawingml/2006/main">
               <a:ext uri="{FF2B5EF4-FFF2-40B4-BE49-F238E27FC236}">
-                <a16:creationId xmlns:a16="http://schemas.microsoft.com/office/drawing/2014/main" id="{9701B19F-7646-4E7F-B839-2F87D24D83E2}"/>
+                <a16:creationId xmlns:a16="http://schemas.microsoft.com/office/drawing/2014/main" id="{850A9B1F-9CCC-4A63-B756-3D3AE894F7D9}"/>
               </a:ext>
             </a:extLst>
           </p:cNvPr>
@@ -20675,7 +20986,9 @@
                     <a:bodyPr/>
                     <a:lstStyle/>
                     <a:p>
-                      <a:pPr algn="l"/>
+                      <a:pPr algn="l">
+                        <a:buNone/>
+                      </a:pPr>
                       <a:r>
                         <a:rPr sz="1650" b="1">
                           <a:solidFill>
@@ -20724,7 +21037,9 @@
                     <a:bodyPr/>
                     <a:lstStyle/>
                     <a:p>
-                      <a:pPr algn="l"/>
+                      <a:pPr algn="l">
+                        <a:buNone/>
+                      </a:pPr>
                       <a:r>
                         <a:rPr sz="1650" b="1">
                           <a:solidFill>
@@ -20767,7 +21082,9 @@
                     <a:bodyPr/>
                     <a:lstStyle/>
                     <a:p>
-                      <a:pPr algn="l"/>
+                      <a:pPr algn="l">
+                        <a:buNone/>
+                      </a:pPr>
                       <a:r>
                         <a:rPr sz="1650" b="1">
                           <a:solidFill>
@@ -20812,7 +21129,9 @@
                     <a:bodyPr/>
                     <a:lstStyle/>
                     <a:p>
-                      <a:pPr algn="l"/>
+                      <a:pPr algn="l">
+                        <a:buNone/>
+                      </a:pPr>
                       <a:r>
                         <a:rPr sz="1575" b="0">
                           <a:solidFill>
@@ -20855,7 +21174,9 @@
                     <a:bodyPr/>
                     <a:lstStyle/>
                     <a:p>
-                      <a:pPr algn="l"/>
+                      <a:pPr algn="l">
+                        <a:buNone/>
+                      </a:pPr>
                       <a:r>
                         <a:rPr sz="1575" b="0">
                           <a:solidFill>
@@ -20892,7 +21213,9 @@
                     <a:bodyPr/>
                     <a:lstStyle/>
                     <a:p>
-                      <a:pPr algn="l"/>
+                      <a:pPr algn="l">
+                        <a:buNone/>
+                      </a:pPr>
                       <a:r>
                         <a:rPr sz="1575" b="0">
                           <a:solidFill>
@@ -20931,7 +21254,9 @@
                     <a:bodyPr/>
                     <a:lstStyle/>
                     <a:p>
-                      <a:pPr algn="l"/>
+                      <a:pPr algn="l">
+                        <a:buNone/>
+                      </a:pPr>
                       <a:r>
                         <a:rPr sz="1575" b="0">
                           <a:solidFill>
@@ -20974,7 +21299,9 @@
                     <a:bodyPr/>
                     <a:lstStyle/>
                     <a:p>
-                      <a:pPr algn="l"/>
+                      <a:pPr algn="l">
+                        <a:buNone/>
+                      </a:pPr>
                       <a:r>
                         <a:rPr sz="1575" b="0">
                           <a:solidFill>
@@ -21011,7 +21338,9 @@
                     <a:bodyPr/>
                     <a:lstStyle/>
                     <a:p>
-                      <a:pPr algn="l"/>
+                      <a:pPr algn="l">
+                        <a:buNone/>
+                      </a:pPr>
                       <a:r>
                         <a:rPr sz="1575" b="0">
                           <a:solidFill>
@@ -21050,7 +21379,9 @@
                     <a:bodyPr/>
                     <a:lstStyle/>
                     <a:p>
-                      <a:pPr algn="l"/>
+                      <a:pPr algn="l">
+                        <a:buNone/>
+                      </a:pPr>
                       <a:r>
                         <a:rPr sz="1575" b="0">
                           <a:solidFill>
@@ -21093,7 +21424,9 @@
                     <a:bodyPr/>
                     <a:lstStyle/>
                     <a:p>
-                      <a:pPr algn="l"/>
+                      <a:pPr algn="l">
+                        <a:buNone/>
+                      </a:pPr>
                       <a:r>
                         <a:rPr sz="1575" b="0">
                           <a:solidFill>
@@ -21130,7 +21463,9 @@
                     <a:bodyPr/>
                     <a:lstStyle/>
                     <a:p>
-                      <a:pPr algn="l"/>
+                      <a:pPr algn="l">
+                        <a:buNone/>
+                      </a:pPr>
                       <a:r>
                         <a:rPr sz="1575" b="0">
                           <a:solidFill>
@@ -21169,7 +21504,9 @@
                     <a:bodyPr/>
                     <a:lstStyle/>
                     <a:p>
-                      <a:pPr algn="l"/>
+                      <a:pPr algn="l">
+                        <a:buNone/>
+                      </a:pPr>
                       <a:r>
                         <a:rPr sz="1575" b="0">
                           <a:solidFill>
@@ -21212,7 +21549,9 @@
                     <a:bodyPr/>
                     <a:lstStyle/>
                     <a:p>
-                      <a:pPr algn="l"/>
+                      <a:pPr algn="l">
+                        <a:buNone/>
+                      </a:pPr>
                       <a:r>
                         <a:rPr sz="1575" b="0">
                           <a:solidFill>
@@ -21249,7 +21588,9 @@
                     <a:bodyPr/>
                     <a:lstStyle/>
                     <a:p>
-                      <a:pPr algn="l"/>
+                      <a:pPr algn="l">
+                        <a:buNone/>
+                      </a:pPr>
                       <a:r>
                         <a:rPr sz="1575" b="0">
                           <a:solidFill>
@@ -21288,7 +21629,9 @@
                     <a:bodyPr/>
                     <a:lstStyle/>
                     <a:p>
-                      <a:pPr algn="l"/>
+                      <a:pPr algn="l">
+                        <a:buNone/>
+                      </a:pPr>
                       <a:r>
                         <a:rPr sz="1575" b="0">
                           <a:solidFill>
@@ -21331,7 +21674,9 @@
                     <a:bodyPr/>
                     <a:lstStyle/>
                     <a:p>
-                      <a:pPr algn="l"/>
+                      <a:pPr algn="l">
+                        <a:buNone/>
+                      </a:pPr>
                       <a:r>
                         <a:rPr sz="1575" b="0">
                           <a:solidFill>
@@ -21368,7 +21713,9 @@
                     <a:bodyPr/>
                     <a:lstStyle/>
                     <a:p>
-                      <a:pPr algn="l"/>
+                      <a:pPr algn="l">
+                        <a:buNone/>
+                      </a:pPr>
                       <a:r>
                         <a:rPr sz="1575" b="0">
                           <a:solidFill>
@@ -21527,6 +21874,7 @@
               </a:defRPr>
             </a:defPPr>
             <a:lvl1pPr algn="l">
+              <a:buNone/>
               <a:defRPr sz="1200" b="1">
                 <a:solidFill>
                   <a:srgbClr val="147D82"/>
@@ -21537,6 +21885,7 @@
               </a:defRPr>
             </a:lvl1pPr>
             <a:lvl2pPr algn="l">
+              <a:buNone/>
               <a:defRPr sz="1200" b="1">
                 <a:solidFill>
                   <a:srgbClr val="147D82"/>
@@ -21547,6 +21896,7 @@
               </a:defRPr>
             </a:lvl2pPr>
             <a:lvl3pPr algn="l">
+              <a:buNone/>
               <a:defRPr sz="1200" b="1">
                 <a:solidFill>
                   <a:srgbClr val="147D82"/>
@@ -21557,6 +21907,7 @@
               </a:defRPr>
             </a:lvl3pPr>
             <a:lvl4pPr algn="l">
+              <a:buNone/>
               <a:defRPr sz="1200" b="1">
                 <a:solidFill>
                   <a:srgbClr val="147D82"/>
@@ -21567,6 +21918,7 @@
               </a:defRPr>
             </a:lvl4pPr>
             <a:lvl5pPr algn="l">
+              <a:buNone/>
               <a:defRPr sz="1200" b="1">
                 <a:solidFill>
                   <a:srgbClr val="147D82"/>
@@ -21577,6 +21929,7 @@
               </a:defRPr>
             </a:lvl5pPr>
             <a:lvl6pPr algn="l">
+              <a:buNone/>
               <a:defRPr sz="1200" b="1">
                 <a:solidFill>
                   <a:srgbClr val="147D82"/>
@@ -21587,6 +21940,7 @@
               </a:defRPr>
             </a:lvl6pPr>
             <a:lvl7pPr algn="l">
+              <a:buNone/>
               <a:defRPr sz="1200" b="1">
                 <a:solidFill>
                   <a:srgbClr val="147D82"/>
@@ -21597,6 +21951,7 @@
               </a:defRPr>
             </a:lvl7pPr>
             <a:lvl8pPr algn="l">
+              <a:buNone/>
               <a:defRPr sz="1200" b="1">
                 <a:solidFill>
                   <a:srgbClr val="147D82"/>
@@ -21607,6 +21962,7 @@
               </a:defRPr>
             </a:lvl8pPr>
             <a:lvl9pPr algn="l">
+              <a:buNone/>
               <a:defRPr sz="1200" b="1">
                 <a:solidFill>
                   <a:srgbClr val="147D82"/>
@@ -21848,6 +22204,7 @@
               </a:defRPr>
             </a:defPPr>
             <a:lvl1pPr algn="l">
+              <a:buNone/>
               <a:defRPr sz="1000">
                 <a:solidFill>
                   <a:srgbClr val="617681"/>
@@ -21858,6 +22215,7 @@
               </a:defRPr>
             </a:lvl1pPr>
             <a:lvl2pPr algn="l">
+              <a:buNone/>
               <a:defRPr sz="1000">
                 <a:solidFill>
                   <a:srgbClr val="617681"/>
@@ -21868,6 +22226,7 @@
               </a:defRPr>
             </a:lvl2pPr>
             <a:lvl3pPr algn="l">
+              <a:buNone/>
               <a:defRPr sz="1000">
                 <a:solidFill>
                   <a:srgbClr val="617681"/>
@@ -21878,6 +22237,7 @@
               </a:defRPr>
             </a:lvl3pPr>
             <a:lvl4pPr algn="l">
+              <a:buNone/>
               <a:defRPr sz="1000">
                 <a:solidFill>
                   <a:srgbClr val="617681"/>
@@ -21888,6 +22248,7 @@
               </a:defRPr>
             </a:lvl4pPr>
             <a:lvl5pPr algn="l">
+              <a:buNone/>
               <a:defRPr sz="1000">
                 <a:solidFill>
                   <a:srgbClr val="617681"/>
@@ -21898,6 +22259,7 @@
               </a:defRPr>
             </a:lvl5pPr>
             <a:lvl6pPr algn="l">
+              <a:buNone/>
               <a:defRPr sz="1000">
                 <a:solidFill>
                   <a:srgbClr val="617681"/>
@@ -21908,6 +22270,7 @@
               </a:defRPr>
             </a:lvl6pPr>
             <a:lvl7pPr algn="l">
+              <a:buNone/>
               <a:defRPr sz="1000">
                 <a:solidFill>
                   <a:srgbClr val="617681"/>
@@ -21918,6 +22281,7 @@
               </a:defRPr>
             </a:lvl7pPr>
             <a:lvl8pPr algn="l">
+              <a:buNone/>
               <a:defRPr sz="1000">
                 <a:solidFill>
                   <a:srgbClr val="617681"/>
@@ -21928,6 +22292,7 @@
               </a:defRPr>
             </a:lvl8pPr>
             <a:lvl9pPr algn="l">
+              <a:buNone/>
               <a:defRPr sz="1000">
                 <a:solidFill>
                   <a:srgbClr val="617681"/>
@@ -23690,6 +24055,7 @@
               </a:defRPr>
             </a:defPPr>
             <a:lvl1pPr algn="l">
+              <a:buNone/>
               <a:defRPr sz="1200" b="1">
                 <a:solidFill>
                   <a:srgbClr val="147D82"/>
@@ -23700,6 +24066,7 @@
               </a:defRPr>
             </a:lvl1pPr>
             <a:lvl2pPr algn="l">
+              <a:buNone/>
               <a:defRPr sz="1200" b="1">
                 <a:solidFill>
                   <a:srgbClr val="147D82"/>
@@ -23710,6 +24077,7 @@
               </a:defRPr>
             </a:lvl2pPr>
             <a:lvl3pPr algn="l">
+              <a:buNone/>
               <a:defRPr sz="1200" b="1">
                 <a:solidFill>
                   <a:srgbClr val="147D82"/>
@@ -23720,6 +24088,7 @@
               </a:defRPr>
             </a:lvl3pPr>
             <a:lvl4pPr algn="l">
+              <a:buNone/>
               <a:defRPr sz="1200" b="1">
                 <a:solidFill>
                   <a:srgbClr val="147D82"/>
@@ -23730,6 +24099,7 @@
               </a:defRPr>
             </a:lvl4pPr>
             <a:lvl5pPr algn="l">
+              <a:buNone/>
               <a:defRPr sz="1200" b="1">
                 <a:solidFill>
                   <a:srgbClr val="147D82"/>
@@ -23740,6 +24110,7 @@
               </a:defRPr>
             </a:lvl5pPr>
             <a:lvl6pPr algn="l">
+              <a:buNone/>
               <a:defRPr sz="1200" b="1">
                 <a:solidFill>
                   <a:srgbClr val="147D82"/>
@@ -23750,6 +24121,7 @@
               </a:defRPr>
             </a:lvl6pPr>
             <a:lvl7pPr algn="l">
+              <a:buNone/>
               <a:defRPr sz="1200" b="1">
                 <a:solidFill>
                   <a:srgbClr val="147D82"/>
@@ -23760,6 +24132,7 @@
               </a:defRPr>
             </a:lvl7pPr>
             <a:lvl8pPr algn="l">
+              <a:buNone/>
               <a:defRPr sz="1200" b="1">
                 <a:solidFill>
                   <a:srgbClr val="147D82"/>
@@ -23770,6 +24143,7 @@
               </a:defRPr>
             </a:lvl8pPr>
             <a:lvl9pPr algn="l">
+              <a:buNone/>
               <a:defRPr sz="1200" b="1">
                 <a:solidFill>
                   <a:srgbClr val="147D82"/>
@@ -24011,6 +24385,7 @@
               </a:defRPr>
             </a:defPPr>
             <a:lvl1pPr algn="l">
+              <a:buNone/>
               <a:defRPr sz="1000">
                 <a:solidFill>
                   <a:srgbClr val="617681"/>
@@ -24021,6 +24396,7 @@
               </a:defRPr>
             </a:lvl1pPr>
             <a:lvl2pPr algn="l">
+              <a:buNone/>
               <a:defRPr sz="1000">
                 <a:solidFill>
                   <a:srgbClr val="617681"/>
@@ -24031,6 +24407,7 @@
               </a:defRPr>
             </a:lvl2pPr>
             <a:lvl3pPr algn="l">
+              <a:buNone/>
               <a:defRPr sz="1000">
                 <a:solidFill>
                   <a:srgbClr val="617681"/>
@@ -24041,6 +24418,7 @@
               </a:defRPr>
             </a:lvl3pPr>
             <a:lvl4pPr algn="l">
+              <a:buNone/>
               <a:defRPr sz="1000">
                 <a:solidFill>
                   <a:srgbClr val="617681"/>
@@ -24051,6 +24429,7 @@
               </a:defRPr>
             </a:lvl4pPr>
             <a:lvl5pPr algn="l">
+              <a:buNone/>
               <a:defRPr sz="1000">
                 <a:solidFill>
                   <a:srgbClr val="617681"/>
@@ -24061,6 +24440,7 @@
               </a:defRPr>
             </a:lvl5pPr>
             <a:lvl6pPr algn="l">
+              <a:buNone/>
               <a:defRPr sz="1000">
                 <a:solidFill>
                   <a:srgbClr val="617681"/>
@@ -24071,6 +24451,7 @@
               </a:defRPr>
             </a:lvl6pPr>
             <a:lvl7pPr algn="l">
+              <a:buNone/>
               <a:defRPr sz="1000">
                 <a:solidFill>
                   <a:srgbClr val="617681"/>
@@ -24081,6 +24462,7 @@
               </a:defRPr>
             </a:lvl7pPr>
             <a:lvl8pPr algn="l">
+              <a:buNone/>
               <a:defRPr sz="1000">
                 <a:solidFill>
                   <a:srgbClr val="617681"/>
@@ -24091,6 +24473,7 @@
               </a:defRPr>
             </a:lvl8pPr>
             <a:lvl9pPr algn="l">
+              <a:buNone/>
               <a:defRPr sz="1000">
                 <a:solidFill>
                   <a:srgbClr val="617681"/>
@@ -24173,6 +24556,7 @@
               </a:defRPr>
             </a:defPPr>
             <a:lvl1pPr algn="l">
+              <a:buNone/>
               <a:defRPr sz="2200" b="1">
                 <a:solidFill>
                   <a:srgbClr val="173A49"/>
@@ -24183,6 +24567,7 @@
               </a:defRPr>
             </a:lvl1pPr>
             <a:lvl2pPr algn="l">
+              <a:buNone/>
               <a:defRPr sz="2200" b="1">
                 <a:solidFill>
                   <a:srgbClr val="173A49"/>
@@ -24193,6 +24578,7 @@
               </a:defRPr>
             </a:lvl2pPr>
             <a:lvl3pPr algn="l">
+              <a:buNone/>
               <a:defRPr sz="2200" b="1">
                 <a:solidFill>
                   <a:srgbClr val="173A49"/>
@@ -24203,6 +24589,7 @@
               </a:defRPr>
             </a:lvl3pPr>
             <a:lvl4pPr algn="l">
+              <a:buNone/>
               <a:defRPr sz="2200" b="1">
                 <a:solidFill>
                   <a:srgbClr val="173A49"/>
@@ -24213,6 +24600,7 @@
               </a:defRPr>
             </a:lvl4pPr>
             <a:lvl5pPr algn="l">
+              <a:buNone/>
               <a:defRPr sz="2200" b="1">
                 <a:solidFill>
                   <a:srgbClr val="173A49"/>
@@ -24223,6 +24611,7 @@
               </a:defRPr>
             </a:lvl5pPr>
             <a:lvl6pPr algn="l">
+              <a:buNone/>
               <a:defRPr sz="2200" b="1">
                 <a:solidFill>
                   <a:srgbClr val="173A49"/>
@@ -24233,6 +24622,7 @@
               </a:defRPr>
             </a:lvl6pPr>
             <a:lvl7pPr algn="l">
+              <a:buNone/>
               <a:defRPr sz="2200" b="1">
                 <a:solidFill>
                   <a:srgbClr val="173A49"/>
@@ -24243,6 +24633,7 @@
               </a:defRPr>
             </a:lvl7pPr>
             <a:lvl8pPr algn="l">
+              <a:buNone/>
               <a:defRPr sz="2200" b="1">
                 <a:solidFill>
                   <a:srgbClr val="173A49"/>
@@ -24253,6 +24644,7 @@
               </a:defRPr>
             </a:lvl8pPr>
             <a:lvl9pPr algn="l">
+              <a:buNone/>
               <a:defRPr sz="2200" b="1">
                 <a:solidFill>
                   <a:srgbClr val="173A49"/>
@@ -24335,6 +24727,7 @@
               </a:defRPr>
             </a:defPPr>
             <a:lvl1pPr algn="l">
+              <a:buNone/>
               <a:defRPr sz="1900">
                 <a:solidFill>
                   <a:srgbClr val="617681"/>
@@ -24345,6 +24738,7 @@
               </a:defRPr>
             </a:lvl1pPr>
             <a:lvl2pPr algn="l">
+              <a:buNone/>
               <a:defRPr sz="1900">
                 <a:solidFill>
                   <a:srgbClr val="617681"/>
@@ -24355,6 +24749,7 @@
               </a:defRPr>
             </a:lvl2pPr>
             <a:lvl3pPr algn="l">
+              <a:buNone/>
               <a:defRPr sz="1900">
                 <a:solidFill>
                   <a:srgbClr val="617681"/>
@@ -24365,6 +24760,7 @@
               </a:defRPr>
             </a:lvl3pPr>
             <a:lvl4pPr algn="l">
+              <a:buNone/>
               <a:defRPr sz="1900">
                 <a:solidFill>
                   <a:srgbClr val="617681"/>
@@ -24375,6 +24771,7 @@
               </a:defRPr>
             </a:lvl4pPr>
             <a:lvl5pPr algn="l">
+              <a:buNone/>
               <a:defRPr sz="1900">
                 <a:solidFill>
                   <a:srgbClr val="617681"/>
@@ -24385,6 +24782,7 @@
               </a:defRPr>
             </a:lvl5pPr>
             <a:lvl6pPr algn="l">
+              <a:buNone/>
               <a:defRPr sz="1900">
                 <a:solidFill>
                   <a:srgbClr val="617681"/>
@@ -24395,6 +24793,7 @@
               </a:defRPr>
             </a:lvl6pPr>
             <a:lvl7pPr algn="l">
+              <a:buNone/>
               <a:defRPr sz="1900">
                 <a:solidFill>
                   <a:srgbClr val="617681"/>
@@ -24405,6 +24804,7 @@
               </a:defRPr>
             </a:lvl7pPr>
             <a:lvl8pPr algn="l">
+              <a:buNone/>
               <a:defRPr sz="1900">
                 <a:solidFill>
                   <a:srgbClr val="617681"/>
@@ -24415,6 +24815,7 @@
               </a:defRPr>
             </a:lvl8pPr>
             <a:lvl9pPr algn="l">
+              <a:buNone/>
               <a:defRPr sz="1900">
                 <a:solidFill>
                   <a:srgbClr val="617681"/>
@@ -24497,6 +24898,7 @@
               </a:defRPr>
             </a:defPPr>
             <a:lvl1pPr algn="l">
+              <a:buNone/>
               <a:defRPr sz="1900">
                 <a:solidFill>
                   <a:srgbClr val="617681"/>
@@ -24507,6 +24909,7 @@
               </a:defRPr>
             </a:lvl1pPr>
             <a:lvl2pPr algn="l">
+              <a:buNone/>
               <a:defRPr sz="1900">
                 <a:solidFill>
                   <a:srgbClr val="617681"/>
@@ -24517,6 +24920,7 @@
               </a:defRPr>
             </a:lvl2pPr>
             <a:lvl3pPr algn="l">
+              <a:buNone/>
               <a:defRPr sz="1900">
                 <a:solidFill>
                   <a:srgbClr val="617681"/>
@@ -24527,6 +24931,7 @@
               </a:defRPr>
             </a:lvl3pPr>
             <a:lvl4pPr algn="l">
+              <a:buNone/>
               <a:defRPr sz="1900">
                 <a:solidFill>
                   <a:srgbClr val="617681"/>
@@ -24537,6 +24942,7 @@
               </a:defRPr>
             </a:lvl4pPr>
             <a:lvl5pPr algn="l">
+              <a:buNone/>
               <a:defRPr sz="1900">
                 <a:solidFill>
                   <a:srgbClr val="617681"/>
@@ -24547,6 +24953,7 @@
               </a:defRPr>
             </a:lvl5pPr>
             <a:lvl6pPr algn="l">
+              <a:buNone/>
               <a:defRPr sz="1900">
                 <a:solidFill>
                   <a:srgbClr val="617681"/>
@@ -24557,6 +24964,7 @@
               </a:defRPr>
             </a:lvl6pPr>
             <a:lvl7pPr algn="l">
+              <a:buNone/>
               <a:defRPr sz="1900">
                 <a:solidFill>
                   <a:srgbClr val="617681"/>
@@ -24567,6 +24975,7 @@
               </a:defRPr>
             </a:lvl7pPr>
             <a:lvl8pPr algn="l">
+              <a:buNone/>
               <a:defRPr sz="1900">
                 <a:solidFill>
                   <a:srgbClr val="617681"/>
@@ -24577,6 +24986,7 @@
               </a:defRPr>
             </a:lvl8pPr>
             <a:lvl9pPr algn="l">
+              <a:buNone/>
               <a:defRPr sz="1900">
                 <a:solidFill>
                   <a:srgbClr val="617681"/>
@@ -24681,7 +25091,7 @@
           <p:cNvPr id="12" name="Picture 11">
             <a:extLst xmlns:a="http://schemas.openxmlformats.org/drawingml/2006/main">
               <a:ext uri="{FF2B5EF4-FFF2-40B4-BE49-F238E27FC236}">
-                <a16:creationId xmlns:a16="http://schemas.microsoft.com/office/drawing/2014/main" id="{280826DD-9434-41F5-B5E6-3322206B3BD4}"/>
+                <a16:creationId xmlns:a16="http://schemas.microsoft.com/office/drawing/2014/main" id="{0330DC48-303E-4F9E-9898-08E404CBB2C8}"/>
               </a:ext>
             </a:extLst>
           </p:cNvPr>
@@ -24691,7 +25101,7 @@
           <p:nvPr/>
         </p:nvPicPr>
         <p:blipFill>
-          <a:blip xmlns:r="http://schemas.openxmlformats.org/officeDocument/2006/relationships" xmlns:a="http://schemas.openxmlformats.org/drawingml/2006/main" r:embed="Rb5f78188c9f14652"/>
+          <a:blip xmlns:r="http://schemas.openxmlformats.org/officeDocument/2006/relationships" xmlns:a="http://schemas.openxmlformats.org/drawingml/2006/main" r:embed="Rc23ccb675f804b4c"/>
           <a:stretch xmlns:a="http://schemas.openxmlformats.org/drawingml/2006/main">
             <a:fillRect l="0" t="0" r="0" b="0"/>
           </a:stretch>
@@ -25040,6 +25450,7 @@
               </a:defRPr>
             </a:defPPr>
             <a:lvl1pPr algn="l">
+              <a:buNone/>
               <a:defRPr sz="1000">
                 <a:solidFill>
                   <a:srgbClr val="617681"/>
@@ -25050,6 +25461,7 @@
               </a:defRPr>
             </a:lvl1pPr>
             <a:lvl2pPr algn="l">
+              <a:buNone/>
               <a:defRPr sz="1000">
                 <a:solidFill>
                   <a:srgbClr val="617681"/>
@@ -25060,6 +25472,7 @@
               </a:defRPr>
             </a:lvl2pPr>
             <a:lvl3pPr algn="l">
+              <a:buNone/>
               <a:defRPr sz="1000">
                 <a:solidFill>
                   <a:srgbClr val="617681"/>
@@ -25070,6 +25483,7 @@
               </a:defRPr>
             </a:lvl3pPr>
             <a:lvl4pPr algn="l">
+              <a:buNone/>
               <a:defRPr sz="1000">
                 <a:solidFill>
                   <a:srgbClr val="617681"/>
@@ -25080,6 +25494,7 @@
               </a:defRPr>
             </a:lvl4pPr>
             <a:lvl5pPr algn="l">
+              <a:buNone/>
               <a:defRPr sz="1000">
                 <a:solidFill>
                   <a:srgbClr val="617681"/>
@@ -25090,6 +25505,7 @@
               </a:defRPr>
             </a:lvl5pPr>
             <a:lvl6pPr algn="l">
+              <a:buNone/>
               <a:defRPr sz="1000">
                 <a:solidFill>
                   <a:srgbClr val="617681"/>
@@ -25100,6 +25516,7 @@
               </a:defRPr>
             </a:lvl6pPr>
             <a:lvl7pPr algn="l">
+              <a:buNone/>
               <a:defRPr sz="1000">
                 <a:solidFill>
                   <a:srgbClr val="617681"/>
@@ -25110,6 +25527,7 @@
               </a:defRPr>
             </a:lvl7pPr>
             <a:lvl8pPr algn="l">
+              <a:buNone/>
               <a:defRPr sz="1000">
                 <a:solidFill>
                   <a:srgbClr val="617681"/>
@@ -25120,6 +25538,7 @@
               </a:defRPr>
             </a:lvl8pPr>
             <a:lvl9pPr algn="l">
+              <a:buNone/>
               <a:defRPr sz="1000">
                 <a:solidFill>
                   <a:srgbClr val="617681"/>
@@ -25436,7 +25855,7 @@
           <p:cNvPr id="13" name="Picture 12">
             <a:extLst xmlns:a="http://schemas.openxmlformats.org/drawingml/2006/main">
               <a:ext uri="{FF2B5EF4-FFF2-40B4-BE49-F238E27FC236}">
-                <a16:creationId xmlns:a16="http://schemas.microsoft.com/office/drawing/2014/main" id="{E3CEB2BD-1B83-43F7-AD54-2C03FDEBE0A0}"/>
+                <a16:creationId xmlns:a16="http://schemas.microsoft.com/office/drawing/2014/main" id="{8B3ED2B1-8FFF-449D-BB89-B5CBD6E96951}"/>
               </a:ext>
             </a:extLst>
           </p:cNvPr>
@@ -25446,7 +25865,7 @@
           <p:nvPr/>
         </p:nvPicPr>
         <p:blipFill>
-          <a:blip xmlns:r="http://schemas.openxmlformats.org/officeDocument/2006/relationships" xmlns:a="http://schemas.openxmlformats.org/drawingml/2006/main" r:embed="R516d98208ce04205"/>
+          <a:blip xmlns:r="http://schemas.openxmlformats.org/officeDocument/2006/relationships" xmlns:a="http://schemas.openxmlformats.org/drawingml/2006/main" r:embed="R494de6054bda46b1"/>
           <a:stretch xmlns:a="http://schemas.openxmlformats.org/drawingml/2006/main">
             <a:fillRect l="0" t="0" r="0" b="0"/>
           </a:stretch>
@@ -25583,6 +26002,7 @@
               </a:defRPr>
             </a:defPPr>
             <a:lvl1pPr algn="l">
+              <a:buNone/>
               <a:defRPr sz="1200" b="1">
                 <a:solidFill>
                   <a:srgbClr val="147D82"/>
@@ -25593,6 +26013,7 @@
               </a:defRPr>
             </a:lvl1pPr>
             <a:lvl2pPr algn="l">
+              <a:buNone/>
               <a:defRPr sz="1200" b="1">
                 <a:solidFill>
                   <a:srgbClr val="147D82"/>
@@ -25603,6 +26024,7 @@
               </a:defRPr>
             </a:lvl2pPr>
             <a:lvl3pPr algn="l">
+              <a:buNone/>
               <a:defRPr sz="1200" b="1">
                 <a:solidFill>
                   <a:srgbClr val="147D82"/>
@@ -25613,6 +26035,7 @@
               </a:defRPr>
             </a:lvl3pPr>
             <a:lvl4pPr algn="l">
+              <a:buNone/>
               <a:defRPr sz="1200" b="1">
                 <a:solidFill>
                   <a:srgbClr val="147D82"/>
@@ -25623,6 +26046,7 @@
               </a:defRPr>
             </a:lvl4pPr>
             <a:lvl5pPr algn="l">
+              <a:buNone/>
               <a:defRPr sz="1200" b="1">
                 <a:solidFill>
                   <a:srgbClr val="147D82"/>
@@ -25633,6 +26057,7 @@
               </a:defRPr>
             </a:lvl5pPr>
             <a:lvl6pPr algn="l">
+              <a:buNone/>
               <a:defRPr sz="1200" b="1">
                 <a:solidFill>
                   <a:srgbClr val="147D82"/>
@@ -25643,6 +26068,7 @@
               </a:defRPr>
             </a:lvl6pPr>
             <a:lvl7pPr algn="l">
+              <a:buNone/>
               <a:defRPr sz="1200" b="1">
                 <a:solidFill>
                   <a:srgbClr val="147D82"/>
@@ -25653,6 +26079,7 @@
               </a:defRPr>
             </a:lvl7pPr>
             <a:lvl8pPr algn="l">
+              <a:buNone/>
               <a:defRPr sz="1200" b="1">
                 <a:solidFill>
                   <a:srgbClr val="147D82"/>
@@ -25663,6 +26090,7 @@
               </a:defRPr>
             </a:lvl8pPr>
             <a:lvl9pPr algn="l">
+              <a:buNone/>
               <a:defRPr sz="1200" b="1">
                 <a:solidFill>
                   <a:srgbClr val="147D82"/>
@@ -25745,6 +26173,7 @@
               </a:defRPr>
             </a:defPPr>
             <a:lvl1pPr algn="l">
+              <a:buNone/>
               <a:defRPr sz="3200" b="1">
                 <a:solidFill>
                   <a:srgbClr val="173A49"/>
@@ -25755,6 +26184,7 @@
               </a:defRPr>
             </a:lvl1pPr>
             <a:lvl2pPr algn="l">
+              <a:buNone/>
               <a:defRPr sz="3200" b="1">
                 <a:solidFill>
                   <a:srgbClr val="173A49"/>
@@ -25765,6 +26195,7 @@
               </a:defRPr>
             </a:lvl2pPr>
             <a:lvl3pPr algn="l">
+              <a:buNone/>
               <a:defRPr sz="3200" b="1">
                 <a:solidFill>
                   <a:srgbClr val="173A49"/>
@@ -25775,6 +26206,7 @@
               </a:defRPr>
             </a:lvl3pPr>
             <a:lvl4pPr algn="l">
+              <a:buNone/>
               <a:defRPr sz="3200" b="1">
                 <a:solidFill>
                   <a:srgbClr val="173A49"/>
@@ -25785,6 +26217,7 @@
               </a:defRPr>
             </a:lvl4pPr>
             <a:lvl5pPr algn="l">
+              <a:buNone/>
               <a:defRPr sz="3200" b="1">
                 <a:solidFill>
                   <a:srgbClr val="173A49"/>
@@ -25795,6 +26228,7 @@
               </a:defRPr>
             </a:lvl5pPr>
             <a:lvl6pPr algn="l">
+              <a:buNone/>
               <a:defRPr sz="3200" b="1">
                 <a:solidFill>
                   <a:srgbClr val="173A49"/>
@@ -25805,6 +26239,7 @@
               </a:defRPr>
             </a:lvl6pPr>
             <a:lvl7pPr algn="l">
+              <a:buNone/>
               <a:defRPr sz="3200" b="1">
                 <a:solidFill>
                   <a:srgbClr val="173A49"/>
@@ -25815,6 +26250,7 @@
               </a:defRPr>
             </a:lvl7pPr>
             <a:lvl8pPr algn="l">
+              <a:buNone/>
               <a:defRPr sz="3200" b="1">
                 <a:solidFill>
                   <a:srgbClr val="173A49"/>
@@ -25825,6 +26261,7 @@
               </a:defRPr>
             </a:lvl8pPr>
             <a:lvl9pPr algn="l">
+              <a:buNone/>
               <a:defRPr sz="3200" b="1">
                 <a:solidFill>
                   <a:srgbClr val="173A49"/>
@@ -26013,6 +26450,7 @@
               </a:defRPr>
             </a:defPPr>
             <a:lvl1pPr algn="l">
+              <a:buNone/>
               <a:defRPr sz="1000">
                 <a:solidFill>
                   <a:srgbClr val="617681"/>
@@ -26023,6 +26461,7 @@
               </a:defRPr>
             </a:lvl1pPr>
             <a:lvl2pPr algn="l">
+              <a:buNone/>
               <a:defRPr sz="1000">
                 <a:solidFill>
                   <a:srgbClr val="617681"/>
@@ -26033,6 +26472,7 @@
               </a:defRPr>
             </a:lvl2pPr>
             <a:lvl3pPr algn="l">
+              <a:buNone/>
               <a:defRPr sz="1000">
                 <a:solidFill>
                   <a:srgbClr val="617681"/>
@@ -26043,6 +26483,7 @@
               </a:defRPr>
             </a:lvl3pPr>
             <a:lvl4pPr algn="l">
+              <a:buNone/>
               <a:defRPr sz="1000">
                 <a:solidFill>
                   <a:srgbClr val="617681"/>
@@ -26053,6 +26494,7 @@
               </a:defRPr>
             </a:lvl4pPr>
             <a:lvl5pPr algn="l">
+              <a:buNone/>
               <a:defRPr sz="1000">
                 <a:solidFill>
                   <a:srgbClr val="617681"/>
@@ -26063,6 +26505,7 @@
               </a:defRPr>
             </a:lvl5pPr>
             <a:lvl6pPr algn="l">
+              <a:buNone/>
               <a:defRPr sz="1000">
                 <a:solidFill>
                   <a:srgbClr val="617681"/>
@@ -26073,6 +26516,7 @@
               </a:defRPr>
             </a:lvl6pPr>
             <a:lvl7pPr algn="l">
+              <a:buNone/>
               <a:defRPr sz="1000">
                 <a:solidFill>
                   <a:srgbClr val="617681"/>
@@ -26083,6 +26527,7 @@
               </a:defRPr>
             </a:lvl7pPr>
             <a:lvl8pPr algn="l">
+              <a:buNone/>
               <a:defRPr sz="1000">
                 <a:solidFill>
                   <a:srgbClr val="617681"/>
@@ -26093,6 +26538,7 @@
               </a:defRPr>
             </a:lvl8pPr>
             <a:lvl9pPr algn="l">
+              <a:buNone/>
               <a:defRPr sz="1000">
                 <a:solidFill>
                   <a:srgbClr val="617681"/>
@@ -26175,6 +26621,7 @@
               </a:defRPr>
             </a:defPPr>
             <a:lvl1pPr algn="l">
+              <a:buNone/>
               <a:defRPr sz="1500">
                 <a:solidFill>
                   <a:srgbClr val="617681"/>
@@ -26185,6 +26632,7 @@
               </a:defRPr>
             </a:lvl1pPr>
             <a:lvl2pPr algn="l">
+              <a:buNone/>
               <a:defRPr sz="1500">
                 <a:solidFill>
                   <a:srgbClr val="617681"/>
@@ -26195,6 +26643,7 @@
               </a:defRPr>
             </a:lvl2pPr>
             <a:lvl3pPr algn="l">
+              <a:buNone/>
               <a:defRPr sz="1500">
                 <a:solidFill>
                   <a:srgbClr val="617681"/>
@@ -26205,6 +26654,7 @@
               </a:defRPr>
             </a:lvl3pPr>
             <a:lvl4pPr algn="l">
+              <a:buNone/>
               <a:defRPr sz="1500">
                 <a:solidFill>
                   <a:srgbClr val="617681"/>
@@ -26215,6 +26665,7 @@
               </a:defRPr>
             </a:lvl4pPr>
             <a:lvl5pPr algn="l">
+              <a:buNone/>
               <a:defRPr sz="1500">
                 <a:solidFill>
                   <a:srgbClr val="617681"/>
@@ -26225,6 +26676,7 @@
               </a:defRPr>
             </a:lvl5pPr>
             <a:lvl6pPr algn="l">
+              <a:buNone/>
               <a:defRPr sz="1500">
                 <a:solidFill>
                   <a:srgbClr val="617681"/>
@@ -26235,6 +26687,7 @@
               </a:defRPr>
             </a:lvl6pPr>
             <a:lvl7pPr algn="l">
+              <a:buNone/>
               <a:defRPr sz="1500">
                 <a:solidFill>
                   <a:srgbClr val="617681"/>
@@ -26245,6 +26698,7 @@
               </a:defRPr>
             </a:lvl7pPr>
             <a:lvl8pPr algn="l">
+              <a:buNone/>
               <a:defRPr sz="1500">
                 <a:solidFill>
                   <a:srgbClr val="617681"/>
@@ -26255,6 +26709,7 @@
               </a:defRPr>
             </a:lvl8pPr>
             <a:lvl9pPr algn="l">
+              <a:buNone/>
               <a:defRPr sz="1500">
                 <a:solidFill>
                   <a:srgbClr val="617681"/>
@@ -26337,6 +26792,7 @@
               </a:defRPr>
             </a:defPPr>
             <a:lvl1pPr algn="l">
+              <a:buNone/>
               <a:defRPr sz="1500">
                 <a:solidFill>
                   <a:srgbClr val="617681"/>
@@ -26347,6 +26803,7 @@
               </a:defRPr>
             </a:lvl1pPr>
             <a:lvl2pPr algn="l">
+              <a:buNone/>
               <a:defRPr sz="1500">
                 <a:solidFill>
                   <a:srgbClr val="617681"/>
@@ -26357,6 +26814,7 @@
               </a:defRPr>
             </a:lvl2pPr>
             <a:lvl3pPr algn="l">
+              <a:buNone/>
               <a:defRPr sz="1500">
                 <a:solidFill>
                   <a:srgbClr val="617681"/>
@@ -26367,6 +26825,7 @@
               </a:defRPr>
             </a:lvl3pPr>
             <a:lvl4pPr algn="l">
+              <a:buNone/>
               <a:defRPr sz="1500">
                 <a:solidFill>
                   <a:srgbClr val="617681"/>
@@ -26377,6 +26836,7 @@
               </a:defRPr>
             </a:lvl4pPr>
             <a:lvl5pPr algn="l">
+              <a:buNone/>
               <a:defRPr sz="1500">
                 <a:solidFill>
                   <a:srgbClr val="617681"/>
@@ -26387,6 +26847,7 @@
               </a:defRPr>
             </a:lvl5pPr>
             <a:lvl6pPr algn="l">
+              <a:buNone/>
               <a:defRPr sz="1500">
                 <a:solidFill>
                   <a:srgbClr val="617681"/>
@@ -26397,6 +26858,7 @@
               </a:defRPr>
             </a:lvl6pPr>
             <a:lvl7pPr algn="l">
+              <a:buNone/>
               <a:defRPr sz="1500">
                 <a:solidFill>
                   <a:srgbClr val="617681"/>
@@ -26407,6 +26869,7 @@
               </a:defRPr>
             </a:lvl7pPr>
             <a:lvl8pPr algn="l">
+              <a:buNone/>
               <a:defRPr sz="1500">
                 <a:solidFill>
                   <a:srgbClr val="617681"/>
@@ -26417,6 +26880,7 @@
               </a:defRPr>
             </a:lvl8pPr>
             <a:lvl9pPr algn="l">
+              <a:buNone/>
               <a:defRPr sz="1500">
                 <a:solidFill>
                   <a:srgbClr val="617681"/>
@@ -26464,7 +26928,7 @@
           <p:cNvPr id="10" name="Table 9">
             <a:extLst xmlns:a="http://schemas.openxmlformats.org/drawingml/2006/main">
               <a:ext uri="{FF2B5EF4-FFF2-40B4-BE49-F238E27FC236}">
-                <a16:creationId xmlns:a16="http://schemas.microsoft.com/office/drawing/2014/main" id="{21D4BB11-6EC0-4C05-857E-E7BE7D68EDD8}"/>
+                <a16:creationId xmlns:a16="http://schemas.microsoft.com/office/drawing/2014/main" id="{56210E90-99E2-40CC-98DD-0B137632A97B}"/>
               </a:ext>
             </a:extLst>
           </p:cNvPr>
@@ -28395,6 +28859,7 @@
               </a:defRPr>
             </a:defPPr>
             <a:lvl1pPr algn="l">
+              <a:buNone/>
               <a:defRPr sz="1200" b="1">
                 <a:solidFill>
                   <a:srgbClr val="147D82"/>
@@ -28405,6 +28870,7 @@
               </a:defRPr>
             </a:lvl1pPr>
             <a:lvl2pPr algn="l">
+              <a:buNone/>
               <a:defRPr sz="1200" b="1">
                 <a:solidFill>
                   <a:srgbClr val="147D82"/>
@@ -28415,6 +28881,7 @@
               </a:defRPr>
             </a:lvl2pPr>
             <a:lvl3pPr algn="l">
+              <a:buNone/>
               <a:defRPr sz="1200" b="1">
                 <a:solidFill>
                   <a:srgbClr val="147D82"/>
@@ -28425,6 +28892,7 @@
               </a:defRPr>
             </a:lvl3pPr>
             <a:lvl4pPr algn="l">
+              <a:buNone/>
               <a:defRPr sz="1200" b="1">
                 <a:solidFill>
                   <a:srgbClr val="147D82"/>
@@ -28435,6 +28903,7 @@
               </a:defRPr>
             </a:lvl4pPr>
             <a:lvl5pPr algn="l">
+              <a:buNone/>
               <a:defRPr sz="1200" b="1">
                 <a:solidFill>
                   <a:srgbClr val="147D82"/>
@@ -28445,6 +28914,7 @@
               </a:defRPr>
             </a:lvl5pPr>
             <a:lvl6pPr algn="l">
+              <a:buNone/>
               <a:defRPr sz="1200" b="1">
                 <a:solidFill>
                   <a:srgbClr val="147D82"/>
@@ -28455,6 +28925,7 @@
               </a:defRPr>
             </a:lvl6pPr>
             <a:lvl7pPr algn="l">
+              <a:buNone/>
               <a:defRPr sz="1200" b="1">
                 <a:solidFill>
                   <a:srgbClr val="147D82"/>
@@ -28465,6 +28936,7 @@
               </a:defRPr>
             </a:lvl7pPr>
             <a:lvl8pPr algn="l">
+              <a:buNone/>
               <a:defRPr sz="1200" b="1">
                 <a:solidFill>
                   <a:srgbClr val="147D82"/>
@@ -28475,6 +28947,7 @@
               </a:defRPr>
             </a:lvl8pPr>
             <a:lvl9pPr algn="l">
+              <a:buNone/>
               <a:defRPr sz="1200" b="1">
                 <a:solidFill>
                   <a:srgbClr val="147D82"/>
@@ -28557,6 +29030,7 @@
               </a:defRPr>
             </a:defPPr>
             <a:lvl1pPr algn="l">
+              <a:buNone/>
               <a:defRPr sz="3200" b="1">
                 <a:solidFill>
                   <a:srgbClr val="173A49"/>
@@ -28567,6 +29041,7 @@
               </a:defRPr>
             </a:lvl1pPr>
             <a:lvl2pPr algn="l">
+              <a:buNone/>
               <a:defRPr sz="3200" b="1">
                 <a:solidFill>
                   <a:srgbClr val="173A49"/>
@@ -28577,6 +29052,7 @@
               </a:defRPr>
             </a:lvl2pPr>
             <a:lvl3pPr algn="l">
+              <a:buNone/>
               <a:defRPr sz="3200" b="1">
                 <a:solidFill>
                   <a:srgbClr val="173A49"/>
@@ -28587,6 +29063,7 @@
               </a:defRPr>
             </a:lvl3pPr>
             <a:lvl4pPr algn="l">
+              <a:buNone/>
               <a:defRPr sz="3200" b="1">
                 <a:solidFill>
                   <a:srgbClr val="173A49"/>
@@ -28597,6 +29074,7 @@
               </a:defRPr>
             </a:lvl4pPr>
             <a:lvl5pPr algn="l">
+              <a:buNone/>
               <a:defRPr sz="3200" b="1">
                 <a:solidFill>
                   <a:srgbClr val="173A49"/>
@@ -28607,6 +29085,7 @@
               </a:defRPr>
             </a:lvl5pPr>
             <a:lvl6pPr algn="l">
+              <a:buNone/>
               <a:defRPr sz="3200" b="1">
                 <a:solidFill>
                   <a:srgbClr val="173A49"/>
@@ -28617,6 +29096,7 @@
               </a:defRPr>
             </a:lvl6pPr>
             <a:lvl7pPr algn="l">
+              <a:buNone/>
               <a:defRPr sz="3200" b="1">
                 <a:solidFill>
                   <a:srgbClr val="173A49"/>
@@ -28627,6 +29107,7 @@
               </a:defRPr>
             </a:lvl7pPr>
             <a:lvl8pPr algn="l">
+              <a:buNone/>
               <a:defRPr sz="3200" b="1">
                 <a:solidFill>
                   <a:srgbClr val="173A49"/>
@@ -28637,6 +29118,7 @@
               </a:defRPr>
             </a:lvl8pPr>
             <a:lvl9pPr algn="l">
+              <a:buNone/>
               <a:defRPr sz="3200" b="1">
                 <a:solidFill>
                   <a:srgbClr val="173A49"/>
@@ -28825,6 +29307,7 @@
               </a:defRPr>
             </a:defPPr>
             <a:lvl1pPr algn="l">
+              <a:buNone/>
               <a:defRPr sz="1000">
                 <a:solidFill>
                   <a:srgbClr val="617681"/>
@@ -28835,6 +29318,7 @@
               </a:defRPr>
             </a:lvl1pPr>
             <a:lvl2pPr algn="l">
+              <a:buNone/>
               <a:defRPr sz="1000">
                 <a:solidFill>
                   <a:srgbClr val="617681"/>
@@ -28845,6 +29329,7 @@
               </a:defRPr>
             </a:lvl2pPr>
             <a:lvl3pPr algn="l">
+              <a:buNone/>
               <a:defRPr sz="1000">
                 <a:solidFill>
                   <a:srgbClr val="617681"/>
@@ -28855,6 +29340,7 @@
               </a:defRPr>
             </a:lvl3pPr>
             <a:lvl4pPr algn="l">
+              <a:buNone/>
               <a:defRPr sz="1000">
                 <a:solidFill>
                   <a:srgbClr val="617681"/>
@@ -28865,6 +29351,7 @@
               </a:defRPr>
             </a:lvl4pPr>
             <a:lvl5pPr algn="l">
+              <a:buNone/>
               <a:defRPr sz="1000">
                 <a:solidFill>
                   <a:srgbClr val="617681"/>
@@ -28875,6 +29362,7 @@
               </a:defRPr>
             </a:lvl5pPr>
             <a:lvl6pPr algn="l">
+              <a:buNone/>
               <a:defRPr sz="1000">
                 <a:solidFill>
                   <a:srgbClr val="617681"/>
@@ -28885,6 +29373,7 @@
               </a:defRPr>
             </a:lvl6pPr>
             <a:lvl7pPr algn="l">
+              <a:buNone/>
               <a:defRPr sz="1000">
                 <a:solidFill>
                   <a:srgbClr val="617681"/>
@@ -28895,6 +29384,7 @@
               </a:defRPr>
             </a:lvl7pPr>
             <a:lvl8pPr algn="l">
+              <a:buNone/>
               <a:defRPr sz="1000">
                 <a:solidFill>
                   <a:srgbClr val="617681"/>
@@ -28905,6 +29395,7 @@
               </a:defRPr>
             </a:lvl8pPr>
             <a:lvl9pPr algn="l">
+              <a:buNone/>
               <a:defRPr sz="1000">
                 <a:solidFill>
                   <a:srgbClr val="617681"/>
@@ -29009,7 +29500,7 @@
           <p:cNvPr id="9" name="Picture 8">
             <a:extLst xmlns:a="http://schemas.openxmlformats.org/drawingml/2006/main">
               <a:ext uri="{FF2B5EF4-FFF2-40B4-BE49-F238E27FC236}">
-                <a16:creationId xmlns:a16="http://schemas.microsoft.com/office/drawing/2014/main" id="{BE7125FC-0A37-420F-B830-4C3B38EE463F}"/>
+                <a16:creationId xmlns:a16="http://schemas.microsoft.com/office/drawing/2014/main" id="{93AC608C-C5FF-4E35-8105-E1AEB8A4F65D}"/>
               </a:ext>
             </a:extLst>
           </p:cNvPr>
@@ -29019,7 +29510,7 @@
           <p:nvPr/>
         </p:nvPicPr>
         <p:blipFill>
-          <a:blip xmlns:r="http://schemas.openxmlformats.org/officeDocument/2006/relationships" xmlns:a="http://schemas.openxmlformats.org/drawingml/2006/main" r:embed="R3e64de4bdd6e4a68"/>
+          <a:blip xmlns:r="http://schemas.openxmlformats.org/officeDocument/2006/relationships" xmlns:a="http://schemas.openxmlformats.org/drawingml/2006/main" r:embed="R967853f812b844be"/>
           <a:stretch xmlns:a="http://schemas.openxmlformats.org/drawingml/2006/main">
             <a:fillRect l="0" t="0" r="0" b="0"/>
           </a:stretch>
@@ -29262,6 +29753,7 @@
               </a:defRPr>
             </a:defPPr>
             <a:lvl1pPr algn="l">
+              <a:buNone/>
               <a:defRPr sz="1200" b="1">
                 <a:solidFill>
                   <a:srgbClr val="147D82"/>
@@ -29272,6 +29764,7 @@
               </a:defRPr>
             </a:lvl1pPr>
             <a:lvl2pPr algn="l">
+              <a:buNone/>
               <a:defRPr sz="1200" b="1">
                 <a:solidFill>
                   <a:srgbClr val="147D82"/>
@@ -29282,6 +29775,7 @@
               </a:defRPr>
             </a:lvl2pPr>
             <a:lvl3pPr algn="l">
+              <a:buNone/>
               <a:defRPr sz="1200" b="1">
                 <a:solidFill>
                   <a:srgbClr val="147D82"/>
@@ -29292,6 +29786,7 @@
               </a:defRPr>
             </a:lvl3pPr>
             <a:lvl4pPr algn="l">
+              <a:buNone/>
               <a:defRPr sz="1200" b="1">
                 <a:solidFill>
                   <a:srgbClr val="147D82"/>
@@ -29302,6 +29797,7 @@
               </a:defRPr>
             </a:lvl4pPr>
             <a:lvl5pPr algn="l">
+              <a:buNone/>
               <a:defRPr sz="1200" b="1">
                 <a:solidFill>
                   <a:srgbClr val="147D82"/>
@@ -29312,6 +29808,7 @@
               </a:defRPr>
             </a:lvl5pPr>
             <a:lvl6pPr algn="l">
+              <a:buNone/>
               <a:defRPr sz="1200" b="1">
                 <a:solidFill>
                   <a:srgbClr val="147D82"/>
@@ -29322,6 +29819,7 @@
               </a:defRPr>
             </a:lvl6pPr>
             <a:lvl7pPr algn="l">
+              <a:buNone/>
               <a:defRPr sz="1200" b="1">
                 <a:solidFill>
                   <a:srgbClr val="147D82"/>
@@ -29332,6 +29830,7 @@
               </a:defRPr>
             </a:lvl7pPr>
             <a:lvl8pPr algn="l">
+              <a:buNone/>
               <a:defRPr sz="1200" b="1">
                 <a:solidFill>
                   <a:srgbClr val="147D82"/>
@@ -29342,6 +29841,7 @@
               </a:defRPr>
             </a:lvl8pPr>
             <a:lvl9pPr algn="l">
+              <a:buNone/>
               <a:defRPr sz="1200" b="1">
                 <a:solidFill>
                   <a:srgbClr val="147D82"/>
@@ -29424,6 +29924,7 @@
               </a:defRPr>
             </a:defPPr>
             <a:lvl1pPr algn="l">
+              <a:buNone/>
               <a:defRPr sz="3200" b="1">
                 <a:solidFill>
                   <a:srgbClr val="173A49"/>
@@ -29434,6 +29935,7 @@
               </a:defRPr>
             </a:lvl1pPr>
             <a:lvl2pPr algn="l">
+              <a:buNone/>
               <a:defRPr sz="3200" b="1">
                 <a:solidFill>
                   <a:srgbClr val="173A49"/>
@@ -29444,6 +29946,7 @@
               </a:defRPr>
             </a:lvl2pPr>
             <a:lvl3pPr algn="l">
+              <a:buNone/>
               <a:defRPr sz="3200" b="1">
                 <a:solidFill>
                   <a:srgbClr val="173A49"/>
@@ -29454,6 +29957,7 @@
               </a:defRPr>
             </a:lvl3pPr>
             <a:lvl4pPr algn="l">
+              <a:buNone/>
               <a:defRPr sz="3200" b="1">
                 <a:solidFill>
                   <a:srgbClr val="173A49"/>
@@ -29464,6 +29968,7 @@
               </a:defRPr>
             </a:lvl4pPr>
             <a:lvl5pPr algn="l">
+              <a:buNone/>
               <a:defRPr sz="3200" b="1">
                 <a:solidFill>
                   <a:srgbClr val="173A49"/>
@@ -29474,6 +29979,7 @@
               </a:defRPr>
             </a:lvl5pPr>
             <a:lvl6pPr algn="l">
+              <a:buNone/>
               <a:defRPr sz="3200" b="1">
                 <a:solidFill>
                   <a:srgbClr val="173A49"/>
@@ -29484,6 +29990,7 @@
               </a:defRPr>
             </a:lvl6pPr>
             <a:lvl7pPr algn="l">
+              <a:buNone/>
               <a:defRPr sz="3200" b="1">
                 <a:solidFill>
                   <a:srgbClr val="173A49"/>
@@ -29494,6 +30001,7 @@
               </a:defRPr>
             </a:lvl7pPr>
             <a:lvl8pPr algn="l">
+              <a:buNone/>
               <a:defRPr sz="3200" b="1">
                 <a:solidFill>
                   <a:srgbClr val="173A49"/>
@@ -29504,6 +30012,7 @@
               </a:defRPr>
             </a:lvl8pPr>
             <a:lvl9pPr algn="l">
+              <a:buNone/>
               <a:defRPr sz="3200" b="1">
                 <a:solidFill>
                   <a:srgbClr val="173A49"/>
@@ -29692,6 +30201,7 @@
               </a:defRPr>
             </a:defPPr>
             <a:lvl1pPr algn="l">
+              <a:buNone/>
               <a:defRPr sz="1000">
                 <a:solidFill>
                   <a:srgbClr val="617681"/>
@@ -29702,6 +30212,7 @@
               </a:defRPr>
             </a:lvl1pPr>
             <a:lvl2pPr algn="l">
+              <a:buNone/>
               <a:defRPr sz="1000">
                 <a:solidFill>
                   <a:srgbClr val="617681"/>
@@ -29712,6 +30223,7 @@
               </a:defRPr>
             </a:lvl2pPr>
             <a:lvl3pPr algn="l">
+              <a:buNone/>
               <a:defRPr sz="1000">
                 <a:solidFill>
                   <a:srgbClr val="617681"/>
@@ -29722,6 +30234,7 @@
               </a:defRPr>
             </a:lvl3pPr>
             <a:lvl4pPr algn="l">
+              <a:buNone/>
               <a:defRPr sz="1000">
                 <a:solidFill>
                   <a:srgbClr val="617681"/>
@@ -29732,6 +30245,7 @@
               </a:defRPr>
             </a:lvl4pPr>
             <a:lvl5pPr algn="l">
+              <a:buNone/>
               <a:defRPr sz="1000">
                 <a:solidFill>
                   <a:srgbClr val="617681"/>
@@ -29742,6 +30256,7 @@
               </a:defRPr>
             </a:lvl5pPr>
             <a:lvl6pPr algn="l">
+              <a:buNone/>
               <a:defRPr sz="1000">
                 <a:solidFill>
                   <a:srgbClr val="617681"/>
@@ -29752,6 +30267,7 @@
               </a:defRPr>
             </a:lvl6pPr>
             <a:lvl7pPr algn="l">
+              <a:buNone/>
               <a:defRPr sz="1000">
                 <a:solidFill>
                   <a:srgbClr val="617681"/>
@@ -29762,6 +30278,7 @@
               </a:defRPr>
             </a:lvl7pPr>
             <a:lvl8pPr algn="l">
+              <a:buNone/>
               <a:defRPr sz="1000">
                 <a:solidFill>
                   <a:srgbClr val="617681"/>
@@ -29772,6 +30289,7 @@
               </a:defRPr>
             </a:lvl8pPr>
             <a:lvl9pPr algn="l">
+              <a:buNone/>
               <a:defRPr sz="1000">
                 <a:solidFill>
                   <a:srgbClr val="617681"/>
@@ -29876,7 +30394,7 @@
           <p:cNvPr id="9" name="Picture 8">
             <a:extLst xmlns:a="http://schemas.openxmlformats.org/drawingml/2006/main">
               <a:ext uri="{FF2B5EF4-FFF2-40B4-BE49-F238E27FC236}">
-                <a16:creationId xmlns:a16="http://schemas.microsoft.com/office/drawing/2014/main" id="{28FD1177-FDCE-406B-AB6C-836904634378}"/>
+                <a16:creationId xmlns:a16="http://schemas.microsoft.com/office/drawing/2014/main" id="{481FD231-993D-40C1-A8FA-FC8DE42F15D4}"/>
               </a:ext>
             </a:extLst>
           </p:cNvPr>
@@ -29886,7 +30404,7 @@
           <p:nvPr/>
         </p:nvPicPr>
         <p:blipFill>
-          <a:blip xmlns:r="http://schemas.openxmlformats.org/officeDocument/2006/relationships" xmlns:a="http://schemas.openxmlformats.org/drawingml/2006/main" r:embed="R541ceb4983c04198"/>
+          <a:blip xmlns:r="http://schemas.openxmlformats.org/officeDocument/2006/relationships" xmlns:a="http://schemas.openxmlformats.org/drawingml/2006/main" r:embed="R0a8a36c7e5444ece"/>
           <a:stretch xmlns:a="http://schemas.openxmlformats.org/drawingml/2006/main">
             <a:fillRect l="0" t="0" r="0" b="0"/>
           </a:stretch>
@@ -30129,6 +30647,7 @@
               </a:defRPr>
             </a:defPPr>
             <a:lvl1pPr algn="l">
+              <a:buNone/>
               <a:defRPr sz="1200" b="1">
                 <a:solidFill>
                   <a:srgbClr val="147D82"/>
@@ -30139,6 +30658,7 @@
               </a:defRPr>
             </a:lvl1pPr>
             <a:lvl2pPr algn="l">
+              <a:buNone/>
               <a:defRPr sz="1200" b="1">
                 <a:solidFill>
                   <a:srgbClr val="147D82"/>
@@ -30149,6 +30669,7 @@
               </a:defRPr>
             </a:lvl2pPr>
             <a:lvl3pPr algn="l">
+              <a:buNone/>
               <a:defRPr sz="1200" b="1">
                 <a:solidFill>
                   <a:srgbClr val="147D82"/>
@@ -30159,6 +30680,7 @@
               </a:defRPr>
             </a:lvl3pPr>
             <a:lvl4pPr algn="l">
+              <a:buNone/>
               <a:defRPr sz="1200" b="1">
                 <a:solidFill>
                   <a:srgbClr val="147D82"/>
@@ -30169,6 +30691,7 @@
               </a:defRPr>
             </a:lvl4pPr>
             <a:lvl5pPr algn="l">
+              <a:buNone/>
               <a:defRPr sz="1200" b="1">
                 <a:solidFill>
                   <a:srgbClr val="147D82"/>
@@ -30179,6 +30702,7 @@
               </a:defRPr>
             </a:lvl5pPr>
             <a:lvl6pPr algn="l">
+              <a:buNone/>
               <a:defRPr sz="1200" b="1">
                 <a:solidFill>
                   <a:srgbClr val="147D82"/>
@@ -30189,6 +30713,7 @@
               </a:defRPr>
             </a:lvl6pPr>
             <a:lvl7pPr algn="l">
+              <a:buNone/>
               <a:defRPr sz="1200" b="1">
                 <a:solidFill>
                   <a:srgbClr val="147D82"/>
@@ -30199,6 +30724,7 @@
               </a:defRPr>
             </a:lvl7pPr>
             <a:lvl8pPr algn="l">
+              <a:buNone/>
               <a:defRPr sz="1200" b="1">
                 <a:solidFill>
                   <a:srgbClr val="147D82"/>
@@ -30209,6 +30735,7 @@
               </a:defRPr>
             </a:lvl8pPr>
             <a:lvl9pPr algn="l">
+              <a:buNone/>
               <a:defRPr sz="1200" b="1">
                 <a:solidFill>
                   <a:srgbClr val="147D82"/>
@@ -30291,6 +30818,7 @@
               </a:defRPr>
             </a:defPPr>
             <a:lvl1pPr algn="l">
+              <a:buNone/>
               <a:defRPr sz="3200" b="1">
                 <a:solidFill>
                   <a:srgbClr val="173A49"/>
@@ -30301,6 +30829,7 @@
               </a:defRPr>
             </a:lvl1pPr>
             <a:lvl2pPr algn="l">
+              <a:buNone/>
               <a:defRPr sz="3200" b="1">
                 <a:solidFill>
                   <a:srgbClr val="173A49"/>
@@ -30311,6 +30840,7 @@
               </a:defRPr>
             </a:lvl2pPr>
             <a:lvl3pPr algn="l">
+              <a:buNone/>
               <a:defRPr sz="3200" b="1">
                 <a:solidFill>
                   <a:srgbClr val="173A49"/>
@@ -30321,6 +30851,7 @@
               </a:defRPr>
             </a:lvl3pPr>
             <a:lvl4pPr algn="l">
+              <a:buNone/>
               <a:defRPr sz="3200" b="1">
                 <a:solidFill>
                   <a:srgbClr val="173A49"/>
@@ -30331,6 +30862,7 @@
               </a:defRPr>
             </a:lvl4pPr>
             <a:lvl5pPr algn="l">
+              <a:buNone/>
               <a:defRPr sz="3200" b="1">
                 <a:solidFill>
                   <a:srgbClr val="173A49"/>
@@ -30341,6 +30873,7 @@
               </a:defRPr>
             </a:lvl5pPr>
             <a:lvl6pPr algn="l">
+              <a:buNone/>
               <a:defRPr sz="3200" b="1">
                 <a:solidFill>
                   <a:srgbClr val="173A49"/>
@@ -30351,6 +30884,7 @@
               </a:defRPr>
             </a:lvl6pPr>
             <a:lvl7pPr algn="l">
+              <a:buNone/>
               <a:defRPr sz="3200" b="1">
                 <a:solidFill>
                   <a:srgbClr val="173A49"/>
@@ -30361,6 +30895,7 @@
               </a:defRPr>
             </a:lvl7pPr>
             <a:lvl8pPr algn="l">
+              <a:buNone/>
               <a:defRPr sz="3200" b="1">
                 <a:solidFill>
                   <a:srgbClr val="173A49"/>
@@ -30371,6 +30906,7 @@
               </a:defRPr>
             </a:lvl8pPr>
             <a:lvl9pPr algn="l">
+              <a:buNone/>
               <a:defRPr sz="3200" b="1">
                 <a:solidFill>
                   <a:srgbClr val="173A49"/>
@@ -30559,6 +31095,7 @@
               </a:defRPr>
             </a:defPPr>
             <a:lvl1pPr algn="l">
+              <a:buNone/>
               <a:defRPr sz="1000">
                 <a:solidFill>
                   <a:srgbClr val="617681"/>
@@ -30569,6 +31106,7 @@
               </a:defRPr>
             </a:lvl1pPr>
             <a:lvl2pPr algn="l">
+              <a:buNone/>
               <a:defRPr sz="1000">
                 <a:solidFill>
                   <a:srgbClr val="617681"/>
@@ -30579,6 +31117,7 @@
               </a:defRPr>
             </a:lvl2pPr>
             <a:lvl3pPr algn="l">
+              <a:buNone/>
               <a:defRPr sz="1000">
                 <a:solidFill>
                   <a:srgbClr val="617681"/>
@@ -30589,6 +31128,7 @@
               </a:defRPr>
             </a:lvl3pPr>
             <a:lvl4pPr algn="l">
+              <a:buNone/>
               <a:defRPr sz="1000">
                 <a:solidFill>
                   <a:srgbClr val="617681"/>
@@ -30599,6 +31139,7 @@
               </a:defRPr>
             </a:lvl4pPr>
             <a:lvl5pPr algn="l">
+              <a:buNone/>
               <a:defRPr sz="1000">
                 <a:solidFill>
                   <a:srgbClr val="617681"/>
@@ -30609,6 +31150,7 @@
               </a:defRPr>
             </a:lvl5pPr>
             <a:lvl6pPr algn="l">
+              <a:buNone/>
               <a:defRPr sz="1000">
                 <a:solidFill>
                   <a:srgbClr val="617681"/>
@@ -30619,6 +31161,7 @@
               </a:defRPr>
             </a:lvl6pPr>
             <a:lvl7pPr algn="l">
+              <a:buNone/>
               <a:defRPr sz="1000">
                 <a:solidFill>
                   <a:srgbClr val="617681"/>
@@ -30629,6 +31172,7 @@
               </a:defRPr>
             </a:lvl7pPr>
             <a:lvl8pPr algn="l">
+              <a:buNone/>
               <a:defRPr sz="1000">
                 <a:solidFill>
                   <a:srgbClr val="617681"/>
@@ -30639,6 +31183,7 @@
               </a:defRPr>
             </a:lvl8pPr>
             <a:lvl9pPr algn="l">
+              <a:buNone/>
               <a:defRPr sz="1000">
                 <a:solidFill>
                   <a:srgbClr val="617681"/>
@@ -30977,7 +31522,7 @@
           <p:cNvPr id="13" name="Picture 12">
             <a:extLst xmlns:a="http://schemas.openxmlformats.org/drawingml/2006/main">
               <a:ext uri="{FF2B5EF4-FFF2-40B4-BE49-F238E27FC236}">
-                <a16:creationId xmlns:a16="http://schemas.microsoft.com/office/drawing/2014/main" id="{73B4156E-A243-4101-BBCB-50FC703A72C3}"/>
+                <a16:creationId xmlns:a16="http://schemas.microsoft.com/office/drawing/2014/main" id="{0C995D4E-FE53-410A-B496-35AAB440A94A}"/>
               </a:ext>
             </a:extLst>
           </p:cNvPr>
@@ -30987,7 +31532,7 @@
           <p:nvPr/>
         </p:nvPicPr>
         <p:blipFill>
-          <a:blip xmlns:r="http://schemas.openxmlformats.org/officeDocument/2006/relationships" xmlns:a="http://schemas.openxmlformats.org/drawingml/2006/main" r:embed="Rf1932f99a9f84152"/>
+          <a:blip xmlns:r="http://schemas.openxmlformats.org/officeDocument/2006/relationships" xmlns:a="http://schemas.openxmlformats.org/drawingml/2006/main" r:embed="Rc8950847021447bb"/>
           <a:stretch xmlns:a="http://schemas.openxmlformats.org/drawingml/2006/main">
             <a:fillRect l="0" t="0" r="0" b="0"/>
           </a:stretch>

</xml_diff>